<commit_message>
Polish SLSTP presentation rendering
</commit_message>
<xml_diff>
--- a/presentation/SLSTP_2026_Generative_Transcriptomics.pptx
+++ b/presentation/SLSTP_2026_Generative_Transcriptomics.pptx
@@ -22149,7 +22149,7 @@
                 </a:solidFill>
                 <a:latin typeface="Arial"/>
               </a:rPr>
-              <a:t>Can generated RNA-seq improve tissue-specific FLT vs GC analysis?</a:t>
+              <a:t>Can generated RNA-seq improve FLT vs GC analysis within each tissue?</a:t>
             </a:r>
           </a:p>
           <a:p>
@@ -23148,7 +23148,7 @@
                 </a:solidFill>
                 <a:latin typeface="Arial"/>
               </a:rPr>
-              <a:t>Kidney adds a focused signal; other tissues remain exploratory</a:t>
+              <a:t>Kidney adds a focused signal; other tissues are exploratory</a:t>
             </a:r>
           </a:p>
         </p:txBody>
@@ -28844,7 +28844,7 @@
                 </a:solidFill>
                 <a:latin typeface="Arial"/>
               </a:rPr>
-              <a:t>DDIM matched expression and was harder to distinguish from real data</a:t>
+              <a:t>DDIM matched expression and reduced separability</a:t>
             </a:r>
           </a:p>
         </p:txBody>
@@ -33160,102 +33160,25 @@
       </p:sp>
       <p:sp>
         <p:nvSpPr>
-          <p:cNvPr id="14" name="TextBox 13"/>
-          <p:cNvSpPr txBox="1"/>
-          <p:nvPr/>
-        </p:nvSpPr>
-        <p:spPr>
-          <a:xfrm>
-            <a:off x="3401568" y="4005072"/>
-            <a:ext cx="1335024" cy="274320"/>
-          </a:xfrm>
-          <a:prstGeom prst="rect">
-            <a:avLst/>
-          </a:prstGeom>
-          <a:noFill/>
-        </p:spPr>
-        <p:txBody>
-          <a:bodyPr wrap="square" lIns="18288" rIns="18288" tIns="18288" bIns="18288" anchor="t">
-            <a:spAutoFit/>
-          </a:bodyPr>
-          <a:lstStyle/>
-          <a:p>
-            <a:pPr algn="ctr">
-              <a:spcAft>
-                <a:spcPts val="0"/>
-              </a:spcAft>
-            </a:pPr>
-            <a:r>
-              <a:rPr sz="1500" b="1" i="0">
-                <a:solidFill>
-                  <a:srgbClr val="178681"/>
-                </a:solidFill>
-                <a:latin typeface="Arial"/>
-              </a:rPr>
-              <a:t>26 promoted</a:t>
-            </a:r>
-          </a:p>
-        </p:txBody>
-      </p:sp>
-      <p:sp>
-        <p:nvSpPr>
-          <p:cNvPr id="15" name="TextBox 14"/>
-          <p:cNvSpPr txBox="1"/>
-          <p:nvPr/>
-        </p:nvSpPr>
-        <p:spPr>
-          <a:xfrm>
-            <a:off x="3310128" y="4334256"/>
-            <a:ext cx="1517904" cy="457200"/>
-          </a:xfrm>
-          <a:prstGeom prst="rect">
-            <a:avLst/>
-          </a:prstGeom>
-          <a:noFill/>
-        </p:spPr>
-        <p:txBody>
-          <a:bodyPr wrap="square" lIns="18288" rIns="18288" tIns="18288" bIns="18288" anchor="t">
-            <a:spAutoFit/>
-          </a:bodyPr>
-          <a:lstStyle/>
-          <a:p>
-            <a:pPr algn="ctr">
-              <a:spcAft>
-                <a:spcPts val="0"/>
-              </a:spcAft>
-            </a:pPr>
-            <a:r>
-              <a:rPr sz="1150" b="0" i="0">
-                <a:solidFill>
-                  <a:srgbClr val="59697A"/>
-                </a:solidFill>
-                <a:latin typeface="Arial"/>
-              </a:rPr>
-              <a:t>selected only with
-synthetic guidance</a:t>
-            </a:r>
-          </a:p>
-        </p:txBody>
-      </p:sp>
-      <p:sp>
-        <p:nvSpPr>
-          <p:cNvPr id="16" name="Right Arrow 15"/>
+          <p:cNvPr id="14" name="Rounded Rectangle 13"/>
           <p:cNvSpPr/>
           <p:nvPr/>
         </p:nvSpPr>
         <p:spPr>
           <a:xfrm>
-            <a:off x="5285232" y="3017520"/>
-            <a:ext cx="594360" cy="438912"/>
-          </a:xfrm>
-          <a:prstGeom prst="rightArrow">
+            <a:off x="3218688" y="4535424"/>
+            <a:ext cx="1700784" cy="713232"/>
+          </a:xfrm>
+          <a:prstGeom prst="roundRect">
             <a:avLst/>
           </a:prstGeom>
           <a:solidFill>
-            <a:srgbClr val="178681"/>
+            <a:srgbClr val="E8F3F1"/>
           </a:solidFill>
-          <a:ln>
-            <a:noFill/>
+          <a:ln w="10160">
+            <a:solidFill>
+              <a:srgbClr val="178681"/>
+            </a:solidFill>
           </a:ln>
         </p:spPr>
         <p:style>
@@ -33282,25 +33205,102 @@
       </p:sp>
       <p:sp>
         <p:nvSpPr>
-          <p:cNvPr id="17" name="Rounded Rectangle 16"/>
+          <p:cNvPr id="15" name="TextBox 14"/>
+          <p:cNvSpPr txBox="1"/>
+          <p:nvPr/>
+        </p:nvSpPr>
+        <p:spPr>
+          <a:xfrm>
+            <a:off x="3346704" y="4626864"/>
+            <a:ext cx="1444752" cy="219456"/>
+          </a:xfrm>
+          <a:prstGeom prst="rect">
+            <a:avLst/>
+          </a:prstGeom>
+          <a:noFill/>
+        </p:spPr>
+        <p:txBody>
+          <a:bodyPr wrap="square" lIns="18288" rIns="18288" tIns="18288" bIns="18288" anchor="t">
+            <a:spAutoFit/>
+          </a:bodyPr>
+          <a:lstStyle/>
+          <a:p>
+            <a:pPr algn="ctr">
+              <a:spcAft>
+                <a:spcPts val="0"/>
+              </a:spcAft>
+            </a:pPr>
+            <a:r>
+              <a:rPr sz="1350" b="1" i="0">
+                <a:solidFill>
+                  <a:srgbClr val="178681"/>
+                </a:solidFill>
+                <a:latin typeface="Arial"/>
+              </a:rPr>
+              <a:t>26 promoted</a:t>
+            </a:r>
+          </a:p>
+        </p:txBody>
+      </p:sp>
+      <p:sp>
+        <p:nvSpPr>
+          <p:cNvPr id="16" name="TextBox 15"/>
+          <p:cNvSpPr txBox="1"/>
+          <p:nvPr/>
+        </p:nvSpPr>
+        <p:spPr>
+          <a:xfrm>
+            <a:off x="3364992" y="4882896"/>
+            <a:ext cx="1408176" cy="292608"/>
+          </a:xfrm>
+          <a:prstGeom prst="rect">
+            <a:avLst/>
+          </a:prstGeom>
+          <a:noFill/>
+        </p:spPr>
+        <p:txBody>
+          <a:bodyPr wrap="square" lIns="18288" rIns="18288" tIns="18288" bIns="18288" anchor="t">
+            <a:spAutoFit/>
+          </a:bodyPr>
+          <a:lstStyle/>
+          <a:p>
+            <a:pPr algn="ctr">
+              <a:spcAft>
+                <a:spcPts val="0"/>
+              </a:spcAft>
+            </a:pPr>
+            <a:r>
+              <a:rPr sz="950" b="0" i="0">
+                <a:solidFill>
+                  <a:srgbClr val="59697A"/>
+                </a:solidFill>
+                <a:latin typeface="Arial"/>
+              </a:rPr>
+              <a:t>selected only with
+synthetic guidance</a:t>
+            </a:r>
+          </a:p>
+        </p:txBody>
+      </p:sp>
+      <p:sp>
+        <p:nvSpPr>
+          <p:cNvPr id="17" name="Right Arrow 16"/>
           <p:cNvSpPr/>
           <p:nvPr/>
         </p:nvSpPr>
         <p:spPr>
           <a:xfrm>
-            <a:off x="6108192" y="2039112"/>
-            <a:ext cx="5468112" cy="3355848"/>
-          </a:xfrm>
-          <a:prstGeom prst="roundRect">
+            <a:off x="5285232" y="3017520"/>
+            <a:ext cx="594360" cy="438912"/>
+          </a:xfrm>
+          <a:prstGeom prst="rightArrow">
             <a:avLst/>
           </a:prstGeom>
           <a:solidFill>
-            <a:srgbClr val="E9F1F7"/>
+            <a:srgbClr val="178681"/>
           </a:solidFill>
-          <a:ln w="10160">
-            <a:solidFill>
-              <a:srgbClr val="2D6496"/>
-            </a:solidFill>
+          <a:ln>
+            <a:noFill/>
           </a:ln>
         </p:spPr>
         <p:style>
@@ -33327,62 +33327,25 @@
       </p:sp>
       <p:sp>
         <p:nvSpPr>
-          <p:cNvPr id="18" name="TextBox 17"/>
-          <p:cNvSpPr txBox="1"/>
-          <p:nvPr/>
-        </p:nvSpPr>
-        <p:spPr>
-          <a:xfrm>
-            <a:off x="6419088" y="2304288"/>
-            <a:ext cx="4846320" cy="365760"/>
-          </a:xfrm>
-          <a:prstGeom prst="rect">
-            <a:avLst/>
-          </a:prstGeom>
-          <a:noFill/>
-        </p:spPr>
-        <p:txBody>
-          <a:bodyPr wrap="square" lIns="18288" rIns="18288" tIns="18288" bIns="18288" anchor="t">
-            <a:spAutoFit/>
-          </a:bodyPr>
-          <a:lstStyle/>
-          <a:p>
-            <a:pPr algn="ctr">
-              <a:spcAft>
-                <a:spcPts val="0"/>
-              </a:spcAft>
-            </a:pPr>
-            <a:r>
-              <a:rPr sz="2000" b="1" i="0">
-                <a:solidFill>
-                  <a:srgbClr val="2D6496"/>
-                </a:solidFill>
-                <a:latin typeface="Arial"/>
-              </a:rPr>
-              <a:t>Real OSDR association test</a:t>
-            </a:r>
-          </a:p>
-        </p:txBody>
-      </p:sp>
-      <p:sp>
-        <p:nvSpPr>
-          <p:cNvPr id="19" name="Oval 18"/>
+          <p:cNvPr id="18" name="Rounded Rectangle 17"/>
           <p:cNvSpPr/>
           <p:nvPr/>
         </p:nvSpPr>
         <p:spPr>
           <a:xfrm>
-            <a:off x="6601968" y="3017520"/>
-            <a:ext cx="91440" cy="91440"/>
-          </a:xfrm>
-          <a:prstGeom prst="ellipse">
+            <a:off x="6108192" y="2039112"/>
+            <a:ext cx="5468112" cy="3355848"/>
+          </a:xfrm>
+          <a:prstGeom prst="roundRect">
             <a:avLst/>
           </a:prstGeom>
           <a:solidFill>
-            <a:srgbClr val="2D6496"/>
+            <a:srgbClr val="E9F1F7"/>
           </a:solidFill>
-          <a:ln>
-            <a:noFill/>
+          <a:ln w="10160">
+            <a:solidFill>
+              <a:srgbClr val="2D6496"/>
+            </a:solidFill>
           </a:ln>
         </p:spPr>
         <p:style>
@@ -33409,14 +33372,14 @@
       </p:sp>
       <p:sp>
         <p:nvSpPr>
-          <p:cNvPr id="20" name="TextBox 19"/>
+          <p:cNvPr id="19" name="TextBox 18"/>
           <p:cNvSpPr txBox="1"/>
           <p:nvPr/>
         </p:nvSpPr>
         <p:spPr>
           <a:xfrm>
-            <a:off x="6766559" y="2907792"/>
-            <a:ext cx="4361688" cy="530352"/>
+            <a:off x="6419088" y="2304288"/>
+            <a:ext cx="4846320" cy="365760"/>
           </a:xfrm>
           <a:prstGeom prst="rect">
             <a:avLst/>
@@ -33424,37 +33387,37 @@
           <a:noFill/>
         </p:spPr>
         <p:txBody>
-          <a:bodyPr wrap="square" lIns="18288" rIns="18288" tIns="18288" bIns="18288" anchor="ctr">
+          <a:bodyPr wrap="square" lIns="18288" rIns="18288" tIns="18288" bIns="18288" anchor="t">
             <a:spAutoFit/>
           </a:bodyPr>
           <a:lstStyle/>
           <a:p>
-            <a:pPr algn="l">
+            <a:pPr algn="ctr">
               <a:spcAft>
                 <a:spcPts val="0"/>
               </a:spcAft>
             </a:pPr>
             <a:r>
-              <a:rPr sz="1500" b="0" i="0">
-                <a:solidFill>
-                  <a:srgbClr val="263746"/>
+              <a:rPr sz="2000" b="1" i="0">
+                <a:solidFill>
+                  <a:srgbClr val="2D6496"/>
                 </a:solidFill>
                 <a:latin typeface="Arial"/>
               </a:rPr>
-              <a:t>Estimate FLT vs GC inside each accession</a:t>
-            </a:r>
-          </a:p>
-        </p:txBody>
-      </p:sp>
-      <p:sp>
-        <p:nvSpPr>
-          <p:cNvPr id="21" name="Oval 20"/>
+              <a:t>Real OSDR association test</a:t>
+            </a:r>
+          </a:p>
+        </p:txBody>
+      </p:sp>
+      <p:sp>
+        <p:nvSpPr>
+          <p:cNvPr id="20" name="Oval 19"/>
           <p:cNvSpPr/>
           <p:nvPr/>
         </p:nvSpPr>
         <p:spPr>
           <a:xfrm>
-            <a:off x="6601968" y="3547872"/>
+            <a:off x="6601968" y="3017520"/>
             <a:ext cx="91440" cy="91440"/>
           </a:xfrm>
           <a:prstGeom prst="ellipse">
@@ -33491,13 +33454,13 @@
       </p:sp>
       <p:sp>
         <p:nvSpPr>
-          <p:cNvPr id="22" name="TextBox 21"/>
+          <p:cNvPr id="21" name="TextBox 20"/>
           <p:cNvSpPr txBox="1"/>
           <p:nvPr/>
         </p:nvSpPr>
         <p:spPr>
           <a:xfrm>
-            <a:off x="6766559" y="3438144"/>
+            <a:off x="6766559" y="2907792"/>
             <a:ext cx="4361688" cy="530352"/>
           </a:xfrm>
           <a:prstGeom prst="rect">
@@ -33523,20 +33486,20 @@
                 </a:solidFill>
                 <a:latin typeface="Arial"/>
               </a:rPr>
-              <a:t>Combine accession effects with a random-effects model</a:t>
-            </a:r>
-          </a:p>
-        </p:txBody>
-      </p:sp>
-      <p:sp>
-        <p:nvSpPr>
-          <p:cNvPr id="23" name="Oval 22"/>
+              <a:t>Estimate FLT vs GC inside each accession</a:t>
+            </a:r>
+          </a:p>
+        </p:txBody>
+      </p:sp>
+      <p:sp>
+        <p:nvSpPr>
+          <p:cNvPr id="22" name="Oval 21"/>
           <p:cNvSpPr/>
           <p:nvPr/>
         </p:nvSpPr>
         <p:spPr>
           <a:xfrm>
-            <a:off x="6601968" y="4078224"/>
+            <a:off x="6601968" y="3547872"/>
             <a:ext cx="91440" cy="91440"/>
           </a:xfrm>
           <a:prstGeom prst="ellipse">
@@ -33573,13 +33536,13 @@
       </p:sp>
       <p:sp>
         <p:nvSpPr>
-          <p:cNvPr id="24" name="TextBox 23"/>
+          <p:cNvPr id="23" name="TextBox 22"/>
           <p:cNvSpPr txBox="1"/>
           <p:nvPr/>
         </p:nvSpPr>
         <p:spPr>
           <a:xfrm>
-            <a:off x="6766559" y="3968496"/>
+            <a:off x="6766559" y="3438144"/>
             <a:ext cx="4361688" cy="530352"/>
           </a:xfrm>
           <a:prstGeom prst="rect">
@@ -33605,32 +33568,30 @@
                 </a:solidFill>
                 <a:latin typeface="Arial"/>
               </a:rPr>
-              <a:t>Apply BH FDR within each tissue</a:t>
-            </a:r>
-          </a:p>
-        </p:txBody>
-      </p:sp>
-      <p:sp>
-        <p:nvSpPr>
-          <p:cNvPr id="25" name="Rounded Rectangle 24"/>
+              <a:t>Combine accession effects with a random-effects model</a:t>
+            </a:r>
+          </a:p>
+        </p:txBody>
+      </p:sp>
+      <p:sp>
+        <p:nvSpPr>
+          <p:cNvPr id="24" name="Oval 23"/>
           <p:cNvSpPr/>
           <p:nvPr/>
         </p:nvSpPr>
         <p:spPr>
           <a:xfrm>
-            <a:off x="6547104" y="4681728"/>
-            <a:ext cx="4572000" cy="475488"/>
-          </a:xfrm>
-          <a:prstGeom prst="roundRect">
+            <a:off x="6601968" y="4078224"/>
+            <a:ext cx="91440" cy="91440"/>
+          </a:xfrm>
+          <a:prstGeom prst="ellipse">
             <a:avLst/>
           </a:prstGeom>
           <a:solidFill>
-            <a:srgbClr val="082B55"/>
+            <a:srgbClr val="2D6496"/>
           </a:solidFill>
-          <a:ln w="10160">
-            <a:solidFill>
-              <a:srgbClr val="082B55"/>
-            </a:solidFill>
+          <a:ln>
+            <a:noFill/>
           </a:ln>
         </p:spPr>
         <p:style>
@@ -33657,14 +33618,14 @@
       </p:sp>
       <p:sp>
         <p:nvSpPr>
-          <p:cNvPr id="26" name="TextBox 25"/>
+          <p:cNvPr id="25" name="TextBox 24"/>
           <p:cNvSpPr txBox="1"/>
           <p:nvPr/>
         </p:nvSpPr>
         <p:spPr>
           <a:xfrm>
-            <a:off x="6711696" y="4764024"/>
-            <a:ext cx="4251960" cy="265176"/>
+            <a:off x="6766559" y="3968496"/>
+            <a:ext cx="4361688" cy="530352"/>
           </a:xfrm>
           <a:prstGeom prst="rect">
             <a:avLst/>
@@ -33672,48 +33633,48 @@
           <a:noFill/>
         </p:spPr>
         <p:txBody>
-          <a:bodyPr wrap="square" lIns="18288" rIns="18288" tIns="18288" bIns="18288" anchor="t">
+          <a:bodyPr wrap="square" lIns="18288" rIns="18288" tIns="18288" bIns="18288" anchor="ctr">
             <a:spAutoFit/>
           </a:bodyPr>
           <a:lstStyle/>
           <a:p>
-            <a:pPr algn="ctr">
+            <a:pPr algn="l">
               <a:spcAft>
                 <a:spcPts val="0"/>
               </a:spcAft>
             </a:pPr>
             <a:r>
-              <a:rPr sz="1600" b="1" i="0">
-                <a:solidFill>
-                  <a:srgbClr val="FFFFFF"/>
+              <a:rPr sz="1500" b="0" i="0">
+                <a:solidFill>
+                  <a:srgbClr val="263746"/>
                 </a:solidFill>
                 <a:latin typeface="Arial"/>
               </a:rPr>
-              <a:t>49 synthetic-informed associations</a:t>
-            </a:r>
-          </a:p>
-        </p:txBody>
-      </p:sp>
-      <p:sp>
-        <p:nvSpPr>
-          <p:cNvPr id="27" name="Rounded Rectangle 26"/>
+              <a:t>Apply BH FDR within each tissue</a:t>
+            </a:r>
+          </a:p>
+        </p:txBody>
+      </p:sp>
+      <p:sp>
+        <p:nvSpPr>
+          <p:cNvPr id="26" name="Rounded Rectangle 25"/>
           <p:cNvSpPr/>
           <p:nvPr/>
         </p:nvSpPr>
         <p:spPr>
           <a:xfrm>
-            <a:off x="475488" y="5650992"/>
-            <a:ext cx="11109960" cy="530352"/>
+            <a:off x="6547104" y="4681728"/>
+            <a:ext cx="4572000" cy="475488"/>
           </a:xfrm>
           <a:prstGeom prst="roundRect">
             <a:avLst/>
           </a:prstGeom>
           <a:solidFill>
-            <a:srgbClr val="F7F9FA"/>
+            <a:srgbClr val="082B55"/>
           </a:solidFill>
           <a:ln w="10160">
             <a:solidFill>
-              <a:srgbClr val="DDE4E8"/>
+              <a:srgbClr val="082B55"/>
             </a:solidFill>
           </a:ln>
         </p:spPr>
@@ -33741,7 +33702,91 @@
       </p:sp>
       <p:sp>
         <p:nvSpPr>
-          <p:cNvPr id="28" name="TextBox 27"/>
+          <p:cNvPr id="27" name="TextBox 26"/>
+          <p:cNvSpPr txBox="1"/>
+          <p:nvPr/>
+        </p:nvSpPr>
+        <p:spPr>
+          <a:xfrm>
+            <a:off x="6711696" y="4764024"/>
+            <a:ext cx="4251960" cy="265176"/>
+          </a:xfrm>
+          <a:prstGeom prst="rect">
+            <a:avLst/>
+          </a:prstGeom>
+          <a:noFill/>
+        </p:spPr>
+        <p:txBody>
+          <a:bodyPr wrap="square" lIns="18288" rIns="18288" tIns="18288" bIns="18288" anchor="t">
+            <a:spAutoFit/>
+          </a:bodyPr>
+          <a:lstStyle/>
+          <a:p>
+            <a:pPr algn="ctr">
+              <a:spcAft>
+                <a:spcPts val="0"/>
+              </a:spcAft>
+            </a:pPr>
+            <a:r>
+              <a:rPr sz="1600" b="1" i="0">
+                <a:solidFill>
+                  <a:srgbClr val="FFFFFF"/>
+                </a:solidFill>
+                <a:latin typeface="Arial"/>
+              </a:rPr>
+              <a:t>49 synthetic-informed associations</a:t>
+            </a:r>
+          </a:p>
+        </p:txBody>
+      </p:sp>
+      <p:sp>
+        <p:nvSpPr>
+          <p:cNvPr id="28" name="Rounded Rectangle 27"/>
+          <p:cNvSpPr/>
+          <p:nvPr/>
+        </p:nvSpPr>
+        <p:spPr>
+          <a:xfrm>
+            <a:off x="475488" y="5650992"/>
+            <a:ext cx="11109960" cy="530352"/>
+          </a:xfrm>
+          <a:prstGeom prst="roundRect">
+            <a:avLst/>
+          </a:prstGeom>
+          <a:solidFill>
+            <a:srgbClr val="F7F9FA"/>
+          </a:solidFill>
+          <a:ln w="10160">
+            <a:solidFill>
+              <a:srgbClr val="DDE4E8"/>
+            </a:solidFill>
+          </a:ln>
+        </p:spPr>
+        <p:style>
+          <a:lnRef idx="1">
+            <a:schemeClr val="accent1"/>
+          </a:lnRef>
+          <a:fillRef idx="3">
+            <a:schemeClr val="accent1"/>
+          </a:fillRef>
+          <a:effectRef idx="2">
+            <a:schemeClr val="accent1"/>
+          </a:effectRef>
+          <a:fontRef idx="minor">
+            <a:schemeClr val="lt1"/>
+          </a:fontRef>
+        </p:style>
+        <p:txBody>
+          <a:bodyPr rtlCol="0" anchor="ctr"/>
+          <a:lstStyle/>
+          <a:p>
+            <a:pPr algn="ctr"/>
+          </a:p>
+        </p:txBody>
+      </p:sp>
+      <p:sp>
+        <p:nvSpPr>
+          <p:cNvPr id="29" name="TextBox 28"/>
           <p:cNvSpPr txBox="1"/>
           <p:nvPr/>
         </p:nvSpPr>

</xml_diff>

<commit_message>
Clean title slide background artifacts
</commit_message>
<xml_diff>
--- a/presentation/SLSTP_2026_Generative_Transcriptomics.pptx
+++ b/presentation/SLSTP_2026_Generative_Transcriptomics.pptx
@@ -22111,6 +22111,49 @@
       </p:grpSpPr>
       <p:sp>
         <p:nvSpPr>
+          <p:cNvPr id="4" name="Title background artifact mask"/>
+          <p:cNvSpPr/>
+          <p:nvPr/>
+        </p:nvSpPr>
+        <p:spPr>
+          <a:xfrm>
+            <a:off x="0" y="4956048"/>
+            <a:ext cx="3931920" cy="1901952"/>
+          </a:xfrm>
+          <a:prstGeom prst="rect">
+            <a:avLst/>
+          </a:prstGeom>
+          <a:solidFill>
+            <a:srgbClr val="000000"/>
+          </a:solidFill>
+          <a:ln>
+            <a:noFill/>
+          </a:ln>
+        </p:spPr>
+        <p:style>
+          <a:lnRef idx="1">
+            <a:schemeClr val="accent1"/>
+          </a:lnRef>
+          <a:fillRef idx="3">
+            <a:schemeClr val="accent1"/>
+          </a:fillRef>
+          <a:effectRef idx="2">
+            <a:schemeClr val="accent1"/>
+          </a:effectRef>
+          <a:fontRef idx="minor">
+            <a:schemeClr val="lt1"/>
+          </a:fontRef>
+        </p:style>
+        <p:txBody>
+          <a:bodyPr rtlCol="0" anchor="ctr"/>
+          <a:lstStyle/>
+          <a:p>
+            <a:pPr algn="ctr"/>
+          </a:p>
+        </p:txBody>
+      </p:sp>
+      <p:sp>
+        <p:nvSpPr>
           <p:cNvPr id="2" name="Subtitle 1">
             <a:extLst>
               <a:ext uri="{FF2B5EF4-FFF2-40B4-BE49-F238E27FC236}">
@@ -22259,7 +22302,7 @@
       </p:sp>
       <p:sp>
         <p:nvSpPr>
-          <p:cNvPr id="4" name="TextBox 3"/>
+          <p:cNvPr id="5" name="TextBox 4"/>
           <p:cNvSpPr txBox="1"/>
           <p:nvPr/>
         </p:nvSpPr>
@@ -22292,6 +22335,45 @@
                 <a:latin typeface="Arial"/>
               </a:rPr>
               <a:t>SLSTP FINAL PRESENTATION</a:t>
+            </a:r>
+          </a:p>
+        </p:txBody>
+      </p:sp>
+      <p:sp>
+        <p:nvSpPr>
+          <p:cNvPr id="6" name="TextBox 5"/>
+          <p:cNvSpPr txBox="1"/>
+          <p:nvPr/>
+        </p:nvSpPr>
+        <p:spPr>
+          <a:xfrm>
+            <a:off x="566928" y="6510528"/>
+            <a:ext cx="3017520" cy="201168"/>
+          </a:xfrm>
+          <a:prstGeom prst="rect">
+            <a:avLst/>
+          </a:prstGeom>
+          <a:noFill/>
+        </p:spPr>
+        <p:txBody>
+          <a:bodyPr wrap="square" lIns="18288" rIns="18288" tIns="18288" bIns="18288" anchor="t">
+            <a:spAutoFit/>
+          </a:bodyPr>
+          <a:lstStyle/>
+          <a:p>
+            <a:pPr algn="l">
+              <a:spcAft>
+                <a:spcPts val="0"/>
+              </a:spcAft>
+            </a:pPr>
+            <a:r>
+              <a:rPr sz="1050" b="0" i="0">
+                <a:solidFill>
+                  <a:srgbClr val="B9C7D5"/>
+                </a:solidFill>
+                <a:latin typeface="Arial"/>
+              </a:rPr>
+              <a:t>Biological &amp; Physical Sciences</a:t>
             </a:r>
           </a:p>
         </p:txBody>

</xml_diff>

<commit_message>
Fix reinforced Venn label layout
</commit_message>
<xml_diff>
--- a/presentation/SLSTP_2026_Generative_Transcriptomics.pptx
+++ b/presentation/SLSTP_2026_Generative_Transcriptomics.pptx
@@ -33157,24 +33157,64 @@
       </p:sp>
       <p:sp>
         <p:nvSpPr>
-          <p:cNvPr id="12" name="Rounded Rectangle 11"/>
+          <p:cNvPr id="12" name="TextBox 11"/>
+          <p:cNvSpPr txBox="1"/>
+          <p:nvPr/>
+        </p:nvSpPr>
+        <p:spPr>
+          <a:xfrm>
+            <a:off x="2304288" y="3044952"/>
+            <a:ext cx="969264" cy="585216"/>
+          </a:xfrm>
+          <a:prstGeom prst="rect">
+            <a:avLst/>
+          </a:prstGeom>
+          <a:noFill/>
+        </p:spPr>
+        <p:txBody>
+          <a:bodyPr wrap="square" lIns="18288" rIns="18288" tIns="18288" bIns="18288" anchor="t">
+            <a:spAutoFit/>
+          </a:bodyPr>
+          <a:lstStyle/>
+          <a:p>
+            <a:pPr algn="ctr">
+              <a:spcAft>
+                <a:spcPts val="0"/>
+              </a:spcAft>
+            </a:pPr>
+            <a:r>
+              <a:rPr sz="1200" b="1" i="0">
+                <a:solidFill>
+                  <a:srgbClr val="D37B00"/>
+                </a:solidFill>
+                <a:latin typeface="Arial"/>
+              </a:rPr>
+              <a:t>23
+reinforced</a:t>
+            </a:r>
+          </a:p>
+        </p:txBody>
+      </p:sp>
+      <p:sp>
+        <p:nvSpPr>
+          <p:cNvPr id="13" name="Rounded Rectangle 12"/>
           <p:cNvSpPr/>
           <p:nvPr/>
         </p:nvSpPr>
         <p:spPr>
           <a:xfrm>
-            <a:off x="1993392" y="2880360"/>
-            <a:ext cx="1572768" cy="841248"/>
+            <a:off x="3218688" y="4535424"/>
+            <a:ext cx="1700784" cy="713232"/>
           </a:xfrm>
           <a:prstGeom prst="roundRect">
             <a:avLst/>
           </a:prstGeom>
           <a:solidFill>
-            <a:srgbClr val="F8F1E2"/>
+            <a:srgbClr val="E8F3F1"/>
           </a:solidFill>
           <a:ln w="10160">
             <a:solidFill>
-              <a:srgbClr val="D37B00"/>
+              <a:srgbClr val="178681"/>
             </a:solidFill>
           </a:ln>
         </p:spPr>
@@ -33202,14 +33242,14 @@
       </p:sp>
       <p:sp>
         <p:nvSpPr>
-          <p:cNvPr id="13" name="TextBox 12"/>
+          <p:cNvPr id="14" name="TextBox 13"/>
           <p:cNvSpPr txBox="1"/>
           <p:nvPr/>
         </p:nvSpPr>
         <p:spPr>
           <a:xfrm>
-            <a:off x="2176272" y="2999232"/>
-            <a:ext cx="1207008" cy="548640"/>
+            <a:off x="3346704" y="4626864"/>
+            <a:ext cx="1444752" cy="219456"/>
           </a:xfrm>
           <a:prstGeom prst="rect">
             <a:avLst/>
@@ -33228,39 +33268,76 @@
               </a:spcAft>
             </a:pPr>
             <a:r>
-              <a:rPr sz="1700" b="1" i="0">
-                <a:solidFill>
-                  <a:srgbClr val="D37B00"/>
+              <a:rPr sz="1350" b="1" i="0">
+                <a:solidFill>
+                  <a:srgbClr val="178681"/>
                 </a:solidFill>
                 <a:latin typeface="Arial"/>
               </a:rPr>
-              <a:t>23
-reinforced</a:t>
-            </a:r>
-          </a:p>
-        </p:txBody>
-      </p:sp>
-      <p:sp>
-        <p:nvSpPr>
-          <p:cNvPr id="14" name="Rounded Rectangle 13"/>
+              <a:t>26 promoted</a:t>
+            </a:r>
+          </a:p>
+        </p:txBody>
+      </p:sp>
+      <p:sp>
+        <p:nvSpPr>
+          <p:cNvPr id="15" name="TextBox 14"/>
+          <p:cNvSpPr txBox="1"/>
+          <p:nvPr/>
+        </p:nvSpPr>
+        <p:spPr>
+          <a:xfrm>
+            <a:off x="3364992" y="4882896"/>
+            <a:ext cx="1408176" cy="292608"/>
+          </a:xfrm>
+          <a:prstGeom prst="rect">
+            <a:avLst/>
+          </a:prstGeom>
+          <a:noFill/>
+        </p:spPr>
+        <p:txBody>
+          <a:bodyPr wrap="square" lIns="18288" rIns="18288" tIns="18288" bIns="18288" anchor="t">
+            <a:spAutoFit/>
+          </a:bodyPr>
+          <a:lstStyle/>
+          <a:p>
+            <a:pPr algn="ctr">
+              <a:spcAft>
+                <a:spcPts val="0"/>
+              </a:spcAft>
+            </a:pPr>
+            <a:r>
+              <a:rPr sz="950" b="0" i="0">
+                <a:solidFill>
+                  <a:srgbClr val="59697A"/>
+                </a:solidFill>
+                <a:latin typeface="Arial"/>
+              </a:rPr>
+              <a:t>selected only with
+synthetic guidance</a:t>
+            </a:r>
+          </a:p>
+        </p:txBody>
+      </p:sp>
+      <p:sp>
+        <p:nvSpPr>
+          <p:cNvPr id="16" name="Right Arrow 15"/>
           <p:cNvSpPr/>
           <p:nvPr/>
         </p:nvSpPr>
         <p:spPr>
           <a:xfrm>
-            <a:off x="3218688" y="4535424"/>
-            <a:ext cx="1700784" cy="713232"/>
-          </a:xfrm>
-          <a:prstGeom prst="roundRect">
+            <a:off x="5285232" y="3017520"/>
+            <a:ext cx="594360" cy="438912"/>
+          </a:xfrm>
+          <a:prstGeom prst="rightArrow">
             <a:avLst/>
           </a:prstGeom>
           <a:solidFill>
-            <a:srgbClr val="E8F3F1"/>
+            <a:srgbClr val="178681"/>
           </a:solidFill>
-          <a:ln w="10160">
-            <a:solidFill>
-              <a:srgbClr val="178681"/>
-            </a:solidFill>
+          <a:ln>
+            <a:noFill/>
           </a:ln>
         </p:spPr>
         <p:style>
@@ -33287,102 +33364,25 @@
       </p:sp>
       <p:sp>
         <p:nvSpPr>
-          <p:cNvPr id="15" name="TextBox 14"/>
-          <p:cNvSpPr txBox="1"/>
-          <p:nvPr/>
-        </p:nvSpPr>
-        <p:spPr>
-          <a:xfrm>
-            <a:off x="3346704" y="4626864"/>
-            <a:ext cx="1444752" cy="219456"/>
-          </a:xfrm>
-          <a:prstGeom prst="rect">
-            <a:avLst/>
-          </a:prstGeom>
-          <a:noFill/>
-        </p:spPr>
-        <p:txBody>
-          <a:bodyPr wrap="square" lIns="18288" rIns="18288" tIns="18288" bIns="18288" anchor="t">
-            <a:spAutoFit/>
-          </a:bodyPr>
-          <a:lstStyle/>
-          <a:p>
-            <a:pPr algn="ctr">
-              <a:spcAft>
-                <a:spcPts val="0"/>
-              </a:spcAft>
-            </a:pPr>
-            <a:r>
-              <a:rPr sz="1350" b="1" i="0">
-                <a:solidFill>
-                  <a:srgbClr val="178681"/>
-                </a:solidFill>
-                <a:latin typeface="Arial"/>
-              </a:rPr>
-              <a:t>26 promoted</a:t>
-            </a:r>
-          </a:p>
-        </p:txBody>
-      </p:sp>
-      <p:sp>
-        <p:nvSpPr>
-          <p:cNvPr id="16" name="TextBox 15"/>
-          <p:cNvSpPr txBox="1"/>
-          <p:nvPr/>
-        </p:nvSpPr>
-        <p:spPr>
-          <a:xfrm>
-            <a:off x="3364992" y="4882896"/>
-            <a:ext cx="1408176" cy="292608"/>
-          </a:xfrm>
-          <a:prstGeom prst="rect">
-            <a:avLst/>
-          </a:prstGeom>
-          <a:noFill/>
-        </p:spPr>
-        <p:txBody>
-          <a:bodyPr wrap="square" lIns="18288" rIns="18288" tIns="18288" bIns="18288" anchor="t">
-            <a:spAutoFit/>
-          </a:bodyPr>
-          <a:lstStyle/>
-          <a:p>
-            <a:pPr algn="ctr">
-              <a:spcAft>
-                <a:spcPts val="0"/>
-              </a:spcAft>
-            </a:pPr>
-            <a:r>
-              <a:rPr sz="950" b="0" i="0">
-                <a:solidFill>
-                  <a:srgbClr val="59697A"/>
-                </a:solidFill>
-                <a:latin typeface="Arial"/>
-              </a:rPr>
-              <a:t>selected only with
-synthetic guidance</a:t>
-            </a:r>
-          </a:p>
-        </p:txBody>
-      </p:sp>
-      <p:sp>
-        <p:nvSpPr>
-          <p:cNvPr id="17" name="Right Arrow 16"/>
+          <p:cNvPr id="17" name="Rounded Rectangle 16"/>
           <p:cNvSpPr/>
           <p:nvPr/>
         </p:nvSpPr>
         <p:spPr>
           <a:xfrm>
-            <a:off x="5285232" y="3017520"/>
-            <a:ext cx="594360" cy="438912"/>
-          </a:xfrm>
-          <a:prstGeom prst="rightArrow">
+            <a:off x="6108192" y="2039112"/>
+            <a:ext cx="5468112" cy="3355848"/>
+          </a:xfrm>
+          <a:prstGeom prst="roundRect">
             <a:avLst/>
           </a:prstGeom>
           <a:solidFill>
-            <a:srgbClr val="178681"/>
+            <a:srgbClr val="E9F1F7"/>
           </a:solidFill>
-          <a:ln>
-            <a:noFill/>
+          <a:ln w="10160">
+            <a:solidFill>
+              <a:srgbClr val="2D6496"/>
+            </a:solidFill>
           </a:ln>
         </p:spPr>
         <p:style>
@@ -33409,25 +33409,62 @@
       </p:sp>
       <p:sp>
         <p:nvSpPr>
-          <p:cNvPr id="18" name="Rounded Rectangle 17"/>
+          <p:cNvPr id="18" name="TextBox 17"/>
+          <p:cNvSpPr txBox="1"/>
+          <p:nvPr/>
+        </p:nvSpPr>
+        <p:spPr>
+          <a:xfrm>
+            <a:off x="6419088" y="2304288"/>
+            <a:ext cx="4846320" cy="365760"/>
+          </a:xfrm>
+          <a:prstGeom prst="rect">
+            <a:avLst/>
+          </a:prstGeom>
+          <a:noFill/>
+        </p:spPr>
+        <p:txBody>
+          <a:bodyPr wrap="square" lIns="18288" rIns="18288" tIns="18288" bIns="18288" anchor="t">
+            <a:spAutoFit/>
+          </a:bodyPr>
+          <a:lstStyle/>
+          <a:p>
+            <a:pPr algn="ctr">
+              <a:spcAft>
+                <a:spcPts val="0"/>
+              </a:spcAft>
+            </a:pPr>
+            <a:r>
+              <a:rPr sz="2000" b="1" i="0">
+                <a:solidFill>
+                  <a:srgbClr val="2D6496"/>
+                </a:solidFill>
+                <a:latin typeface="Arial"/>
+              </a:rPr>
+              <a:t>Real OSDR association test</a:t>
+            </a:r>
+          </a:p>
+        </p:txBody>
+      </p:sp>
+      <p:sp>
+        <p:nvSpPr>
+          <p:cNvPr id="19" name="Oval 18"/>
           <p:cNvSpPr/>
           <p:nvPr/>
         </p:nvSpPr>
         <p:spPr>
           <a:xfrm>
-            <a:off x="6108192" y="2039112"/>
-            <a:ext cx="5468112" cy="3355848"/>
-          </a:xfrm>
-          <a:prstGeom prst="roundRect">
+            <a:off x="6601968" y="3017520"/>
+            <a:ext cx="91440" cy="91440"/>
+          </a:xfrm>
+          <a:prstGeom prst="ellipse">
             <a:avLst/>
           </a:prstGeom>
           <a:solidFill>
-            <a:srgbClr val="E9F1F7"/>
+            <a:srgbClr val="2D6496"/>
           </a:solidFill>
-          <a:ln w="10160">
-            <a:solidFill>
-              <a:srgbClr val="2D6496"/>
-            </a:solidFill>
+          <a:ln>
+            <a:noFill/>
           </a:ln>
         </p:spPr>
         <p:style>
@@ -33454,14 +33491,14 @@
       </p:sp>
       <p:sp>
         <p:nvSpPr>
-          <p:cNvPr id="19" name="TextBox 18"/>
+          <p:cNvPr id="20" name="TextBox 19"/>
           <p:cNvSpPr txBox="1"/>
           <p:nvPr/>
         </p:nvSpPr>
         <p:spPr>
           <a:xfrm>
-            <a:off x="6419088" y="2304288"/>
-            <a:ext cx="4846320" cy="365760"/>
+            <a:off x="6766559" y="2907792"/>
+            <a:ext cx="4361688" cy="530352"/>
           </a:xfrm>
           <a:prstGeom prst="rect">
             <a:avLst/>
@@ -33469,37 +33506,37 @@
           <a:noFill/>
         </p:spPr>
         <p:txBody>
-          <a:bodyPr wrap="square" lIns="18288" rIns="18288" tIns="18288" bIns="18288" anchor="t">
+          <a:bodyPr wrap="square" lIns="18288" rIns="18288" tIns="18288" bIns="18288" anchor="ctr">
             <a:spAutoFit/>
           </a:bodyPr>
           <a:lstStyle/>
           <a:p>
-            <a:pPr algn="ctr">
+            <a:pPr algn="l">
               <a:spcAft>
                 <a:spcPts val="0"/>
               </a:spcAft>
             </a:pPr>
             <a:r>
-              <a:rPr sz="2000" b="1" i="0">
-                <a:solidFill>
-                  <a:srgbClr val="2D6496"/>
+              <a:rPr sz="1500" b="0" i="0">
+                <a:solidFill>
+                  <a:srgbClr val="263746"/>
                 </a:solidFill>
                 <a:latin typeface="Arial"/>
               </a:rPr>
-              <a:t>Real OSDR association test</a:t>
-            </a:r>
-          </a:p>
-        </p:txBody>
-      </p:sp>
-      <p:sp>
-        <p:nvSpPr>
-          <p:cNvPr id="20" name="Oval 19"/>
+              <a:t>Estimate FLT vs GC inside each accession</a:t>
+            </a:r>
+          </a:p>
+        </p:txBody>
+      </p:sp>
+      <p:sp>
+        <p:nvSpPr>
+          <p:cNvPr id="21" name="Oval 20"/>
           <p:cNvSpPr/>
           <p:nvPr/>
         </p:nvSpPr>
         <p:spPr>
           <a:xfrm>
-            <a:off x="6601968" y="3017520"/>
+            <a:off x="6601968" y="3547872"/>
             <a:ext cx="91440" cy="91440"/>
           </a:xfrm>
           <a:prstGeom prst="ellipse">
@@ -33536,13 +33573,13 @@
       </p:sp>
       <p:sp>
         <p:nvSpPr>
-          <p:cNvPr id="21" name="TextBox 20"/>
+          <p:cNvPr id="22" name="TextBox 21"/>
           <p:cNvSpPr txBox="1"/>
           <p:nvPr/>
         </p:nvSpPr>
         <p:spPr>
           <a:xfrm>
-            <a:off x="6766559" y="2907792"/>
+            <a:off x="6766559" y="3438144"/>
             <a:ext cx="4361688" cy="530352"/>
           </a:xfrm>
           <a:prstGeom prst="rect">
@@ -33568,20 +33605,20 @@
                 </a:solidFill>
                 <a:latin typeface="Arial"/>
               </a:rPr>
-              <a:t>Estimate FLT vs GC inside each accession</a:t>
-            </a:r>
-          </a:p>
-        </p:txBody>
-      </p:sp>
-      <p:sp>
-        <p:nvSpPr>
-          <p:cNvPr id="22" name="Oval 21"/>
+              <a:t>Combine accession effects with a random-effects model</a:t>
+            </a:r>
+          </a:p>
+        </p:txBody>
+      </p:sp>
+      <p:sp>
+        <p:nvSpPr>
+          <p:cNvPr id="23" name="Oval 22"/>
           <p:cNvSpPr/>
           <p:nvPr/>
         </p:nvSpPr>
         <p:spPr>
           <a:xfrm>
-            <a:off x="6601968" y="3547872"/>
+            <a:off x="6601968" y="4078224"/>
             <a:ext cx="91440" cy="91440"/>
           </a:xfrm>
           <a:prstGeom prst="ellipse">
@@ -33618,13 +33655,13 @@
       </p:sp>
       <p:sp>
         <p:nvSpPr>
-          <p:cNvPr id="23" name="TextBox 22"/>
+          <p:cNvPr id="24" name="TextBox 23"/>
           <p:cNvSpPr txBox="1"/>
           <p:nvPr/>
         </p:nvSpPr>
         <p:spPr>
           <a:xfrm>
-            <a:off x="6766559" y="3438144"/>
+            <a:off x="6766559" y="3968496"/>
             <a:ext cx="4361688" cy="530352"/>
           </a:xfrm>
           <a:prstGeom prst="rect">
@@ -33650,30 +33687,32 @@
                 </a:solidFill>
                 <a:latin typeface="Arial"/>
               </a:rPr>
-              <a:t>Combine accession effects with a random-effects model</a:t>
-            </a:r>
-          </a:p>
-        </p:txBody>
-      </p:sp>
-      <p:sp>
-        <p:nvSpPr>
-          <p:cNvPr id="24" name="Oval 23"/>
+              <a:t>Apply BH FDR within each tissue</a:t>
+            </a:r>
+          </a:p>
+        </p:txBody>
+      </p:sp>
+      <p:sp>
+        <p:nvSpPr>
+          <p:cNvPr id="25" name="Rounded Rectangle 24"/>
           <p:cNvSpPr/>
           <p:nvPr/>
         </p:nvSpPr>
         <p:spPr>
           <a:xfrm>
-            <a:off x="6601968" y="4078224"/>
-            <a:ext cx="91440" cy="91440"/>
-          </a:xfrm>
-          <a:prstGeom prst="ellipse">
+            <a:off x="6547104" y="4681728"/>
+            <a:ext cx="4572000" cy="475488"/>
+          </a:xfrm>
+          <a:prstGeom prst="roundRect">
             <a:avLst/>
           </a:prstGeom>
           <a:solidFill>
-            <a:srgbClr val="2D6496"/>
+            <a:srgbClr val="082B55"/>
           </a:solidFill>
-          <a:ln>
-            <a:noFill/>
+          <a:ln w="10160">
+            <a:solidFill>
+              <a:srgbClr val="082B55"/>
+            </a:solidFill>
           </a:ln>
         </p:spPr>
         <p:style>
@@ -33700,14 +33739,14 @@
       </p:sp>
       <p:sp>
         <p:nvSpPr>
-          <p:cNvPr id="25" name="TextBox 24"/>
+          <p:cNvPr id="26" name="TextBox 25"/>
           <p:cNvSpPr txBox="1"/>
           <p:nvPr/>
         </p:nvSpPr>
         <p:spPr>
           <a:xfrm>
-            <a:off x="6766559" y="3968496"/>
-            <a:ext cx="4361688" cy="530352"/>
+            <a:off x="6711696" y="4764024"/>
+            <a:ext cx="4251960" cy="265176"/>
           </a:xfrm>
           <a:prstGeom prst="rect">
             <a:avLst/>
@@ -33715,48 +33754,48 @@
           <a:noFill/>
         </p:spPr>
         <p:txBody>
-          <a:bodyPr wrap="square" lIns="18288" rIns="18288" tIns="18288" bIns="18288" anchor="ctr">
+          <a:bodyPr wrap="square" lIns="18288" rIns="18288" tIns="18288" bIns="18288" anchor="t">
             <a:spAutoFit/>
           </a:bodyPr>
           <a:lstStyle/>
           <a:p>
-            <a:pPr algn="l">
+            <a:pPr algn="ctr">
               <a:spcAft>
                 <a:spcPts val="0"/>
               </a:spcAft>
             </a:pPr>
             <a:r>
-              <a:rPr sz="1500" b="0" i="0">
-                <a:solidFill>
-                  <a:srgbClr val="263746"/>
+              <a:rPr sz="1600" b="1" i="0">
+                <a:solidFill>
+                  <a:srgbClr val="FFFFFF"/>
                 </a:solidFill>
                 <a:latin typeface="Arial"/>
               </a:rPr>
-              <a:t>Apply BH FDR within each tissue</a:t>
-            </a:r>
-          </a:p>
-        </p:txBody>
-      </p:sp>
-      <p:sp>
-        <p:nvSpPr>
-          <p:cNvPr id="26" name="Rounded Rectangle 25"/>
+              <a:t>49 synthetic-informed associations</a:t>
+            </a:r>
+          </a:p>
+        </p:txBody>
+      </p:sp>
+      <p:sp>
+        <p:nvSpPr>
+          <p:cNvPr id="27" name="Rounded Rectangle 26"/>
           <p:cNvSpPr/>
           <p:nvPr/>
         </p:nvSpPr>
         <p:spPr>
           <a:xfrm>
-            <a:off x="6547104" y="4681728"/>
-            <a:ext cx="4572000" cy="475488"/>
+            <a:off x="475488" y="5650992"/>
+            <a:ext cx="11109960" cy="530352"/>
           </a:xfrm>
           <a:prstGeom prst="roundRect">
             <a:avLst/>
           </a:prstGeom>
           <a:solidFill>
-            <a:srgbClr val="082B55"/>
+            <a:srgbClr val="F7F9FA"/>
           </a:solidFill>
           <a:ln w="10160">
             <a:solidFill>
-              <a:srgbClr val="082B55"/>
+              <a:srgbClr val="DDE4E8"/>
             </a:solidFill>
           </a:ln>
         </p:spPr>
@@ -33784,91 +33823,7 @@
       </p:sp>
       <p:sp>
         <p:nvSpPr>
-          <p:cNvPr id="27" name="TextBox 26"/>
-          <p:cNvSpPr txBox="1"/>
-          <p:nvPr/>
-        </p:nvSpPr>
-        <p:spPr>
-          <a:xfrm>
-            <a:off x="6711696" y="4764024"/>
-            <a:ext cx="4251960" cy="265176"/>
-          </a:xfrm>
-          <a:prstGeom prst="rect">
-            <a:avLst/>
-          </a:prstGeom>
-          <a:noFill/>
-        </p:spPr>
-        <p:txBody>
-          <a:bodyPr wrap="square" lIns="18288" rIns="18288" tIns="18288" bIns="18288" anchor="t">
-            <a:spAutoFit/>
-          </a:bodyPr>
-          <a:lstStyle/>
-          <a:p>
-            <a:pPr algn="ctr">
-              <a:spcAft>
-                <a:spcPts val="0"/>
-              </a:spcAft>
-            </a:pPr>
-            <a:r>
-              <a:rPr sz="1600" b="1" i="0">
-                <a:solidFill>
-                  <a:srgbClr val="FFFFFF"/>
-                </a:solidFill>
-                <a:latin typeface="Arial"/>
-              </a:rPr>
-              <a:t>49 synthetic-informed associations</a:t>
-            </a:r>
-          </a:p>
-        </p:txBody>
-      </p:sp>
-      <p:sp>
-        <p:nvSpPr>
-          <p:cNvPr id="28" name="Rounded Rectangle 27"/>
-          <p:cNvSpPr/>
-          <p:nvPr/>
-        </p:nvSpPr>
-        <p:spPr>
-          <a:xfrm>
-            <a:off x="475488" y="5650992"/>
-            <a:ext cx="11109960" cy="530352"/>
-          </a:xfrm>
-          <a:prstGeom prst="roundRect">
-            <a:avLst/>
-          </a:prstGeom>
-          <a:solidFill>
-            <a:srgbClr val="F7F9FA"/>
-          </a:solidFill>
-          <a:ln w="10160">
-            <a:solidFill>
-              <a:srgbClr val="DDE4E8"/>
-            </a:solidFill>
-          </a:ln>
-        </p:spPr>
-        <p:style>
-          <a:lnRef idx="1">
-            <a:schemeClr val="accent1"/>
-          </a:lnRef>
-          <a:fillRef idx="3">
-            <a:schemeClr val="accent1"/>
-          </a:fillRef>
-          <a:effectRef idx="2">
-            <a:schemeClr val="accent1"/>
-          </a:effectRef>
-          <a:fontRef idx="minor">
-            <a:schemeClr val="lt1"/>
-          </a:fontRef>
-        </p:style>
-        <p:txBody>
-          <a:bodyPr rtlCol="0" anchor="ctr"/>
-          <a:lstStyle/>
-          <a:p>
-            <a:pPr algn="ctr"/>
-          </a:p>
-        </p:txBody>
-      </p:sp>
-      <p:sp>
-        <p:nvSpPr>
-          <p:cNvPr id="29" name="TextBox 28"/>
+          <p:cNvPr id="28" name="TextBox 27"/>
           <p:cNvSpPr txBox="1"/>
           <p:nvPr/>
         </p:nvSpPr>

</xml_diff>

<commit_message>
Refine title slide typography
</commit_message>
<xml_diff>
--- a/presentation/SLSTP_2026_Generative_Transcriptomics.pptx
+++ b/presentation/SLSTP_2026_Generative_Transcriptomics.pptx
@@ -22277,12 +22277,23 @@
             <p:ph type="body" sz="quarter" idx="14"/>
           </p:nvPr>
         </p:nvSpPr>
-        <p:spPr/>
-        <p:txBody>
-          <a:bodyPr/>
+        <p:spPr>
+          <a:xfrm>
+            <a:off x="566928" y="2157984"/>
+            <a:ext cx="4297680" cy="1417320"/>
+          </a:xfrm>
+        </p:spPr>
+        <p:txBody>
+          <a:bodyPr wrap="square" lIns="0" rIns="0" tIns="0" bIns="0" anchor="t"/>
           <a:lstStyle/>
           <a:p>
             <a:pPr>
+              <a:lnSpc>
+                <a:spcPct val="100000"/>
+              </a:lnSpc>
+              <a:spcBef>
+                <a:spcPts val="0"/>
+              </a:spcBef>
               <a:spcAft>
                 <a:spcPts val="0"/>
               </a:spcAft>
@@ -22294,8 +22305,7 @@
                 </a:solidFill>
                 <a:latin typeface="Arial"/>
               </a:rPr>
-              <a:t>Synthetic transcriptomics
-for mouse spaceflight</a:t>
+              <a:t>Synthetic transcriptomics for mouse spaceflight</a:t>
             </a:r>
           </a:p>
         </p:txBody>
@@ -22303,45 +22313,6 @@
       <p:sp>
         <p:nvSpPr>
           <p:cNvPr id="5" name="TextBox 4"/>
-          <p:cNvSpPr txBox="1"/>
-          <p:nvPr/>
-        </p:nvSpPr>
-        <p:spPr>
-          <a:xfrm>
-            <a:off x="493776" y="987552"/>
-            <a:ext cx="3474720" cy="228600"/>
-          </a:xfrm>
-          <a:prstGeom prst="rect">
-            <a:avLst/>
-          </a:prstGeom>
-          <a:noFill/>
-        </p:spPr>
-        <p:txBody>
-          <a:bodyPr wrap="square" lIns="18288" rIns="18288" tIns="18288" bIns="18288" anchor="t">
-            <a:spAutoFit/>
-          </a:bodyPr>
-          <a:lstStyle/>
-          <a:p>
-            <a:pPr algn="l">
-              <a:spcAft>
-                <a:spcPts val="0"/>
-              </a:spcAft>
-            </a:pPr>
-            <a:r>
-              <a:rPr sz="1050" b="1" i="0">
-                <a:solidFill>
-                  <a:srgbClr val="D5A64A"/>
-                </a:solidFill>
-                <a:latin typeface="Arial"/>
-              </a:rPr>
-              <a:t>SLSTP FINAL PRESENTATION</a:t>
-            </a:r>
-          </a:p>
-        </p:txBody>
-      </p:sp>
-      <p:sp>
-        <p:nvSpPr>
-          <p:cNvPr id="6" name="TextBox 5"/>
           <p:cNvSpPr txBox="1"/>
           <p:nvPr/>
         </p:nvSpPr>

</xml_diff>

<commit_message>
Align slide 9 Venn labels
</commit_message>
<xml_diff>
--- a/presentation/SLSTP_2026_Generative_Transcriptomics.pptx
+++ b/presentation/SLSTP_2026_Generative_Transcriptomics.pptx
@@ -36214,8 +36214,8 @@
         </p:nvSpPr>
         <p:spPr>
           <a:xfrm>
-            <a:off x="502920" y="1847088"/>
-            <a:ext cx="3657600" cy="310896"/>
+            <a:off x="566928" y="1847088"/>
+            <a:ext cx="4443984" cy="310896"/>
           </a:xfrm>
           <a:prstGeom prst="rect">
             <a:avLst/>
@@ -36339,8 +36339,8 @@
         </p:nvSpPr>
         <p:spPr>
           <a:xfrm>
-            <a:off x="749808" y="2770632"/>
-            <a:ext cx="1234440" cy="658368"/>
+            <a:off x="649224" y="2816352"/>
+            <a:ext cx="1609344" cy="265176"/>
           </a:xfrm>
           <a:prstGeom prst="rect">
             <a:avLst/>
@@ -36348,7 +36348,7 @@
           <a:noFill/>
         </p:spPr>
         <p:txBody>
-          <a:bodyPr wrap="square" lIns="18288" rIns="18288" tIns="18288" bIns="18288" anchor="t">
+          <a:bodyPr wrap="square" lIns="0" rIns="0" tIns="0" bIns="0" anchor="t">
             <a:spAutoFit/>
           </a:bodyPr>
           <a:lstStyle/>
@@ -36359,14 +36359,13 @@
               </a:spcAft>
             </a:pPr>
             <a:r>
-              <a:rPr sz="1700" b="1" i="0">
+              <a:rPr sz="1600" b="1" i="0">
                 <a:solidFill>
                   <a:srgbClr val="2D6496"/>
                 </a:solidFill>
                 <a:latin typeface="Arial"/>
               </a:rPr>
-              <a:t>Real-only
-ranking</a:t>
+              <a:t>Real-only</a:t>
             </a:r>
           </a:p>
         </p:txBody>
@@ -36379,8 +36378,8 @@
         </p:nvSpPr>
         <p:spPr>
           <a:xfrm>
-            <a:off x="3566160" y="2770632"/>
-            <a:ext cx="1234440" cy="658368"/>
+            <a:off x="649224" y="3108960"/>
+            <a:ext cx="1609344" cy="265176"/>
           </a:xfrm>
           <a:prstGeom prst="rect">
             <a:avLst/>
@@ -36388,7 +36387,7 @@
           <a:noFill/>
         </p:spPr>
         <p:txBody>
-          <a:bodyPr wrap="square" lIns="18288" rIns="18288" tIns="18288" bIns="18288" anchor="t">
+          <a:bodyPr wrap="square" lIns="0" rIns="0" tIns="0" bIns="0" anchor="t">
             <a:spAutoFit/>
           </a:bodyPr>
           <a:lstStyle/>
@@ -36401,12 +36400,11 @@
             <a:r>
               <a:rPr sz="1600" b="1" i="0">
                 <a:solidFill>
-                  <a:srgbClr val="178681"/>
+                  <a:srgbClr val="2D6496"/>
                 </a:solidFill>
                 <a:latin typeface="Arial"/>
               </a:rPr>
-              <a:t>Synthetic-informed
-ranking</a:t>
+              <a:t>ranking</a:t>
             </a:r>
           </a:p>
         </p:txBody>
@@ -36419,8 +36417,8 @@
         </p:nvSpPr>
         <p:spPr>
           <a:xfrm>
-            <a:off x="2304288" y="3044952"/>
-            <a:ext cx="969264" cy="585216"/>
+            <a:off x="3300984" y="2816352"/>
+            <a:ext cx="1719072" cy="265176"/>
           </a:xfrm>
           <a:prstGeom prst="rect">
             <a:avLst/>
@@ -36428,7 +36426,7 @@
           <a:noFill/>
         </p:spPr>
         <p:txBody>
-          <a:bodyPr wrap="square" lIns="18288" rIns="18288" tIns="18288" bIns="18288" anchor="t">
+          <a:bodyPr wrap="square" lIns="0" rIns="0" tIns="0" bIns="0" anchor="t">
             <a:spAutoFit/>
           </a:bodyPr>
           <a:lstStyle/>
@@ -36439,21 +36437,137 @@
               </a:spcAft>
             </a:pPr>
             <a:r>
-              <a:rPr sz="1200" b="1" i="0">
-                <a:solidFill>
-                  <a:srgbClr val="D37B00"/>
+              <a:rPr sz="1350" b="1" i="0">
+                <a:solidFill>
+                  <a:srgbClr val="178681"/>
                 </a:solidFill>
                 <a:latin typeface="Arial"/>
               </a:rPr>
-              <a:t>23
-reinforced</a:t>
-            </a:r>
-          </a:p>
-        </p:txBody>
-      </p:sp>
-      <p:sp>
-        <p:nvSpPr>
-          <p:cNvPr id="13" name="Rounded Rectangle 12"/>
+              <a:t>Synthetic-guided</a:t>
+            </a:r>
+          </a:p>
+        </p:txBody>
+      </p:sp>
+      <p:sp>
+        <p:nvSpPr>
+          <p:cNvPr id="13" name="TextBox 12"/>
+          <p:cNvSpPr txBox="1"/>
+          <p:nvPr/>
+        </p:nvSpPr>
+        <p:spPr>
+          <a:xfrm>
+            <a:off x="3300984" y="3108960"/>
+            <a:ext cx="1719072" cy="265176"/>
+          </a:xfrm>
+          <a:prstGeom prst="rect">
+            <a:avLst/>
+          </a:prstGeom>
+          <a:noFill/>
+        </p:spPr>
+        <p:txBody>
+          <a:bodyPr wrap="square" lIns="0" rIns="0" tIns="0" bIns="0" anchor="t">
+            <a:spAutoFit/>
+          </a:bodyPr>
+          <a:lstStyle/>
+          <a:p>
+            <a:pPr algn="ctr">
+              <a:spcAft>
+                <a:spcPts val="0"/>
+              </a:spcAft>
+            </a:pPr>
+            <a:r>
+              <a:rPr sz="1600" b="1" i="0">
+                <a:solidFill>
+                  <a:srgbClr val="178681"/>
+                </a:solidFill>
+                <a:latin typeface="Arial"/>
+              </a:rPr>
+              <a:t>ranking</a:t>
+            </a:r>
+          </a:p>
+        </p:txBody>
+      </p:sp>
+      <p:sp>
+        <p:nvSpPr>
+          <p:cNvPr id="14" name="TextBox 13"/>
+          <p:cNvSpPr txBox="1"/>
+          <p:nvPr/>
+        </p:nvSpPr>
+        <p:spPr>
+          <a:xfrm>
+            <a:off x="2304288" y="2999232"/>
+            <a:ext cx="969264" cy="219456"/>
+          </a:xfrm>
+          <a:prstGeom prst="rect">
+            <a:avLst/>
+          </a:prstGeom>
+          <a:noFill/>
+        </p:spPr>
+        <p:txBody>
+          <a:bodyPr wrap="square" lIns="0" rIns="0" tIns="0" bIns="0" anchor="t">
+            <a:spAutoFit/>
+          </a:bodyPr>
+          <a:lstStyle/>
+          <a:p>
+            <a:pPr algn="ctr">
+              <a:spcAft>
+                <a:spcPts val="0"/>
+              </a:spcAft>
+            </a:pPr>
+            <a:r>
+              <a:rPr sz="1200" b="1" i="0">
+                <a:solidFill>
+                  <a:srgbClr val="D37B00"/>
+                </a:solidFill>
+                <a:latin typeface="Arial"/>
+              </a:rPr>
+              <a:t>23</a:t>
+            </a:r>
+          </a:p>
+        </p:txBody>
+      </p:sp>
+      <p:sp>
+        <p:nvSpPr>
+          <p:cNvPr id="15" name="TextBox 14"/>
+          <p:cNvSpPr txBox="1"/>
+          <p:nvPr/>
+        </p:nvSpPr>
+        <p:spPr>
+          <a:xfrm>
+            <a:off x="2304288" y="3236976"/>
+            <a:ext cx="969264" cy="219456"/>
+          </a:xfrm>
+          <a:prstGeom prst="rect">
+            <a:avLst/>
+          </a:prstGeom>
+          <a:noFill/>
+        </p:spPr>
+        <p:txBody>
+          <a:bodyPr wrap="square" lIns="0" rIns="0" tIns="0" bIns="0" anchor="t">
+            <a:spAutoFit/>
+          </a:bodyPr>
+          <a:lstStyle/>
+          <a:p>
+            <a:pPr algn="ctr">
+              <a:spcAft>
+                <a:spcPts val="0"/>
+              </a:spcAft>
+            </a:pPr>
+            <a:r>
+              <a:rPr sz="1200" b="1" i="0">
+                <a:solidFill>
+                  <a:srgbClr val="D37B00"/>
+                </a:solidFill>
+                <a:latin typeface="Arial"/>
+              </a:rPr>
+              <a:t>reinforced</a:t>
+            </a:r>
+          </a:p>
+        </p:txBody>
+      </p:sp>
+      <p:sp>
+        <p:nvSpPr>
+          <p:cNvPr id="16" name="Rounded Rectangle 15"/>
           <p:cNvSpPr/>
           <p:nvPr/>
         </p:nvSpPr>
@@ -36498,7 +36612,7 @@
       </p:sp>
       <p:sp>
         <p:nvSpPr>
-          <p:cNvPr id="14" name="TextBox 13"/>
+          <p:cNvPr id="17" name="TextBox 16"/>
           <p:cNvSpPr txBox="1"/>
           <p:nvPr/>
         </p:nvSpPr>
@@ -36537,7 +36651,7 @@
       </p:sp>
       <p:sp>
         <p:nvSpPr>
-          <p:cNvPr id="15" name="TextBox 14"/>
+          <p:cNvPr id="18" name="TextBox 17"/>
           <p:cNvSpPr txBox="1"/>
           <p:nvPr/>
         </p:nvSpPr>
@@ -36577,7 +36691,7 @@
       </p:sp>
       <p:sp>
         <p:nvSpPr>
-          <p:cNvPr id="16" name="Right Arrow 15"/>
+          <p:cNvPr id="19" name="Right Arrow 18"/>
           <p:cNvSpPr/>
           <p:nvPr/>
         </p:nvSpPr>
@@ -36620,7 +36734,7 @@
       </p:sp>
       <p:sp>
         <p:nvSpPr>
-          <p:cNvPr id="17" name="Rounded Rectangle 16"/>
+          <p:cNvPr id="20" name="Rounded Rectangle 19"/>
           <p:cNvSpPr/>
           <p:nvPr/>
         </p:nvSpPr>
@@ -36665,7 +36779,7 @@
       </p:sp>
       <p:sp>
         <p:nvSpPr>
-          <p:cNvPr id="18" name="TextBox 17"/>
+          <p:cNvPr id="21" name="TextBox 20"/>
           <p:cNvSpPr txBox="1"/>
           <p:nvPr/>
         </p:nvSpPr>
@@ -36704,7 +36818,7 @@
       </p:sp>
       <p:sp>
         <p:nvSpPr>
-          <p:cNvPr id="19" name="Oval 18"/>
+          <p:cNvPr id="22" name="Oval 21"/>
           <p:cNvSpPr/>
           <p:nvPr/>
         </p:nvSpPr>
@@ -36747,7 +36861,7 @@
       </p:sp>
       <p:sp>
         <p:nvSpPr>
-          <p:cNvPr id="20" name="TextBox 19"/>
+          <p:cNvPr id="23" name="TextBox 22"/>
           <p:cNvSpPr txBox="1"/>
           <p:nvPr/>
         </p:nvSpPr>
@@ -36786,7 +36900,7 @@
       </p:sp>
       <p:sp>
         <p:nvSpPr>
-          <p:cNvPr id="21" name="Oval 20"/>
+          <p:cNvPr id="24" name="Oval 23"/>
           <p:cNvSpPr/>
           <p:nvPr/>
         </p:nvSpPr>
@@ -36829,7 +36943,7 @@
       </p:sp>
       <p:sp>
         <p:nvSpPr>
-          <p:cNvPr id="22" name="TextBox 21"/>
+          <p:cNvPr id="25" name="TextBox 24"/>
           <p:cNvSpPr txBox="1"/>
           <p:nvPr/>
         </p:nvSpPr>
@@ -36868,7 +36982,7 @@
       </p:sp>
       <p:sp>
         <p:nvSpPr>
-          <p:cNvPr id="23" name="Oval 22"/>
+          <p:cNvPr id="26" name="Oval 25"/>
           <p:cNvSpPr/>
           <p:nvPr/>
         </p:nvSpPr>
@@ -36911,7 +37025,7 @@
       </p:sp>
       <p:sp>
         <p:nvSpPr>
-          <p:cNvPr id="24" name="TextBox 23"/>
+          <p:cNvPr id="27" name="TextBox 26"/>
           <p:cNvSpPr txBox="1"/>
           <p:nvPr/>
         </p:nvSpPr>
@@ -36950,7 +37064,7 @@
       </p:sp>
       <p:sp>
         <p:nvSpPr>
-          <p:cNvPr id="25" name="Rounded Rectangle 24"/>
+          <p:cNvPr id="28" name="Rounded Rectangle 27"/>
           <p:cNvSpPr/>
           <p:nvPr/>
         </p:nvSpPr>
@@ -36995,7 +37109,7 @@
       </p:sp>
       <p:sp>
         <p:nvSpPr>
-          <p:cNvPr id="26" name="TextBox 25"/>
+          <p:cNvPr id="29" name="TextBox 28"/>
           <p:cNvSpPr txBox="1"/>
           <p:nvPr/>
         </p:nvSpPr>
@@ -37034,7 +37148,7 @@
       </p:sp>
       <p:sp>
         <p:nvSpPr>
-          <p:cNvPr id="27" name="Rounded Rectangle 26"/>
+          <p:cNvPr id="30" name="Rounded Rectangle 29"/>
           <p:cNvSpPr/>
           <p:nvPr/>
         </p:nvSpPr>
@@ -37079,7 +37193,7 @@
       </p:sp>
       <p:sp>
         <p:nvSpPr>
-          <p:cNvPr id="28" name="TextBox 27"/>
+          <p:cNvPr id="31" name="TextBox 30"/>
           <p:cNvSpPr txBox="1"/>
           <p:nvPr/>
         </p:nvSpPr>

</xml_diff>

<commit_message>
Present generator validation before DDIM outputs
</commit_message>
<xml_diff>
--- a/presentation/SLSTP_2026_Generative_Transcriptomics.pptx
+++ b/presentation/SLSTP_2026_Generative_Transcriptomics.pptx
@@ -1410,13 +1410,13 @@
           <a:lstStyle/>
           <a:p>
             <a:r>
-              <a:t>Target time: 0:55</a:t>
+              <a:t>Target time: 1:00</a:t>
             </a:r>
           </a:p>
           <a:p/>
           <a:p>
             <a:r>
-              <a:t>Read the panels from left to right. The same generated profiles begin as noise, develop structure by timestep 200 and approach tissue-conditioned regions at timestep zero. The axes are shared, so the visual change is not caused by rescaling each panel.</a:t>
+              <a:t>Both WGAN-GP and DDIM had high correlation and F1. DDIM had adversarial accuracy near 0.5 and a lower Frechet-distance ratio, so it was harder to separate from real profiles and closer in distribution. The metrics use each model's stated evaluation split, so this is a model-choice summary rather than a paired significance test. These results are why the remaining analyses use DDIM.</a:t>
             </a:r>
           </a:p>
         </p:txBody>
@@ -1492,7 +1492,7 @@
           <a:p/>
           <a:p>
             <a:r>
-              <a:t>This is PCA, not UMAP. Circles are locked real OSDR profiles and crosses are matched DDIM profiles in the same PCA space. On the left, generated samples track the tissue-defined branches. On the right, FLT and GC remain interspersed because condition effects are smaller than tissue effects. Visual overlap is useful but descriptive; the next slide provides the quantitative validation.</a:t>
+              <a:t>Having selected DDIM, read the panels from left to right. The same generated profiles begin as noise, develop structure by timestep 200 and approach tissue-conditioned regions at timestep zero. The axes are shared, so the visual change is not caused by rescaling each panel.</a:t>
             </a:r>
           </a:p>
         </p:txBody>
@@ -1562,13 +1562,13 @@
           <a:lstStyle/>
           <a:p>
             <a:r>
-              <a:t>Target time: 1:00</a:t>
+              <a:t>Target time: 0:55</a:t>
             </a:r>
           </a:p>
           <a:p/>
           <a:p>
             <a:r>
-              <a:t>Both WGAN-GP and DDIM had high correlation and F1. DDIM had adversarial accuracy near 0.5 and a lower Frechet-distance ratio, so it was harder to separate from real profiles and closer in distribution. The metrics use each model's stated evaluation split, so this is a model-choice summary rather than a paired significance test.</a:t>
+              <a:t>This is PCA, not UMAP. Circles are locked real OSDR profiles and crosses are matched DDIM profiles in the same PCA space. On the left, generated samples track the tissue-defined branches. On the right, FLT and GC remain interspersed because condition effects are smaller than tissue effects. Visual overlap is descriptive and complements the quantitative validation shown earlier.</a:t>
             </a:r>
           </a:p>
         </p:txBody>
@@ -31478,7 +31478,7 @@
                 </a:solidFill>
                 <a:latin typeface="Arial"/>
               </a:rPr>
-              <a:t>DIFFUSION</a:t>
+              <a:t>VALIDATION</a:t>
             </a:r>
           </a:p>
         </p:txBody>
@@ -31517,7 +31517,7 @@
                 </a:solidFill>
                 <a:latin typeface="Arial"/>
               </a:rPr>
-              <a:t>Diffusion learns tissue structure from noise</a:t>
+              <a:t>DDIM matched expression and reduced separability</a:t>
             </a:r>
           </a:p>
         </p:txBody>
@@ -31556,35 +31556,56 @@
                 </a:solidFill>
                 <a:latin typeface="Arial"/>
               </a:rPr>
-              <a:t>The same PCA axes follow 1,024 generated profiles through reverse diffusion.</a:t>
-            </a:r>
-          </a:p>
-        </p:txBody>
-      </p:sp>
-      <p:pic>
-        <p:nvPicPr>
-          <p:cNvPr id="7" name="DDIM reverse trajectory at timesteps 1000, 200 and 0" descr="DDIM reverse trajectory at timesteps 1000, 200 and 0"/>
-          <p:cNvPicPr>
-            <a:picLocks noChangeAspect="1"/>
-          </p:cNvPicPr>
+              <a:t>AA closer to 0.5 means a classifier has less success separating real and generated profiles; lower FD is better.</a:t>
+            </a:r>
+          </a:p>
+        </p:txBody>
+      </p:sp>
+      <p:sp>
+        <p:nvSpPr>
+          <p:cNvPr id="7" name="Rounded Rectangle 6"/>
+          <p:cNvSpPr/>
           <p:nvPr/>
-        </p:nvPicPr>
-        <p:blipFill>
-          <a:blip r:embed="rId2"/>
-          <a:stretch>
-            <a:fillRect/>
-          </a:stretch>
-        </p:blipFill>
-        <p:spPr>
-          <a:xfrm>
-            <a:off x="310896" y="1735579"/>
-            <a:ext cx="11558016" cy="4100072"/>
-          </a:xfrm>
-          <a:prstGeom prst="rect">
-            <a:avLst/>
-          </a:prstGeom>
-        </p:spPr>
-      </p:pic>
+        </p:nvSpPr>
+        <p:spPr>
+          <a:xfrm>
+            <a:off x="347472" y="1847088"/>
+            <a:ext cx="3703320" cy="3401568"/>
+          </a:xfrm>
+          <a:prstGeom prst="roundRect">
+            <a:avLst/>
+          </a:prstGeom>
+          <a:solidFill>
+            <a:srgbClr val="E9F1F7"/>
+          </a:solidFill>
+          <a:ln w="10160">
+            <a:solidFill>
+              <a:srgbClr val="C9DCE9"/>
+            </a:solidFill>
+          </a:ln>
+        </p:spPr>
+        <p:style>
+          <a:lnRef idx="1">
+            <a:schemeClr val="accent1"/>
+          </a:lnRef>
+          <a:fillRef idx="3">
+            <a:schemeClr val="accent1"/>
+          </a:fillRef>
+          <a:effectRef idx="2">
+            <a:schemeClr val="accent1"/>
+          </a:effectRef>
+          <a:fontRef idx="minor">
+            <a:schemeClr val="lt1"/>
+          </a:fontRef>
+        </p:style>
+        <p:txBody>
+          <a:bodyPr rtlCol="0" anchor="ctr"/>
+          <a:lstStyle/>
+          <a:p>
+            <a:pPr algn="ctr"/>
+          </a:p>
+        </p:txBody>
+      </p:sp>
       <p:sp>
         <p:nvSpPr>
           <p:cNvPr id="8" name="TextBox 7"/>
@@ -31593,8 +31614,129 @@
         </p:nvSpPr>
         <p:spPr>
           <a:xfrm>
-            <a:off x="713232" y="5943600"/>
-            <a:ext cx="2286000" cy="256032"/>
+            <a:off x="612648" y="2103120"/>
+            <a:ext cx="3154680" cy="320040"/>
+          </a:xfrm>
+          <a:prstGeom prst="rect">
+            <a:avLst/>
+          </a:prstGeom>
+          <a:noFill/>
+        </p:spPr>
+        <p:txBody>
+          <a:bodyPr wrap="square" lIns="18288" rIns="18288" tIns="18288" bIns="18288" anchor="t">
+            <a:spAutoFit/>
+          </a:bodyPr>
+          <a:lstStyle/>
+          <a:p>
+            <a:pPr algn="l">
+              <a:spcAft>
+                <a:spcPts val="0"/>
+              </a:spcAft>
+            </a:pPr>
+            <a:r>
+              <a:rPr sz="1700" b="1" i="0">
+                <a:solidFill>
+                  <a:srgbClr val="2D6496"/>
+                </a:solidFill>
+                <a:latin typeface="Arial"/>
+              </a:rPr>
+              <a:t>ARCHS4 tissue probe</a:t>
+            </a:r>
+          </a:p>
+        </p:txBody>
+      </p:sp>
+      <p:sp>
+        <p:nvSpPr>
+          <p:cNvPr id="9" name="TextBox 8"/>
+          <p:cNvSpPr txBox="1"/>
+          <p:nvPr/>
+        </p:nvSpPr>
+        <p:spPr>
+          <a:xfrm>
+            <a:off x="621792" y="2487168"/>
+            <a:ext cx="3063240" cy="274320"/>
+          </a:xfrm>
+          <a:prstGeom prst="rect">
+            <a:avLst/>
+          </a:prstGeom>
+          <a:noFill/>
+        </p:spPr>
+        <p:txBody>
+          <a:bodyPr wrap="square" lIns="18288" rIns="18288" tIns="18288" bIns="18288" anchor="t">
+            <a:spAutoFit/>
+          </a:bodyPr>
+          <a:lstStyle/>
+          <a:p>
+            <a:pPr algn="l">
+              <a:spcAft>
+                <a:spcPts val="0"/>
+              </a:spcAft>
+            </a:pPr>
+            <a:r>
+              <a:rPr sz="1250" b="0" i="0">
+                <a:solidFill>
+                  <a:srgbClr val="59697A"/>
+                </a:solidFill>
+                <a:latin typeface="Arial"/>
+              </a:rPr>
+              <a:t>Balanced accuracy on held-out real profiles</a:t>
+            </a:r>
+          </a:p>
+        </p:txBody>
+      </p:sp>
+      <p:sp>
+        <p:nvSpPr>
+          <p:cNvPr id="10" name="Rectangle 9"/>
+          <p:cNvSpPr/>
+          <p:nvPr/>
+        </p:nvSpPr>
+        <p:spPr>
+          <a:xfrm>
+            <a:off x="950976" y="3436845"/>
+            <a:ext cx="786384" cy="1299746"/>
+          </a:xfrm>
+          <a:prstGeom prst="rect">
+            <a:avLst/>
+          </a:prstGeom>
+          <a:solidFill>
+            <a:srgbClr val="8A969E"/>
+          </a:solidFill>
+          <a:ln>
+            <a:noFill/>
+          </a:ln>
+        </p:spPr>
+        <p:style>
+          <a:lnRef idx="1">
+            <a:schemeClr val="accent1"/>
+          </a:lnRef>
+          <a:fillRef idx="3">
+            <a:schemeClr val="accent1"/>
+          </a:fillRef>
+          <a:effectRef idx="2">
+            <a:schemeClr val="accent1"/>
+          </a:effectRef>
+          <a:fontRef idx="minor">
+            <a:schemeClr val="lt1"/>
+          </a:fontRef>
+        </p:style>
+        <p:txBody>
+          <a:bodyPr rtlCol="0" anchor="ctr"/>
+          <a:lstStyle/>
+          <a:p>
+            <a:pPr algn="ctr"/>
+          </a:p>
+        </p:txBody>
+      </p:sp>
+      <p:sp>
+        <p:nvSpPr>
+          <p:cNvPr id="11" name="TextBox 10"/>
+          <p:cNvSpPr txBox="1"/>
+          <p:nvPr/>
+        </p:nvSpPr>
+        <p:spPr>
+          <a:xfrm>
+            <a:off x="923544" y="3107661"/>
+            <a:ext cx="868680" cy="274320"/>
           </a:xfrm>
           <a:prstGeom prst="rect">
             <a:avLst/>
@@ -31613,27 +31755,27 @@
               </a:spcAft>
             </a:pPr>
             <a:r>
-              <a:rPr sz="1300" b="1" i="0">
-                <a:solidFill>
-                  <a:srgbClr val="59697A"/>
+              <a:rPr sz="1600" b="1" i="0">
+                <a:solidFill>
+                  <a:srgbClr val="082B55"/>
                 </a:solidFill>
                 <a:latin typeface="Arial"/>
               </a:rPr>
-              <a:t>t = 1000: noise</a:t>
-            </a:r>
-          </a:p>
-        </p:txBody>
-      </p:sp>
-      <p:sp>
-        <p:nvSpPr>
-          <p:cNvPr id="9" name="TextBox 8"/>
+              <a:t>0.781</a:t>
+            </a:r>
+          </a:p>
+        </p:txBody>
+      </p:sp>
+      <p:sp>
+        <p:nvSpPr>
+          <p:cNvPr id="12" name="TextBox 11"/>
           <p:cNvSpPr txBox="1"/>
           <p:nvPr/>
         </p:nvSpPr>
         <p:spPr>
           <a:xfrm>
-            <a:off x="4782312" y="5943600"/>
-            <a:ext cx="2651760" cy="256032"/>
+            <a:off x="676656" y="4809744"/>
+            <a:ext cx="1325880" cy="365760"/>
           </a:xfrm>
           <a:prstGeom prst="rect">
             <a:avLst/>
@@ -31652,27 +31794,70 @@
               </a:spcAft>
             </a:pPr>
             <a:r>
-              <a:rPr sz="1300" b="1" i="0">
-                <a:solidFill>
-                  <a:srgbClr val="59697A"/>
+              <a:rPr sz="1250" b="0" i="0">
+                <a:solidFill>
+                  <a:srgbClr val="263746"/>
                 </a:solidFill>
                 <a:latin typeface="Arial"/>
               </a:rPr>
-              <a:t>t = 200: partial structure</a:t>
-            </a:r>
-          </a:p>
-        </p:txBody>
-      </p:sp>
-      <p:sp>
-        <p:nvSpPr>
-          <p:cNvPr id="10" name="TextBox 9"/>
+              <a:t>Real-trained</a:t>
+            </a:r>
+          </a:p>
+        </p:txBody>
+      </p:sp>
+      <p:sp>
+        <p:nvSpPr>
+          <p:cNvPr id="13" name="Rectangle 12"/>
+          <p:cNvSpPr/>
+          <p:nvPr/>
+        </p:nvSpPr>
+        <p:spPr>
+          <a:xfrm>
+            <a:off x="2523744" y="3436845"/>
+            <a:ext cx="786384" cy="1299746"/>
+          </a:xfrm>
+          <a:prstGeom prst="rect">
+            <a:avLst/>
+          </a:prstGeom>
+          <a:solidFill>
+            <a:srgbClr val="178681"/>
+          </a:solidFill>
+          <a:ln>
+            <a:noFill/>
+          </a:ln>
+        </p:spPr>
+        <p:style>
+          <a:lnRef idx="1">
+            <a:schemeClr val="accent1"/>
+          </a:lnRef>
+          <a:fillRef idx="3">
+            <a:schemeClr val="accent1"/>
+          </a:fillRef>
+          <a:effectRef idx="2">
+            <a:schemeClr val="accent1"/>
+          </a:effectRef>
+          <a:fontRef idx="minor">
+            <a:schemeClr val="lt1"/>
+          </a:fontRef>
+        </p:style>
+        <p:txBody>
+          <a:bodyPr rtlCol="0" anchor="ctr"/>
+          <a:lstStyle/>
+          <a:p>
+            <a:pPr algn="ctr"/>
+          </a:p>
+        </p:txBody>
+      </p:sp>
+      <p:sp>
+        <p:nvSpPr>
+          <p:cNvPr id="14" name="TextBox 13"/>
           <p:cNvSpPr txBox="1"/>
           <p:nvPr/>
         </p:nvSpPr>
         <p:spPr>
           <a:xfrm>
-            <a:off x="8366760" y="5943600"/>
-            <a:ext cx="3108960" cy="256032"/>
+            <a:off x="2496312" y="3107661"/>
+            <a:ext cx="868680" cy="274320"/>
           </a:xfrm>
           <a:prstGeom prst="rect">
             <a:avLst/>
@@ -31691,27 +31876,27 @@
               </a:spcAft>
             </a:pPr>
             <a:r>
-              <a:rPr sz="1300" b="1" i="0">
-                <a:solidFill>
-                  <a:srgbClr val="178681"/>
+              <a:rPr sz="1600" b="1" i="0">
+                <a:solidFill>
+                  <a:srgbClr val="082B55"/>
                 </a:solidFill>
                 <a:latin typeface="Arial"/>
               </a:rPr>
-              <a:t>t = 0: tissue-conditioned profiles</a:t>
-            </a:r>
-          </a:p>
-        </p:txBody>
-      </p:sp>
-      <p:sp>
-        <p:nvSpPr>
-          <p:cNvPr id="11" name="TextBox 10"/>
+              <a:t>0.781</a:t>
+            </a:r>
+          </a:p>
+        </p:txBody>
+      </p:sp>
+      <p:sp>
+        <p:nvSpPr>
+          <p:cNvPr id="15" name="TextBox 14"/>
           <p:cNvSpPr txBox="1"/>
           <p:nvPr/>
         </p:nvSpPr>
         <p:spPr>
           <a:xfrm>
-            <a:off x="329184" y="6510528"/>
-            <a:ext cx="10972800" cy="173736"/>
+            <a:off x="2249424" y="4809744"/>
+            <a:ext cx="1325880" cy="365760"/>
           </a:xfrm>
           <a:prstGeom prst="rect">
             <a:avLst/>
@@ -31719,7 +31904,134 @@
           <a:noFill/>
         </p:spPr>
         <p:txBody>
-          <a:bodyPr wrap="square" lIns="18288" rIns="18288" tIns="18288" bIns="18288" anchor="ctr">
+          <a:bodyPr wrap="square" lIns="18288" rIns="18288" tIns="18288" bIns="18288" anchor="t">
+            <a:spAutoFit/>
+          </a:bodyPr>
+          <a:lstStyle/>
+          <a:p>
+            <a:pPr algn="ctr">
+              <a:spcAft>
+                <a:spcPts val="0"/>
+              </a:spcAft>
+            </a:pPr>
+            <a:r>
+              <a:rPr sz="1250" b="0" i="0">
+                <a:solidFill>
+                  <a:srgbClr val="263746"/>
+                </a:solidFill>
+                <a:latin typeface="Arial"/>
+              </a:rPr>
+              <a:t>Synthetic-trained</a:t>
+            </a:r>
+          </a:p>
+        </p:txBody>
+      </p:sp>
+      <p:sp>
+        <p:nvSpPr>
+          <p:cNvPr id="16" name="Rectangle 15"/>
+          <p:cNvSpPr/>
+          <p:nvPr/>
+        </p:nvSpPr>
+        <p:spPr>
+          <a:xfrm>
+            <a:off x="749808" y="4736592"/>
+            <a:ext cx="2880360" cy="13716"/>
+          </a:xfrm>
+          <a:prstGeom prst="rect">
+            <a:avLst/>
+          </a:prstGeom>
+          <a:solidFill>
+            <a:srgbClr val="A9B5BC"/>
+          </a:solidFill>
+          <a:ln>
+            <a:noFill/>
+          </a:ln>
+        </p:spPr>
+        <p:style>
+          <a:lnRef idx="1">
+            <a:schemeClr val="accent1"/>
+          </a:lnRef>
+          <a:fillRef idx="3">
+            <a:schemeClr val="accent1"/>
+          </a:fillRef>
+          <a:effectRef idx="2">
+            <a:schemeClr val="accent1"/>
+          </a:effectRef>
+          <a:fontRef idx="minor">
+            <a:schemeClr val="lt1"/>
+          </a:fontRef>
+        </p:style>
+        <p:txBody>
+          <a:bodyPr rtlCol="0" anchor="ctr"/>
+          <a:lstStyle/>
+          <a:p>
+            <a:pPr algn="ctr"/>
+          </a:p>
+        </p:txBody>
+      </p:sp>
+      <p:sp>
+        <p:nvSpPr>
+          <p:cNvPr id="17" name="Rounded Rectangle 16"/>
+          <p:cNvSpPr/>
+          <p:nvPr/>
+        </p:nvSpPr>
+        <p:spPr>
+          <a:xfrm>
+            <a:off x="4315968" y="1847088"/>
+            <a:ext cx="7525512" cy="3401568"/>
+          </a:xfrm>
+          <a:prstGeom prst="roundRect">
+            <a:avLst/>
+          </a:prstGeom>
+          <a:solidFill>
+            <a:srgbClr val="FFFFFF"/>
+          </a:solidFill>
+          <a:ln w="10160">
+            <a:solidFill>
+              <a:srgbClr val="DDE4E8"/>
+            </a:solidFill>
+          </a:ln>
+        </p:spPr>
+        <p:style>
+          <a:lnRef idx="1">
+            <a:schemeClr val="accent1"/>
+          </a:lnRef>
+          <a:fillRef idx="3">
+            <a:schemeClr val="accent1"/>
+          </a:fillRef>
+          <a:effectRef idx="2">
+            <a:schemeClr val="accent1"/>
+          </a:effectRef>
+          <a:fontRef idx="minor">
+            <a:schemeClr val="lt1"/>
+          </a:fontRef>
+        </p:style>
+        <p:txBody>
+          <a:bodyPr rtlCol="0" anchor="ctr"/>
+          <a:lstStyle/>
+          <a:p>
+            <a:pPr algn="ctr"/>
+          </a:p>
+        </p:txBody>
+      </p:sp>
+      <p:sp>
+        <p:nvSpPr>
+          <p:cNvPr id="18" name="TextBox 17"/>
+          <p:cNvSpPr txBox="1"/>
+          <p:nvPr/>
+        </p:nvSpPr>
+        <p:spPr>
+          <a:xfrm>
+            <a:off x="4599432" y="2075688"/>
+            <a:ext cx="1417320" cy="256032"/>
+          </a:xfrm>
+          <a:prstGeom prst="rect">
+            <a:avLst/>
+          </a:prstGeom>
+          <a:noFill/>
+        </p:spPr>
+        <p:txBody>
+          <a:bodyPr wrap="square" lIns="18288" rIns="18288" tIns="18288" bIns="18288" anchor="t">
             <a:spAutoFit/>
           </a:bodyPr>
           <a:lstStyle/>
@@ -31730,13 +32042,1002 @@
               </a:spcAft>
             </a:pPr>
             <a:r>
-              <a:rPr sz="720" b="0" i="0">
-                <a:solidFill>
-                  <a:srgbClr val="8A969E"/>
+              <a:rPr sz="1250" b="1" i="0">
+                <a:solidFill>
+                  <a:srgbClr val="59697A"/>
                 </a:solidFill>
                 <a:latin typeface="Arial"/>
               </a:rPr>
-              <a:t>Gray points are real ARCHS4 profiles; colors identify generated tissue conditions. PC1 and PC2 limits are shared across panels.</a:t>
+              <a:t>Metric</a:t>
+            </a:r>
+          </a:p>
+        </p:txBody>
+      </p:sp>
+      <p:sp>
+        <p:nvSpPr>
+          <p:cNvPr id="19" name="TextBox 18"/>
+          <p:cNvSpPr txBox="1"/>
+          <p:nvPr/>
+        </p:nvSpPr>
+        <p:spPr>
+          <a:xfrm>
+            <a:off x="6537960" y="2075688"/>
+            <a:ext cx="1234440" cy="256032"/>
+          </a:xfrm>
+          <a:prstGeom prst="rect">
+            <a:avLst/>
+          </a:prstGeom>
+          <a:noFill/>
+        </p:spPr>
+        <p:txBody>
+          <a:bodyPr wrap="square" lIns="18288" rIns="18288" tIns="18288" bIns="18288" anchor="t">
+            <a:spAutoFit/>
+          </a:bodyPr>
+          <a:lstStyle/>
+          <a:p>
+            <a:pPr algn="ctr">
+              <a:spcAft>
+                <a:spcPts val="0"/>
+              </a:spcAft>
+            </a:pPr>
+            <a:r>
+              <a:rPr sz="1250" b="1" i="0">
+                <a:solidFill>
+                  <a:srgbClr val="D96552"/>
+                </a:solidFill>
+                <a:latin typeface="Arial"/>
+              </a:rPr>
+              <a:t>WGAN-GP</a:t>
+            </a:r>
+          </a:p>
+        </p:txBody>
+      </p:sp>
+      <p:sp>
+        <p:nvSpPr>
+          <p:cNvPr id="20" name="TextBox 19"/>
+          <p:cNvSpPr txBox="1"/>
+          <p:nvPr/>
+        </p:nvSpPr>
+        <p:spPr>
+          <a:xfrm>
+            <a:off x="8257031" y="2075688"/>
+            <a:ext cx="1234440" cy="256032"/>
+          </a:xfrm>
+          <a:prstGeom prst="rect">
+            <a:avLst/>
+          </a:prstGeom>
+          <a:noFill/>
+        </p:spPr>
+        <p:txBody>
+          <a:bodyPr wrap="square" lIns="18288" rIns="18288" tIns="18288" bIns="18288" anchor="t">
+            <a:spAutoFit/>
+          </a:bodyPr>
+          <a:lstStyle/>
+          <a:p>
+            <a:pPr algn="ctr">
+              <a:spcAft>
+                <a:spcPts val="0"/>
+              </a:spcAft>
+            </a:pPr>
+            <a:r>
+              <a:rPr sz="1250" b="1" i="0">
+                <a:solidFill>
+                  <a:srgbClr val="178681"/>
+                </a:solidFill>
+                <a:latin typeface="Arial"/>
+              </a:rPr>
+              <a:t>DDIM</a:t>
+            </a:r>
+          </a:p>
+        </p:txBody>
+      </p:sp>
+      <p:sp>
+        <p:nvSpPr>
+          <p:cNvPr id="21" name="TextBox 20"/>
+          <p:cNvSpPr txBox="1"/>
+          <p:nvPr/>
+        </p:nvSpPr>
+        <p:spPr>
+          <a:xfrm>
+            <a:off x="9802368" y="2075688"/>
+            <a:ext cx="1627632" cy="256032"/>
+          </a:xfrm>
+          <a:prstGeom prst="rect">
+            <a:avLst/>
+          </a:prstGeom>
+          <a:noFill/>
+        </p:spPr>
+        <p:txBody>
+          <a:bodyPr wrap="square" lIns="18288" rIns="18288" tIns="18288" bIns="18288" anchor="t">
+            <a:spAutoFit/>
+          </a:bodyPr>
+          <a:lstStyle/>
+          <a:p>
+            <a:pPr algn="l">
+              <a:spcAft>
+                <a:spcPts val="0"/>
+              </a:spcAft>
+            </a:pPr>
+            <a:r>
+              <a:rPr sz="1250" b="1" i="0">
+                <a:solidFill>
+                  <a:srgbClr val="59697A"/>
+                </a:solidFill>
+                <a:latin typeface="Arial"/>
+              </a:rPr>
+              <a:t>Reading</a:t>
+            </a:r>
+          </a:p>
+        </p:txBody>
+      </p:sp>
+      <p:sp>
+        <p:nvSpPr>
+          <p:cNvPr id="22" name="Rectangle 21"/>
+          <p:cNvSpPr/>
+          <p:nvPr/>
+        </p:nvSpPr>
+        <p:spPr>
+          <a:xfrm>
+            <a:off x="4517136" y="2478024"/>
+            <a:ext cx="7059168" cy="484632"/>
+          </a:xfrm>
+          <a:prstGeom prst="rect">
+            <a:avLst/>
+          </a:prstGeom>
+          <a:solidFill>
+            <a:srgbClr val="F5F7F8"/>
+          </a:solidFill>
+          <a:ln>
+            <a:noFill/>
+          </a:ln>
+        </p:spPr>
+        <p:style>
+          <a:lnRef idx="1">
+            <a:schemeClr val="accent1"/>
+          </a:lnRef>
+          <a:fillRef idx="3">
+            <a:schemeClr val="accent1"/>
+          </a:fillRef>
+          <a:effectRef idx="2">
+            <a:schemeClr val="accent1"/>
+          </a:effectRef>
+          <a:fontRef idx="minor">
+            <a:schemeClr val="lt1"/>
+          </a:fontRef>
+        </p:style>
+        <p:txBody>
+          <a:bodyPr rtlCol="0" anchor="ctr"/>
+          <a:lstStyle/>
+          <a:p>
+            <a:pPr algn="ctr"/>
+          </a:p>
+        </p:txBody>
+      </p:sp>
+      <p:sp>
+        <p:nvSpPr>
+          <p:cNvPr id="23" name="TextBox 22"/>
+          <p:cNvSpPr txBox="1"/>
+          <p:nvPr/>
+        </p:nvSpPr>
+        <p:spPr>
+          <a:xfrm>
+            <a:off x="4599432" y="2542032"/>
+            <a:ext cx="1783080" cy="310896"/>
+          </a:xfrm>
+          <a:prstGeom prst="rect">
+            <a:avLst/>
+          </a:prstGeom>
+          <a:noFill/>
+        </p:spPr>
+        <p:txBody>
+          <a:bodyPr wrap="square" lIns="18288" rIns="18288" tIns="18288" bIns="18288" anchor="t">
+            <a:spAutoFit/>
+          </a:bodyPr>
+          <a:lstStyle/>
+          <a:p>
+            <a:pPr algn="l">
+              <a:spcAft>
+                <a:spcPts val="0"/>
+              </a:spcAft>
+            </a:pPr>
+            <a:r>
+              <a:rPr sz="1400" b="0" i="0">
+                <a:solidFill>
+                  <a:srgbClr val="263746"/>
+                </a:solidFill>
+                <a:latin typeface="Arial"/>
+              </a:rPr>
+              <a:t>Correlation</a:t>
+            </a:r>
+          </a:p>
+        </p:txBody>
+      </p:sp>
+      <p:sp>
+        <p:nvSpPr>
+          <p:cNvPr id="24" name="TextBox 23"/>
+          <p:cNvSpPr txBox="1"/>
+          <p:nvPr/>
+        </p:nvSpPr>
+        <p:spPr>
+          <a:xfrm>
+            <a:off x="6519672" y="2542032"/>
+            <a:ext cx="1261872" cy="310896"/>
+          </a:xfrm>
+          <a:prstGeom prst="rect">
+            <a:avLst/>
+          </a:prstGeom>
+          <a:noFill/>
+        </p:spPr>
+        <p:txBody>
+          <a:bodyPr wrap="square" lIns="18288" rIns="18288" tIns="18288" bIns="18288" anchor="t">
+            <a:spAutoFit/>
+          </a:bodyPr>
+          <a:lstStyle/>
+          <a:p>
+            <a:pPr algn="ctr">
+              <a:spcAft>
+                <a:spcPts val="0"/>
+              </a:spcAft>
+            </a:pPr>
+            <a:r>
+              <a:rPr sz="1600" b="1" i="0">
+                <a:solidFill>
+                  <a:srgbClr val="D96552"/>
+                </a:solidFill>
+                <a:latin typeface="Arial"/>
+              </a:rPr>
+              <a:t>0.976</a:t>
+            </a:r>
+          </a:p>
+        </p:txBody>
+      </p:sp>
+      <p:sp>
+        <p:nvSpPr>
+          <p:cNvPr id="25" name="TextBox 24"/>
+          <p:cNvSpPr txBox="1"/>
+          <p:nvPr/>
+        </p:nvSpPr>
+        <p:spPr>
+          <a:xfrm>
+            <a:off x="8238744" y="2542032"/>
+            <a:ext cx="1261872" cy="310896"/>
+          </a:xfrm>
+          <a:prstGeom prst="rect">
+            <a:avLst/>
+          </a:prstGeom>
+          <a:noFill/>
+        </p:spPr>
+        <p:txBody>
+          <a:bodyPr wrap="square" lIns="18288" rIns="18288" tIns="18288" bIns="18288" anchor="t">
+            <a:spAutoFit/>
+          </a:bodyPr>
+          <a:lstStyle/>
+          <a:p>
+            <a:pPr algn="ctr">
+              <a:spcAft>
+                <a:spcPts val="0"/>
+              </a:spcAft>
+            </a:pPr>
+            <a:r>
+              <a:rPr sz="1600" b="1" i="0">
+                <a:solidFill>
+                  <a:srgbClr val="178681"/>
+                </a:solidFill>
+                <a:latin typeface="Arial"/>
+              </a:rPr>
+              <a:t>0.974</a:t>
+            </a:r>
+          </a:p>
+        </p:txBody>
+      </p:sp>
+      <p:sp>
+        <p:nvSpPr>
+          <p:cNvPr id="26" name="TextBox 25"/>
+          <p:cNvSpPr txBox="1"/>
+          <p:nvPr/>
+        </p:nvSpPr>
+        <p:spPr>
+          <a:xfrm>
+            <a:off x="9820656" y="2542032"/>
+            <a:ext cx="1481328" cy="310896"/>
+          </a:xfrm>
+          <a:prstGeom prst="rect">
+            <a:avLst/>
+          </a:prstGeom>
+          <a:noFill/>
+        </p:spPr>
+        <p:txBody>
+          <a:bodyPr wrap="square" lIns="18288" rIns="18288" tIns="18288" bIns="18288" anchor="t">
+            <a:spAutoFit/>
+          </a:bodyPr>
+          <a:lstStyle/>
+          <a:p>
+            <a:pPr algn="l">
+              <a:spcAft>
+                <a:spcPts val="0"/>
+              </a:spcAft>
+            </a:pPr>
+            <a:r>
+              <a:rPr sz="1350" b="0" i="0">
+                <a:solidFill>
+                  <a:srgbClr val="59697A"/>
+                </a:solidFill>
+                <a:latin typeface="Arial"/>
+              </a:rPr>
+              <a:t>similar</a:t>
+            </a:r>
+          </a:p>
+        </p:txBody>
+      </p:sp>
+      <p:sp>
+        <p:nvSpPr>
+          <p:cNvPr id="27" name="TextBox 26"/>
+          <p:cNvSpPr txBox="1"/>
+          <p:nvPr/>
+        </p:nvSpPr>
+        <p:spPr>
+          <a:xfrm>
+            <a:off x="4599432" y="3118103"/>
+            <a:ext cx="1783080" cy="310896"/>
+          </a:xfrm>
+          <a:prstGeom prst="rect">
+            <a:avLst/>
+          </a:prstGeom>
+          <a:noFill/>
+        </p:spPr>
+        <p:txBody>
+          <a:bodyPr wrap="square" lIns="18288" rIns="18288" tIns="18288" bIns="18288" anchor="t">
+            <a:spAutoFit/>
+          </a:bodyPr>
+          <a:lstStyle/>
+          <a:p>
+            <a:pPr algn="l">
+              <a:spcAft>
+                <a:spcPts val="0"/>
+              </a:spcAft>
+            </a:pPr>
+            <a:r>
+              <a:rPr sz="1400" b="0" i="0">
+                <a:solidFill>
+                  <a:srgbClr val="263746"/>
+                </a:solidFill>
+                <a:latin typeface="Arial"/>
+              </a:rPr>
+              <a:t>F1</a:t>
+            </a:r>
+          </a:p>
+        </p:txBody>
+      </p:sp>
+      <p:sp>
+        <p:nvSpPr>
+          <p:cNvPr id="28" name="TextBox 27"/>
+          <p:cNvSpPr txBox="1"/>
+          <p:nvPr/>
+        </p:nvSpPr>
+        <p:spPr>
+          <a:xfrm>
+            <a:off x="6519672" y="3118103"/>
+            <a:ext cx="1261872" cy="310896"/>
+          </a:xfrm>
+          <a:prstGeom prst="rect">
+            <a:avLst/>
+          </a:prstGeom>
+          <a:noFill/>
+        </p:spPr>
+        <p:txBody>
+          <a:bodyPr wrap="square" lIns="18288" rIns="18288" tIns="18288" bIns="18288" anchor="t">
+            <a:spAutoFit/>
+          </a:bodyPr>
+          <a:lstStyle/>
+          <a:p>
+            <a:pPr algn="ctr">
+              <a:spcAft>
+                <a:spcPts val="0"/>
+              </a:spcAft>
+            </a:pPr>
+            <a:r>
+              <a:rPr sz="1600" b="1" i="0">
+                <a:solidFill>
+                  <a:srgbClr val="D96552"/>
+                </a:solidFill>
+                <a:latin typeface="Arial"/>
+              </a:rPr>
+              <a:t>0.985</a:t>
+            </a:r>
+          </a:p>
+        </p:txBody>
+      </p:sp>
+      <p:sp>
+        <p:nvSpPr>
+          <p:cNvPr id="29" name="TextBox 28"/>
+          <p:cNvSpPr txBox="1"/>
+          <p:nvPr/>
+        </p:nvSpPr>
+        <p:spPr>
+          <a:xfrm>
+            <a:off x="8238744" y="3118103"/>
+            <a:ext cx="1261872" cy="310896"/>
+          </a:xfrm>
+          <a:prstGeom prst="rect">
+            <a:avLst/>
+          </a:prstGeom>
+          <a:noFill/>
+        </p:spPr>
+        <p:txBody>
+          <a:bodyPr wrap="square" lIns="18288" rIns="18288" tIns="18288" bIns="18288" anchor="t">
+            <a:spAutoFit/>
+          </a:bodyPr>
+          <a:lstStyle/>
+          <a:p>
+            <a:pPr algn="ctr">
+              <a:spcAft>
+                <a:spcPts val="0"/>
+              </a:spcAft>
+            </a:pPr>
+            <a:r>
+              <a:rPr sz="1600" b="1" i="0">
+                <a:solidFill>
+                  <a:srgbClr val="178681"/>
+                </a:solidFill>
+                <a:latin typeface="Arial"/>
+              </a:rPr>
+              <a:t>0.997</a:t>
+            </a:r>
+          </a:p>
+        </p:txBody>
+      </p:sp>
+      <p:sp>
+        <p:nvSpPr>
+          <p:cNvPr id="30" name="TextBox 29"/>
+          <p:cNvSpPr txBox="1"/>
+          <p:nvPr/>
+        </p:nvSpPr>
+        <p:spPr>
+          <a:xfrm>
+            <a:off x="9820656" y="3118103"/>
+            <a:ext cx="1481328" cy="310896"/>
+          </a:xfrm>
+          <a:prstGeom prst="rect">
+            <a:avLst/>
+          </a:prstGeom>
+          <a:noFill/>
+        </p:spPr>
+        <p:txBody>
+          <a:bodyPr wrap="square" lIns="18288" rIns="18288" tIns="18288" bIns="18288" anchor="t">
+            <a:spAutoFit/>
+          </a:bodyPr>
+          <a:lstStyle/>
+          <a:p>
+            <a:pPr algn="l">
+              <a:spcAft>
+                <a:spcPts val="0"/>
+              </a:spcAft>
+            </a:pPr>
+            <a:r>
+              <a:rPr sz="1350" b="0" i="0">
+                <a:solidFill>
+                  <a:srgbClr val="59697A"/>
+                </a:solidFill>
+                <a:latin typeface="Arial"/>
+              </a:rPr>
+              <a:t>higher</a:t>
+            </a:r>
+          </a:p>
+        </p:txBody>
+      </p:sp>
+      <p:sp>
+        <p:nvSpPr>
+          <p:cNvPr id="31" name="Rectangle 30"/>
+          <p:cNvSpPr/>
+          <p:nvPr/>
+        </p:nvSpPr>
+        <p:spPr>
+          <a:xfrm>
+            <a:off x="4517136" y="3630168"/>
+            <a:ext cx="7059168" cy="484632"/>
+          </a:xfrm>
+          <a:prstGeom prst="rect">
+            <a:avLst/>
+          </a:prstGeom>
+          <a:solidFill>
+            <a:srgbClr val="F5F7F8"/>
+          </a:solidFill>
+          <a:ln>
+            <a:noFill/>
+          </a:ln>
+        </p:spPr>
+        <p:style>
+          <a:lnRef idx="1">
+            <a:schemeClr val="accent1"/>
+          </a:lnRef>
+          <a:fillRef idx="3">
+            <a:schemeClr val="accent1"/>
+          </a:fillRef>
+          <a:effectRef idx="2">
+            <a:schemeClr val="accent1"/>
+          </a:effectRef>
+          <a:fontRef idx="minor">
+            <a:schemeClr val="lt1"/>
+          </a:fontRef>
+        </p:style>
+        <p:txBody>
+          <a:bodyPr rtlCol="0" anchor="ctr"/>
+          <a:lstStyle/>
+          <a:p>
+            <a:pPr algn="ctr"/>
+          </a:p>
+        </p:txBody>
+      </p:sp>
+      <p:sp>
+        <p:nvSpPr>
+          <p:cNvPr id="32" name="TextBox 31"/>
+          <p:cNvSpPr txBox="1"/>
+          <p:nvPr/>
+        </p:nvSpPr>
+        <p:spPr>
+          <a:xfrm>
+            <a:off x="4599432" y="3694176"/>
+            <a:ext cx="1783080" cy="310896"/>
+          </a:xfrm>
+          <a:prstGeom prst="rect">
+            <a:avLst/>
+          </a:prstGeom>
+          <a:noFill/>
+        </p:spPr>
+        <p:txBody>
+          <a:bodyPr wrap="square" lIns="18288" rIns="18288" tIns="18288" bIns="18288" anchor="t">
+            <a:spAutoFit/>
+          </a:bodyPr>
+          <a:lstStyle/>
+          <a:p>
+            <a:pPr algn="l">
+              <a:spcAft>
+                <a:spcPts val="0"/>
+              </a:spcAft>
+            </a:pPr>
+            <a:r>
+              <a:rPr sz="1400" b="1" i="0">
+                <a:solidFill>
+                  <a:srgbClr val="263746"/>
+                </a:solidFill>
+                <a:latin typeface="Arial"/>
+              </a:rPr>
+              <a:t>Adversarial accuracy</a:t>
+            </a:r>
+          </a:p>
+        </p:txBody>
+      </p:sp>
+      <p:sp>
+        <p:nvSpPr>
+          <p:cNvPr id="33" name="TextBox 32"/>
+          <p:cNvSpPr txBox="1"/>
+          <p:nvPr/>
+        </p:nvSpPr>
+        <p:spPr>
+          <a:xfrm>
+            <a:off x="6519672" y="3694176"/>
+            <a:ext cx="1261872" cy="310896"/>
+          </a:xfrm>
+          <a:prstGeom prst="rect">
+            <a:avLst/>
+          </a:prstGeom>
+          <a:noFill/>
+        </p:spPr>
+        <p:txBody>
+          <a:bodyPr wrap="square" lIns="18288" rIns="18288" tIns="18288" bIns="18288" anchor="t">
+            <a:spAutoFit/>
+          </a:bodyPr>
+          <a:lstStyle/>
+          <a:p>
+            <a:pPr algn="ctr">
+              <a:spcAft>
+                <a:spcPts val="0"/>
+              </a:spcAft>
+            </a:pPr>
+            <a:r>
+              <a:rPr sz="1600" b="1" i="0">
+                <a:solidFill>
+                  <a:srgbClr val="D96552"/>
+                </a:solidFill>
+                <a:latin typeface="Arial"/>
+              </a:rPr>
+              <a:t>0.636</a:t>
+            </a:r>
+          </a:p>
+        </p:txBody>
+      </p:sp>
+      <p:sp>
+        <p:nvSpPr>
+          <p:cNvPr id="34" name="TextBox 33"/>
+          <p:cNvSpPr txBox="1"/>
+          <p:nvPr/>
+        </p:nvSpPr>
+        <p:spPr>
+          <a:xfrm>
+            <a:off x="8238744" y="3694176"/>
+            <a:ext cx="1261872" cy="310896"/>
+          </a:xfrm>
+          <a:prstGeom prst="rect">
+            <a:avLst/>
+          </a:prstGeom>
+          <a:noFill/>
+        </p:spPr>
+        <p:txBody>
+          <a:bodyPr wrap="square" lIns="18288" rIns="18288" tIns="18288" bIns="18288" anchor="t">
+            <a:spAutoFit/>
+          </a:bodyPr>
+          <a:lstStyle/>
+          <a:p>
+            <a:pPr algn="ctr">
+              <a:spcAft>
+                <a:spcPts val="0"/>
+              </a:spcAft>
+            </a:pPr>
+            <a:r>
+              <a:rPr sz="1600" b="1" i="0">
+                <a:solidFill>
+                  <a:srgbClr val="178681"/>
+                </a:solidFill>
+                <a:latin typeface="Arial"/>
+              </a:rPr>
+              <a:t>0.475</a:t>
+            </a:r>
+          </a:p>
+        </p:txBody>
+      </p:sp>
+      <p:sp>
+        <p:nvSpPr>
+          <p:cNvPr id="35" name="TextBox 34"/>
+          <p:cNvSpPr txBox="1"/>
+          <p:nvPr/>
+        </p:nvSpPr>
+        <p:spPr>
+          <a:xfrm>
+            <a:off x="9820656" y="3694176"/>
+            <a:ext cx="1481328" cy="310896"/>
+          </a:xfrm>
+          <a:prstGeom prst="rect">
+            <a:avLst/>
+          </a:prstGeom>
+          <a:noFill/>
+        </p:spPr>
+        <p:txBody>
+          <a:bodyPr wrap="square" lIns="18288" rIns="18288" tIns="18288" bIns="18288" anchor="t">
+            <a:spAutoFit/>
+          </a:bodyPr>
+          <a:lstStyle/>
+          <a:p>
+            <a:pPr algn="l">
+              <a:spcAft>
+                <a:spcPts val="0"/>
+              </a:spcAft>
+            </a:pPr>
+            <a:r>
+              <a:rPr sz="1350" b="0" i="0">
+                <a:solidFill>
+                  <a:srgbClr val="59697A"/>
+                </a:solidFill>
+                <a:latin typeface="Arial"/>
+              </a:rPr>
+              <a:t>closer to 0.5</a:t>
+            </a:r>
+          </a:p>
+        </p:txBody>
+      </p:sp>
+      <p:sp>
+        <p:nvSpPr>
+          <p:cNvPr id="36" name="TextBox 35"/>
+          <p:cNvSpPr txBox="1"/>
+          <p:nvPr/>
+        </p:nvSpPr>
+        <p:spPr>
+          <a:xfrm>
+            <a:off x="4599432" y="4270248"/>
+            <a:ext cx="1783080" cy="310896"/>
+          </a:xfrm>
+          <a:prstGeom prst="rect">
+            <a:avLst/>
+          </a:prstGeom>
+          <a:noFill/>
+        </p:spPr>
+        <p:txBody>
+          <a:bodyPr wrap="square" lIns="18288" rIns="18288" tIns="18288" bIns="18288" anchor="t">
+            <a:spAutoFit/>
+          </a:bodyPr>
+          <a:lstStyle/>
+          <a:p>
+            <a:pPr algn="l">
+              <a:spcAft>
+                <a:spcPts val="0"/>
+              </a:spcAft>
+            </a:pPr>
+            <a:r>
+              <a:rPr sz="1400" b="1" i="0">
+                <a:solidFill>
+                  <a:srgbClr val="263746"/>
+                </a:solidFill>
+                <a:latin typeface="Arial"/>
+              </a:rPr>
+              <a:t>FD / real P95</a:t>
+            </a:r>
+          </a:p>
+        </p:txBody>
+      </p:sp>
+      <p:sp>
+        <p:nvSpPr>
+          <p:cNvPr id="37" name="TextBox 36"/>
+          <p:cNvSpPr txBox="1"/>
+          <p:nvPr/>
+        </p:nvSpPr>
+        <p:spPr>
+          <a:xfrm>
+            <a:off x="6519672" y="4270248"/>
+            <a:ext cx="1261872" cy="310896"/>
+          </a:xfrm>
+          <a:prstGeom prst="rect">
+            <a:avLst/>
+          </a:prstGeom>
+          <a:noFill/>
+        </p:spPr>
+        <p:txBody>
+          <a:bodyPr wrap="square" lIns="18288" rIns="18288" tIns="18288" bIns="18288" anchor="t">
+            <a:spAutoFit/>
+          </a:bodyPr>
+          <a:lstStyle/>
+          <a:p>
+            <a:pPr algn="ctr">
+              <a:spcAft>
+                <a:spcPts val="0"/>
+              </a:spcAft>
+            </a:pPr>
+            <a:r>
+              <a:rPr sz="1600" b="1" i="0">
+                <a:solidFill>
+                  <a:srgbClr val="D96552"/>
+                </a:solidFill>
+                <a:latin typeface="Arial"/>
+              </a:rPr>
+              <a:t>0.144</a:t>
+            </a:r>
+          </a:p>
+        </p:txBody>
+      </p:sp>
+      <p:sp>
+        <p:nvSpPr>
+          <p:cNvPr id="38" name="TextBox 37"/>
+          <p:cNvSpPr txBox="1"/>
+          <p:nvPr/>
+        </p:nvSpPr>
+        <p:spPr>
+          <a:xfrm>
+            <a:off x="8238744" y="4270248"/>
+            <a:ext cx="1261872" cy="310896"/>
+          </a:xfrm>
+          <a:prstGeom prst="rect">
+            <a:avLst/>
+          </a:prstGeom>
+          <a:noFill/>
+        </p:spPr>
+        <p:txBody>
+          <a:bodyPr wrap="square" lIns="18288" rIns="18288" tIns="18288" bIns="18288" anchor="t">
+            <a:spAutoFit/>
+          </a:bodyPr>
+          <a:lstStyle/>
+          <a:p>
+            <a:pPr algn="ctr">
+              <a:spcAft>
+                <a:spcPts val="0"/>
+              </a:spcAft>
+            </a:pPr>
+            <a:r>
+              <a:rPr sz="1600" b="1" i="0">
+                <a:solidFill>
+                  <a:srgbClr val="178681"/>
+                </a:solidFill>
+                <a:latin typeface="Arial"/>
+              </a:rPr>
+              <a:t>0.074</a:t>
+            </a:r>
+          </a:p>
+        </p:txBody>
+      </p:sp>
+      <p:sp>
+        <p:nvSpPr>
+          <p:cNvPr id="39" name="TextBox 38"/>
+          <p:cNvSpPr txBox="1"/>
+          <p:nvPr/>
+        </p:nvSpPr>
+        <p:spPr>
+          <a:xfrm>
+            <a:off x="9820656" y="4270248"/>
+            <a:ext cx="1481328" cy="310896"/>
+          </a:xfrm>
+          <a:prstGeom prst="rect">
+            <a:avLst/>
+          </a:prstGeom>
+          <a:noFill/>
+        </p:spPr>
+        <p:txBody>
+          <a:bodyPr wrap="square" lIns="18288" rIns="18288" tIns="18288" bIns="18288" anchor="t">
+            <a:spAutoFit/>
+          </a:bodyPr>
+          <a:lstStyle/>
+          <a:p>
+            <a:pPr algn="l">
+              <a:spcAft>
+                <a:spcPts val="0"/>
+              </a:spcAft>
+            </a:pPr>
+            <a:r>
+              <a:rPr sz="1350" b="0" i="0">
+                <a:solidFill>
+                  <a:srgbClr val="59697A"/>
+                </a:solidFill>
+                <a:latin typeface="Arial"/>
+              </a:rPr>
+              <a:t>lower</a:t>
+            </a:r>
+          </a:p>
+        </p:txBody>
+      </p:sp>
+      <p:sp>
+        <p:nvSpPr>
+          <p:cNvPr id="40" name="Rounded Rectangle 39"/>
+          <p:cNvSpPr/>
+          <p:nvPr/>
+        </p:nvSpPr>
+        <p:spPr>
+          <a:xfrm>
+            <a:off x="347472" y="5522976"/>
+            <a:ext cx="11494008" cy="667512"/>
+          </a:xfrm>
+          <a:prstGeom prst="roundRect">
+            <a:avLst/>
+          </a:prstGeom>
+          <a:solidFill>
+            <a:srgbClr val="082B55"/>
+          </a:solidFill>
+          <a:ln w="10160">
+            <a:solidFill>
+              <a:srgbClr val="082B55"/>
+            </a:solidFill>
+          </a:ln>
+        </p:spPr>
+        <p:style>
+          <a:lnRef idx="1">
+            <a:schemeClr val="accent1"/>
+          </a:lnRef>
+          <a:fillRef idx="3">
+            <a:schemeClr val="accent1"/>
+          </a:fillRef>
+          <a:effectRef idx="2">
+            <a:schemeClr val="accent1"/>
+          </a:effectRef>
+          <a:fontRef idx="minor">
+            <a:schemeClr val="lt1"/>
+          </a:fontRef>
+        </p:style>
+        <p:txBody>
+          <a:bodyPr rtlCol="0" anchor="ctr"/>
+          <a:lstStyle/>
+          <a:p>
+            <a:pPr algn="ctr"/>
+          </a:p>
+        </p:txBody>
+      </p:sp>
+      <p:sp>
+        <p:nvSpPr>
+          <p:cNvPr id="41" name="TextBox 40"/>
+          <p:cNvSpPr txBox="1"/>
+          <p:nvPr/>
+        </p:nvSpPr>
+        <p:spPr>
+          <a:xfrm>
+            <a:off x="658368" y="5660136"/>
+            <a:ext cx="2331720" cy="310896"/>
+          </a:xfrm>
+          <a:prstGeom prst="rect">
+            <a:avLst/>
+          </a:prstGeom>
+          <a:noFill/>
+        </p:spPr>
+        <p:txBody>
+          <a:bodyPr wrap="square" lIns="18288" rIns="18288" tIns="18288" bIns="18288" anchor="ctr">
+            <a:spAutoFit/>
+          </a:bodyPr>
+          <a:lstStyle/>
+          <a:p>
+            <a:pPr algn="l">
+              <a:spcAft>
+                <a:spcPts val="0"/>
+              </a:spcAft>
+            </a:pPr>
+            <a:r>
+              <a:rPr sz="1800" b="1" i="0">
+                <a:solidFill>
+                  <a:srgbClr val="FFFFFF"/>
+                </a:solidFill>
+                <a:latin typeface="Arial"/>
+              </a:rPr>
+              <a:t>Use DDIM downstream</a:t>
+            </a:r>
+          </a:p>
+        </p:txBody>
+      </p:sp>
+      <p:sp>
+        <p:nvSpPr>
+          <p:cNvPr id="42" name="TextBox 41"/>
+          <p:cNvSpPr txBox="1"/>
+          <p:nvPr/>
+        </p:nvSpPr>
+        <p:spPr>
+          <a:xfrm>
+            <a:off x="2852928" y="5669280"/>
+            <a:ext cx="8394192" cy="292608"/>
+          </a:xfrm>
+          <a:prstGeom prst="rect">
+            <a:avLst/>
+          </a:prstGeom>
+          <a:noFill/>
+        </p:spPr>
+        <p:txBody>
+          <a:bodyPr wrap="square" lIns="18288" rIns="18288" tIns="18288" bIns="18288" anchor="ctr">
+            <a:spAutoFit/>
+          </a:bodyPr>
+          <a:lstStyle/>
+          <a:p>
+            <a:pPr algn="l">
+              <a:spcAft>
+                <a:spcPts val="0"/>
+              </a:spcAft>
+            </a:pPr>
+            <a:r>
+              <a:rPr sz="1500" b="0" i="0">
+                <a:solidFill>
+                  <a:srgbClr val="DCE7F2"/>
+                </a:solidFill>
+                <a:latin typeface="Arial"/>
+              </a:rPr>
+              <a:t>Lower separability and distributional distance, with comparable correlation and higher F1.</a:t>
+            </a:r>
+          </a:p>
+        </p:txBody>
+      </p:sp>
+      <p:sp>
+        <p:nvSpPr>
+          <p:cNvPr id="43" name="TextBox 42"/>
+          <p:cNvSpPr txBox="1"/>
+          <p:nvPr/>
+        </p:nvSpPr>
+        <p:spPr>
+          <a:xfrm>
+            <a:off x="329184" y="6510528"/>
+            <a:ext cx="10972800" cy="173736"/>
+          </a:xfrm>
+          <a:prstGeom prst="rect">
+            <a:avLst/>
+          </a:prstGeom>
+          <a:noFill/>
+        </p:spPr>
+        <p:txBody>
+          <a:bodyPr wrap="square" lIns="18288" rIns="18288" tIns="18288" bIns="18288" anchor="ctr">
+            <a:spAutoFit/>
+          </a:bodyPr>
+          <a:lstStyle/>
+          <a:p>
+            <a:pPr algn="l">
+              <a:spcAft>
+                <a:spcPts val="0"/>
+              </a:spcAft>
+            </a:pPr>
+            <a:r>
+              <a:rPr sz="720" b="0" i="0">
+                <a:solidFill>
+                  <a:srgbClr val="8A969E"/>
+                </a:solidFill>
+                <a:latin typeface="Arial"/>
+              </a:rPr>
+              <a:t>WGAN values use validation data and DDIM values use the stated OSDR test; they are not paired on one common split.</a:t>
             </a:r>
           </a:p>
         </p:txBody>
@@ -31827,7 +33128,7 @@
                 </a:solidFill>
                 <a:latin typeface="Arial"/>
               </a:rPr>
-              <a:t>DIFFUSION OUTPUT</a:t>
+              <a:t>DIFFUSION</a:t>
             </a:r>
           </a:p>
         </p:txBody>
@@ -31866,7 +33167,7 @@
                 </a:solidFill>
                 <a:latin typeface="Arial"/>
               </a:rPr>
-              <a:t>Generated profiles track the real OSDR PCA manifold</a:t>
+              <a:t>Diffusion learns tissue structure from noise</a:t>
             </a:r>
           </a:p>
         </p:txBody>
@@ -31905,14 +33206,14 @@
                 </a:solidFill>
                 <a:latin typeface="Arial"/>
               </a:rPr>
-              <a:t>Circles are locked real OSDR profiles; crosses are matched DDIM profiles from generation seed 5020.</a:t>
+              <a:t>The same PCA axes follow 1,024 generated profiles through reverse diffusion.</a:t>
             </a:r>
           </a:p>
         </p:txBody>
       </p:sp>
       <p:pic>
         <p:nvPicPr>
-          <p:cNvPr id="7" name="PCA of locked real and matched DDIM OSDR profiles by tissue and condition" descr="PCA of locked real and matched DDIM OSDR profiles by tissue and condition"/>
+          <p:cNvPr id="7" name="DDIM reverse trajectory at timesteps 1000, 200 and 0" descr="DDIM reverse trajectory at timesteps 1000, 200 and 0"/>
           <p:cNvPicPr>
             <a:picLocks noChangeAspect="1"/>
           </p:cNvPicPr>
@@ -31926,8 +33227,8 @@
         </p:blipFill>
         <p:spPr>
           <a:xfrm>
-            <a:off x="1009356" y="1700784"/>
-            <a:ext cx="10161095" cy="4169663"/>
+            <a:off x="310896" y="1735579"/>
+            <a:ext cx="11558016" cy="4100072"/>
           </a:xfrm>
           <a:prstGeom prst="rect">
             <a:avLst/>
@@ -31936,59 +33237,14 @@
       </p:pic>
       <p:sp>
         <p:nvSpPr>
-          <p:cNvPr id="8" name="Rounded Rectangle 7"/>
-          <p:cNvSpPr/>
-          <p:nvPr/>
-        </p:nvSpPr>
-        <p:spPr>
-          <a:xfrm>
-            <a:off x="438912" y="5907024"/>
-            <a:ext cx="11311128" cy="438912"/>
-          </a:xfrm>
-          <a:prstGeom prst="roundRect">
-            <a:avLst/>
-          </a:prstGeom>
-          <a:solidFill>
-            <a:srgbClr val="E9F1F7"/>
-          </a:solidFill>
-          <a:ln w="10160">
-            <a:solidFill>
-              <a:srgbClr val="C9DCE9"/>
-            </a:solidFill>
-          </a:ln>
-        </p:spPr>
-        <p:style>
-          <a:lnRef idx="1">
-            <a:schemeClr val="accent1"/>
-          </a:lnRef>
-          <a:fillRef idx="3">
-            <a:schemeClr val="accent1"/>
-          </a:fillRef>
-          <a:effectRef idx="2">
-            <a:schemeClr val="accent1"/>
-          </a:effectRef>
-          <a:fontRef idx="minor">
-            <a:schemeClr val="lt1"/>
-          </a:fontRef>
-        </p:style>
-        <p:txBody>
-          <a:bodyPr rtlCol="0" anchor="ctr"/>
-          <a:lstStyle/>
-          <a:p>
-            <a:pPr algn="ctr"/>
-          </a:p>
-        </p:txBody>
-      </p:sp>
-      <p:sp>
-        <p:nvSpPr>
-          <p:cNvPr id="9" name="TextBox 8"/>
+          <p:cNvPr id="8" name="TextBox 7"/>
           <p:cNvSpPr txBox="1"/>
           <p:nvPr/>
         </p:nvSpPr>
         <p:spPr>
           <a:xfrm>
-            <a:off x="667512" y="5989320"/>
-            <a:ext cx="10844784" cy="246888"/>
+            <a:off x="713232" y="5943600"/>
+            <a:ext cx="2286000" cy="256032"/>
           </a:xfrm>
           <a:prstGeom prst="rect">
             <a:avLst/>
@@ -32007,13 +33263,52 @@
               </a:spcAft>
             </a:pPr>
             <a:r>
-              <a:rPr sz="1330" b="1" i="0">
-                <a:solidFill>
-                  <a:srgbClr val="082B55"/>
+              <a:rPr sz="1300" b="1" i="0">
+                <a:solidFill>
+                  <a:srgbClr val="59697A"/>
                 </a:solidFill>
                 <a:latin typeface="Arial"/>
               </a:rPr>
-              <a:t>Interpretation: tissue structure dominates; FLT and GC are subtler. PCA is descriptive, so quantitative metrics determine validation.</a:t>
+              <a:t>t = 1000: noise</a:t>
+            </a:r>
+          </a:p>
+        </p:txBody>
+      </p:sp>
+      <p:sp>
+        <p:nvSpPr>
+          <p:cNvPr id="9" name="TextBox 8"/>
+          <p:cNvSpPr txBox="1"/>
+          <p:nvPr/>
+        </p:nvSpPr>
+        <p:spPr>
+          <a:xfrm>
+            <a:off x="4782312" y="5943600"/>
+            <a:ext cx="2651760" cy="256032"/>
+          </a:xfrm>
+          <a:prstGeom prst="rect">
+            <a:avLst/>
+          </a:prstGeom>
+          <a:noFill/>
+        </p:spPr>
+        <p:txBody>
+          <a:bodyPr wrap="square" lIns="18288" rIns="18288" tIns="18288" bIns="18288" anchor="t">
+            <a:spAutoFit/>
+          </a:bodyPr>
+          <a:lstStyle/>
+          <a:p>
+            <a:pPr algn="ctr">
+              <a:spcAft>
+                <a:spcPts val="0"/>
+              </a:spcAft>
+            </a:pPr>
+            <a:r>
+              <a:rPr sz="1300" b="1" i="0">
+                <a:solidFill>
+                  <a:srgbClr val="59697A"/>
+                </a:solidFill>
+                <a:latin typeface="Arial"/>
+              </a:rPr>
+              <a:t>t = 200: partial structure</a:t>
             </a:r>
           </a:p>
         </p:txBody>
@@ -32021,6 +33316,45 @@
       <p:sp>
         <p:nvSpPr>
           <p:cNvPr id="10" name="TextBox 9"/>
+          <p:cNvSpPr txBox="1"/>
+          <p:nvPr/>
+        </p:nvSpPr>
+        <p:spPr>
+          <a:xfrm>
+            <a:off x="8366760" y="5943600"/>
+            <a:ext cx="3108960" cy="256032"/>
+          </a:xfrm>
+          <a:prstGeom prst="rect">
+            <a:avLst/>
+          </a:prstGeom>
+          <a:noFill/>
+        </p:spPr>
+        <p:txBody>
+          <a:bodyPr wrap="square" lIns="18288" rIns="18288" tIns="18288" bIns="18288" anchor="t">
+            <a:spAutoFit/>
+          </a:bodyPr>
+          <a:lstStyle/>
+          <a:p>
+            <a:pPr algn="ctr">
+              <a:spcAft>
+                <a:spcPts val="0"/>
+              </a:spcAft>
+            </a:pPr>
+            <a:r>
+              <a:rPr sz="1300" b="1" i="0">
+                <a:solidFill>
+                  <a:srgbClr val="178681"/>
+                </a:solidFill>
+                <a:latin typeface="Arial"/>
+              </a:rPr>
+              <a:t>t = 0: tissue-conditioned profiles</a:t>
+            </a:r>
+          </a:p>
+        </p:txBody>
+      </p:sp>
+      <p:sp>
+        <p:nvSpPr>
+          <p:cNvPr id="11" name="TextBox 10"/>
           <p:cNvSpPr txBox="1"/>
           <p:nvPr/>
         </p:nvSpPr>
@@ -32052,7 +33386,7 @@
                 </a:solidFill>
                 <a:latin typeface="Arial"/>
               </a:rPr>
-              <a:t>PCA was fitted in the common locked OSDR expression space. This is PCA, not UMAP.</a:t>
+              <a:t>Gray points are real ARCHS4 profiles; colors identify generated tissue conditions. PC1 and PC2 limits are shared across panels.</a:t>
             </a:r>
           </a:p>
         </p:txBody>
@@ -32143,7 +33477,7 @@
                 </a:solidFill>
                 <a:latin typeface="Arial"/>
               </a:rPr>
-              <a:t>VALIDATION</a:t>
+              <a:t>DIFFUSION OUTPUT</a:t>
             </a:r>
           </a:p>
         </p:txBody>
@@ -32182,7 +33516,7 @@
                 </a:solidFill>
                 <a:latin typeface="Arial"/>
               </a:rPr>
-              <a:t>DDIM matched expression and reduced separability</a:t>
+              <a:t>Generated profiles track the real OSDR PCA manifold</a:t>
             </a:r>
           </a:p>
         </p:txBody>
@@ -32221,21 +33555,45 @@
                 </a:solidFill>
                 <a:latin typeface="Arial"/>
               </a:rPr>
-              <a:t>AA closer to 0.5 means a classifier has less success separating real and generated profiles; lower FD is better.</a:t>
-            </a:r>
-          </a:p>
-        </p:txBody>
-      </p:sp>
-      <p:sp>
-        <p:nvSpPr>
-          <p:cNvPr id="7" name="Rounded Rectangle 6"/>
+              <a:t>Circles are locked real OSDR profiles; crosses are matched DDIM profiles from generation seed 5020.</a:t>
+            </a:r>
+          </a:p>
+        </p:txBody>
+      </p:sp>
+      <p:pic>
+        <p:nvPicPr>
+          <p:cNvPr id="7" name="PCA of locked real and matched DDIM OSDR profiles by tissue and condition" descr="PCA of locked real and matched DDIM OSDR profiles by tissue and condition"/>
+          <p:cNvPicPr>
+            <a:picLocks noChangeAspect="1"/>
+          </p:cNvPicPr>
+          <p:nvPr/>
+        </p:nvPicPr>
+        <p:blipFill>
+          <a:blip r:embed="rId2"/>
+          <a:stretch>
+            <a:fillRect/>
+          </a:stretch>
+        </p:blipFill>
+        <p:spPr>
+          <a:xfrm>
+            <a:off x="1009356" y="1700784"/>
+            <a:ext cx="10161095" cy="4169663"/>
+          </a:xfrm>
+          <a:prstGeom prst="rect">
+            <a:avLst/>
+          </a:prstGeom>
+        </p:spPr>
+      </p:pic>
+      <p:sp>
+        <p:nvSpPr>
+          <p:cNvPr id="8" name="Rounded Rectangle 7"/>
           <p:cNvSpPr/>
           <p:nvPr/>
         </p:nvSpPr>
         <p:spPr>
           <a:xfrm>
-            <a:off x="347472" y="1847088"/>
-            <a:ext cx="3703320" cy="3401568"/>
+            <a:off x="438912" y="5907024"/>
+            <a:ext cx="11311128" cy="438912"/>
           </a:xfrm>
           <a:prstGeom prst="roundRect">
             <a:avLst/>
@@ -32273,14 +33631,14 @@
       </p:sp>
       <p:sp>
         <p:nvSpPr>
-          <p:cNvPr id="8" name="TextBox 7"/>
+          <p:cNvPr id="9" name="TextBox 8"/>
           <p:cNvSpPr txBox="1"/>
           <p:nvPr/>
         </p:nvSpPr>
         <p:spPr>
           <a:xfrm>
-            <a:off x="612648" y="2103120"/>
-            <a:ext cx="3154680" cy="320040"/>
+            <a:off x="667512" y="5989320"/>
+            <a:ext cx="10844784" cy="246888"/>
           </a:xfrm>
           <a:prstGeom prst="rect">
             <a:avLst/>
@@ -32289,6 +33647,45 @@
         </p:spPr>
         <p:txBody>
           <a:bodyPr wrap="square" lIns="18288" rIns="18288" tIns="18288" bIns="18288" anchor="t">
+            <a:spAutoFit/>
+          </a:bodyPr>
+          <a:lstStyle/>
+          <a:p>
+            <a:pPr algn="ctr">
+              <a:spcAft>
+                <a:spcPts val="0"/>
+              </a:spcAft>
+            </a:pPr>
+            <a:r>
+              <a:rPr sz="1330" b="1" i="0">
+                <a:solidFill>
+                  <a:srgbClr val="082B55"/>
+                </a:solidFill>
+                <a:latin typeface="Arial"/>
+              </a:rPr>
+              <a:t>Interpretation: tissue structure dominates; FLT and GC are subtler. PCA is descriptive, so quantitative metrics determine validation.</a:t>
+            </a:r>
+          </a:p>
+        </p:txBody>
+      </p:sp>
+      <p:sp>
+        <p:nvSpPr>
+          <p:cNvPr id="10" name="TextBox 9"/>
+          <p:cNvSpPr txBox="1"/>
+          <p:nvPr/>
+        </p:nvSpPr>
+        <p:spPr>
+          <a:xfrm>
+            <a:off x="329184" y="6510528"/>
+            <a:ext cx="10972800" cy="173736"/>
+          </a:xfrm>
+          <a:prstGeom prst="rect">
+            <a:avLst/>
+          </a:prstGeom>
+          <a:noFill/>
+        </p:spPr>
+        <p:txBody>
+          <a:bodyPr wrap="square" lIns="18288" rIns="18288" tIns="18288" bIns="18288" anchor="ctr">
             <a:spAutoFit/>
           </a:bodyPr>
           <a:lstStyle/>
@@ -32299,1410 +33696,13 @@
               </a:spcAft>
             </a:pPr>
             <a:r>
-              <a:rPr sz="1700" b="1" i="0">
-                <a:solidFill>
-                  <a:srgbClr val="2D6496"/>
+              <a:rPr sz="720" b="0" i="0">
+                <a:solidFill>
+                  <a:srgbClr val="8A969E"/>
                 </a:solidFill>
                 <a:latin typeface="Arial"/>
               </a:rPr>
-              <a:t>ARCHS4 tissue probe</a:t>
-            </a:r>
-          </a:p>
-        </p:txBody>
-      </p:sp>
-      <p:sp>
-        <p:nvSpPr>
-          <p:cNvPr id="9" name="TextBox 8"/>
-          <p:cNvSpPr txBox="1"/>
-          <p:nvPr/>
-        </p:nvSpPr>
-        <p:spPr>
-          <a:xfrm>
-            <a:off x="621792" y="2487168"/>
-            <a:ext cx="3063240" cy="274320"/>
-          </a:xfrm>
-          <a:prstGeom prst="rect">
-            <a:avLst/>
-          </a:prstGeom>
-          <a:noFill/>
-        </p:spPr>
-        <p:txBody>
-          <a:bodyPr wrap="square" lIns="18288" rIns="18288" tIns="18288" bIns="18288" anchor="t">
-            <a:spAutoFit/>
-          </a:bodyPr>
-          <a:lstStyle/>
-          <a:p>
-            <a:pPr algn="l">
-              <a:spcAft>
-                <a:spcPts val="0"/>
-              </a:spcAft>
-            </a:pPr>
-            <a:r>
-              <a:rPr sz="1250" b="0" i="0">
-                <a:solidFill>
-                  <a:srgbClr val="59697A"/>
-                </a:solidFill>
-                <a:latin typeface="Arial"/>
-              </a:rPr>
-              <a:t>Balanced accuracy on held-out real profiles</a:t>
-            </a:r>
-          </a:p>
-        </p:txBody>
-      </p:sp>
-      <p:sp>
-        <p:nvSpPr>
-          <p:cNvPr id="10" name="Rectangle 9"/>
-          <p:cNvSpPr/>
-          <p:nvPr/>
-        </p:nvSpPr>
-        <p:spPr>
-          <a:xfrm>
-            <a:off x="950976" y="3436845"/>
-            <a:ext cx="786384" cy="1299746"/>
-          </a:xfrm>
-          <a:prstGeom prst="rect">
-            <a:avLst/>
-          </a:prstGeom>
-          <a:solidFill>
-            <a:srgbClr val="8A969E"/>
-          </a:solidFill>
-          <a:ln>
-            <a:noFill/>
-          </a:ln>
-        </p:spPr>
-        <p:style>
-          <a:lnRef idx="1">
-            <a:schemeClr val="accent1"/>
-          </a:lnRef>
-          <a:fillRef idx="3">
-            <a:schemeClr val="accent1"/>
-          </a:fillRef>
-          <a:effectRef idx="2">
-            <a:schemeClr val="accent1"/>
-          </a:effectRef>
-          <a:fontRef idx="minor">
-            <a:schemeClr val="lt1"/>
-          </a:fontRef>
-        </p:style>
-        <p:txBody>
-          <a:bodyPr rtlCol="0" anchor="ctr"/>
-          <a:lstStyle/>
-          <a:p>
-            <a:pPr algn="ctr"/>
-          </a:p>
-        </p:txBody>
-      </p:sp>
-      <p:sp>
-        <p:nvSpPr>
-          <p:cNvPr id="11" name="TextBox 10"/>
-          <p:cNvSpPr txBox="1"/>
-          <p:nvPr/>
-        </p:nvSpPr>
-        <p:spPr>
-          <a:xfrm>
-            <a:off x="923544" y="3107661"/>
-            <a:ext cx="868680" cy="274320"/>
-          </a:xfrm>
-          <a:prstGeom prst="rect">
-            <a:avLst/>
-          </a:prstGeom>
-          <a:noFill/>
-        </p:spPr>
-        <p:txBody>
-          <a:bodyPr wrap="square" lIns="18288" rIns="18288" tIns="18288" bIns="18288" anchor="t">
-            <a:spAutoFit/>
-          </a:bodyPr>
-          <a:lstStyle/>
-          <a:p>
-            <a:pPr algn="ctr">
-              <a:spcAft>
-                <a:spcPts val="0"/>
-              </a:spcAft>
-            </a:pPr>
-            <a:r>
-              <a:rPr sz="1600" b="1" i="0">
-                <a:solidFill>
-                  <a:srgbClr val="082B55"/>
-                </a:solidFill>
-                <a:latin typeface="Arial"/>
-              </a:rPr>
-              <a:t>0.781</a:t>
-            </a:r>
-          </a:p>
-        </p:txBody>
-      </p:sp>
-      <p:sp>
-        <p:nvSpPr>
-          <p:cNvPr id="12" name="TextBox 11"/>
-          <p:cNvSpPr txBox="1"/>
-          <p:nvPr/>
-        </p:nvSpPr>
-        <p:spPr>
-          <a:xfrm>
-            <a:off x="676656" y="4809744"/>
-            <a:ext cx="1325880" cy="365760"/>
-          </a:xfrm>
-          <a:prstGeom prst="rect">
-            <a:avLst/>
-          </a:prstGeom>
-          <a:noFill/>
-        </p:spPr>
-        <p:txBody>
-          <a:bodyPr wrap="square" lIns="18288" rIns="18288" tIns="18288" bIns="18288" anchor="t">
-            <a:spAutoFit/>
-          </a:bodyPr>
-          <a:lstStyle/>
-          <a:p>
-            <a:pPr algn="ctr">
-              <a:spcAft>
-                <a:spcPts val="0"/>
-              </a:spcAft>
-            </a:pPr>
-            <a:r>
-              <a:rPr sz="1250" b="0" i="0">
-                <a:solidFill>
-                  <a:srgbClr val="263746"/>
-                </a:solidFill>
-                <a:latin typeface="Arial"/>
-              </a:rPr>
-              <a:t>Real-trained</a:t>
-            </a:r>
-          </a:p>
-        </p:txBody>
-      </p:sp>
-      <p:sp>
-        <p:nvSpPr>
-          <p:cNvPr id="13" name="Rectangle 12"/>
-          <p:cNvSpPr/>
-          <p:nvPr/>
-        </p:nvSpPr>
-        <p:spPr>
-          <a:xfrm>
-            <a:off x="2523744" y="3436845"/>
-            <a:ext cx="786384" cy="1299746"/>
-          </a:xfrm>
-          <a:prstGeom prst="rect">
-            <a:avLst/>
-          </a:prstGeom>
-          <a:solidFill>
-            <a:srgbClr val="178681"/>
-          </a:solidFill>
-          <a:ln>
-            <a:noFill/>
-          </a:ln>
-        </p:spPr>
-        <p:style>
-          <a:lnRef idx="1">
-            <a:schemeClr val="accent1"/>
-          </a:lnRef>
-          <a:fillRef idx="3">
-            <a:schemeClr val="accent1"/>
-          </a:fillRef>
-          <a:effectRef idx="2">
-            <a:schemeClr val="accent1"/>
-          </a:effectRef>
-          <a:fontRef idx="minor">
-            <a:schemeClr val="lt1"/>
-          </a:fontRef>
-        </p:style>
-        <p:txBody>
-          <a:bodyPr rtlCol="0" anchor="ctr"/>
-          <a:lstStyle/>
-          <a:p>
-            <a:pPr algn="ctr"/>
-          </a:p>
-        </p:txBody>
-      </p:sp>
-      <p:sp>
-        <p:nvSpPr>
-          <p:cNvPr id="14" name="TextBox 13"/>
-          <p:cNvSpPr txBox="1"/>
-          <p:nvPr/>
-        </p:nvSpPr>
-        <p:spPr>
-          <a:xfrm>
-            <a:off x="2496312" y="3107661"/>
-            <a:ext cx="868680" cy="274320"/>
-          </a:xfrm>
-          <a:prstGeom prst="rect">
-            <a:avLst/>
-          </a:prstGeom>
-          <a:noFill/>
-        </p:spPr>
-        <p:txBody>
-          <a:bodyPr wrap="square" lIns="18288" rIns="18288" tIns="18288" bIns="18288" anchor="t">
-            <a:spAutoFit/>
-          </a:bodyPr>
-          <a:lstStyle/>
-          <a:p>
-            <a:pPr algn="ctr">
-              <a:spcAft>
-                <a:spcPts val="0"/>
-              </a:spcAft>
-            </a:pPr>
-            <a:r>
-              <a:rPr sz="1600" b="1" i="0">
-                <a:solidFill>
-                  <a:srgbClr val="082B55"/>
-                </a:solidFill>
-                <a:latin typeface="Arial"/>
-              </a:rPr>
-              <a:t>0.781</a:t>
-            </a:r>
-          </a:p>
-        </p:txBody>
-      </p:sp>
-      <p:sp>
-        <p:nvSpPr>
-          <p:cNvPr id="15" name="TextBox 14"/>
-          <p:cNvSpPr txBox="1"/>
-          <p:nvPr/>
-        </p:nvSpPr>
-        <p:spPr>
-          <a:xfrm>
-            <a:off x="2249424" y="4809744"/>
-            <a:ext cx="1325880" cy="365760"/>
-          </a:xfrm>
-          <a:prstGeom prst="rect">
-            <a:avLst/>
-          </a:prstGeom>
-          <a:noFill/>
-        </p:spPr>
-        <p:txBody>
-          <a:bodyPr wrap="square" lIns="18288" rIns="18288" tIns="18288" bIns="18288" anchor="t">
-            <a:spAutoFit/>
-          </a:bodyPr>
-          <a:lstStyle/>
-          <a:p>
-            <a:pPr algn="ctr">
-              <a:spcAft>
-                <a:spcPts val="0"/>
-              </a:spcAft>
-            </a:pPr>
-            <a:r>
-              <a:rPr sz="1250" b="0" i="0">
-                <a:solidFill>
-                  <a:srgbClr val="263746"/>
-                </a:solidFill>
-                <a:latin typeface="Arial"/>
-              </a:rPr>
-              <a:t>Synthetic-trained</a:t>
-            </a:r>
-          </a:p>
-        </p:txBody>
-      </p:sp>
-      <p:sp>
-        <p:nvSpPr>
-          <p:cNvPr id="16" name="Rectangle 15"/>
-          <p:cNvSpPr/>
-          <p:nvPr/>
-        </p:nvSpPr>
-        <p:spPr>
-          <a:xfrm>
-            <a:off x="749808" y="4736592"/>
-            <a:ext cx="2880360" cy="13716"/>
-          </a:xfrm>
-          <a:prstGeom prst="rect">
-            <a:avLst/>
-          </a:prstGeom>
-          <a:solidFill>
-            <a:srgbClr val="A9B5BC"/>
-          </a:solidFill>
-          <a:ln>
-            <a:noFill/>
-          </a:ln>
-        </p:spPr>
-        <p:style>
-          <a:lnRef idx="1">
-            <a:schemeClr val="accent1"/>
-          </a:lnRef>
-          <a:fillRef idx="3">
-            <a:schemeClr val="accent1"/>
-          </a:fillRef>
-          <a:effectRef idx="2">
-            <a:schemeClr val="accent1"/>
-          </a:effectRef>
-          <a:fontRef idx="minor">
-            <a:schemeClr val="lt1"/>
-          </a:fontRef>
-        </p:style>
-        <p:txBody>
-          <a:bodyPr rtlCol="0" anchor="ctr"/>
-          <a:lstStyle/>
-          <a:p>
-            <a:pPr algn="ctr"/>
-          </a:p>
-        </p:txBody>
-      </p:sp>
-      <p:sp>
-        <p:nvSpPr>
-          <p:cNvPr id="17" name="Rounded Rectangle 16"/>
-          <p:cNvSpPr/>
-          <p:nvPr/>
-        </p:nvSpPr>
-        <p:spPr>
-          <a:xfrm>
-            <a:off x="4315968" y="1847088"/>
-            <a:ext cx="7525512" cy="3401568"/>
-          </a:xfrm>
-          <a:prstGeom prst="roundRect">
-            <a:avLst/>
-          </a:prstGeom>
-          <a:solidFill>
-            <a:srgbClr val="FFFFFF"/>
-          </a:solidFill>
-          <a:ln w="10160">
-            <a:solidFill>
-              <a:srgbClr val="DDE4E8"/>
-            </a:solidFill>
-          </a:ln>
-        </p:spPr>
-        <p:style>
-          <a:lnRef idx="1">
-            <a:schemeClr val="accent1"/>
-          </a:lnRef>
-          <a:fillRef idx="3">
-            <a:schemeClr val="accent1"/>
-          </a:fillRef>
-          <a:effectRef idx="2">
-            <a:schemeClr val="accent1"/>
-          </a:effectRef>
-          <a:fontRef idx="minor">
-            <a:schemeClr val="lt1"/>
-          </a:fontRef>
-        </p:style>
-        <p:txBody>
-          <a:bodyPr rtlCol="0" anchor="ctr"/>
-          <a:lstStyle/>
-          <a:p>
-            <a:pPr algn="ctr"/>
-          </a:p>
-        </p:txBody>
-      </p:sp>
-      <p:sp>
-        <p:nvSpPr>
-          <p:cNvPr id="18" name="TextBox 17"/>
-          <p:cNvSpPr txBox="1"/>
-          <p:nvPr/>
-        </p:nvSpPr>
-        <p:spPr>
-          <a:xfrm>
-            <a:off x="4599432" y="2075688"/>
-            <a:ext cx="1417320" cy="256032"/>
-          </a:xfrm>
-          <a:prstGeom prst="rect">
-            <a:avLst/>
-          </a:prstGeom>
-          <a:noFill/>
-        </p:spPr>
-        <p:txBody>
-          <a:bodyPr wrap="square" lIns="18288" rIns="18288" tIns="18288" bIns="18288" anchor="t">
-            <a:spAutoFit/>
-          </a:bodyPr>
-          <a:lstStyle/>
-          <a:p>
-            <a:pPr algn="l">
-              <a:spcAft>
-                <a:spcPts val="0"/>
-              </a:spcAft>
-            </a:pPr>
-            <a:r>
-              <a:rPr sz="1250" b="1" i="0">
-                <a:solidFill>
-                  <a:srgbClr val="59697A"/>
-                </a:solidFill>
-                <a:latin typeface="Arial"/>
-              </a:rPr>
-              <a:t>Metric</a:t>
-            </a:r>
-          </a:p>
-        </p:txBody>
-      </p:sp>
-      <p:sp>
-        <p:nvSpPr>
-          <p:cNvPr id="19" name="TextBox 18"/>
-          <p:cNvSpPr txBox="1"/>
-          <p:nvPr/>
-        </p:nvSpPr>
-        <p:spPr>
-          <a:xfrm>
-            <a:off x="6537960" y="2075688"/>
-            <a:ext cx="1234440" cy="256032"/>
-          </a:xfrm>
-          <a:prstGeom prst="rect">
-            <a:avLst/>
-          </a:prstGeom>
-          <a:noFill/>
-        </p:spPr>
-        <p:txBody>
-          <a:bodyPr wrap="square" lIns="18288" rIns="18288" tIns="18288" bIns="18288" anchor="t">
-            <a:spAutoFit/>
-          </a:bodyPr>
-          <a:lstStyle/>
-          <a:p>
-            <a:pPr algn="ctr">
-              <a:spcAft>
-                <a:spcPts val="0"/>
-              </a:spcAft>
-            </a:pPr>
-            <a:r>
-              <a:rPr sz="1250" b="1" i="0">
-                <a:solidFill>
-                  <a:srgbClr val="D96552"/>
-                </a:solidFill>
-                <a:latin typeface="Arial"/>
-              </a:rPr>
-              <a:t>WGAN-GP</a:t>
-            </a:r>
-          </a:p>
-        </p:txBody>
-      </p:sp>
-      <p:sp>
-        <p:nvSpPr>
-          <p:cNvPr id="20" name="TextBox 19"/>
-          <p:cNvSpPr txBox="1"/>
-          <p:nvPr/>
-        </p:nvSpPr>
-        <p:spPr>
-          <a:xfrm>
-            <a:off x="8257031" y="2075688"/>
-            <a:ext cx="1234440" cy="256032"/>
-          </a:xfrm>
-          <a:prstGeom prst="rect">
-            <a:avLst/>
-          </a:prstGeom>
-          <a:noFill/>
-        </p:spPr>
-        <p:txBody>
-          <a:bodyPr wrap="square" lIns="18288" rIns="18288" tIns="18288" bIns="18288" anchor="t">
-            <a:spAutoFit/>
-          </a:bodyPr>
-          <a:lstStyle/>
-          <a:p>
-            <a:pPr algn="ctr">
-              <a:spcAft>
-                <a:spcPts val="0"/>
-              </a:spcAft>
-            </a:pPr>
-            <a:r>
-              <a:rPr sz="1250" b="1" i="0">
-                <a:solidFill>
-                  <a:srgbClr val="178681"/>
-                </a:solidFill>
-                <a:latin typeface="Arial"/>
-              </a:rPr>
-              <a:t>DDIM</a:t>
-            </a:r>
-          </a:p>
-        </p:txBody>
-      </p:sp>
-      <p:sp>
-        <p:nvSpPr>
-          <p:cNvPr id="21" name="TextBox 20"/>
-          <p:cNvSpPr txBox="1"/>
-          <p:nvPr/>
-        </p:nvSpPr>
-        <p:spPr>
-          <a:xfrm>
-            <a:off x="9802368" y="2075688"/>
-            <a:ext cx="1627632" cy="256032"/>
-          </a:xfrm>
-          <a:prstGeom prst="rect">
-            <a:avLst/>
-          </a:prstGeom>
-          <a:noFill/>
-        </p:spPr>
-        <p:txBody>
-          <a:bodyPr wrap="square" lIns="18288" rIns="18288" tIns="18288" bIns="18288" anchor="t">
-            <a:spAutoFit/>
-          </a:bodyPr>
-          <a:lstStyle/>
-          <a:p>
-            <a:pPr algn="l">
-              <a:spcAft>
-                <a:spcPts val="0"/>
-              </a:spcAft>
-            </a:pPr>
-            <a:r>
-              <a:rPr sz="1250" b="1" i="0">
-                <a:solidFill>
-                  <a:srgbClr val="59697A"/>
-                </a:solidFill>
-                <a:latin typeface="Arial"/>
-              </a:rPr>
-              <a:t>Reading</a:t>
-            </a:r>
-          </a:p>
-        </p:txBody>
-      </p:sp>
-      <p:sp>
-        <p:nvSpPr>
-          <p:cNvPr id="22" name="Rectangle 21"/>
-          <p:cNvSpPr/>
-          <p:nvPr/>
-        </p:nvSpPr>
-        <p:spPr>
-          <a:xfrm>
-            <a:off x="4517136" y="2478024"/>
-            <a:ext cx="7059168" cy="484632"/>
-          </a:xfrm>
-          <a:prstGeom prst="rect">
-            <a:avLst/>
-          </a:prstGeom>
-          <a:solidFill>
-            <a:srgbClr val="F5F7F8"/>
-          </a:solidFill>
-          <a:ln>
-            <a:noFill/>
-          </a:ln>
-        </p:spPr>
-        <p:style>
-          <a:lnRef idx="1">
-            <a:schemeClr val="accent1"/>
-          </a:lnRef>
-          <a:fillRef idx="3">
-            <a:schemeClr val="accent1"/>
-          </a:fillRef>
-          <a:effectRef idx="2">
-            <a:schemeClr val="accent1"/>
-          </a:effectRef>
-          <a:fontRef idx="minor">
-            <a:schemeClr val="lt1"/>
-          </a:fontRef>
-        </p:style>
-        <p:txBody>
-          <a:bodyPr rtlCol="0" anchor="ctr"/>
-          <a:lstStyle/>
-          <a:p>
-            <a:pPr algn="ctr"/>
-          </a:p>
-        </p:txBody>
-      </p:sp>
-      <p:sp>
-        <p:nvSpPr>
-          <p:cNvPr id="23" name="TextBox 22"/>
-          <p:cNvSpPr txBox="1"/>
-          <p:nvPr/>
-        </p:nvSpPr>
-        <p:spPr>
-          <a:xfrm>
-            <a:off x="4599432" y="2542032"/>
-            <a:ext cx="1783080" cy="310896"/>
-          </a:xfrm>
-          <a:prstGeom prst="rect">
-            <a:avLst/>
-          </a:prstGeom>
-          <a:noFill/>
-        </p:spPr>
-        <p:txBody>
-          <a:bodyPr wrap="square" lIns="18288" rIns="18288" tIns="18288" bIns="18288" anchor="t">
-            <a:spAutoFit/>
-          </a:bodyPr>
-          <a:lstStyle/>
-          <a:p>
-            <a:pPr algn="l">
-              <a:spcAft>
-                <a:spcPts val="0"/>
-              </a:spcAft>
-            </a:pPr>
-            <a:r>
-              <a:rPr sz="1400" b="0" i="0">
-                <a:solidFill>
-                  <a:srgbClr val="263746"/>
-                </a:solidFill>
-                <a:latin typeface="Arial"/>
-              </a:rPr>
-              <a:t>Correlation</a:t>
-            </a:r>
-          </a:p>
-        </p:txBody>
-      </p:sp>
-      <p:sp>
-        <p:nvSpPr>
-          <p:cNvPr id="24" name="TextBox 23"/>
-          <p:cNvSpPr txBox="1"/>
-          <p:nvPr/>
-        </p:nvSpPr>
-        <p:spPr>
-          <a:xfrm>
-            <a:off x="6519672" y="2542032"/>
-            <a:ext cx="1261872" cy="310896"/>
-          </a:xfrm>
-          <a:prstGeom prst="rect">
-            <a:avLst/>
-          </a:prstGeom>
-          <a:noFill/>
-        </p:spPr>
-        <p:txBody>
-          <a:bodyPr wrap="square" lIns="18288" rIns="18288" tIns="18288" bIns="18288" anchor="t">
-            <a:spAutoFit/>
-          </a:bodyPr>
-          <a:lstStyle/>
-          <a:p>
-            <a:pPr algn="ctr">
-              <a:spcAft>
-                <a:spcPts val="0"/>
-              </a:spcAft>
-            </a:pPr>
-            <a:r>
-              <a:rPr sz="1600" b="1" i="0">
-                <a:solidFill>
-                  <a:srgbClr val="D96552"/>
-                </a:solidFill>
-                <a:latin typeface="Arial"/>
-              </a:rPr>
-              <a:t>0.976</a:t>
-            </a:r>
-          </a:p>
-        </p:txBody>
-      </p:sp>
-      <p:sp>
-        <p:nvSpPr>
-          <p:cNvPr id="25" name="TextBox 24"/>
-          <p:cNvSpPr txBox="1"/>
-          <p:nvPr/>
-        </p:nvSpPr>
-        <p:spPr>
-          <a:xfrm>
-            <a:off x="8238744" y="2542032"/>
-            <a:ext cx="1261872" cy="310896"/>
-          </a:xfrm>
-          <a:prstGeom prst="rect">
-            <a:avLst/>
-          </a:prstGeom>
-          <a:noFill/>
-        </p:spPr>
-        <p:txBody>
-          <a:bodyPr wrap="square" lIns="18288" rIns="18288" tIns="18288" bIns="18288" anchor="t">
-            <a:spAutoFit/>
-          </a:bodyPr>
-          <a:lstStyle/>
-          <a:p>
-            <a:pPr algn="ctr">
-              <a:spcAft>
-                <a:spcPts val="0"/>
-              </a:spcAft>
-            </a:pPr>
-            <a:r>
-              <a:rPr sz="1600" b="1" i="0">
-                <a:solidFill>
-                  <a:srgbClr val="178681"/>
-                </a:solidFill>
-                <a:latin typeface="Arial"/>
-              </a:rPr>
-              <a:t>0.974</a:t>
-            </a:r>
-          </a:p>
-        </p:txBody>
-      </p:sp>
-      <p:sp>
-        <p:nvSpPr>
-          <p:cNvPr id="26" name="TextBox 25"/>
-          <p:cNvSpPr txBox="1"/>
-          <p:nvPr/>
-        </p:nvSpPr>
-        <p:spPr>
-          <a:xfrm>
-            <a:off x="9820656" y="2542032"/>
-            <a:ext cx="1481328" cy="310896"/>
-          </a:xfrm>
-          <a:prstGeom prst="rect">
-            <a:avLst/>
-          </a:prstGeom>
-          <a:noFill/>
-        </p:spPr>
-        <p:txBody>
-          <a:bodyPr wrap="square" lIns="18288" rIns="18288" tIns="18288" bIns="18288" anchor="t">
-            <a:spAutoFit/>
-          </a:bodyPr>
-          <a:lstStyle/>
-          <a:p>
-            <a:pPr algn="l">
-              <a:spcAft>
-                <a:spcPts val="0"/>
-              </a:spcAft>
-            </a:pPr>
-            <a:r>
-              <a:rPr sz="1350" b="0" i="0">
-                <a:solidFill>
-                  <a:srgbClr val="59697A"/>
-                </a:solidFill>
-                <a:latin typeface="Arial"/>
-              </a:rPr>
-              <a:t>similar</a:t>
-            </a:r>
-          </a:p>
-        </p:txBody>
-      </p:sp>
-      <p:sp>
-        <p:nvSpPr>
-          <p:cNvPr id="27" name="TextBox 26"/>
-          <p:cNvSpPr txBox="1"/>
-          <p:nvPr/>
-        </p:nvSpPr>
-        <p:spPr>
-          <a:xfrm>
-            <a:off x="4599432" y="3118103"/>
-            <a:ext cx="1783080" cy="310896"/>
-          </a:xfrm>
-          <a:prstGeom prst="rect">
-            <a:avLst/>
-          </a:prstGeom>
-          <a:noFill/>
-        </p:spPr>
-        <p:txBody>
-          <a:bodyPr wrap="square" lIns="18288" rIns="18288" tIns="18288" bIns="18288" anchor="t">
-            <a:spAutoFit/>
-          </a:bodyPr>
-          <a:lstStyle/>
-          <a:p>
-            <a:pPr algn="l">
-              <a:spcAft>
-                <a:spcPts val="0"/>
-              </a:spcAft>
-            </a:pPr>
-            <a:r>
-              <a:rPr sz="1400" b="0" i="0">
-                <a:solidFill>
-                  <a:srgbClr val="263746"/>
-                </a:solidFill>
-                <a:latin typeface="Arial"/>
-              </a:rPr>
-              <a:t>F1</a:t>
-            </a:r>
-          </a:p>
-        </p:txBody>
-      </p:sp>
-      <p:sp>
-        <p:nvSpPr>
-          <p:cNvPr id="28" name="TextBox 27"/>
-          <p:cNvSpPr txBox="1"/>
-          <p:nvPr/>
-        </p:nvSpPr>
-        <p:spPr>
-          <a:xfrm>
-            <a:off x="6519672" y="3118103"/>
-            <a:ext cx="1261872" cy="310896"/>
-          </a:xfrm>
-          <a:prstGeom prst="rect">
-            <a:avLst/>
-          </a:prstGeom>
-          <a:noFill/>
-        </p:spPr>
-        <p:txBody>
-          <a:bodyPr wrap="square" lIns="18288" rIns="18288" tIns="18288" bIns="18288" anchor="t">
-            <a:spAutoFit/>
-          </a:bodyPr>
-          <a:lstStyle/>
-          <a:p>
-            <a:pPr algn="ctr">
-              <a:spcAft>
-                <a:spcPts val="0"/>
-              </a:spcAft>
-            </a:pPr>
-            <a:r>
-              <a:rPr sz="1600" b="1" i="0">
-                <a:solidFill>
-                  <a:srgbClr val="D96552"/>
-                </a:solidFill>
-                <a:latin typeface="Arial"/>
-              </a:rPr>
-              <a:t>0.985</a:t>
-            </a:r>
-          </a:p>
-        </p:txBody>
-      </p:sp>
-      <p:sp>
-        <p:nvSpPr>
-          <p:cNvPr id="29" name="TextBox 28"/>
-          <p:cNvSpPr txBox="1"/>
-          <p:nvPr/>
-        </p:nvSpPr>
-        <p:spPr>
-          <a:xfrm>
-            <a:off x="8238744" y="3118103"/>
-            <a:ext cx="1261872" cy="310896"/>
-          </a:xfrm>
-          <a:prstGeom prst="rect">
-            <a:avLst/>
-          </a:prstGeom>
-          <a:noFill/>
-        </p:spPr>
-        <p:txBody>
-          <a:bodyPr wrap="square" lIns="18288" rIns="18288" tIns="18288" bIns="18288" anchor="t">
-            <a:spAutoFit/>
-          </a:bodyPr>
-          <a:lstStyle/>
-          <a:p>
-            <a:pPr algn="ctr">
-              <a:spcAft>
-                <a:spcPts val="0"/>
-              </a:spcAft>
-            </a:pPr>
-            <a:r>
-              <a:rPr sz="1600" b="1" i="0">
-                <a:solidFill>
-                  <a:srgbClr val="178681"/>
-                </a:solidFill>
-                <a:latin typeface="Arial"/>
-              </a:rPr>
-              <a:t>0.997</a:t>
-            </a:r>
-          </a:p>
-        </p:txBody>
-      </p:sp>
-      <p:sp>
-        <p:nvSpPr>
-          <p:cNvPr id="30" name="TextBox 29"/>
-          <p:cNvSpPr txBox="1"/>
-          <p:nvPr/>
-        </p:nvSpPr>
-        <p:spPr>
-          <a:xfrm>
-            <a:off x="9820656" y="3118103"/>
-            <a:ext cx="1481328" cy="310896"/>
-          </a:xfrm>
-          <a:prstGeom prst="rect">
-            <a:avLst/>
-          </a:prstGeom>
-          <a:noFill/>
-        </p:spPr>
-        <p:txBody>
-          <a:bodyPr wrap="square" lIns="18288" rIns="18288" tIns="18288" bIns="18288" anchor="t">
-            <a:spAutoFit/>
-          </a:bodyPr>
-          <a:lstStyle/>
-          <a:p>
-            <a:pPr algn="l">
-              <a:spcAft>
-                <a:spcPts val="0"/>
-              </a:spcAft>
-            </a:pPr>
-            <a:r>
-              <a:rPr sz="1350" b="0" i="0">
-                <a:solidFill>
-                  <a:srgbClr val="59697A"/>
-                </a:solidFill>
-                <a:latin typeface="Arial"/>
-              </a:rPr>
-              <a:t>higher</a:t>
-            </a:r>
-          </a:p>
-        </p:txBody>
-      </p:sp>
-      <p:sp>
-        <p:nvSpPr>
-          <p:cNvPr id="31" name="Rectangle 30"/>
-          <p:cNvSpPr/>
-          <p:nvPr/>
-        </p:nvSpPr>
-        <p:spPr>
-          <a:xfrm>
-            <a:off x="4517136" y="3630168"/>
-            <a:ext cx="7059168" cy="484632"/>
-          </a:xfrm>
-          <a:prstGeom prst="rect">
-            <a:avLst/>
-          </a:prstGeom>
-          <a:solidFill>
-            <a:srgbClr val="F5F7F8"/>
-          </a:solidFill>
-          <a:ln>
-            <a:noFill/>
-          </a:ln>
-        </p:spPr>
-        <p:style>
-          <a:lnRef idx="1">
-            <a:schemeClr val="accent1"/>
-          </a:lnRef>
-          <a:fillRef idx="3">
-            <a:schemeClr val="accent1"/>
-          </a:fillRef>
-          <a:effectRef idx="2">
-            <a:schemeClr val="accent1"/>
-          </a:effectRef>
-          <a:fontRef idx="minor">
-            <a:schemeClr val="lt1"/>
-          </a:fontRef>
-        </p:style>
-        <p:txBody>
-          <a:bodyPr rtlCol="0" anchor="ctr"/>
-          <a:lstStyle/>
-          <a:p>
-            <a:pPr algn="ctr"/>
-          </a:p>
-        </p:txBody>
-      </p:sp>
-      <p:sp>
-        <p:nvSpPr>
-          <p:cNvPr id="32" name="TextBox 31"/>
-          <p:cNvSpPr txBox="1"/>
-          <p:nvPr/>
-        </p:nvSpPr>
-        <p:spPr>
-          <a:xfrm>
-            <a:off x="4599432" y="3694176"/>
-            <a:ext cx="1783080" cy="310896"/>
-          </a:xfrm>
-          <a:prstGeom prst="rect">
-            <a:avLst/>
-          </a:prstGeom>
-          <a:noFill/>
-        </p:spPr>
-        <p:txBody>
-          <a:bodyPr wrap="square" lIns="18288" rIns="18288" tIns="18288" bIns="18288" anchor="t">
-            <a:spAutoFit/>
-          </a:bodyPr>
-          <a:lstStyle/>
-          <a:p>
-            <a:pPr algn="l">
-              <a:spcAft>
-                <a:spcPts val="0"/>
-              </a:spcAft>
-            </a:pPr>
-            <a:r>
-              <a:rPr sz="1400" b="1" i="0">
-                <a:solidFill>
-                  <a:srgbClr val="263746"/>
-                </a:solidFill>
-                <a:latin typeface="Arial"/>
-              </a:rPr>
-              <a:t>Adversarial accuracy</a:t>
-            </a:r>
-          </a:p>
-        </p:txBody>
-      </p:sp>
-      <p:sp>
-        <p:nvSpPr>
-          <p:cNvPr id="33" name="TextBox 32"/>
-          <p:cNvSpPr txBox="1"/>
-          <p:nvPr/>
-        </p:nvSpPr>
-        <p:spPr>
-          <a:xfrm>
-            <a:off x="6519672" y="3694176"/>
-            <a:ext cx="1261872" cy="310896"/>
-          </a:xfrm>
-          <a:prstGeom prst="rect">
-            <a:avLst/>
-          </a:prstGeom>
-          <a:noFill/>
-        </p:spPr>
-        <p:txBody>
-          <a:bodyPr wrap="square" lIns="18288" rIns="18288" tIns="18288" bIns="18288" anchor="t">
-            <a:spAutoFit/>
-          </a:bodyPr>
-          <a:lstStyle/>
-          <a:p>
-            <a:pPr algn="ctr">
-              <a:spcAft>
-                <a:spcPts val="0"/>
-              </a:spcAft>
-            </a:pPr>
-            <a:r>
-              <a:rPr sz="1600" b="1" i="0">
-                <a:solidFill>
-                  <a:srgbClr val="D96552"/>
-                </a:solidFill>
-                <a:latin typeface="Arial"/>
-              </a:rPr>
-              <a:t>0.636</a:t>
-            </a:r>
-          </a:p>
-        </p:txBody>
-      </p:sp>
-      <p:sp>
-        <p:nvSpPr>
-          <p:cNvPr id="34" name="TextBox 33"/>
-          <p:cNvSpPr txBox="1"/>
-          <p:nvPr/>
-        </p:nvSpPr>
-        <p:spPr>
-          <a:xfrm>
-            <a:off x="8238744" y="3694176"/>
-            <a:ext cx="1261872" cy="310896"/>
-          </a:xfrm>
-          <a:prstGeom prst="rect">
-            <a:avLst/>
-          </a:prstGeom>
-          <a:noFill/>
-        </p:spPr>
-        <p:txBody>
-          <a:bodyPr wrap="square" lIns="18288" rIns="18288" tIns="18288" bIns="18288" anchor="t">
-            <a:spAutoFit/>
-          </a:bodyPr>
-          <a:lstStyle/>
-          <a:p>
-            <a:pPr algn="ctr">
-              <a:spcAft>
-                <a:spcPts val="0"/>
-              </a:spcAft>
-            </a:pPr>
-            <a:r>
-              <a:rPr sz="1600" b="1" i="0">
-                <a:solidFill>
-                  <a:srgbClr val="178681"/>
-                </a:solidFill>
-                <a:latin typeface="Arial"/>
-              </a:rPr>
-              <a:t>0.475</a:t>
-            </a:r>
-          </a:p>
-        </p:txBody>
-      </p:sp>
-      <p:sp>
-        <p:nvSpPr>
-          <p:cNvPr id="35" name="TextBox 34"/>
-          <p:cNvSpPr txBox="1"/>
-          <p:nvPr/>
-        </p:nvSpPr>
-        <p:spPr>
-          <a:xfrm>
-            <a:off x="9820656" y="3694176"/>
-            <a:ext cx="1481328" cy="310896"/>
-          </a:xfrm>
-          <a:prstGeom prst="rect">
-            <a:avLst/>
-          </a:prstGeom>
-          <a:noFill/>
-        </p:spPr>
-        <p:txBody>
-          <a:bodyPr wrap="square" lIns="18288" rIns="18288" tIns="18288" bIns="18288" anchor="t">
-            <a:spAutoFit/>
-          </a:bodyPr>
-          <a:lstStyle/>
-          <a:p>
-            <a:pPr algn="l">
-              <a:spcAft>
-                <a:spcPts val="0"/>
-              </a:spcAft>
-            </a:pPr>
-            <a:r>
-              <a:rPr sz="1350" b="0" i="0">
-                <a:solidFill>
-                  <a:srgbClr val="59697A"/>
-                </a:solidFill>
-                <a:latin typeface="Arial"/>
-              </a:rPr>
-              <a:t>closer to 0.5</a:t>
-            </a:r>
-          </a:p>
-        </p:txBody>
-      </p:sp>
-      <p:sp>
-        <p:nvSpPr>
-          <p:cNvPr id="36" name="TextBox 35"/>
-          <p:cNvSpPr txBox="1"/>
-          <p:nvPr/>
-        </p:nvSpPr>
-        <p:spPr>
-          <a:xfrm>
-            <a:off x="4599432" y="4270248"/>
-            <a:ext cx="1783080" cy="310896"/>
-          </a:xfrm>
-          <a:prstGeom prst="rect">
-            <a:avLst/>
-          </a:prstGeom>
-          <a:noFill/>
-        </p:spPr>
-        <p:txBody>
-          <a:bodyPr wrap="square" lIns="18288" rIns="18288" tIns="18288" bIns="18288" anchor="t">
-            <a:spAutoFit/>
-          </a:bodyPr>
-          <a:lstStyle/>
-          <a:p>
-            <a:pPr algn="l">
-              <a:spcAft>
-                <a:spcPts val="0"/>
-              </a:spcAft>
-            </a:pPr>
-            <a:r>
-              <a:rPr sz="1400" b="1" i="0">
-                <a:solidFill>
-                  <a:srgbClr val="263746"/>
-                </a:solidFill>
-                <a:latin typeface="Arial"/>
-              </a:rPr>
-              <a:t>FD / real P95</a:t>
-            </a:r>
-          </a:p>
-        </p:txBody>
-      </p:sp>
-      <p:sp>
-        <p:nvSpPr>
-          <p:cNvPr id="37" name="TextBox 36"/>
-          <p:cNvSpPr txBox="1"/>
-          <p:nvPr/>
-        </p:nvSpPr>
-        <p:spPr>
-          <a:xfrm>
-            <a:off x="6519672" y="4270248"/>
-            <a:ext cx="1261872" cy="310896"/>
-          </a:xfrm>
-          <a:prstGeom prst="rect">
-            <a:avLst/>
-          </a:prstGeom>
-          <a:noFill/>
-        </p:spPr>
-        <p:txBody>
-          <a:bodyPr wrap="square" lIns="18288" rIns="18288" tIns="18288" bIns="18288" anchor="t">
-            <a:spAutoFit/>
-          </a:bodyPr>
-          <a:lstStyle/>
-          <a:p>
-            <a:pPr algn="ctr">
-              <a:spcAft>
-                <a:spcPts val="0"/>
-              </a:spcAft>
-            </a:pPr>
-            <a:r>
-              <a:rPr sz="1600" b="1" i="0">
-                <a:solidFill>
-                  <a:srgbClr val="D96552"/>
-                </a:solidFill>
-                <a:latin typeface="Arial"/>
-              </a:rPr>
-              <a:t>0.144</a:t>
-            </a:r>
-          </a:p>
-        </p:txBody>
-      </p:sp>
-      <p:sp>
-        <p:nvSpPr>
-          <p:cNvPr id="38" name="TextBox 37"/>
-          <p:cNvSpPr txBox="1"/>
-          <p:nvPr/>
-        </p:nvSpPr>
-        <p:spPr>
-          <a:xfrm>
-            <a:off x="8238744" y="4270248"/>
-            <a:ext cx="1261872" cy="310896"/>
-          </a:xfrm>
-          <a:prstGeom prst="rect">
-            <a:avLst/>
-          </a:prstGeom>
-          <a:noFill/>
-        </p:spPr>
-        <p:txBody>
-          <a:bodyPr wrap="square" lIns="18288" rIns="18288" tIns="18288" bIns="18288" anchor="t">
-            <a:spAutoFit/>
-          </a:bodyPr>
-          <a:lstStyle/>
-          <a:p>
-            <a:pPr algn="ctr">
-              <a:spcAft>
-                <a:spcPts val="0"/>
-              </a:spcAft>
-            </a:pPr>
-            <a:r>
-              <a:rPr sz="1600" b="1" i="0">
-                <a:solidFill>
-                  <a:srgbClr val="178681"/>
-                </a:solidFill>
-                <a:latin typeface="Arial"/>
-              </a:rPr>
-              <a:t>0.074</a:t>
-            </a:r>
-          </a:p>
-        </p:txBody>
-      </p:sp>
-      <p:sp>
-        <p:nvSpPr>
-          <p:cNvPr id="39" name="TextBox 38"/>
-          <p:cNvSpPr txBox="1"/>
-          <p:nvPr/>
-        </p:nvSpPr>
-        <p:spPr>
-          <a:xfrm>
-            <a:off x="9820656" y="4270248"/>
-            <a:ext cx="1481328" cy="310896"/>
-          </a:xfrm>
-          <a:prstGeom prst="rect">
-            <a:avLst/>
-          </a:prstGeom>
-          <a:noFill/>
-        </p:spPr>
-        <p:txBody>
-          <a:bodyPr wrap="square" lIns="18288" rIns="18288" tIns="18288" bIns="18288" anchor="t">
-            <a:spAutoFit/>
-          </a:bodyPr>
-          <a:lstStyle/>
-          <a:p>
-            <a:pPr algn="l">
-              <a:spcAft>
-                <a:spcPts val="0"/>
-              </a:spcAft>
-            </a:pPr>
-            <a:r>
-              <a:rPr sz="1350" b="0" i="0">
-                <a:solidFill>
-                  <a:srgbClr val="59697A"/>
-                </a:solidFill>
-                <a:latin typeface="Arial"/>
-              </a:rPr>
-              <a:t>lower</a:t>
-            </a:r>
-          </a:p>
-        </p:txBody>
-      </p:sp>
-      <p:sp>
-        <p:nvSpPr>
-          <p:cNvPr id="40" name="Rounded Rectangle 39"/>
-          <p:cNvSpPr/>
-          <p:nvPr/>
-        </p:nvSpPr>
-        <p:spPr>
-          <a:xfrm>
-            <a:off x="347472" y="5522976"/>
-            <a:ext cx="11494008" cy="667512"/>
-          </a:xfrm>
-          <a:prstGeom prst="roundRect">
-            <a:avLst/>
-          </a:prstGeom>
-          <a:solidFill>
-            <a:srgbClr val="082B55"/>
-          </a:solidFill>
-          <a:ln w="10160">
-            <a:solidFill>
-              <a:srgbClr val="082B55"/>
-            </a:solidFill>
-          </a:ln>
-        </p:spPr>
-        <p:style>
-          <a:lnRef idx="1">
-            <a:schemeClr val="accent1"/>
-          </a:lnRef>
-          <a:fillRef idx="3">
-            <a:schemeClr val="accent1"/>
-          </a:fillRef>
-          <a:effectRef idx="2">
-            <a:schemeClr val="accent1"/>
-          </a:effectRef>
-          <a:fontRef idx="minor">
-            <a:schemeClr val="lt1"/>
-          </a:fontRef>
-        </p:style>
-        <p:txBody>
-          <a:bodyPr rtlCol="0" anchor="ctr"/>
-          <a:lstStyle/>
-          <a:p>
-            <a:pPr algn="ctr"/>
-          </a:p>
-        </p:txBody>
-      </p:sp>
-      <p:sp>
-        <p:nvSpPr>
-          <p:cNvPr id="41" name="TextBox 40"/>
-          <p:cNvSpPr txBox="1"/>
-          <p:nvPr/>
-        </p:nvSpPr>
-        <p:spPr>
-          <a:xfrm>
-            <a:off x="658368" y="5660136"/>
-            <a:ext cx="2331720" cy="310896"/>
-          </a:xfrm>
-          <a:prstGeom prst="rect">
-            <a:avLst/>
-          </a:prstGeom>
-          <a:noFill/>
-        </p:spPr>
-        <p:txBody>
-          <a:bodyPr wrap="square" lIns="18288" rIns="18288" tIns="18288" bIns="18288" anchor="ctr">
-            <a:spAutoFit/>
-          </a:bodyPr>
-          <a:lstStyle/>
-          <a:p>
-            <a:pPr algn="l">
-              <a:spcAft>
-                <a:spcPts val="0"/>
-              </a:spcAft>
-            </a:pPr>
-            <a:r>
-              <a:rPr sz="1800" b="1" i="0">
-                <a:solidFill>
-                  <a:srgbClr val="FFFFFF"/>
-                </a:solidFill>
-                <a:latin typeface="Arial"/>
-              </a:rPr>
-              <a:t>Use DDIM downstream</a:t>
-            </a:r>
-          </a:p>
-        </p:txBody>
-      </p:sp>
-      <p:sp>
-        <p:nvSpPr>
-          <p:cNvPr id="42" name="TextBox 41"/>
-          <p:cNvSpPr txBox="1"/>
-          <p:nvPr/>
-        </p:nvSpPr>
-        <p:spPr>
-          <a:xfrm>
-            <a:off x="2852928" y="5669280"/>
-            <a:ext cx="8394192" cy="292608"/>
-          </a:xfrm>
-          <a:prstGeom prst="rect">
-            <a:avLst/>
-          </a:prstGeom>
-          <a:noFill/>
-        </p:spPr>
-        <p:txBody>
-          <a:bodyPr wrap="square" lIns="18288" rIns="18288" tIns="18288" bIns="18288" anchor="ctr">
-            <a:spAutoFit/>
-          </a:bodyPr>
-          <a:lstStyle/>
-          <a:p>
-            <a:pPr algn="l">
-              <a:spcAft>
-                <a:spcPts val="0"/>
-              </a:spcAft>
-            </a:pPr>
-            <a:r>
-              <a:rPr sz="1500" b="0" i="0">
-                <a:solidFill>
-                  <a:srgbClr val="DCE7F2"/>
-                </a:solidFill>
-                <a:latin typeface="Arial"/>
-              </a:rPr>
-              <a:t>Lower separability and distributional distance, with comparable correlation and higher F1.</a:t>
-            </a:r>
-          </a:p>
-        </p:txBody>
-      </p:sp>
-      <p:sp>
-        <p:nvSpPr>
-          <p:cNvPr id="43" name="TextBox 42"/>
-          <p:cNvSpPr txBox="1"/>
-          <p:nvPr/>
-        </p:nvSpPr>
-        <p:spPr>
-          <a:xfrm>
-            <a:off x="329184" y="6510528"/>
-            <a:ext cx="10972800" cy="173736"/>
-          </a:xfrm>
-          <a:prstGeom prst="rect">
-            <a:avLst/>
-          </a:prstGeom>
-          <a:noFill/>
-        </p:spPr>
-        <p:txBody>
-          <a:bodyPr wrap="square" lIns="18288" rIns="18288" tIns="18288" bIns="18288" anchor="ctr">
-            <a:spAutoFit/>
-          </a:bodyPr>
-          <a:lstStyle/>
-          <a:p>
-            <a:pPr algn="l">
-              <a:spcAft>
-                <a:spcPts val="0"/>
-              </a:spcAft>
-            </a:pPr>
-            <a:r>
-              <a:rPr sz="720" b="0" i="0">
-                <a:solidFill>
-                  <a:srgbClr val="8A969E"/>
-                </a:solidFill>
-                <a:latin typeface="Arial"/>
-              </a:rPr>
-              <a:t>WGAN values use validation data and DDIM values use the stated OSDR test; they are not paired on one common split.</a:t>
+              <a:t>PCA was fitted in the common locked OSDR expression space. This is PCA, not UMAP.</a:t>
             </a:r>
           </a:p>
         </p:txBody>

</xml_diff>

<commit_message>
Separate promoted and reinforced presentation rows
</commit_message>
<xml_diff>
--- a/presentation/SLSTP_2026_Generative_Transcriptomics.pptx
+++ b/presentation/SLSTP_2026_Generative_Transcriptomics.pptx
@@ -1191,7 +1191,7 @@
           <a:p/>
           <a:p>
             <a:r>
-              <a:t>Pooled muscle, kidney, spleen and skin each produced a distinct synthetic-informed result. Read these as separate hypotheses, not as grouped biology. Pooled muscle is heterogeneous, kidney suggests phosphoinositide and glucose handling, spleen suggests adhesion and extracellular-matrix or immune organization, and skin contributes a single interferon-linked candidate.</a:t>
+              <a:t>Promoted and reinforced genes are shown on separate subrows for each tissue. Pooled muscle, kidney, spleen and skin each produced a distinct synthetic-informed result. Read these as separate hypotheses, not as grouped biology. Pooled muscle is heterogeneous, kidney suggests phosphoinositide and glucose handling, spleen suggests adhesion and extracellular-matrix or immune organization, and skin contributes a single interferon-linked candidate.</a:t>
             </a:r>
           </a:p>
         </p:txBody>
@@ -1267,7 +1267,7 @@
           <a:p/>
           <a:p>
             <a:r>
-              <a:t>Eye, adrenal gland, gastrocnemius and tibialis anterior are reported separately as well. Eye reinforces lower cytokinesis, adrenal contributes two unmatched candidates, gastrocnemius combines an NF-kappa-B stress signal with an autophagy or myogenesis candidate, and tibialis anterior spans stress, cell-cycle, ganglioside and mitophagy hypotheses.</a:t>
+              <a:t>Promoted and reinforced genes remain separated here as well. Eye reinforces lower cytokinesis, adrenal contributes two unmatched candidates, gastrocnemius combines an NF-kappa-B stress signal with an autophagy or myogenesis candidate, and tibialis anterior spans stress, cell-cycle, ganglioside and mitophagy hypotheses.</a:t>
             </a:r>
           </a:p>
         </p:txBody>
@@ -31562,7 +31562,7 @@
                 </a:solidFill>
                 <a:latin typeface="Arial"/>
               </a:rPr>
-              <a:t>These results remain distinct; their placement on one slide does not imply shared biology.</a:t>
+              <a:t>Promoted and reinforced selections are separated within every tissue.</a:t>
             </a:r>
           </a:p>
         </p:txBody>
@@ -31576,7 +31576,7 @@
         <p:spPr>
           <a:xfrm>
             <a:off x="658368" y="1828800"/>
-            <a:ext cx="1874519" cy="256032"/>
+            <a:ext cx="1554480" cy="256032"/>
           </a:xfrm>
           <a:prstGeom prst="rect">
             <a:avLst/>
@@ -31614,8 +31614,8 @@
         </p:nvSpPr>
         <p:spPr>
           <a:xfrm>
-            <a:off x="2697480" y="1828800"/>
-            <a:ext cx="3566160" cy="256032"/>
+            <a:off x="2267712" y="1828800"/>
+            <a:ext cx="1051560" cy="256032"/>
           </a:xfrm>
           <a:prstGeom prst="rect">
             <a:avLst/>
@@ -31640,7 +31640,7 @@
                 </a:solidFill>
                 <a:latin typeface="Arial"/>
               </a:rPr>
-              <a:t>Synthetic-informed genes</a:t>
+              <a:t>Selection</a:t>
             </a:r>
           </a:p>
         </p:txBody>
@@ -31653,8 +31653,8 @@
         </p:nvSpPr>
         <p:spPr>
           <a:xfrm>
-            <a:off x="6583680" y="1828800"/>
-            <a:ext cx="4663440" cy="256032"/>
+            <a:off x="3456432" y="1828800"/>
+            <a:ext cx="2880360" cy="256032"/>
           </a:xfrm>
           <a:prstGeom prst="rect">
             <a:avLst/>
@@ -31679,6 +31679,45 @@
                 </a:solidFill>
                 <a:latin typeface="Arial"/>
               </a:rPr>
+              <a:t>Genes and FLT direction</a:t>
+            </a:r>
+          </a:p>
+        </p:txBody>
+      </p:sp>
+      <p:sp>
+        <p:nvSpPr>
+          <p:cNvPr id="10" name="TextBox 9"/>
+          <p:cNvSpPr txBox="1"/>
+          <p:nvPr/>
+        </p:nvSpPr>
+        <p:spPr>
+          <a:xfrm>
+            <a:off x="6583680" y="1828800"/>
+            <a:ext cx="4663440" cy="256032"/>
+          </a:xfrm>
+          <a:prstGeom prst="rect">
+            <a:avLst/>
+          </a:prstGeom>
+          <a:noFill/>
+        </p:spPr>
+        <p:txBody>
+          <a:bodyPr wrap="square" lIns="18288" rIns="18288" tIns="18288" bIns="18288" anchor="t">
+            <a:spAutoFit/>
+          </a:bodyPr>
+          <a:lstStyle/>
+          <a:p>
+            <a:pPr algn="l">
+              <a:spcAft>
+                <a:spcPts val="0"/>
+              </a:spcAft>
+            </a:pPr>
+            <a:r>
+              <a:rPr sz="1150" b="1" i="0">
+                <a:solidFill>
+                  <a:srgbClr val="59697A"/>
+                </a:solidFill>
+                <a:latin typeface="Arial"/>
+              </a:rPr>
               <a:t>Interpretation</a:t>
             </a:r>
           </a:p>
@@ -31686,7 +31725,7 @@
       </p:sp>
       <p:sp>
         <p:nvSpPr>
-          <p:cNvPr id="10" name="Rectangle 9"/>
+          <p:cNvPr id="11" name="Rectangle 10"/>
           <p:cNvSpPr/>
           <p:nvPr/>
         </p:nvSpPr>
@@ -31731,7 +31770,7 @@
       </p:sp>
       <p:sp>
         <p:nvSpPr>
-          <p:cNvPr id="11" name="Rectangle 10"/>
+          <p:cNvPr id="12" name="Rectangle 11"/>
           <p:cNvSpPr/>
           <p:nvPr/>
         </p:nvSpPr>
@@ -31774,14 +31813,14 @@
       </p:sp>
       <p:sp>
         <p:nvSpPr>
-          <p:cNvPr id="12" name="TextBox 11"/>
+          <p:cNvPr id="13" name="TextBox 12"/>
           <p:cNvSpPr txBox="1"/>
           <p:nvPr/>
         </p:nvSpPr>
         <p:spPr>
           <a:xfrm>
             <a:off x="658368" y="2331720"/>
-            <a:ext cx="1874519" cy="402336"/>
+            <a:ext cx="1481328" cy="402336"/>
           </a:xfrm>
           <a:prstGeom prst="rect">
             <a:avLst/>
@@ -31800,7 +31839,7 @@
               </a:spcAft>
             </a:pPr>
             <a:r>
-              <a:rPr sz="1550" b="1" i="0">
+              <a:rPr sz="1500" b="1" i="0">
                 <a:solidFill>
                   <a:srgbClr val="2D6496"/>
                 </a:solidFill>
@@ -31813,14 +31852,57 @@
       </p:sp>
       <p:sp>
         <p:nvSpPr>
-          <p:cNvPr id="13" name="TextBox 12"/>
+          <p:cNvPr id="14" name="Rectangle 13"/>
+          <p:cNvSpPr/>
+          <p:nvPr/>
+        </p:nvSpPr>
+        <p:spPr>
+          <a:xfrm>
+            <a:off x="2212848" y="2551176"/>
+            <a:ext cx="4041648" cy="10972"/>
+          </a:xfrm>
+          <a:prstGeom prst="rect">
+            <a:avLst/>
+          </a:prstGeom>
+          <a:solidFill>
+            <a:srgbClr val="DDE4E8"/>
+          </a:solidFill>
+          <a:ln>
+            <a:noFill/>
+          </a:ln>
+        </p:spPr>
+        <p:style>
+          <a:lnRef idx="1">
+            <a:schemeClr val="accent1"/>
+          </a:lnRef>
+          <a:fillRef idx="3">
+            <a:schemeClr val="accent1"/>
+          </a:fillRef>
+          <a:effectRef idx="2">
+            <a:schemeClr val="accent1"/>
+          </a:effectRef>
+          <a:fontRef idx="minor">
+            <a:schemeClr val="lt1"/>
+          </a:fontRef>
+        </p:style>
+        <p:txBody>
+          <a:bodyPr rtlCol="0" anchor="ctr"/>
+          <a:lstStyle/>
+          <a:p>
+            <a:pPr algn="ctr"/>
+          </a:p>
+        </p:txBody>
+      </p:sp>
+      <p:sp>
+        <p:nvSpPr>
+          <p:cNvPr id="15" name="TextBox 14"/>
           <p:cNvSpPr txBox="1"/>
           <p:nvPr/>
         </p:nvSpPr>
         <p:spPr>
           <a:xfrm>
-            <a:off x="2697480" y="2258568"/>
-            <a:ext cx="3566160" cy="566928"/>
+            <a:off x="2267712" y="2221992"/>
+            <a:ext cx="1024128" cy="228600"/>
           </a:xfrm>
           <a:prstGeom prst="rect">
             <a:avLst/>
@@ -31839,27 +31921,27 @@
               </a:spcAft>
             </a:pPr>
             <a:r>
-              <a:rPr sz="1250" b="0" i="0">
-                <a:solidFill>
-                  <a:srgbClr val="263746"/>
-                </a:solidFill>
-                <a:latin typeface="Arial"/>
-              </a:rPr>
-              <a:t>12 genes: 4 promoted, 8 reinforced</a:t>
-            </a:r>
-          </a:p>
-        </p:txBody>
-      </p:sp>
-      <p:sp>
-        <p:nvSpPr>
-          <p:cNvPr id="14" name="TextBox 13"/>
+              <a:rPr sz="1050" b="1" i="0">
+                <a:solidFill>
+                  <a:srgbClr val="D96552"/>
+                </a:solidFill>
+                <a:latin typeface="Arial"/>
+              </a:rPr>
+              <a:t>Promoted</a:t>
+            </a:r>
+          </a:p>
+        </p:txBody>
+      </p:sp>
+      <p:sp>
+        <p:nvSpPr>
+          <p:cNvPr id="16" name="TextBox 15"/>
           <p:cNvSpPr txBox="1"/>
           <p:nvPr/>
         </p:nvSpPr>
         <p:spPr>
           <a:xfrm>
-            <a:off x="6583680" y="2240280"/>
-            <a:ext cx="4754880" cy="603504"/>
+            <a:off x="3456432" y="2194560"/>
+            <a:ext cx="2816352" cy="320040"/>
           </a:xfrm>
           <a:prstGeom prst="rect">
             <a:avLst/>
@@ -31878,6 +31960,123 @@
               </a:spcAft>
             </a:pPr>
             <a:r>
+              <a:rPr sz="1050" b="0" i="0">
+                <a:solidFill>
+                  <a:srgbClr val="263746"/>
+                </a:solidFill>
+                <a:latin typeface="Arial"/>
+              </a:rPr>
+              <a:t>Lower: Klhl21, Mapkapk5, Reep5, Itgb5</a:t>
+            </a:r>
+          </a:p>
+        </p:txBody>
+      </p:sp>
+      <p:sp>
+        <p:nvSpPr>
+          <p:cNvPr id="17" name="TextBox 16"/>
+          <p:cNvSpPr txBox="1"/>
+          <p:nvPr/>
+        </p:nvSpPr>
+        <p:spPr>
+          <a:xfrm>
+            <a:off x="2267712" y="2624328"/>
+            <a:ext cx="1024128" cy="228600"/>
+          </a:xfrm>
+          <a:prstGeom prst="rect">
+            <a:avLst/>
+          </a:prstGeom>
+          <a:noFill/>
+        </p:spPr>
+        <p:txBody>
+          <a:bodyPr wrap="square" lIns="18288" rIns="18288" tIns="18288" bIns="18288" anchor="ctr">
+            <a:spAutoFit/>
+          </a:bodyPr>
+          <a:lstStyle/>
+          <a:p>
+            <a:pPr algn="l">
+              <a:spcAft>
+                <a:spcPts val="0"/>
+              </a:spcAft>
+            </a:pPr>
+            <a:r>
+              <a:rPr sz="1050" b="1" i="0">
+                <a:solidFill>
+                  <a:srgbClr val="178681"/>
+                </a:solidFill>
+                <a:latin typeface="Arial"/>
+              </a:rPr>
+              <a:t>Reinforced</a:t>
+            </a:r>
+          </a:p>
+        </p:txBody>
+      </p:sp>
+      <p:sp>
+        <p:nvSpPr>
+          <p:cNvPr id="18" name="TextBox 17"/>
+          <p:cNvSpPr txBox="1"/>
+          <p:nvPr/>
+        </p:nvSpPr>
+        <p:spPr>
+          <a:xfrm>
+            <a:off x="3456432" y="2587752"/>
+            <a:ext cx="2816352" cy="320040"/>
+          </a:xfrm>
+          <a:prstGeom prst="rect">
+            <a:avLst/>
+          </a:prstGeom>
+          <a:noFill/>
+        </p:spPr>
+        <p:txBody>
+          <a:bodyPr wrap="square" lIns="18288" rIns="18288" tIns="18288" bIns="18288" anchor="ctr">
+            <a:spAutoFit/>
+          </a:bodyPr>
+          <a:lstStyle/>
+          <a:p>
+            <a:pPr algn="l">
+              <a:spcAft>
+                <a:spcPts val="0"/>
+              </a:spcAft>
+            </a:pPr>
+            <a:r>
+              <a:rPr sz="1050" b="0" i="0">
+                <a:solidFill>
+                  <a:srgbClr val="263746"/>
+                </a:solidFill>
+                <a:latin typeface="Arial"/>
+              </a:rPr>
+              <a:t>Higher: Sox4, Cebpd, Sh3bp5, Prkcd, Arid5b, Sesn1, Tle1; lower: Bphl</a:t>
+            </a:r>
+          </a:p>
+        </p:txBody>
+      </p:sp>
+      <p:sp>
+        <p:nvSpPr>
+          <p:cNvPr id="19" name="TextBox 18"/>
+          <p:cNvSpPr txBox="1"/>
+          <p:nvPr/>
+        </p:nvSpPr>
+        <p:spPr>
+          <a:xfrm>
+            <a:off x="6583680" y="2240280"/>
+            <a:ext cx="4754880" cy="603504"/>
+          </a:xfrm>
+          <a:prstGeom prst="rect">
+            <a:avLst/>
+          </a:prstGeom>
+          <a:noFill/>
+        </p:spPr>
+        <p:txBody>
+          <a:bodyPr wrap="square" lIns="18288" rIns="18288" tIns="18288" bIns="18288" anchor="ctr">
+            <a:spAutoFit/>
+          </a:bodyPr>
+          <a:lstStyle/>
+          <a:p>
+            <a:pPr algn="l">
+              <a:spcAft>
+                <a:spcPts val="0"/>
+              </a:spcAft>
+            </a:pPr>
+            <a:r>
               <a:rPr sz="1220" b="0" i="0">
                 <a:solidFill>
                   <a:srgbClr val="263746"/>
@@ -31891,7 +32090,7 @@
       </p:sp>
       <p:sp>
         <p:nvSpPr>
-          <p:cNvPr id="15" name="Rectangle 14"/>
+          <p:cNvPr id="20" name="Rectangle 19"/>
           <p:cNvSpPr/>
           <p:nvPr/>
         </p:nvSpPr>
@@ -31936,7 +32135,7 @@
       </p:sp>
       <p:sp>
         <p:nvSpPr>
-          <p:cNvPr id="16" name="Rectangle 15"/>
+          <p:cNvPr id="21" name="Rectangle 20"/>
           <p:cNvSpPr/>
           <p:nvPr/>
         </p:nvSpPr>
@@ -31979,14 +32178,14 @@
       </p:sp>
       <p:sp>
         <p:nvSpPr>
-          <p:cNvPr id="17" name="TextBox 16"/>
+          <p:cNvPr id="22" name="TextBox 21"/>
           <p:cNvSpPr txBox="1"/>
           <p:nvPr/>
         </p:nvSpPr>
         <p:spPr>
           <a:xfrm>
             <a:off x="658368" y="3300984"/>
-            <a:ext cx="1874519" cy="402336"/>
+            <a:ext cx="1481328" cy="402336"/>
           </a:xfrm>
           <a:prstGeom prst="rect">
             <a:avLst/>
@@ -32005,7 +32204,7 @@
               </a:spcAft>
             </a:pPr>
             <a:r>
-              <a:rPr sz="1550" b="1" i="0">
+              <a:rPr sz="1500" b="1" i="0">
                 <a:solidFill>
                   <a:srgbClr val="8063A6"/>
                 </a:solidFill>
@@ -32018,14 +32217,57 @@
       </p:sp>
       <p:sp>
         <p:nvSpPr>
-          <p:cNvPr id="18" name="TextBox 17"/>
+          <p:cNvPr id="23" name="Rectangle 22"/>
+          <p:cNvSpPr/>
+          <p:nvPr/>
+        </p:nvSpPr>
+        <p:spPr>
+          <a:xfrm>
+            <a:off x="2212848" y="3520440"/>
+            <a:ext cx="4041648" cy="10972"/>
+          </a:xfrm>
+          <a:prstGeom prst="rect">
+            <a:avLst/>
+          </a:prstGeom>
+          <a:solidFill>
+            <a:srgbClr val="DDE4E8"/>
+          </a:solidFill>
+          <a:ln>
+            <a:noFill/>
+          </a:ln>
+        </p:spPr>
+        <p:style>
+          <a:lnRef idx="1">
+            <a:schemeClr val="accent1"/>
+          </a:lnRef>
+          <a:fillRef idx="3">
+            <a:schemeClr val="accent1"/>
+          </a:fillRef>
+          <a:effectRef idx="2">
+            <a:schemeClr val="accent1"/>
+          </a:effectRef>
+          <a:fontRef idx="minor">
+            <a:schemeClr val="lt1"/>
+          </a:fontRef>
+        </p:style>
+        <p:txBody>
+          <a:bodyPr rtlCol="0" anchor="ctr"/>
+          <a:lstStyle/>
+          <a:p>
+            <a:pPr algn="ctr"/>
+          </a:p>
+        </p:txBody>
+      </p:sp>
+      <p:sp>
+        <p:nvSpPr>
+          <p:cNvPr id="24" name="TextBox 23"/>
           <p:cNvSpPr txBox="1"/>
           <p:nvPr/>
         </p:nvSpPr>
         <p:spPr>
           <a:xfrm>
-            <a:off x="2697480" y="3227832"/>
-            <a:ext cx="3566160" cy="566928"/>
+            <a:off x="2267712" y="3191256"/>
+            <a:ext cx="1024128" cy="228600"/>
           </a:xfrm>
           <a:prstGeom prst="rect">
             <a:avLst/>
@@ -32044,27 +32286,27 @@
               </a:spcAft>
             </a:pPr>
             <a:r>
-              <a:rPr sz="1250" b="0" i="0">
-                <a:solidFill>
-                  <a:srgbClr val="263746"/>
-                </a:solidFill>
-                <a:latin typeface="Arial"/>
-              </a:rPr>
-              <a:t>[P] Inpp4b higher; [R] Slc37a4 higher</a:t>
-            </a:r>
-          </a:p>
-        </p:txBody>
-      </p:sp>
-      <p:sp>
-        <p:nvSpPr>
-          <p:cNvPr id="19" name="TextBox 18"/>
+              <a:rPr sz="1050" b="1" i="0">
+                <a:solidFill>
+                  <a:srgbClr val="D96552"/>
+                </a:solidFill>
+                <a:latin typeface="Arial"/>
+              </a:rPr>
+              <a:t>Promoted</a:t>
+            </a:r>
+          </a:p>
+        </p:txBody>
+      </p:sp>
+      <p:sp>
+        <p:nvSpPr>
+          <p:cNvPr id="25" name="TextBox 24"/>
           <p:cNvSpPr txBox="1"/>
           <p:nvPr/>
         </p:nvSpPr>
         <p:spPr>
           <a:xfrm>
-            <a:off x="6583680" y="3209544"/>
-            <a:ext cx="4754880" cy="603504"/>
+            <a:off x="3456432" y="3163824"/>
+            <a:ext cx="2816352" cy="320040"/>
           </a:xfrm>
           <a:prstGeom prst="rect">
             <a:avLst/>
@@ -32083,6 +32325,123 @@
               </a:spcAft>
             </a:pPr>
             <a:r>
+              <a:rPr sz="1050" b="0" i="0">
+                <a:solidFill>
+                  <a:srgbClr val="263746"/>
+                </a:solidFill>
+                <a:latin typeface="Arial"/>
+              </a:rPr>
+              <a:t>Inpp4b higher</a:t>
+            </a:r>
+          </a:p>
+        </p:txBody>
+      </p:sp>
+      <p:sp>
+        <p:nvSpPr>
+          <p:cNvPr id="26" name="TextBox 25"/>
+          <p:cNvSpPr txBox="1"/>
+          <p:nvPr/>
+        </p:nvSpPr>
+        <p:spPr>
+          <a:xfrm>
+            <a:off x="2267712" y="3593592"/>
+            <a:ext cx="1024128" cy="228600"/>
+          </a:xfrm>
+          <a:prstGeom prst="rect">
+            <a:avLst/>
+          </a:prstGeom>
+          <a:noFill/>
+        </p:spPr>
+        <p:txBody>
+          <a:bodyPr wrap="square" lIns="18288" rIns="18288" tIns="18288" bIns="18288" anchor="ctr">
+            <a:spAutoFit/>
+          </a:bodyPr>
+          <a:lstStyle/>
+          <a:p>
+            <a:pPr algn="l">
+              <a:spcAft>
+                <a:spcPts val="0"/>
+              </a:spcAft>
+            </a:pPr>
+            <a:r>
+              <a:rPr sz="1050" b="1" i="0">
+                <a:solidFill>
+                  <a:srgbClr val="178681"/>
+                </a:solidFill>
+                <a:latin typeface="Arial"/>
+              </a:rPr>
+              <a:t>Reinforced</a:t>
+            </a:r>
+          </a:p>
+        </p:txBody>
+      </p:sp>
+      <p:sp>
+        <p:nvSpPr>
+          <p:cNvPr id="27" name="TextBox 26"/>
+          <p:cNvSpPr txBox="1"/>
+          <p:nvPr/>
+        </p:nvSpPr>
+        <p:spPr>
+          <a:xfrm>
+            <a:off x="3456432" y="3557016"/>
+            <a:ext cx="2816352" cy="320040"/>
+          </a:xfrm>
+          <a:prstGeom prst="rect">
+            <a:avLst/>
+          </a:prstGeom>
+          <a:noFill/>
+        </p:spPr>
+        <p:txBody>
+          <a:bodyPr wrap="square" lIns="18288" rIns="18288" tIns="18288" bIns="18288" anchor="ctr">
+            <a:spAutoFit/>
+          </a:bodyPr>
+          <a:lstStyle/>
+          <a:p>
+            <a:pPr algn="l">
+              <a:spcAft>
+                <a:spcPts val="0"/>
+              </a:spcAft>
+            </a:pPr>
+            <a:r>
+              <a:rPr sz="1050" b="0" i="0">
+                <a:solidFill>
+                  <a:srgbClr val="263746"/>
+                </a:solidFill>
+                <a:latin typeface="Arial"/>
+              </a:rPr>
+              <a:t>Slc37a4 higher</a:t>
+            </a:r>
+          </a:p>
+        </p:txBody>
+      </p:sp>
+      <p:sp>
+        <p:nvSpPr>
+          <p:cNvPr id="28" name="TextBox 27"/>
+          <p:cNvSpPr txBox="1"/>
+          <p:nvPr/>
+        </p:nvSpPr>
+        <p:spPr>
+          <a:xfrm>
+            <a:off x="6583680" y="3209544"/>
+            <a:ext cx="4754880" cy="603504"/>
+          </a:xfrm>
+          <a:prstGeom prst="rect">
+            <a:avLst/>
+          </a:prstGeom>
+          <a:noFill/>
+        </p:spPr>
+        <p:txBody>
+          <a:bodyPr wrap="square" lIns="18288" rIns="18288" tIns="18288" bIns="18288" anchor="ctr">
+            <a:spAutoFit/>
+          </a:bodyPr>
+          <a:lstStyle/>
+          <a:p>
+            <a:pPr algn="l">
+              <a:spcAft>
+                <a:spcPts val="0"/>
+              </a:spcAft>
+            </a:pPr>
+            <a:r>
               <a:rPr sz="1220" b="0" i="0">
                 <a:solidFill>
                   <a:srgbClr val="263746"/>
@@ -32096,7 +32455,7 @@
       </p:sp>
       <p:sp>
         <p:nvSpPr>
-          <p:cNvPr id="20" name="Rectangle 19"/>
+          <p:cNvPr id="29" name="Rectangle 28"/>
           <p:cNvSpPr/>
           <p:nvPr/>
         </p:nvSpPr>
@@ -32141,7 +32500,7 @@
       </p:sp>
       <p:sp>
         <p:nvSpPr>
-          <p:cNvPr id="21" name="Rectangle 20"/>
+          <p:cNvPr id="30" name="Rectangle 29"/>
           <p:cNvSpPr/>
           <p:nvPr/>
         </p:nvSpPr>
@@ -32184,14 +32543,14 @@
       </p:sp>
       <p:sp>
         <p:nvSpPr>
-          <p:cNvPr id="22" name="TextBox 21"/>
+          <p:cNvPr id="31" name="TextBox 30"/>
           <p:cNvSpPr txBox="1"/>
           <p:nvPr/>
         </p:nvSpPr>
         <p:spPr>
           <a:xfrm>
             <a:off x="658368" y="4270248"/>
-            <a:ext cx="1874519" cy="402336"/>
+            <a:ext cx="1481328" cy="402336"/>
           </a:xfrm>
           <a:prstGeom prst="rect">
             <a:avLst/>
@@ -32210,7 +32569,7 @@
               </a:spcAft>
             </a:pPr>
             <a:r>
-              <a:rPr sz="1550" b="1" i="0">
+              <a:rPr sz="1500" b="1" i="0">
                 <a:solidFill>
                   <a:srgbClr val="178681"/>
                 </a:solidFill>
@@ -32223,14 +32582,57 @@
       </p:sp>
       <p:sp>
         <p:nvSpPr>
-          <p:cNvPr id="23" name="TextBox 22"/>
+          <p:cNvPr id="32" name="Rectangle 31"/>
+          <p:cNvSpPr/>
+          <p:nvPr/>
+        </p:nvSpPr>
+        <p:spPr>
+          <a:xfrm>
+            <a:off x="2212848" y="4489704"/>
+            <a:ext cx="4041648" cy="10972"/>
+          </a:xfrm>
+          <a:prstGeom prst="rect">
+            <a:avLst/>
+          </a:prstGeom>
+          <a:solidFill>
+            <a:srgbClr val="DDE4E8"/>
+          </a:solidFill>
+          <a:ln>
+            <a:noFill/>
+          </a:ln>
+        </p:spPr>
+        <p:style>
+          <a:lnRef idx="1">
+            <a:schemeClr val="accent1"/>
+          </a:lnRef>
+          <a:fillRef idx="3">
+            <a:schemeClr val="accent1"/>
+          </a:fillRef>
+          <a:effectRef idx="2">
+            <a:schemeClr val="accent1"/>
+          </a:effectRef>
+          <a:fontRef idx="minor">
+            <a:schemeClr val="lt1"/>
+          </a:fontRef>
+        </p:style>
+        <p:txBody>
+          <a:bodyPr rtlCol="0" anchor="ctr"/>
+          <a:lstStyle/>
+          <a:p>
+            <a:pPr algn="ctr"/>
+          </a:p>
+        </p:txBody>
+      </p:sp>
+      <p:sp>
+        <p:nvSpPr>
+          <p:cNvPr id="33" name="TextBox 32"/>
           <p:cNvSpPr txBox="1"/>
           <p:nvPr/>
         </p:nvSpPr>
         <p:spPr>
           <a:xfrm>
-            <a:off x="2697480" y="4197096"/>
-            <a:ext cx="3566160" cy="566928"/>
+            <a:off x="2267712" y="4160520"/>
+            <a:ext cx="1024128" cy="228600"/>
           </a:xfrm>
           <a:prstGeom prst="rect">
             <a:avLst/>
@@ -32249,27 +32651,27 @@
               </a:spcAft>
             </a:pPr>
             <a:r>
-              <a:rPr sz="1250" b="0" i="0">
-                <a:solidFill>
-                  <a:srgbClr val="263746"/>
-                </a:solidFill>
-                <a:latin typeface="Arial"/>
-              </a:rPr>
-              <a:t>[P] Rai14, Myl9, Ptprk higher; [R] Loxl1 higher</a:t>
-            </a:r>
-          </a:p>
-        </p:txBody>
-      </p:sp>
-      <p:sp>
-        <p:nvSpPr>
-          <p:cNvPr id="24" name="TextBox 23"/>
+              <a:rPr sz="1050" b="1" i="0">
+                <a:solidFill>
+                  <a:srgbClr val="D96552"/>
+                </a:solidFill>
+                <a:latin typeface="Arial"/>
+              </a:rPr>
+              <a:t>Promoted</a:t>
+            </a:r>
+          </a:p>
+        </p:txBody>
+      </p:sp>
+      <p:sp>
+        <p:nvSpPr>
+          <p:cNvPr id="34" name="TextBox 33"/>
           <p:cNvSpPr txBox="1"/>
           <p:nvPr/>
         </p:nvSpPr>
         <p:spPr>
           <a:xfrm>
-            <a:off x="6583680" y="4178808"/>
-            <a:ext cx="4754880" cy="603504"/>
+            <a:off x="3456432" y="4133088"/>
+            <a:ext cx="2816352" cy="320040"/>
           </a:xfrm>
           <a:prstGeom prst="rect">
             <a:avLst/>
@@ -32288,6 +32690,123 @@
               </a:spcAft>
             </a:pPr>
             <a:r>
+              <a:rPr sz="1050" b="0" i="0">
+                <a:solidFill>
+                  <a:srgbClr val="263746"/>
+                </a:solidFill>
+                <a:latin typeface="Arial"/>
+              </a:rPr>
+              <a:t>Rai14, Myl9, Ptprk higher</a:t>
+            </a:r>
+          </a:p>
+        </p:txBody>
+      </p:sp>
+      <p:sp>
+        <p:nvSpPr>
+          <p:cNvPr id="35" name="TextBox 34"/>
+          <p:cNvSpPr txBox="1"/>
+          <p:nvPr/>
+        </p:nvSpPr>
+        <p:spPr>
+          <a:xfrm>
+            <a:off x="2267712" y="4562856"/>
+            <a:ext cx="1024128" cy="228600"/>
+          </a:xfrm>
+          <a:prstGeom prst="rect">
+            <a:avLst/>
+          </a:prstGeom>
+          <a:noFill/>
+        </p:spPr>
+        <p:txBody>
+          <a:bodyPr wrap="square" lIns="18288" rIns="18288" tIns="18288" bIns="18288" anchor="ctr">
+            <a:spAutoFit/>
+          </a:bodyPr>
+          <a:lstStyle/>
+          <a:p>
+            <a:pPr algn="l">
+              <a:spcAft>
+                <a:spcPts val="0"/>
+              </a:spcAft>
+            </a:pPr>
+            <a:r>
+              <a:rPr sz="1050" b="1" i="0">
+                <a:solidFill>
+                  <a:srgbClr val="178681"/>
+                </a:solidFill>
+                <a:latin typeface="Arial"/>
+              </a:rPr>
+              <a:t>Reinforced</a:t>
+            </a:r>
+          </a:p>
+        </p:txBody>
+      </p:sp>
+      <p:sp>
+        <p:nvSpPr>
+          <p:cNvPr id="36" name="TextBox 35"/>
+          <p:cNvSpPr txBox="1"/>
+          <p:nvPr/>
+        </p:nvSpPr>
+        <p:spPr>
+          <a:xfrm>
+            <a:off x="3456432" y="4526280"/>
+            <a:ext cx="2816352" cy="320040"/>
+          </a:xfrm>
+          <a:prstGeom prst="rect">
+            <a:avLst/>
+          </a:prstGeom>
+          <a:noFill/>
+        </p:spPr>
+        <p:txBody>
+          <a:bodyPr wrap="square" lIns="18288" rIns="18288" tIns="18288" bIns="18288" anchor="ctr">
+            <a:spAutoFit/>
+          </a:bodyPr>
+          <a:lstStyle/>
+          <a:p>
+            <a:pPr algn="l">
+              <a:spcAft>
+                <a:spcPts val="0"/>
+              </a:spcAft>
+            </a:pPr>
+            <a:r>
+              <a:rPr sz="1050" b="0" i="0">
+                <a:solidFill>
+                  <a:srgbClr val="263746"/>
+                </a:solidFill>
+                <a:latin typeface="Arial"/>
+              </a:rPr>
+              <a:t>Loxl1 higher</a:t>
+            </a:r>
+          </a:p>
+        </p:txBody>
+      </p:sp>
+      <p:sp>
+        <p:nvSpPr>
+          <p:cNvPr id="37" name="TextBox 36"/>
+          <p:cNvSpPr txBox="1"/>
+          <p:nvPr/>
+        </p:nvSpPr>
+        <p:spPr>
+          <a:xfrm>
+            <a:off x="6583680" y="4178808"/>
+            <a:ext cx="4754880" cy="603504"/>
+          </a:xfrm>
+          <a:prstGeom prst="rect">
+            <a:avLst/>
+          </a:prstGeom>
+          <a:noFill/>
+        </p:spPr>
+        <p:txBody>
+          <a:bodyPr wrap="square" lIns="18288" rIns="18288" tIns="18288" bIns="18288" anchor="ctr">
+            <a:spAutoFit/>
+          </a:bodyPr>
+          <a:lstStyle/>
+          <a:p>
+            <a:pPr algn="l">
+              <a:spcAft>
+                <a:spcPts val="0"/>
+              </a:spcAft>
+            </a:pPr>
+            <a:r>
               <a:rPr sz="1220" b="0" i="0">
                 <a:solidFill>
                   <a:srgbClr val="263746"/>
@@ -32301,7 +32820,7 @@
       </p:sp>
       <p:sp>
         <p:nvSpPr>
-          <p:cNvPr id="25" name="Rectangle 24"/>
+          <p:cNvPr id="38" name="Rectangle 37"/>
           <p:cNvSpPr/>
           <p:nvPr/>
         </p:nvSpPr>
@@ -32346,7 +32865,7 @@
       </p:sp>
       <p:sp>
         <p:nvSpPr>
-          <p:cNvPr id="26" name="Rectangle 25"/>
+          <p:cNvPr id="39" name="Rectangle 38"/>
           <p:cNvSpPr/>
           <p:nvPr/>
         </p:nvSpPr>
@@ -32389,14 +32908,14 @@
       </p:sp>
       <p:sp>
         <p:nvSpPr>
-          <p:cNvPr id="27" name="TextBox 26"/>
+          <p:cNvPr id="40" name="TextBox 39"/>
           <p:cNvSpPr txBox="1"/>
           <p:nvPr/>
         </p:nvSpPr>
         <p:spPr>
           <a:xfrm>
             <a:off x="658368" y="5239512"/>
-            <a:ext cx="1874519" cy="402336"/>
+            <a:ext cx="1481328" cy="402336"/>
           </a:xfrm>
           <a:prstGeom prst="rect">
             <a:avLst/>
@@ -32415,7 +32934,7 @@
               </a:spcAft>
             </a:pPr>
             <a:r>
-              <a:rPr sz="1550" b="1" i="0">
+              <a:rPr sz="1500" b="1" i="0">
                 <a:solidFill>
                   <a:srgbClr val="D37B00"/>
                 </a:solidFill>
@@ -32428,14 +32947,57 @@
       </p:sp>
       <p:sp>
         <p:nvSpPr>
-          <p:cNvPr id="28" name="TextBox 27"/>
+          <p:cNvPr id="41" name="Rectangle 40"/>
+          <p:cNvSpPr/>
+          <p:nvPr/>
+        </p:nvSpPr>
+        <p:spPr>
+          <a:xfrm>
+            <a:off x="2212848" y="5458968"/>
+            <a:ext cx="4041648" cy="10972"/>
+          </a:xfrm>
+          <a:prstGeom prst="rect">
+            <a:avLst/>
+          </a:prstGeom>
+          <a:solidFill>
+            <a:srgbClr val="DDE4E8"/>
+          </a:solidFill>
+          <a:ln>
+            <a:noFill/>
+          </a:ln>
+        </p:spPr>
+        <p:style>
+          <a:lnRef idx="1">
+            <a:schemeClr val="accent1"/>
+          </a:lnRef>
+          <a:fillRef idx="3">
+            <a:schemeClr val="accent1"/>
+          </a:fillRef>
+          <a:effectRef idx="2">
+            <a:schemeClr val="accent1"/>
+          </a:effectRef>
+          <a:fontRef idx="minor">
+            <a:schemeClr val="lt1"/>
+          </a:fontRef>
+        </p:style>
+        <p:txBody>
+          <a:bodyPr rtlCol="0" anchor="ctr"/>
+          <a:lstStyle/>
+          <a:p>
+            <a:pPr algn="ctr"/>
+          </a:p>
+        </p:txBody>
+      </p:sp>
+      <p:sp>
+        <p:nvSpPr>
+          <p:cNvPr id="42" name="TextBox 41"/>
           <p:cNvSpPr txBox="1"/>
           <p:nvPr/>
         </p:nvSpPr>
         <p:spPr>
           <a:xfrm>
-            <a:off x="2697480" y="5166360"/>
-            <a:ext cx="3566160" cy="566928"/>
+            <a:off x="2267712" y="5129784"/>
+            <a:ext cx="1024128" cy="228600"/>
           </a:xfrm>
           <a:prstGeom prst="rect">
             <a:avLst/>
@@ -32454,27 +33016,27 @@
               </a:spcAft>
             </a:pPr>
             <a:r>
-              <a:rPr sz="1250" b="0" i="0">
-                <a:solidFill>
-                  <a:srgbClr val="263746"/>
-                </a:solidFill>
-                <a:latin typeface="Arial"/>
-              </a:rPr>
-              <a:t>[P] Plscr1 higher</a:t>
-            </a:r>
-          </a:p>
-        </p:txBody>
-      </p:sp>
-      <p:sp>
-        <p:nvSpPr>
-          <p:cNvPr id="29" name="TextBox 28"/>
+              <a:rPr sz="1050" b="1" i="0">
+                <a:solidFill>
+                  <a:srgbClr val="D96552"/>
+                </a:solidFill>
+                <a:latin typeface="Arial"/>
+              </a:rPr>
+              <a:t>Promoted</a:t>
+            </a:r>
+          </a:p>
+        </p:txBody>
+      </p:sp>
+      <p:sp>
+        <p:nvSpPr>
+          <p:cNvPr id="43" name="TextBox 42"/>
           <p:cNvSpPr txBox="1"/>
           <p:nvPr/>
         </p:nvSpPr>
         <p:spPr>
           <a:xfrm>
-            <a:off x="6583680" y="5148072"/>
-            <a:ext cx="4754880" cy="603504"/>
+            <a:off x="3456432" y="5102352"/>
+            <a:ext cx="2816352" cy="320040"/>
           </a:xfrm>
           <a:prstGeom prst="rect">
             <a:avLst/>
@@ -32493,27 +33055,27 @@
               </a:spcAft>
             </a:pPr>
             <a:r>
-              <a:rPr sz="1220" b="0" i="0">
+              <a:rPr sz="1050" b="0" i="0">
                 <a:solidFill>
                   <a:srgbClr val="263746"/>
                 </a:solidFill>
                 <a:latin typeface="Arial"/>
               </a:rPr>
-              <a:t>Interferon-linked skin candidate within broader cell-cycle and DNA-repair responses; a single-gene result.</a:t>
-            </a:r>
-          </a:p>
-        </p:txBody>
-      </p:sp>
-      <p:sp>
-        <p:nvSpPr>
-          <p:cNvPr id="30" name="TextBox 29"/>
+              <a:t>Plscr1 higher</a:t>
+            </a:r>
+          </a:p>
+        </p:txBody>
+      </p:sp>
+      <p:sp>
+        <p:nvSpPr>
+          <p:cNvPr id="44" name="TextBox 43"/>
           <p:cNvSpPr txBox="1"/>
           <p:nvPr/>
         </p:nvSpPr>
         <p:spPr>
           <a:xfrm>
-            <a:off x="329184" y="6510528"/>
-            <a:ext cx="10972800" cy="173736"/>
+            <a:off x="2267712" y="5532120"/>
+            <a:ext cx="1024128" cy="228600"/>
           </a:xfrm>
           <a:prstGeom prst="rect">
             <a:avLst/>
@@ -32532,13 +33094,130 @@
               </a:spcAft>
             </a:pPr>
             <a:r>
+              <a:rPr sz="1050" b="1" i="0">
+                <a:solidFill>
+                  <a:srgbClr val="178681"/>
+                </a:solidFill>
+                <a:latin typeface="Arial"/>
+              </a:rPr>
+              <a:t>Reinforced</a:t>
+            </a:r>
+          </a:p>
+        </p:txBody>
+      </p:sp>
+      <p:sp>
+        <p:nvSpPr>
+          <p:cNvPr id="45" name="TextBox 44"/>
+          <p:cNvSpPr txBox="1"/>
+          <p:nvPr/>
+        </p:nvSpPr>
+        <p:spPr>
+          <a:xfrm>
+            <a:off x="3456432" y="5495544"/>
+            <a:ext cx="2816352" cy="320040"/>
+          </a:xfrm>
+          <a:prstGeom prst="rect">
+            <a:avLst/>
+          </a:prstGeom>
+          <a:noFill/>
+        </p:spPr>
+        <p:txBody>
+          <a:bodyPr wrap="square" lIns="18288" rIns="18288" tIns="18288" bIns="18288" anchor="ctr">
+            <a:spAutoFit/>
+          </a:bodyPr>
+          <a:lstStyle/>
+          <a:p>
+            <a:pPr algn="l">
+              <a:spcAft>
+                <a:spcPts val="0"/>
+              </a:spcAft>
+            </a:pPr>
+            <a:r>
+              <a:rPr sz="1050" b="0" i="0">
+                <a:solidFill>
+                  <a:srgbClr val="263746"/>
+                </a:solidFill>
+                <a:latin typeface="Arial"/>
+              </a:rPr>
+              <a:t>None</a:t>
+            </a:r>
+          </a:p>
+        </p:txBody>
+      </p:sp>
+      <p:sp>
+        <p:nvSpPr>
+          <p:cNvPr id="46" name="TextBox 45"/>
+          <p:cNvSpPr txBox="1"/>
+          <p:nvPr/>
+        </p:nvSpPr>
+        <p:spPr>
+          <a:xfrm>
+            <a:off x="6583680" y="5148072"/>
+            <a:ext cx="4754880" cy="603504"/>
+          </a:xfrm>
+          <a:prstGeom prst="rect">
+            <a:avLst/>
+          </a:prstGeom>
+          <a:noFill/>
+        </p:spPr>
+        <p:txBody>
+          <a:bodyPr wrap="square" lIns="18288" rIns="18288" tIns="18288" bIns="18288" anchor="ctr">
+            <a:spAutoFit/>
+          </a:bodyPr>
+          <a:lstStyle/>
+          <a:p>
+            <a:pPr algn="l">
+              <a:spcAft>
+                <a:spcPts val="0"/>
+              </a:spcAft>
+            </a:pPr>
+            <a:r>
+              <a:rPr sz="1220" b="0" i="0">
+                <a:solidFill>
+                  <a:srgbClr val="263746"/>
+                </a:solidFill>
+                <a:latin typeface="Arial"/>
+              </a:rPr>
+              <a:t>Interferon-linked skin candidate within broader cell-cycle and DNA-repair responses; a single-gene result.</a:t>
+            </a:r>
+          </a:p>
+        </p:txBody>
+      </p:sp>
+      <p:sp>
+        <p:nvSpPr>
+          <p:cNvPr id="47" name="TextBox 46"/>
+          <p:cNvSpPr txBox="1"/>
+          <p:nvPr/>
+        </p:nvSpPr>
+        <p:spPr>
+          <a:xfrm>
+            <a:off x="329184" y="6510528"/>
+            <a:ext cx="10972800" cy="173736"/>
+          </a:xfrm>
+          <a:prstGeom prst="rect">
+            <a:avLst/>
+          </a:prstGeom>
+          <a:noFill/>
+        </p:spPr>
+        <p:txBody>
+          <a:bodyPr wrap="square" lIns="18288" rIns="18288" tIns="18288" bIns="18288" anchor="ctr">
+            <a:spAutoFit/>
+          </a:bodyPr>
+          <a:lstStyle/>
+          <a:p>
+            <a:pPr algn="l">
+              <a:spcAft>
+                <a:spcPts val="0"/>
+              </a:spcAft>
+            </a:pPr>
+            <a:r>
               <a:rPr sz="720" b="0" i="0">
                 <a:solidFill>
                   <a:srgbClr val="8A969E"/>
                 </a:solidFill>
                 <a:latin typeface="Arial"/>
               </a:rPr>
-              <a:t>[P] promoted; [R] reinforced. All listed effects passed BH FDR in observed OSDR profiles.</a:t>
+              <a:t>All listed effects passed BH FDR in observed OSDR profiles; 'None' means no gene in that selection category.</a:t>
             </a:r>
           </a:p>
         </p:txBody>
@@ -32707,7 +33386,7 @@
                 </a:solidFill>
                 <a:latin typeface="Arial"/>
               </a:rPr>
-              <a:t>Each row reports its own selected genes and the narrowest supported interpretation.</a:t>
+              <a:t>Promoted and reinforced selections are separated within every tissue.</a:t>
             </a:r>
           </a:p>
         </p:txBody>
@@ -32721,7 +33400,7 @@
         <p:spPr>
           <a:xfrm>
             <a:off x="658368" y="1828800"/>
-            <a:ext cx="1874519" cy="256032"/>
+            <a:ext cx="1554480" cy="256032"/>
           </a:xfrm>
           <a:prstGeom prst="rect">
             <a:avLst/>
@@ -32759,8 +33438,8 @@
         </p:nvSpPr>
         <p:spPr>
           <a:xfrm>
-            <a:off x="2697480" y="1828800"/>
-            <a:ext cx="3566160" cy="256032"/>
+            <a:off x="2267712" y="1828800"/>
+            <a:ext cx="1051560" cy="256032"/>
           </a:xfrm>
           <a:prstGeom prst="rect">
             <a:avLst/>
@@ -32785,7 +33464,7 @@
                 </a:solidFill>
                 <a:latin typeface="Arial"/>
               </a:rPr>
-              <a:t>Synthetic-informed genes</a:t>
+              <a:t>Selection</a:t>
             </a:r>
           </a:p>
         </p:txBody>
@@ -32798,8 +33477,8 @@
         </p:nvSpPr>
         <p:spPr>
           <a:xfrm>
-            <a:off x="6583680" y="1828800"/>
-            <a:ext cx="4663440" cy="256032"/>
+            <a:off x="3456432" y="1828800"/>
+            <a:ext cx="2880360" cy="256032"/>
           </a:xfrm>
           <a:prstGeom prst="rect">
             <a:avLst/>
@@ -32824,6 +33503,45 @@
                 </a:solidFill>
                 <a:latin typeface="Arial"/>
               </a:rPr>
+              <a:t>Genes and FLT direction</a:t>
+            </a:r>
+          </a:p>
+        </p:txBody>
+      </p:sp>
+      <p:sp>
+        <p:nvSpPr>
+          <p:cNvPr id="10" name="TextBox 9"/>
+          <p:cNvSpPr txBox="1"/>
+          <p:nvPr/>
+        </p:nvSpPr>
+        <p:spPr>
+          <a:xfrm>
+            <a:off x="6583680" y="1828800"/>
+            <a:ext cx="4663440" cy="256032"/>
+          </a:xfrm>
+          <a:prstGeom prst="rect">
+            <a:avLst/>
+          </a:prstGeom>
+          <a:noFill/>
+        </p:spPr>
+        <p:txBody>
+          <a:bodyPr wrap="square" lIns="18288" rIns="18288" tIns="18288" bIns="18288" anchor="t">
+            <a:spAutoFit/>
+          </a:bodyPr>
+          <a:lstStyle/>
+          <a:p>
+            <a:pPr algn="l">
+              <a:spcAft>
+                <a:spcPts val="0"/>
+              </a:spcAft>
+            </a:pPr>
+            <a:r>
+              <a:rPr sz="1150" b="1" i="0">
+                <a:solidFill>
+                  <a:srgbClr val="59697A"/>
+                </a:solidFill>
+                <a:latin typeface="Arial"/>
+              </a:rPr>
               <a:t>Interpretation</a:t>
             </a:r>
           </a:p>
@@ -32831,7 +33549,7 @@
       </p:sp>
       <p:sp>
         <p:nvSpPr>
-          <p:cNvPr id="10" name="Rectangle 9"/>
+          <p:cNvPr id="11" name="Rectangle 10"/>
           <p:cNvSpPr/>
           <p:nvPr/>
         </p:nvSpPr>
@@ -32876,7 +33594,7 @@
       </p:sp>
       <p:sp>
         <p:nvSpPr>
-          <p:cNvPr id="11" name="Rectangle 10"/>
+          <p:cNvPr id="12" name="Rectangle 11"/>
           <p:cNvSpPr/>
           <p:nvPr/>
         </p:nvSpPr>
@@ -32919,14 +33637,14 @@
       </p:sp>
       <p:sp>
         <p:nvSpPr>
-          <p:cNvPr id="12" name="TextBox 11"/>
+          <p:cNvPr id="13" name="TextBox 12"/>
           <p:cNvSpPr txBox="1"/>
           <p:nvPr/>
         </p:nvSpPr>
         <p:spPr>
           <a:xfrm>
             <a:off x="658368" y="2331720"/>
-            <a:ext cx="1874519" cy="402336"/>
+            <a:ext cx="1481328" cy="402336"/>
           </a:xfrm>
           <a:prstGeom prst="rect">
             <a:avLst/>
@@ -32945,7 +33663,7 @@
               </a:spcAft>
             </a:pPr>
             <a:r>
-              <a:rPr sz="1550" b="1" i="0">
+              <a:rPr sz="1500" b="1" i="0">
                 <a:solidFill>
                   <a:srgbClr val="478A64"/>
                 </a:solidFill>
@@ -32958,14 +33676,57 @@
       </p:sp>
       <p:sp>
         <p:nvSpPr>
-          <p:cNvPr id="13" name="TextBox 12"/>
+          <p:cNvPr id="14" name="Rectangle 13"/>
+          <p:cNvSpPr/>
+          <p:nvPr/>
+        </p:nvSpPr>
+        <p:spPr>
+          <a:xfrm>
+            <a:off x="2212848" y="2551176"/>
+            <a:ext cx="4041648" cy="10972"/>
+          </a:xfrm>
+          <a:prstGeom prst="rect">
+            <a:avLst/>
+          </a:prstGeom>
+          <a:solidFill>
+            <a:srgbClr val="DDE4E8"/>
+          </a:solidFill>
+          <a:ln>
+            <a:noFill/>
+          </a:ln>
+        </p:spPr>
+        <p:style>
+          <a:lnRef idx="1">
+            <a:schemeClr val="accent1"/>
+          </a:lnRef>
+          <a:fillRef idx="3">
+            <a:schemeClr val="accent1"/>
+          </a:fillRef>
+          <a:effectRef idx="2">
+            <a:schemeClr val="accent1"/>
+          </a:effectRef>
+          <a:fontRef idx="minor">
+            <a:schemeClr val="lt1"/>
+          </a:fontRef>
+        </p:style>
+        <p:txBody>
+          <a:bodyPr rtlCol="0" anchor="ctr"/>
+          <a:lstStyle/>
+          <a:p>
+            <a:pPr algn="ctr"/>
+          </a:p>
+        </p:txBody>
+      </p:sp>
+      <p:sp>
+        <p:nvSpPr>
+          <p:cNvPr id="15" name="TextBox 14"/>
           <p:cNvSpPr txBox="1"/>
           <p:nvPr/>
         </p:nvSpPr>
         <p:spPr>
           <a:xfrm>
-            <a:off x="2697480" y="2258568"/>
-            <a:ext cx="3566160" cy="566928"/>
+            <a:off x="2267712" y="2221992"/>
+            <a:ext cx="1024128" cy="228600"/>
           </a:xfrm>
           <a:prstGeom prst="rect">
             <a:avLst/>
@@ -32984,27 +33745,27 @@
               </a:spcAft>
             </a:pPr>
             <a:r>
-              <a:rPr sz="1250" b="0" i="0">
-                <a:solidFill>
-                  <a:srgbClr val="263746"/>
-                </a:solidFill>
-                <a:latin typeface="Arial"/>
-              </a:rPr>
-              <a:t>[R] Klhl21 lower</a:t>
-            </a:r>
-          </a:p>
-        </p:txBody>
-      </p:sp>
-      <p:sp>
-        <p:nvSpPr>
-          <p:cNvPr id="14" name="TextBox 13"/>
+              <a:rPr sz="1050" b="1" i="0">
+                <a:solidFill>
+                  <a:srgbClr val="D96552"/>
+                </a:solidFill>
+                <a:latin typeface="Arial"/>
+              </a:rPr>
+              <a:t>Promoted</a:t>
+            </a:r>
+          </a:p>
+        </p:txBody>
+      </p:sp>
+      <p:sp>
+        <p:nvSpPr>
+          <p:cNvPr id="16" name="TextBox 15"/>
           <p:cNvSpPr txBox="1"/>
           <p:nvPr/>
         </p:nvSpPr>
         <p:spPr>
           <a:xfrm>
-            <a:off x="6583680" y="2240280"/>
-            <a:ext cx="4754880" cy="603504"/>
+            <a:off x="3456432" y="2194560"/>
+            <a:ext cx="2816352" cy="320040"/>
           </a:xfrm>
           <a:prstGeom prst="rect">
             <a:avLst/>
@@ -33023,6 +33784,123 @@
               </a:spcAft>
             </a:pPr>
             <a:r>
+              <a:rPr sz="1050" b="0" i="0">
+                <a:solidFill>
+                  <a:srgbClr val="263746"/>
+                </a:solidFill>
+                <a:latin typeface="Arial"/>
+              </a:rPr>
+              <a:t>None</a:t>
+            </a:r>
+          </a:p>
+        </p:txBody>
+      </p:sp>
+      <p:sp>
+        <p:nvSpPr>
+          <p:cNvPr id="17" name="TextBox 16"/>
+          <p:cNvSpPr txBox="1"/>
+          <p:nvPr/>
+        </p:nvSpPr>
+        <p:spPr>
+          <a:xfrm>
+            <a:off x="2267712" y="2624328"/>
+            <a:ext cx="1024128" cy="228600"/>
+          </a:xfrm>
+          <a:prstGeom prst="rect">
+            <a:avLst/>
+          </a:prstGeom>
+          <a:noFill/>
+        </p:spPr>
+        <p:txBody>
+          <a:bodyPr wrap="square" lIns="18288" rIns="18288" tIns="18288" bIns="18288" anchor="ctr">
+            <a:spAutoFit/>
+          </a:bodyPr>
+          <a:lstStyle/>
+          <a:p>
+            <a:pPr algn="l">
+              <a:spcAft>
+                <a:spcPts val="0"/>
+              </a:spcAft>
+            </a:pPr>
+            <a:r>
+              <a:rPr sz="1050" b="1" i="0">
+                <a:solidFill>
+                  <a:srgbClr val="178681"/>
+                </a:solidFill>
+                <a:latin typeface="Arial"/>
+              </a:rPr>
+              <a:t>Reinforced</a:t>
+            </a:r>
+          </a:p>
+        </p:txBody>
+      </p:sp>
+      <p:sp>
+        <p:nvSpPr>
+          <p:cNvPr id="18" name="TextBox 17"/>
+          <p:cNvSpPr txBox="1"/>
+          <p:nvPr/>
+        </p:nvSpPr>
+        <p:spPr>
+          <a:xfrm>
+            <a:off x="3456432" y="2587752"/>
+            <a:ext cx="2816352" cy="320040"/>
+          </a:xfrm>
+          <a:prstGeom prst="rect">
+            <a:avLst/>
+          </a:prstGeom>
+          <a:noFill/>
+        </p:spPr>
+        <p:txBody>
+          <a:bodyPr wrap="square" lIns="18288" rIns="18288" tIns="18288" bIns="18288" anchor="ctr">
+            <a:spAutoFit/>
+          </a:bodyPr>
+          <a:lstStyle/>
+          <a:p>
+            <a:pPr algn="l">
+              <a:spcAft>
+                <a:spcPts val="0"/>
+              </a:spcAft>
+            </a:pPr>
+            <a:r>
+              <a:rPr sz="1050" b="0" i="0">
+                <a:solidFill>
+                  <a:srgbClr val="263746"/>
+                </a:solidFill>
+                <a:latin typeface="Arial"/>
+              </a:rPr>
+              <a:t>Klhl21 lower</a:t>
+            </a:r>
+          </a:p>
+        </p:txBody>
+      </p:sp>
+      <p:sp>
+        <p:nvSpPr>
+          <p:cNvPr id="19" name="TextBox 18"/>
+          <p:cNvSpPr txBox="1"/>
+          <p:nvPr/>
+        </p:nvSpPr>
+        <p:spPr>
+          <a:xfrm>
+            <a:off x="6583680" y="2240280"/>
+            <a:ext cx="4754880" cy="603504"/>
+          </a:xfrm>
+          <a:prstGeom prst="rect">
+            <a:avLst/>
+          </a:prstGeom>
+          <a:noFill/>
+        </p:spPr>
+        <p:txBody>
+          <a:bodyPr wrap="square" lIns="18288" rIns="18288" tIns="18288" bIns="18288" anchor="ctr">
+            <a:spAutoFit/>
+          </a:bodyPr>
+          <a:lstStyle/>
+          <a:p>
+            <a:pPr algn="l">
+              <a:spcAft>
+                <a:spcPts val="0"/>
+              </a:spcAft>
+            </a:pPr>
+            <a:r>
               <a:rPr sz="1220" b="0" i="0">
                 <a:solidFill>
                   <a:srgbClr val="263746"/>
@@ -33036,7 +33914,7 @@
       </p:sp>
       <p:sp>
         <p:nvSpPr>
-          <p:cNvPr id="15" name="Rectangle 14"/>
+          <p:cNvPr id="20" name="Rectangle 19"/>
           <p:cNvSpPr/>
           <p:nvPr/>
         </p:nvSpPr>
@@ -33081,7 +33959,7 @@
       </p:sp>
       <p:sp>
         <p:nvSpPr>
-          <p:cNvPr id="16" name="Rectangle 15"/>
+          <p:cNvPr id="21" name="Rectangle 20"/>
           <p:cNvSpPr/>
           <p:nvPr/>
         </p:nvSpPr>
@@ -33124,14 +34002,14 @@
       </p:sp>
       <p:sp>
         <p:nvSpPr>
-          <p:cNvPr id="17" name="TextBox 16"/>
+          <p:cNvPr id="22" name="TextBox 21"/>
           <p:cNvSpPr txBox="1"/>
           <p:nvPr/>
         </p:nvSpPr>
         <p:spPr>
           <a:xfrm>
             <a:off x="658368" y="3300984"/>
-            <a:ext cx="1874519" cy="402336"/>
+            <a:ext cx="1481328" cy="402336"/>
           </a:xfrm>
           <a:prstGeom prst="rect">
             <a:avLst/>
@@ -33150,7 +34028,7 @@
               </a:spcAft>
             </a:pPr>
             <a:r>
-              <a:rPr sz="1550" b="1" i="0">
+              <a:rPr sz="1500" b="1" i="0">
                 <a:solidFill>
                   <a:srgbClr val="8A969E"/>
                 </a:solidFill>
@@ -33163,14 +34041,57 @@
       </p:sp>
       <p:sp>
         <p:nvSpPr>
-          <p:cNvPr id="18" name="TextBox 17"/>
+          <p:cNvPr id="23" name="Rectangle 22"/>
+          <p:cNvSpPr/>
+          <p:nvPr/>
+        </p:nvSpPr>
+        <p:spPr>
+          <a:xfrm>
+            <a:off x="2212848" y="3520440"/>
+            <a:ext cx="4041648" cy="10972"/>
+          </a:xfrm>
+          <a:prstGeom prst="rect">
+            <a:avLst/>
+          </a:prstGeom>
+          <a:solidFill>
+            <a:srgbClr val="DDE4E8"/>
+          </a:solidFill>
+          <a:ln>
+            <a:noFill/>
+          </a:ln>
+        </p:spPr>
+        <p:style>
+          <a:lnRef idx="1">
+            <a:schemeClr val="accent1"/>
+          </a:lnRef>
+          <a:fillRef idx="3">
+            <a:schemeClr val="accent1"/>
+          </a:fillRef>
+          <a:effectRef idx="2">
+            <a:schemeClr val="accent1"/>
+          </a:effectRef>
+          <a:fontRef idx="minor">
+            <a:schemeClr val="lt1"/>
+          </a:fontRef>
+        </p:style>
+        <p:txBody>
+          <a:bodyPr rtlCol="0" anchor="ctr"/>
+          <a:lstStyle/>
+          <a:p>
+            <a:pPr algn="ctr"/>
+          </a:p>
+        </p:txBody>
+      </p:sp>
+      <p:sp>
+        <p:nvSpPr>
+          <p:cNvPr id="24" name="TextBox 23"/>
           <p:cNvSpPr txBox="1"/>
           <p:nvPr/>
         </p:nvSpPr>
         <p:spPr>
           <a:xfrm>
-            <a:off x="2697480" y="3227832"/>
-            <a:ext cx="3566160" cy="566928"/>
+            <a:off x="2267712" y="3191256"/>
+            <a:ext cx="1024128" cy="228600"/>
           </a:xfrm>
           <a:prstGeom prst="rect">
             <a:avLst/>
@@ -33189,27 +34110,27 @@
               </a:spcAft>
             </a:pPr>
             <a:r>
-              <a:rPr sz="1250" b="0" i="0">
-                <a:solidFill>
-                  <a:srgbClr val="263746"/>
-                </a:solidFill>
-                <a:latin typeface="Arial"/>
-              </a:rPr>
-              <a:t>[P] Psmb8 lower; [R] Tspan4 lower</a:t>
-            </a:r>
-          </a:p>
-        </p:txBody>
-      </p:sp>
-      <p:sp>
-        <p:nvSpPr>
-          <p:cNvPr id="19" name="TextBox 18"/>
+              <a:rPr sz="1050" b="1" i="0">
+                <a:solidFill>
+                  <a:srgbClr val="D96552"/>
+                </a:solidFill>
+                <a:latin typeface="Arial"/>
+              </a:rPr>
+              <a:t>Promoted</a:t>
+            </a:r>
+          </a:p>
+        </p:txBody>
+      </p:sp>
+      <p:sp>
+        <p:nvSpPr>
+          <p:cNvPr id="25" name="TextBox 24"/>
           <p:cNvSpPr txBox="1"/>
           <p:nvPr/>
         </p:nvSpPr>
         <p:spPr>
           <a:xfrm>
-            <a:off x="6583680" y="3209544"/>
-            <a:ext cx="4754880" cy="603504"/>
+            <a:off x="3456432" y="3163824"/>
+            <a:ext cx="2816352" cy="320040"/>
           </a:xfrm>
           <a:prstGeom prst="rect">
             <a:avLst/>
@@ -33228,6 +34149,123 @@
               </a:spcAft>
             </a:pPr>
             <a:r>
+              <a:rPr sz="1050" b="0" i="0">
+                <a:solidFill>
+                  <a:srgbClr val="263746"/>
+                </a:solidFill>
+                <a:latin typeface="Arial"/>
+              </a:rPr>
+              <a:t>Psmb8 lower</a:t>
+            </a:r>
+          </a:p>
+        </p:txBody>
+      </p:sp>
+      <p:sp>
+        <p:nvSpPr>
+          <p:cNvPr id="26" name="TextBox 25"/>
+          <p:cNvSpPr txBox="1"/>
+          <p:nvPr/>
+        </p:nvSpPr>
+        <p:spPr>
+          <a:xfrm>
+            <a:off x="2267712" y="3593592"/>
+            <a:ext cx="1024128" cy="228600"/>
+          </a:xfrm>
+          <a:prstGeom prst="rect">
+            <a:avLst/>
+          </a:prstGeom>
+          <a:noFill/>
+        </p:spPr>
+        <p:txBody>
+          <a:bodyPr wrap="square" lIns="18288" rIns="18288" tIns="18288" bIns="18288" anchor="ctr">
+            <a:spAutoFit/>
+          </a:bodyPr>
+          <a:lstStyle/>
+          <a:p>
+            <a:pPr algn="l">
+              <a:spcAft>
+                <a:spcPts val="0"/>
+              </a:spcAft>
+            </a:pPr>
+            <a:r>
+              <a:rPr sz="1050" b="1" i="0">
+                <a:solidFill>
+                  <a:srgbClr val="178681"/>
+                </a:solidFill>
+                <a:latin typeface="Arial"/>
+              </a:rPr>
+              <a:t>Reinforced</a:t>
+            </a:r>
+          </a:p>
+        </p:txBody>
+      </p:sp>
+      <p:sp>
+        <p:nvSpPr>
+          <p:cNvPr id="27" name="TextBox 26"/>
+          <p:cNvSpPr txBox="1"/>
+          <p:nvPr/>
+        </p:nvSpPr>
+        <p:spPr>
+          <a:xfrm>
+            <a:off x="3456432" y="3557016"/>
+            <a:ext cx="2816352" cy="320040"/>
+          </a:xfrm>
+          <a:prstGeom prst="rect">
+            <a:avLst/>
+          </a:prstGeom>
+          <a:noFill/>
+        </p:spPr>
+        <p:txBody>
+          <a:bodyPr wrap="square" lIns="18288" rIns="18288" tIns="18288" bIns="18288" anchor="ctr">
+            <a:spAutoFit/>
+          </a:bodyPr>
+          <a:lstStyle/>
+          <a:p>
+            <a:pPr algn="l">
+              <a:spcAft>
+                <a:spcPts val="0"/>
+              </a:spcAft>
+            </a:pPr>
+            <a:r>
+              <a:rPr sz="1050" b="0" i="0">
+                <a:solidFill>
+                  <a:srgbClr val="263746"/>
+                </a:solidFill>
+                <a:latin typeface="Arial"/>
+              </a:rPr>
+              <a:t>Tspan4 lower</a:t>
+            </a:r>
+          </a:p>
+        </p:txBody>
+      </p:sp>
+      <p:sp>
+        <p:nvSpPr>
+          <p:cNvPr id="28" name="TextBox 27"/>
+          <p:cNvSpPr txBox="1"/>
+          <p:nvPr/>
+        </p:nvSpPr>
+        <p:spPr>
+          <a:xfrm>
+            <a:off x="6583680" y="3209544"/>
+            <a:ext cx="4754880" cy="603504"/>
+          </a:xfrm>
+          <a:prstGeom prst="rect">
+            <a:avLst/>
+          </a:prstGeom>
+          <a:noFill/>
+        </p:spPr>
+        <p:txBody>
+          <a:bodyPr wrap="square" lIns="18288" rIns="18288" tIns="18288" bIns="18288" anchor="ctr">
+            <a:spAutoFit/>
+          </a:bodyPr>
+          <a:lstStyle/>
+          <a:p>
+            <a:pPr algn="l">
+              <a:spcAft>
+                <a:spcPts val="0"/>
+              </a:spcAft>
+            </a:pPr>
+            <a:r>
               <a:rPr sz="1220" b="0" i="0">
                 <a:solidFill>
                   <a:srgbClr val="263746"/>
@@ -33241,7 +34279,7 @@
       </p:sp>
       <p:sp>
         <p:nvSpPr>
-          <p:cNvPr id="20" name="Rectangle 19"/>
+          <p:cNvPr id="29" name="Rectangle 28"/>
           <p:cNvSpPr/>
           <p:nvPr/>
         </p:nvSpPr>
@@ -33286,7 +34324,7 @@
       </p:sp>
       <p:sp>
         <p:nvSpPr>
-          <p:cNvPr id="21" name="Rectangle 20"/>
+          <p:cNvPr id="30" name="Rectangle 29"/>
           <p:cNvSpPr/>
           <p:nvPr/>
         </p:nvSpPr>
@@ -33329,14 +34367,14 @@
       </p:sp>
       <p:sp>
         <p:nvSpPr>
-          <p:cNvPr id="22" name="TextBox 21"/>
+          <p:cNvPr id="31" name="TextBox 30"/>
           <p:cNvSpPr txBox="1"/>
           <p:nvPr/>
         </p:nvSpPr>
         <p:spPr>
           <a:xfrm>
             <a:off x="658368" y="4270248"/>
-            <a:ext cx="1874519" cy="402336"/>
+            <a:ext cx="1481328" cy="402336"/>
           </a:xfrm>
           <a:prstGeom prst="rect">
             <a:avLst/>
@@ -33355,7 +34393,7 @@
               </a:spcAft>
             </a:pPr>
             <a:r>
-              <a:rPr sz="1550" b="1" i="0">
+              <a:rPr sz="1500" b="1" i="0">
                 <a:solidFill>
                   <a:srgbClr val="2D6496"/>
                 </a:solidFill>
@@ -33368,14 +34406,57 @@
       </p:sp>
       <p:sp>
         <p:nvSpPr>
-          <p:cNvPr id="23" name="TextBox 22"/>
+          <p:cNvPr id="32" name="Rectangle 31"/>
+          <p:cNvSpPr/>
+          <p:nvPr/>
+        </p:nvSpPr>
+        <p:spPr>
+          <a:xfrm>
+            <a:off x="2212848" y="4489704"/>
+            <a:ext cx="4041648" cy="10972"/>
+          </a:xfrm>
+          <a:prstGeom prst="rect">
+            <a:avLst/>
+          </a:prstGeom>
+          <a:solidFill>
+            <a:srgbClr val="DDE4E8"/>
+          </a:solidFill>
+          <a:ln>
+            <a:noFill/>
+          </a:ln>
+        </p:spPr>
+        <p:style>
+          <a:lnRef idx="1">
+            <a:schemeClr val="accent1"/>
+          </a:lnRef>
+          <a:fillRef idx="3">
+            <a:schemeClr val="accent1"/>
+          </a:fillRef>
+          <a:effectRef idx="2">
+            <a:schemeClr val="accent1"/>
+          </a:effectRef>
+          <a:fontRef idx="minor">
+            <a:schemeClr val="lt1"/>
+          </a:fontRef>
+        </p:style>
+        <p:txBody>
+          <a:bodyPr rtlCol="0" anchor="ctr"/>
+          <a:lstStyle/>
+          <a:p>
+            <a:pPr algn="ctr"/>
+          </a:p>
+        </p:txBody>
+      </p:sp>
+      <p:sp>
+        <p:nvSpPr>
+          <p:cNvPr id="33" name="TextBox 32"/>
           <p:cNvSpPr txBox="1"/>
           <p:nvPr/>
         </p:nvSpPr>
         <p:spPr>
           <a:xfrm>
-            <a:off x="2697480" y="4197096"/>
-            <a:ext cx="3566160" cy="566928"/>
+            <a:off x="2267712" y="4160520"/>
+            <a:ext cx="1024128" cy="228600"/>
           </a:xfrm>
           <a:prstGeom prst="rect">
             <a:avLst/>
@@ -33394,27 +34475,27 @@
               </a:spcAft>
             </a:pPr>
             <a:r>
-              <a:rPr sz="1250" b="0" i="0">
-                <a:solidFill>
-                  <a:srgbClr val="263746"/>
-                </a:solidFill>
-                <a:latin typeface="Arial"/>
-              </a:rPr>
-              <a:t>[P] Nfkbia higher; [P] Fhl2 lower</a:t>
-            </a:r>
-          </a:p>
-        </p:txBody>
-      </p:sp>
-      <p:sp>
-        <p:nvSpPr>
-          <p:cNvPr id="24" name="TextBox 23"/>
+              <a:rPr sz="1050" b="1" i="0">
+                <a:solidFill>
+                  <a:srgbClr val="D96552"/>
+                </a:solidFill>
+                <a:latin typeface="Arial"/>
+              </a:rPr>
+              <a:t>Promoted</a:t>
+            </a:r>
+          </a:p>
+        </p:txBody>
+      </p:sp>
+      <p:sp>
+        <p:nvSpPr>
+          <p:cNvPr id="34" name="TextBox 33"/>
           <p:cNvSpPr txBox="1"/>
           <p:nvPr/>
         </p:nvSpPr>
         <p:spPr>
           <a:xfrm>
-            <a:off x="6583680" y="4178808"/>
-            <a:ext cx="4754880" cy="603504"/>
+            <a:off x="3456432" y="4133088"/>
+            <a:ext cx="2816352" cy="320040"/>
           </a:xfrm>
           <a:prstGeom prst="rect">
             <a:avLst/>
@@ -33433,6 +34514,123 @@
               </a:spcAft>
             </a:pPr>
             <a:r>
+              <a:rPr sz="1050" b="0" i="0">
+                <a:solidFill>
+                  <a:srgbClr val="263746"/>
+                </a:solidFill>
+                <a:latin typeface="Arial"/>
+              </a:rPr>
+              <a:t>Nfkbia higher; Fhl2 lower</a:t>
+            </a:r>
+          </a:p>
+        </p:txBody>
+      </p:sp>
+      <p:sp>
+        <p:nvSpPr>
+          <p:cNvPr id="35" name="TextBox 34"/>
+          <p:cNvSpPr txBox="1"/>
+          <p:nvPr/>
+        </p:nvSpPr>
+        <p:spPr>
+          <a:xfrm>
+            <a:off x="2267712" y="4562856"/>
+            <a:ext cx="1024128" cy="228600"/>
+          </a:xfrm>
+          <a:prstGeom prst="rect">
+            <a:avLst/>
+          </a:prstGeom>
+          <a:noFill/>
+        </p:spPr>
+        <p:txBody>
+          <a:bodyPr wrap="square" lIns="18288" rIns="18288" tIns="18288" bIns="18288" anchor="ctr">
+            <a:spAutoFit/>
+          </a:bodyPr>
+          <a:lstStyle/>
+          <a:p>
+            <a:pPr algn="l">
+              <a:spcAft>
+                <a:spcPts val="0"/>
+              </a:spcAft>
+            </a:pPr>
+            <a:r>
+              <a:rPr sz="1050" b="1" i="0">
+                <a:solidFill>
+                  <a:srgbClr val="178681"/>
+                </a:solidFill>
+                <a:latin typeface="Arial"/>
+              </a:rPr>
+              <a:t>Reinforced</a:t>
+            </a:r>
+          </a:p>
+        </p:txBody>
+      </p:sp>
+      <p:sp>
+        <p:nvSpPr>
+          <p:cNvPr id="36" name="TextBox 35"/>
+          <p:cNvSpPr txBox="1"/>
+          <p:nvPr/>
+        </p:nvSpPr>
+        <p:spPr>
+          <a:xfrm>
+            <a:off x="3456432" y="4526280"/>
+            <a:ext cx="2816352" cy="320040"/>
+          </a:xfrm>
+          <a:prstGeom prst="rect">
+            <a:avLst/>
+          </a:prstGeom>
+          <a:noFill/>
+        </p:spPr>
+        <p:txBody>
+          <a:bodyPr wrap="square" lIns="18288" rIns="18288" tIns="18288" bIns="18288" anchor="ctr">
+            <a:spAutoFit/>
+          </a:bodyPr>
+          <a:lstStyle/>
+          <a:p>
+            <a:pPr algn="l">
+              <a:spcAft>
+                <a:spcPts val="0"/>
+              </a:spcAft>
+            </a:pPr>
+            <a:r>
+              <a:rPr sz="1050" b="0" i="0">
+                <a:solidFill>
+                  <a:srgbClr val="263746"/>
+                </a:solidFill>
+                <a:latin typeface="Arial"/>
+              </a:rPr>
+              <a:t>None</a:t>
+            </a:r>
+          </a:p>
+        </p:txBody>
+      </p:sp>
+      <p:sp>
+        <p:nvSpPr>
+          <p:cNvPr id="37" name="TextBox 36"/>
+          <p:cNvSpPr txBox="1"/>
+          <p:nvPr/>
+        </p:nvSpPr>
+        <p:spPr>
+          <a:xfrm>
+            <a:off x="6583680" y="4178808"/>
+            <a:ext cx="4754880" cy="603504"/>
+          </a:xfrm>
+          <a:prstGeom prst="rect">
+            <a:avLst/>
+          </a:prstGeom>
+          <a:noFill/>
+        </p:spPr>
+        <p:txBody>
+          <a:bodyPr wrap="square" lIns="18288" rIns="18288" tIns="18288" bIns="18288" anchor="ctr">
+            <a:spAutoFit/>
+          </a:bodyPr>
+          <a:lstStyle/>
+          <a:p>
+            <a:pPr algn="l">
+              <a:spcAft>
+                <a:spcPts val="0"/>
+              </a:spcAft>
+            </a:pPr>
+            <a:r>
               <a:rPr sz="1220" b="0" i="0">
                 <a:solidFill>
                   <a:srgbClr val="263746"/>
@@ -33446,7 +34644,7 @@
       </p:sp>
       <p:sp>
         <p:nvSpPr>
-          <p:cNvPr id="25" name="Rectangle 24"/>
+          <p:cNvPr id="38" name="Rectangle 37"/>
           <p:cNvSpPr/>
           <p:nvPr/>
         </p:nvSpPr>
@@ -33491,7 +34689,7 @@
       </p:sp>
       <p:sp>
         <p:nvSpPr>
-          <p:cNvPr id="26" name="Rectangle 25"/>
+          <p:cNvPr id="39" name="Rectangle 38"/>
           <p:cNvSpPr/>
           <p:nvPr/>
         </p:nvSpPr>
@@ -33534,14 +34732,14 @@
       </p:sp>
       <p:sp>
         <p:nvSpPr>
-          <p:cNvPr id="27" name="TextBox 26"/>
+          <p:cNvPr id="40" name="TextBox 39"/>
           <p:cNvSpPr txBox="1"/>
           <p:nvPr/>
         </p:nvSpPr>
         <p:spPr>
           <a:xfrm>
             <a:off x="658368" y="5239512"/>
-            <a:ext cx="1874519" cy="402336"/>
+            <a:ext cx="1481328" cy="402336"/>
           </a:xfrm>
           <a:prstGeom prst="rect">
             <a:avLst/>
@@ -33560,7 +34758,7 @@
               </a:spcAft>
             </a:pPr>
             <a:r>
-              <a:rPr sz="1550" b="1" i="0">
+              <a:rPr sz="1500" b="1" i="0">
                 <a:solidFill>
                   <a:srgbClr val="178681"/>
                 </a:solidFill>
@@ -33573,14 +34771,57 @@
       </p:sp>
       <p:sp>
         <p:nvSpPr>
-          <p:cNvPr id="28" name="TextBox 27"/>
+          <p:cNvPr id="41" name="Rectangle 40"/>
+          <p:cNvSpPr/>
+          <p:nvPr/>
+        </p:nvSpPr>
+        <p:spPr>
+          <a:xfrm>
+            <a:off x="2212848" y="5458968"/>
+            <a:ext cx="4041648" cy="10972"/>
+          </a:xfrm>
+          <a:prstGeom prst="rect">
+            <a:avLst/>
+          </a:prstGeom>
+          <a:solidFill>
+            <a:srgbClr val="DDE4E8"/>
+          </a:solidFill>
+          <a:ln>
+            <a:noFill/>
+          </a:ln>
+        </p:spPr>
+        <p:style>
+          <a:lnRef idx="1">
+            <a:schemeClr val="accent1"/>
+          </a:lnRef>
+          <a:fillRef idx="3">
+            <a:schemeClr val="accent1"/>
+          </a:fillRef>
+          <a:effectRef idx="2">
+            <a:schemeClr val="accent1"/>
+          </a:effectRef>
+          <a:fontRef idx="minor">
+            <a:schemeClr val="lt1"/>
+          </a:fontRef>
+        </p:style>
+        <p:txBody>
+          <a:bodyPr rtlCol="0" anchor="ctr"/>
+          <a:lstStyle/>
+          <a:p>
+            <a:pPr algn="ctr"/>
+          </a:p>
+        </p:txBody>
+      </p:sp>
+      <p:sp>
+        <p:nvSpPr>
+          <p:cNvPr id="42" name="TextBox 41"/>
           <p:cNvSpPr txBox="1"/>
           <p:nvPr/>
         </p:nvSpPr>
         <p:spPr>
           <a:xfrm>
-            <a:off x="2697480" y="5166360"/>
-            <a:ext cx="3566160" cy="566928"/>
+            <a:off x="2267712" y="5129784"/>
+            <a:ext cx="1024128" cy="228600"/>
           </a:xfrm>
           <a:prstGeom prst="rect">
             <a:avLst/>
@@ -33599,27 +34840,27 @@
               </a:spcAft>
             </a:pPr>
             <a:r>
-              <a:rPr sz="1250" b="0" i="0">
-                <a:solidFill>
-                  <a:srgbClr val="263746"/>
-                </a:solidFill>
-                <a:latin typeface="Arial"/>
-              </a:rPr>
-              <a:t>[P] Cebpd higher; [R] Cdkn1a, St3gal5, Bnip3 higher</a:t>
-            </a:r>
-          </a:p>
-        </p:txBody>
-      </p:sp>
-      <p:sp>
-        <p:nvSpPr>
-          <p:cNvPr id="29" name="TextBox 28"/>
+              <a:rPr sz="1050" b="1" i="0">
+                <a:solidFill>
+                  <a:srgbClr val="D96552"/>
+                </a:solidFill>
+                <a:latin typeface="Arial"/>
+              </a:rPr>
+              <a:t>Promoted</a:t>
+            </a:r>
+          </a:p>
+        </p:txBody>
+      </p:sp>
+      <p:sp>
+        <p:nvSpPr>
+          <p:cNvPr id="43" name="TextBox 42"/>
           <p:cNvSpPr txBox="1"/>
           <p:nvPr/>
         </p:nvSpPr>
         <p:spPr>
           <a:xfrm>
-            <a:off x="6583680" y="5148072"/>
-            <a:ext cx="4754880" cy="603504"/>
+            <a:off x="3456432" y="5102352"/>
+            <a:ext cx="2816352" cy="320040"/>
           </a:xfrm>
           <a:prstGeom prst="rect">
             <a:avLst/>
@@ -33638,27 +34879,27 @@
               </a:spcAft>
             </a:pPr>
             <a:r>
-              <a:rPr sz="1220" b="0" i="0">
+              <a:rPr sz="1050" b="0" i="0">
                 <a:solidFill>
                   <a:srgbClr val="263746"/>
                 </a:solidFill>
                 <a:latin typeface="Arial"/>
               </a:rPr>
-              <a:t>Stress, cell-cycle, ganglioside-signaling and mitophagy candidates with mixed or complementary prior evidence.</a:t>
-            </a:r>
-          </a:p>
-        </p:txBody>
-      </p:sp>
-      <p:sp>
-        <p:nvSpPr>
-          <p:cNvPr id="30" name="TextBox 29"/>
+              <a:t>Cebpd higher</a:t>
+            </a:r>
+          </a:p>
+        </p:txBody>
+      </p:sp>
+      <p:sp>
+        <p:nvSpPr>
+          <p:cNvPr id="44" name="TextBox 43"/>
           <p:cNvSpPr txBox="1"/>
           <p:nvPr/>
         </p:nvSpPr>
         <p:spPr>
           <a:xfrm>
-            <a:off x="329184" y="6510528"/>
-            <a:ext cx="10972800" cy="173736"/>
+            <a:off x="2267712" y="5532120"/>
+            <a:ext cx="1024128" cy="228600"/>
           </a:xfrm>
           <a:prstGeom prst="rect">
             <a:avLst/>
@@ -33677,13 +34918,130 @@
               </a:spcAft>
             </a:pPr>
             <a:r>
+              <a:rPr sz="1050" b="1" i="0">
+                <a:solidFill>
+                  <a:srgbClr val="178681"/>
+                </a:solidFill>
+                <a:latin typeface="Arial"/>
+              </a:rPr>
+              <a:t>Reinforced</a:t>
+            </a:r>
+          </a:p>
+        </p:txBody>
+      </p:sp>
+      <p:sp>
+        <p:nvSpPr>
+          <p:cNvPr id="45" name="TextBox 44"/>
+          <p:cNvSpPr txBox="1"/>
+          <p:nvPr/>
+        </p:nvSpPr>
+        <p:spPr>
+          <a:xfrm>
+            <a:off x="3456432" y="5495544"/>
+            <a:ext cx="2816352" cy="320040"/>
+          </a:xfrm>
+          <a:prstGeom prst="rect">
+            <a:avLst/>
+          </a:prstGeom>
+          <a:noFill/>
+        </p:spPr>
+        <p:txBody>
+          <a:bodyPr wrap="square" lIns="18288" rIns="18288" tIns="18288" bIns="18288" anchor="ctr">
+            <a:spAutoFit/>
+          </a:bodyPr>
+          <a:lstStyle/>
+          <a:p>
+            <a:pPr algn="l">
+              <a:spcAft>
+                <a:spcPts val="0"/>
+              </a:spcAft>
+            </a:pPr>
+            <a:r>
+              <a:rPr sz="1050" b="0" i="0">
+                <a:solidFill>
+                  <a:srgbClr val="263746"/>
+                </a:solidFill>
+                <a:latin typeface="Arial"/>
+              </a:rPr>
+              <a:t>Cdkn1a, St3gal5, Bnip3 higher</a:t>
+            </a:r>
+          </a:p>
+        </p:txBody>
+      </p:sp>
+      <p:sp>
+        <p:nvSpPr>
+          <p:cNvPr id="46" name="TextBox 45"/>
+          <p:cNvSpPr txBox="1"/>
+          <p:nvPr/>
+        </p:nvSpPr>
+        <p:spPr>
+          <a:xfrm>
+            <a:off x="6583680" y="5148072"/>
+            <a:ext cx="4754880" cy="603504"/>
+          </a:xfrm>
+          <a:prstGeom prst="rect">
+            <a:avLst/>
+          </a:prstGeom>
+          <a:noFill/>
+        </p:spPr>
+        <p:txBody>
+          <a:bodyPr wrap="square" lIns="18288" rIns="18288" tIns="18288" bIns="18288" anchor="ctr">
+            <a:spAutoFit/>
+          </a:bodyPr>
+          <a:lstStyle/>
+          <a:p>
+            <a:pPr algn="l">
+              <a:spcAft>
+                <a:spcPts val="0"/>
+              </a:spcAft>
+            </a:pPr>
+            <a:r>
+              <a:rPr sz="1220" b="0" i="0">
+                <a:solidFill>
+                  <a:srgbClr val="263746"/>
+                </a:solidFill>
+                <a:latin typeface="Arial"/>
+              </a:rPr>
+              <a:t>Stress, cell-cycle, ganglioside-signaling and mitophagy candidates with mixed or complementary prior evidence.</a:t>
+            </a:r>
+          </a:p>
+        </p:txBody>
+      </p:sp>
+      <p:sp>
+        <p:nvSpPr>
+          <p:cNvPr id="47" name="TextBox 46"/>
+          <p:cNvSpPr txBox="1"/>
+          <p:nvPr/>
+        </p:nvSpPr>
+        <p:spPr>
+          <a:xfrm>
+            <a:off x="329184" y="6510528"/>
+            <a:ext cx="10972800" cy="173736"/>
+          </a:xfrm>
+          <a:prstGeom prst="rect">
+            <a:avLst/>
+          </a:prstGeom>
+          <a:noFill/>
+        </p:spPr>
+        <p:txBody>
+          <a:bodyPr wrap="square" lIns="18288" rIns="18288" tIns="18288" bIns="18288" anchor="ctr">
+            <a:spAutoFit/>
+          </a:bodyPr>
+          <a:lstStyle/>
+          <a:p>
+            <a:pPr algn="l">
+              <a:spcAft>
+                <a:spcPts val="0"/>
+              </a:spcAft>
+            </a:pPr>
+            <a:r>
               <a:rPr sz="720" b="0" i="0">
                 <a:solidFill>
                   <a:srgbClr val="8A969E"/>
                 </a:solidFill>
                 <a:latin typeface="Arial"/>
               </a:rPr>
-              <a:t>[P] promoted; [R] reinforced. Interpretations follow the independent literature annotations in Table S16.</a:t>
+              <a:t>Interpretations follow the independent literature annotations in Table S16; 'None' means no gene in that selection category.</a:t>
             </a:r>
           </a:p>
         </p:txBody>

</xml_diff>

<commit_message>
Reaudit manuscript and slides with Humanizer
</commit_message>
<xml_diff>
--- a/presentation/SLSTP_2026_Generative_Transcriptomics.pptx
+++ b/presentation/SLSTP_2026_Generative_Transcriptomics.pptx
@@ -1191,7 +1191,7 @@
           <a:p/>
           <a:p>
             <a:r>
-              <a:t>Promoted and reinforced genes are shown on separate subrows for each tissue. Pooled muscle, kidney, spleen and skin each produced a distinct synthetic-informed result. Read these as separate hypotheses, not as grouped biology. Pooled muscle is heterogeneous, kidney suggests phosphoinositide and glucose handling, spleen suggests adhesion and extracellular-matrix or immune organization, and skin contributes a single interferon-linked candidate.</a:t>
+              <a:t>Promoted and reinforced genes are shown on separate subrows for each tissue. Pooled muscle, kidney, spleen and skin each produced a distinct synthetic-informed result. The rows share a slide for presentation space; each remains a separate hypothesis. Pooled muscle is heterogeneous, kidney suggests phosphoinositide and glucose handling, spleen suggests adhesion and extracellular-matrix or immune organization, and skin contributes a single interferon-linked candidate.</a:t>
             </a:r>
           </a:p>
         </p:txBody>
@@ -1343,7 +1343,7 @@
           <a:p/>
           <a:p>
             <a:r>
-              <a:t>The useful role was tissue-specific feature ranking or limited regularization, not increasing biological sample size. Literature annotation then separated exact recovery, process-level agreement and complementary hypotheses. Independent samples and cell-resolved experiments are the next tests.</a:t>
+              <a:t>Synthetic data was useful for tissue-specific feature ranking and limited regularization. It did not increase biological sample size. Literature annotation separated exact recovery, process-level agreement and complementary hypotheses. Independent samples and cell-resolved experiments are the next tests.</a:t>
             </a:r>
           </a:p>
         </p:txBody>
@@ -1647,7 +1647,7 @@
           <a:p/>
           <a:p>
             <a:r>
-              <a:t>Both WGAN-GP and DDIM had high correlation and F1. DDIM had adversarial accuracy near 0.5 and a lower Frechet-distance ratio, so it was harder to separate from real profiles and closer in distribution. The metrics use each model's stated evaluation split. These results are why the remaining analyses use DDIM.</a:t>
+              <a:t>Both WGAN-GP and DDIM had high correlation and F1. DDIM had adversarial accuracy near 0.5 and a lower Frechet-distance ratio, so it was harder to separate from real profiles and closer in distribution. The metrics use each model's stated evaluation split. DDIM was used for the remaining analyses.</a:t>
             </a:r>
           </a:p>
         </p:txBody>

</xml_diff>

<commit_message>
Clarify selected pipeline configuration
</commit_message>
<xml_diff>
--- a/presentation/SLSTP_2026_Generative_Transcriptomics.pptx
+++ b/presentation/SLSTP_2026_Generative_Transcriptomics.pptx
@@ -46656,7 +46656,7 @@
         </p:nvSpPr>
         <p:spPr>
           <a:xfrm>
-            <a:off x="585216" y="5321808"/>
+            <a:off x="585216" y="5312664"/>
             <a:ext cx="1298448" cy="228600"/>
           </a:xfrm>
           <a:prstGeom prst="rect">
@@ -46695,8 +46695,8 @@
         </p:nvSpPr>
         <p:spPr>
           <a:xfrm>
-            <a:off x="585216" y="5669280"/>
-            <a:ext cx="1234440" cy="256032"/>
+            <a:off x="585216" y="5660136"/>
+            <a:ext cx="1234440" cy="219456"/>
           </a:xfrm>
           <a:prstGeom prst="rect">
             <a:avLst/>
@@ -46715,13 +46715,13 @@
               </a:spcAft>
             </a:pPr>
             <a:r>
-              <a:rPr sz="1050" b="0" i="0">
+              <a:rPr sz="960" b="0" i="0">
                 <a:solidFill>
                   <a:srgbClr val="59697A"/>
                 </a:solidFill>
                 <a:latin typeface="Arial"/>
               </a:rPr>
-              <a:t>No global correction</a:t>
+              <a:t>Used downstream</a:t>
             </a:r>
           </a:p>
         </p:txBody>
@@ -46734,8 +46734,8 @@
         </p:nvSpPr>
         <p:spPr>
           <a:xfrm>
-            <a:off x="1938528" y="5303520"/>
-            <a:ext cx="1591056" cy="329184"/>
+            <a:off x="1920240" y="5239512"/>
+            <a:ext cx="1965960" cy="448056"/>
           </a:xfrm>
           <a:prstGeom prst="roundRect">
             <a:avLst/>
@@ -46743,7 +46743,7 @@
           <a:solidFill>
             <a:srgbClr val="FFFFFF"/>
           </a:solidFill>
-          <a:ln w="25400">
+          <a:ln w="10160">
             <a:solidFill>
               <a:srgbClr val="178681"/>
             </a:solidFill>
@@ -46773,44 +46773,40 @@
       </p:sp>
       <p:sp>
         <p:nvSpPr>
-          <p:cNvPr id="118" name="Oval 117"/>
-          <p:cNvSpPr/>
-          <p:nvPr/>
-        </p:nvSpPr>
-        <p:spPr>
-          <a:xfrm>
-            <a:off x="1988820" y="5442508"/>
-            <a:ext cx="50292" cy="50292"/>
-          </a:xfrm>
-          <a:prstGeom prst="ellipse">
-            <a:avLst/>
-          </a:prstGeom>
-          <a:solidFill>
-            <a:srgbClr val="178681"/>
-          </a:solidFill>
-          <a:ln>
-            <a:noFill/>
-          </a:ln>
-        </p:spPr>
-        <p:style>
-          <a:lnRef idx="1">
-            <a:schemeClr val="accent1"/>
-          </a:lnRef>
-          <a:fillRef idx="3">
-            <a:schemeClr val="accent1"/>
-          </a:fillRef>
-          <a:effectRef idx="2">
-            <a:schemeClr val="accent1"/>
-          </a:effectRef>
-          <a:fontRef idx="minor">
-            <a:schemeClr val="lt1"/>
-          </a:fontRef>
-        </p:style>
-        <p:txBody>
-          <a:bodyPr rtlCol="0" anchor="ctr"/>
-          <a:lstStyle/>
-          <a:p>
-            <a:pPr algn="ctr"/>
+          <p:cNvPr id="118" name="TextBox 117"/>
+          <p:cNvSpPr txBox="1"/>
+          <p:nvPr/>
+        </p:nvSpPr>
+        <p:spPr>
+          <a:xfrm>
+            <a:off x="2011680" y="5285232"/>
+            <a:ext cx="1783080" cy="109728"/>
+          </a:xfrm>
+          <a:prstGeom prst="rect">
+            <a:avLst/>
+          </a:prstGeom>
+          <a:noFill/>
+        </p:spPr>
+        <p:txBody>
+          <a:bodyPr wrap="square" lIns="0" rIns="0" tIns="0" bIns="0" anchor="t">
+            <a:spAutoFit/>
+          </a:bodyPr>
+          <a:lstStyle/>
+          <a:p>
+            <a:pPr algn="l">
+              <a:spcAft>
+                <a:spcPts val="0"/>
+              </a:spcAft>
+            </a:pPr>
+            <a:r>
+              <a:rPr sz="710" b="1" i="0">
+                <a:solidFill>
+                  <a:srgbClr val="178681"/>
+                </a:solidFill>
+                <a:latin typeface="Arial"/>
+              </a:rPr>
+              <a:t>PREPROCESS</a:t>
+            </a:r>
           </a:p>
         </p:txBody>
       </p:sp>
@@ -46822,8 +46818,8 @@
         </p:nvSpPr>
         <p:spPr>
           <a:xfrm>
-            <a:off x="2075688" y="5353812"/>
-            <a:ext cx="1426464" cy="210312"/>
+            <a:off x="2011680" y="5431536"/>
+            <a:ext cx="1783080" cy="173736"/>
           </a:xfrm>
           <a:prstGeom prst="rect">
             <a:avLst/>
@@ -46831,7 +46827,7 @@
           <a:noFill/>
         </p:spPr>
         <p:txBody>
-          <a:bodyPr wrap="square" lIns="0" rIns="0" tIns="0" bIns="0" anchor="ctr">
+          <a:bodyPr wrap="square" lIns="0" rIns="0" tIns="0" bIns="0" anchor="t">
             <a:spAutoFit/>
           </a:bodyPr>
           <a:lstStyle/>
@@ -46842,13 +46838,13 @@
               </a:spcAft>
             </a:pPr>
             <a:r>
-              <a:rPr sz="930" b="1" i="0">
+              <a:rPr sz="910" b="1" i="0">
                 <a:solidFill>
                   <a:srgbClr val="263746"/>
                 </a:solidFill>
                 <a:latin typeface="Arial"/>
               </a:rPr>
-              <a:t>ARCHS4 pretrain</a:t>
+              <a:t>TPM / MaxAbs / 974 landmarks</a:t>
             </a:r>
           </a:p>
         </p:txBody>
@@ -46861,7 +46857,7 @@
         </p:nvSpPr>
         <p:spPr>
           <a:xfrm>
-            <a:off x="3584448" y="5367528"/>
+            <a:off x="3950208" y="5358384"/>
             <a:ext cx="210312" cy="182880"/>
           </a:xfrm>
           <a:prstGeom prst="rightArrow">
@@ -46904,8 +46900,1215 @@
         </p:nvSpPr>
         <p:spPr>
           <a:xfrm>
-            <a:off x="3858768" y="5303520"/>
-            <a:ext cx="1591056" cy="329184"/>
+            <a:off x="4251960" y="5239512"/>
+            <a:ext cx="1691640" cy="448056"/>
+          </a:xfrm>
+          <a:prstGeom prst="roundRect">
+            <a:avLst/>
+          </a:prstGeom>
+          <a:solidFill>
+            <a:srgbClr val="FFFFFF"/>
+          </a:solidFill>
+          <a:ln w="10160">
+            <a:solidFill>
+              <a:srgbClr val="178681"/>
+            </a:solidFill>
+          </a:ln>
+        </p:spPr>
+        <p:style>
+          <a:lnRef idx="1">
+            <a:schemeClr val="accent1"/>
+          </a:lnRef>
+          <a:fillRef idx="3">
+            <a:schemeClr val="accent1"/>
+          </a:fillRef>
+          <a:effectRef idx="2">
+            <a:schemeClr val="accent1"/>
+          </a:effectRef>
+          <a:fontRef idx="minor">
+            <a:schemeClr val="lt1"/>
+          </a:fontRef>
+        </p:style>
+        <p:txBody>
+          <a:bodyPr rtlCol="0" anchor="ctr"/>
+          <a:lstStyle/>
+          <a:p>
+            <a:pPr algn="ctr"/>
+          </a:p>
+        </p:txBody>
+      </p:sp>
+      <p:sp>
+        <p:nvSpPr>
+          <p:cNvPr id="122" name="TextBox 121"/>
+          <p:cNvSpPr txBox="1"/>
+          <p:nvPr/>
+        </p:nvSpPr>
+        <p:spPr>
+          <a:xfrm>
+            <a:off x="4343400" y="5285232"/>
+            <a:ext cx="1508760" cy="109728"/>
+          </a:xfrm>
+          <a:prstGeom prst="rect">
+            <a:avLst/>
+          </a:prstGeom>
+          <a:noFill/>
+        </p:spPr>
+        <p:txBody>
+          <a:bodyPr wrap="square" lIns="0" rIns="0" tIns="0" bIns="0" anchor="t">
+            <a:spAutoFit/>
+          </a:bodyPr>
+          <a:lstStyle/>
+          <a:p>
+            <a:pPr algn="l">
+              <a:spcAft>
+                <a:spcPts val="0"/>
+              </a:spcAft>
+            </a:pPr>
+            <a:r>
+              <a:rPr sz="710" b="1" i="0">
+                <a:solidFill>
+                  <a:srgbClr val="178681"/>
+                </a:solidFill>
+                <a:latin typeface="Arial"/>
+              </a:rPr>
+              <a:t>PRETRAIN</a:t>
+            </a:r>
+          </a:p>
+        </p:txBody>
+      </p:sp>
+      <p:sp>
+        <p:nvSpPr>
+          <p:cNvPr id="123" name="TextBox 122"/>
+          <p:cNvSpPr txBox="1"/>
+          <p:nvPr/>
+        </p:nvSpPr>
+        <p:spPr>
+          <a:xfrm>
+            <a:off x="4343400" y="5431536"/>
+            <a:ext cx="1508760" cy="173736"/>
+          </a:xfrm>
+          <a:prstGeom prst="rect">
+            <a:avLst/>
+          </a:prstGeom>
+          <a:noFill/>
+        </p:spPr>
+        <p:txBody>
+          <a:bodyPr wrap="square" lIns="0" rIns="0" tIns="0" bIns="0" anchor="t">
+            <a:spAutoFit/>
+          </a:bodyPr>
+          <a:lstStyle/>
+          <a:p>
+            <a:pPr algn="ctr">
+              <a:spcAft>
+                <a:spcPts val="0"/>
+              </a:spcAft>
+            </a:pPr>
+            <a:r>
+              <a:rPr sz="910" b="1" i="0">
+                <a:solidFill>
+                  <a:srgbClr val="263746"/>
+                </a:solidFill>
+                <a:latin typeface="Arial"/>
+              </a:rPr>
+              <a:t>ARCHS4</a:t>
+            </a:r>
+          </a:p>
+        </p:txBody>
+      </p:sp>
+      <p:sp>
+        <p:nvSpPr>
+          <p:cNvPr id="124" name="Right Arrow 123"/>
+          <p:cNvSpPr/>
+          <p:nvPr/>
+        </p:nvSpPr>
+        <p:spPr>
+          <a:xfrm>
+            <a:off x="6007608" y="5358384"/>
+            <a:ext cx="210312" cy="182880"/>
+          </a:xfrm>
+          <a:prstGeom prst="rightArrow">
+            <a:avLst/>
+          </a:prstGeom>
+          <a:solidFill>
+            <a:srgbClr val="8A969E"/>
+          </a:solidFill>
+          <a:ln>
+            <a:noFill/>
+          </a:ln>
+        </p:spPr>
+        <p:style>
+          <a:lnRef idx="1">
+            <a:schemeClr val="accent1"/>
+          </a:lnRef>
+          <a:fillRef idx="3">
+            <a:schemeClr val="accent1"/>
+          </a:fillRef>
+          <a:effectRef idx="2">
+            <a:schemeClr val="accent1"/>
+          </a:effectRef>
+          <a:fontRef idx="minor">
+            <a:schemeClr val="lt1"/>
+          </a:fontRef>
+        </p:style>
+        <p:txBody>
+          <a:bodyPr rtlCol="0" anchor="ctr"/>
+          <a:lstStyle/>
+          <a:p>
+            <a:pPr algn="ctr"/>
+          </a:p>
+        </p:txBody>
+      </p:sp>
+      <p:sp>
+        <p:nvSpPr>
+          <p:cNvPr id="125" name="Rounded Rectangle 124"/>
+          <p:cNvSpPr/>
+          <p:nvPr/>
+        </p:nvSpPr>
+        <p:spPr>
+          <a:xfrm>
+            <a:off x="6309360" y="5239512"/>
+            <a:ext cx="1691640" cy="448056"/>
+          </a:xfrm>
+          <a:prstGeom prst="roundRect">
+            <a:avLst/>
+          </a:prstGeom>
+          <a:solidFill>
+            <a:srgbClr val="FFFFFF"/>
+          </a:solidFill>
+          <a:ln w="10160">
+            <a:solidFill>
+              <a:srgbClr val="2D6496"/>
+            </a:solidFill>
+          </a:ln>
+        </p:spPr>
+        <p:style>
+          <a:lnRef idx="1">
+            <a:schemeClr val="accent1"/>
+          </a:lnRef>
+          <a:fillRef idx="3">
+            <a:schemeClr val="accent1"/>
+          </a:fillRef>
+          <a:effectRef idx="2">
+            <a:schemeClr val="accent1"/>
+          </a:effectRef>
+          <a:fontRef idx="minor">
+            <a:schemeClr val="lt1"/>
+          </a:fontRef>
+        </p:style>
+        <p:txBody>
+          <a:bodyPr rtlCol="0" anchor="ctr"/>
+          <a:lstStyle/>
+          <a:p>
+            <a:pPr algn="ctr"/>
+          </a:p>
+        </p:txBody>
+      </p:sp>
+      <p:sp>
+        <p:nvSpPr>
+          <p:cNvPr id="126" name="TextBox 125"/>
+          <p:cNvSpPr txBox="1"/>
+          <p:nvPr/>
+        </p:nvSpPr>
+        <p:spPr>
+          <a:xfrm>
+            <a:off x="6400800" y="5285232"/>
+            <a:ext cx="1508760" cy="109728"/>
+          </a:xfrm>
+          <a:prstGeom prst="rect">
+            <a:avLst/>
+          </a:prstGeom>
+          <a:noFill/>
+        </p:spPr>
+        <p:txBody>
+          <a:bodyPr wrap="square" lIns="0" rIns="0" tIns="0" bIns="0" anchor="t">
+            <a:spAutoFit/>
+          </a:bodyPr>
+          <a:lstStyle/>
+          <a:p>
+            <a:pPr algn="l">
+              <a:spcAft>
+                <a:spcPts val="0"/>
+              </a:spcAft>
+            </a:pPr>
+            <a:r>
+              <a:rPr sz="710" b="1" i="0">
+                <a:solidFill>
+                  <a:srgbClr val="2D6496"/>
+                </a:solidFill>
+                <a:latin typeface="Arial"/>
+              </a:rPr>
+              <a:t>ADAPT</a:t>
+            </a:r>
+          </a:p>
+        </p:txBody>
+      </p:sp>
+      <p:sp>
+        <p:nvSpPr>
+          <p:cNvPr id="127" name="TextBox 126"/>
+          <p:cNvSpPr txBox="1"/>
+          <p:nvPr/>
+        </p:nvSpPr>
+        <p:spPr>
+          <a:xfrm>
+            <a:off x="6400800" y="5431536"/>
+            <a:ext cx="1508760" cy="173736"/>
+          </a:xfrm>
+          <a:prstGeom prst="rect">
+            <a:avLst/>
+          </a:prstGeom>
+          <a:noFill/>
+        </p:spPr>
+        <p:txBody>
+          <a:bodyPr wrap="square" lIns="0" rIns="0" tIns="0" bIns="0" anchor="t">
+            <a:spAutoFit/>
+          </a:bodyPr>
+          <a:lstStyle/>
+          <a:p>
+            <a:pPr algn="ctr">
+              <a:spcAft>
+                <a:spcPts val="0"/>
+              </a:spcAft>
+            </a:pPr>
+            <a:r>
+              <a:rPr sz="910" b="1" i="0">
+                <a:solidFill>
+                  <a:srgbClr val="263746"/>
+                </a:solidFill>
+                <a:latin typeface="Arial"/>
+              </a:rPr>
+              <a:t>OSDR</a:t>
+            </a:r>
+          </a:p>
+        </p:txBody>
+      </p:sp>
+      <p:sp>
+        <p:nvSpPr>
+          <p:cNvPr id="128" name="Right Arrow 127"/>
+          <p:cNvSpPr/>
+          <p:nvPr/>
+        </p:nvSpPr>
+        <p:spPr>
+          <a:xfrm>
+            <a:off x="8065008" y="5358384"/>
+            <a:ext cx="210312" cy="182880"/>
+          </a:xfrm>
+          <a:prstGeom prst="rightArrow">
+            <a:avLst/>
+          </a:prstGeom>
+          <a:solidFill>
+            <a:srgbClr val="8A969E"/>
+          </a:solidFill>
+          <a:ln>
+            <a:noFill/>
+          </a:ln>
+        </p:spPr>
+        <p:style>
+          <a:lnRef idx="1">
+            <a:schemeClr val="accent1"/>
+          </a:lnRef>
+          <a:fillRef idx="3">
+            <a:schemeClr val="accent1"/>
+          </a:fillRef>
+          <a:effectRef idx="2">
+            <a:schemeClr val="accent1"/>
+          </a:effectRef>
+          <a:fontRef idx="minor">
+            <a:schemeClr val="lt1"/>
+          </a:fontRef>
+        </p:style>
+        <p:txBody>
+          <a:bodyPr rtlCol="0" anchor="ctr"/>
+          <a:lstStyle/>
+          <a:p>
+            <a:pPr algn="ctr"/>
+          </a:p>
+        </p:txBody>
+      </p:sp>
+      <p:sp>
+        <p:nvSpPr>
+          <p:cNvPr id="129" name="Rounded Rectangle 128"/>
+          <p:cNvSpPr/>
+          <p:nvPr/>
+        </p:nvSpPr>
+        <p:spPr>
+          <a:xfrm>
+            <a:off x="8366760" y="5239512"/>
+            <a:ext cx="2240280" cy="448056"/>
+          </a:xfrm>
+          <a:prstGeom prst="roundRect">
+            <a:avLst/>
+          </a:prstGeom>
+          <a:solidFill>
+            <a:srgbClr val="FFFFFF"/>
+          </a:solidFill>
+          <a:ln w="10160">
+            <a:solidFill>
+              <a:srgbClr val="D37B00"/>
+            </a:solidFill>
+          </a:ln>
+        </p:spPr>
+        <p:style>
+          <a:lnRef idx="1">
+            <a:schemeClr val="accent1"/>
+          </a:lnRef>
+          <a:fillRef idx="3">
+            <a:schemeClr val="accent1"/>
+          </a:fillRef>
+          <a:effectRef idx="2">
+            <a:schemeClr val="accent1"/>
+          </a:effectRef>
+          <a:fontRef idx="minor">
+            <a:schemeClr val="lt1"/>
+          </a:fontRef>
+        </p:style>
+        <p:txBody>
+          <a:bodyPr rtlCol="0" anchor="ctr"/>
+          <a:lstStyle/>
+          <a:p>
+            <a:pPr algn="ctr"/>
+          </a:p>
+        </p:txBody>
+      </p:sp>
+      <p:sp>
+        <p:nvSpPr>
+          <p:cNvPr id="130" name="TextBox 129"/>
+          <p:cNvSpPr txBox="1"/>
+          <p:nvPr/>
+        </p:nvSpPr>
+        <p:spPr>
+          <a:xfrm>
+            <a:off x="8458200" y="5285232"/>
+            <a:ext cx="2057400" cy="109728"/>
+          </a:xfrm>
+          <a:prstGeom prst="rect">
+            <a:avLst/>
+          </a:prstGeom>
+          <a:noFill/>
+        </p:spPr>
+        <p:txBody>
+          <a:bodyPr wrap="square" lIns="0" rIns="0" tIns="0" bIns="0" anchor="t">
+            <a:spAutoFit/>
+          </a:bodyPr>
+          <a:lstStyle/>
+          <a:p>
+            <a:pPr algn="l">
+              <a:spcAft>
+                <a:spcPts val="0"/>
+              </a:spcAft>
+            </a:pPr>
+            <a:r>
+              <a:rPr sz="710" b="1" i="0">
+                <a:solidFill>
+                  <a:srgbClr val="D37B00"/>
+                </a:solidFill>
+                <a:latin typeface="Arial"/>
+              </a:rPr>
+              <a:t>GENERATE</a:t>
+            </a:r>
+          </a:p>
+        </p:txBody>
+      </p:sp>
+      <p:sp>
+        <p:nvSpPr>
+          <p:cNvPr id="131" name="TextBox 130"/>
+          <p:cNvSpPr txBox="1"/>
+          <p:nvPr/>
+        </p:nvSpPr>
+        <p:spPr>
+          <a:xfrm>
+            <a:off x="8458200" y="5431536"/>
+            <a:ext cx="2057400" cy="173736"/>
+          </a:xfrm>
+          <a:prstGeom prst="rect">
+            <a:avLst/>
+          </a:prstGeom>
+          <a:noFill/>
+        </p:spPr>
+        <p:txBody>
+          <a:bodyPr wrap="square" lIns="0" rIns="0" tIns="0" bIns="0" anchor="t">
+            <a:spAutoFit/>
+          </a:bodyPr>
+          <a:lstStyle/>
+          <a:p>
+            <a:pPr algn="ctr">
+              <a:spcAft>
+                <a:spcPts val="0"/>
+              </a:spcAft>
+            </a:pPr>
+            <a:r>
+              <a:rPr sz="910" b="1" i="0">
+                <a:solidFill>
+                  <a:srgbClr val="263746"/>
+                </a:solidFill>
+                <a:latin typeface="Arial"/>
+              </a:rPr>
+              <a:t>Conditional DDIM</a:t>
+            </a:r>
+          </a:p>
+        </p:txBody>
+      </p:sp>
+      <p:sp>
+        <p:nvSpPr>
+          <p:cNvPr id="132" name="TextBox 131"/>
+          <p:cNvSpPr txBox="1"/>
+          <p:nvPr/>
+        </p:nvSpPr>
+        <p:spPr>
+          <a:xfrm>
+            <a:off x="1920240" y="5824728"/>
+            <a:ext cx="658368" cy="146304"/>
+          </a:xfrm>
+          <a:prstGeom prst="rect">
+            <a:avLst/>
+          </a:prstGeom>
+          <a:noFill/>
+        </p:spPr>
+        <p:txBody>
+          <a:bodyPr wrap="square" lIns="0" rIns="0" tIns="0" bIns="0" anchor="t">
+            <a:spAutoFit/>
+          </a:bodyPr>
+          <a:lstStyle/>
+          <a:p>
+            <a:pPr algn="l">
+              <a:spcAft>
+                <a:spcPts val="0"/>
+              </a:spcAft>
+            </a:pPr>
+            <a:r>
+              <a:rPr sz="730" b="1" i="0">
+                <a:solidFill>
+                  <a:srgbClr val="478A64"/>
+                </a:solidFill>
+                <a:latin typeface="Arial"/>
+              </a:rPr>
+              <a:t>CONDITION</a:t>
+            </a:r>
+          </a:p>
+        </p:txBody>
+      </p:sp>
+      <p:sp>
+        <p:nvSpPr>
+          <p:cNvPr id="133" name="Rounded Rectangle 132"/>
+          <p:cNvSpPr/>
+          <p:nvPr/>
+        </p:nvSpPr>
+        <p:spPr>
+          <a:xfrm>
+            <a:off x="2633472" y="5733288"/>
+            <a:ext cx="822960" cy="329184"/>
+          </a:xfrm>
+          <a:prstGeom prst="roundRect">
+            <a:avLst/>
+          </a:prstGeom>
+          <a:solidFill>
+            <a:srgbClr val="FFFFFF"/>
+          </a:solidFill>
+          <a:ln w="25400">
+            <a:solidFill>
+              <a:srgbClr val="478A64"/>
+            </a:solidFill>
+          </a:ln>
+        </p:spPr>
+        <p:style>
+          <a:lnRef idx="1">
+            <a:schemeClr val="accent1"/>
+          </a:lnRef>
+          <a:fillRef idx="3">
+            <a:schemeClr val="accent1"/>
+          </a:fillRef>
+          <a:effectRef idx="2">
+            <a:schemeClr val="accent1"/>
+          </a:effectRef>
+          <a:fontRef idx="minor">
+            <a:schemeClr val="lt1"/>
+          </a:fontRef>
+        </p:style>
+        <p:txBody>
+          <a:bodyPr rtlCol="0" anchor="ctr"/>
+          <a:lstStyle/>
+          <a:p>
+            <a:pPr algn="ctr"/>
+          </a:p>
+        </p:txBody>
+      </p:sp>
+      <p:sp>
+        <p:nvSpPr>
+          <p:cNvPr id="134" name="Oval 133"/>
+          <p:cNvSpPr/>
+          <p:nvPr/>
+        </p:nvSpPr>
+        <p:spPr>
+          <a:xfrm>
+            <a:off x="2683764" y="5872276"/>
+            <a:ext cx="50292" cy="50292"/>
+          </a:xfrm>
+          <a:prstGeom prst="ellipse">
+            <a:avLst/>
+          </a:prstGeom>
+          <a:solidFill>
+            <a:srgbClr val="478A64"/>
+          </a:solidFill>
+          <a:ln>
+            <a:noFill/>
+          </a:ln>
+        </p:spPr>
+        <p:style>
+          <a:lnRef idx="1">
+            <a:schemeClr val="accent1"/>
+          </a:lnRef>
+          <a:fillRef idx="3">
+            <a:schemeClr val="accent1"/>
+          </a:fillRef>
+          <a:effectRef idx="2">
+            <a:schemeClr val="accent1"/>
+          </a:effectRef>
+          <a:fontRef idx="minor">
+            <a:schemeClr val="lt1"/>
+          </a:fontRef>
+        </p:style>
+        <p:txBody>
+          <a:bodyPr rtlCol="0" anchor="ctr"/>
+          <a:lstStyle/>
+          <a:p>
+            <a:pPr algn="ctr"/>
+          </a:p>
+        </p:txBody>
+      </p:sp>
+      <p:sp>
+        <p:nvSpPr>
+          <p:cNvPr id="135" name="TextBox 134"/>
+          <p:cNvSpPr txBox="1"/>
+          <p:nvPr/>
+        </p:nvSpPr>
+        <p:spPr>
+          <a:xfrm>
+            <a:off x="2770632" y="5783579"/>
+            <a:ext cx="658368" cy="210312"/>
+          </a:xfrm>
+          <a:prstGeom prst="rect">
+            <a:avLst/>
+          </a:prstGeom>
+          <a:noFill/>
+        </p:spPr>
+        <p:txBody>
+          <a:bodyPr wrap="square" lIns="0" rIns="0" tIns="0" bIns="0" anchor="ctr">
+            <a:spAutoFit/>
+          </a:bodyPr>
+          <a:lstStyle/>
+          <a:p>
+            <a:pPr algn="ctr">
+              <a:spcAft>
+                <a:spcPts val="0"/>
+              </a:spcAft>
+            </a:pPr>
+            <a:r>
+              <a:rPr sz="780" b="1" i="0">
+                <a:solidFill>
+                  <a:srgbClr val="263746"/>
+                </a:solidFill>
+                <a:latin typeface="Arial"/>
+              </a:rPr>
+              <a:t>Tissue</a:t>
+            </a:r>
+          </a:p>
+        </p:txBody>
+      </p:sp>
+      <p:sp>
+        <p:nvSpPr>
+          <p:cNvPr id="136" name="Rounded Rectangle 135"/>
+          <p:cNvSpPr/>
+          <p:nvPr/>
+        </p:nvSpPr>
+        <p:spPr>
+          <a:xfrm>
+            <a:off x="3520440" y="5733288"/>
+            <a:ext cx="914400" cy="329184"/>
+          </a:xfrm>
+          <a:prstGeom prst="roundRect">
+            <a:avLst/>
+          </a:prstGeom>
+          <a:solidFill>
+            <a:srgbClr val="FFFFFF"/>
+          </a:solidFill>
+          <a:ln w="25400">
+            <a:solidFill>
+              <a:srgbClr val="478A64"/>
+            </a:solidFill>
+          </a:ln>
+        </p:spPr>
+        <p:style>
+          <a:lnRef idx="1">
+            <a:schemeClr val="accent1"/>
+          </a:lnRef>
+          <a:fillRef idx="3">
+            <a:schemeClr val="accent1"/>
+          </a:fillRef>
+          <a:effectRef idx="2">
+            <a:schemeClr val="accent1"/>
+          </a:effectRef>
+          <a:fontRef idx="minor">
+            <a:schemeClr val="lt1"/>
+          </a:fontRef>
+        </p:style>
+        <p:txBody>
+          <a:bodyPr rtlCol="0" anchor="ctr"/>
+          <a:lstStyle/>
+          <a:p>
+            <a:pPr algn="ctr"/>
+          </a:p>
+        </p:txBody>
+      </p:sp>
+      <p:sp>
+        <p:nvSpPr>
+          <p:cNvPr id="137" name="Oval 136"/>
+          <p:cNvSpPr/>
+          <p:nvPr/>
+        </p:nvSpPr>
+        <p:spPr>
+          <a:xfrm>
+            <a:off x="3570732" y="5872276"/>
+            <a:ext cx="50292" cy="50292"/>
+          </a:xfrm>
+          <a:prstGeom prst="ellipse">
+            <a:avLst/>
+          </a:prstGeom>
+          <a:solidFill>
+            <a:srgbClr val="478A64"/>
+          </a:solidFill>
+          <a:ln>
+            <a:noFill/>
+          </a:ln>
+        </p:spPr>
+        <p:style>
+          <a:lnRef idx="1">
+            <a:schemeClr val="accent1"/>
+          </a:lnRef>
+          <a:fillRef idx="3">
+            <a:schemeClr val="accent1"/>
+          </a:fillRef>
+          <a:effectRef idx="2">
+            <a:schemeClr val="accent1"/>
+          </a:effectRef>
+          <a:fontRef idx="minor">
+            <a:schemeClr val="lt1"/>
+          </a:fontRef>
+        </p:style>
+        <p:txBody>
+          <a:bodyPr rtlCol="0" anchor="ctr"/>
+          <a:lstStyle/>
+          <a:p>
+            <a:pPr algn="ctr"/>
+          </a:p>
+        </p:txBody>
+      </p:sp>
+      <p:sp>
+        <p:nvSpPr>
+          <p:cNvPr id="138" name="TextBox 137"/>
+          <p:cNvSpPr txBox="1"/>
+          <p:nvPr/>
+        </p:nvSpPr>
+        <p:spPr>
+          <a:xfrm>
+            <a:off x="3657600" y="5783579"/>
+            <a:ext cx="749808" cy="210312"/>
+          </a:xfrm>
+          <a:prstGeom prst="rect">
+            <a:avLst/>
+          </a:prstGeom>
+          <a:noFill/>
+        </p:spPr>
+        <p:txBody>
+          <a:bodyPr wrap="square" lIns="0" rIns="0" tIns="0" bIns="0" anchor="ctr">
+            <a:spAutoFit/>
+          </a:bodyPr>
+          <a:lstStyle/>
+          <a:p>
+            <a:pPr algn="ctr">
+              <a:spcAft>
+                <a:spcPts val="0"/>
+              </a:spcAft>
+            </a:pPr>
+            <a:r>
+              <a:rPr sz="780" b="1" i="0">
+                <a:solidFill>
+                  <a:srgbClr val="263746"/>
+                </a:solidFill>
+                <a:latin typeface="Arial"/>
+              </a:rPr>
+              <a:t>FLT / GC</a:t>
+            </a:r>
+          </a:p>
+        </p:txBody>
+      </p:sp>
+      <p:sp>
+        <p:nvSpPr>
+          <p:cNvPr id="139" name="Rounded Rectangle 138"/>
+          <p:cNvSpPr/>
+          <p:nvPr/>
+        </p:nvSpPr>
+        <p:spPr>
+          <a:xfrm>
+            <a:off x="4498848" y="5733288"/>
+            <a:ext cx="1042415" cy="329184"/>
+          </a:xfrm>
+          <a:prstGeom prst="roundRect">
+            <a:avLst/>
+          </a:prstGeom>
+          <a:solidFill>
+            <a:srgbClr val="FFFFFF"/>
+          </a:solidFill>
+          <a:ln w="25400">
+            <a:solidFill>
+              <a:srgbClr val="478A64"/>
+            </a:solidFill>
+          </a:ln>
+        </p:spPr>
+        <p:style>
+          <a:lnRef idx="1">
+            <a:schemeClr val="accent1"/>
+          </a:lnRef>
+          <a:fillRef idx="3">
+            <a:schemeClr val="accent1"/>
+          </a:fillRef>
+          <a:effectRef idx="2">
+            <a:schemeClr val="accent1"/>
+          </a:effectRef>
+          <a:fontRef idx="minor">
+            <a:schemeClr val="lt1"/>
+          </a:fontRef>
+        </p:style>
+        <p:txBody>
+          <a:bodyPr rtlCol="0" anchor="ctr"/>
+          <a:lstStyle/>
+          <a:p>
+            <a:pPr algn="ctr"/>
+          </a:p>
+        </p:txBody>
+      </p:sp>
+      <p:sp>
+        <p:nvSpPr>
+          <p:cNvPr id="140" name="Oval 139"/>
+          <p:cNvSpPr/>
+          <p:nvPr/>
+        </p:nvSpPr>
+        <p:spPr>
+          <a:xfrm>
+            <a:off x="4549140" y="5872276"/>
+            <a:ext cx="50292" cy="50292"/>
+          </a:xfrm>
+          <a:prstGeom prst="ellipse">
+            <a:avLst/>
+          </a:prstGeom>
+          <a:solidFill>
+            <a:srgbClr val="478A64"/>
+          </a:solidFill>
+          <a:ln>
+            <a:noFill/>
+          </a:ln>
+        </p:spPr>
+        <p:style>
+          <a:lnRef idx="1">
+            <a:schemeClr val="accent1"/>
+          </a:lnRef>
+          <a:fillRef idx="3">
+            <a:schemeClr val="accent1"/>
+          </a:fillRef>
+          <a:effectRef idx="2">
+            <a:schemeClr val="accent1"/>
+          </a:effectRef>
+          <a:fontRef idx="minor">
+            <a:schemeClr val="lt1"/>
+          </a:fontRef>
+        </p:style>
+        <p:txBody>
+          <a:bodyPr rtlCol="0" anchor="ctr"/>
+          <a:lstStyle/>
+          <a:p>
+            <a:pPr algn="ctr"/>
+          </a:p>
+        </p:txBody>
+      </p:sp>
+      <p:sp>
+        <p:nvSpPr>
+          <p:cNvPr id="141" name="TextBox 140"/>
+          <p:cNvSpPr txBox="1"/>
+          <p:nvPr/>
+        </p:nvSpPr>
+        <p:spPr>
+          <a:xfrm>
+            <a:off x="4636008" y="5783579"/>
+            <a:ext cx="877824" cy="210312"/>
+          </a:xfrm>
+          <a:prstGeom prst="rect">
+            <a:avLst/>
+          </a:prstGeom>
+          <a:noFill/>
+        </p:spPr>
+        <p:txBody>
+          <a:bodyPr wrap="square" lIns="0" rIns="0" tIns="0" bIns="0" anchor="ctr">
+            <a:spAutoFit/>
+          </a:bodyPr>
+          <a:lstStyle/>
+          <a:p>
+            <a:pPr algn="ctr">
+              <a:spcAft>
+                <a:spcPts val="0"/>
+              </a:spcAft>
+            </a:pPr>
+            <a:r>
+              <a:rPr sz="780" b="1" i="0">
+                <a:solidFill>
+                  <a:srgbClr val="263746"/>
+                </a:solidFill>
+                <a:latin typeface="Arial"/>
+              </a:rPr>
+              <a:t>Accession</a:t>
+            </a:r>
+          </a:p>
+        </p:txBody>
+      </p:sp>
+      <p:sp>
+        <p:nvSpPr>
+          <p:cNvPr id="142" name="Rounded Rectangle 141"/>
+          <p:cNvSpPr/>
+          <p:nvPr/>
+        </p:nvSpPr>
+        <p:spPr>
+          <a:xfrm>
+            <a:off x="5605272" y="5733288"/>
+            <a:ext cx="1261872" cy="329184"/>
+          </a:xfrm>
+          <a:prstGeom prst="roundRect">
+            <a:avLst/>
+          </a:prstGeom>
+          <a:solidFill>
+            <a:srgbClr val="FFFFFF"/>
+          </a:solidFill>
+          <a:ln w="25400">
+            <a:solidFill>
+              <a:srgbClr val="478A64"/>
+            </a:solidFill>
+          </a:ln>
+        </p:spPr>
+        <p:style>
+          <a:lnRef idx="1">
+            <a:schemeClr val="accent1"/>
+          </a:lnRef>
+          <a:fillRef idx="3">
+            <a:schemeClr val="accent1"/>
+          </a:fillRef>
+          <a:effectRef idx="2">
+            <a:schemeClr val="accent1"/>
+          </a:effectRef>
+          <a:fontRef idx="minor">
+            <a:schemeClr val="lt1"/>
+          </a:fontRef>
+        </p:style>
+        <p:txBody>
+          <a:bodyPr rtlCol="0" anchor="ctr"/>
+          <a:lstStyle/>
+          <a:p>
+            <a:pPr algn="ctr"/>
+          </a:p>
+        </p:txBody>
+      </p:sp>
+      <p:sp>
+        <p:nvSpPr>
+          <p:cNvPr id="143" name="Oval 142"/>
+          <p:cNvSpPr/>
+          <p:nvPr/>
+        </p:nvSpPr>
+        <p:spPr>
+          <a:xfrm>
+            <a:off x="5655564" y="5872276"/>
+            <a:ext cx="50292" cy="50292"/>
+          </a:xfrm>
+          <a:prstGeom prst="ellipse">
+            <a:avLst/>
+          </a:prstGeom>
+          <a:solidFill>
+            <a:srgbClr val="478A64"/>
+          </a:solidFill>
+          <a:ln>
+            <a:noFill/>
+          </a:ln>
+        </p:spPr>
+        <p:style>
+          <a:lnRef idx="1">
+            <a:schemeClr val="accent1"/>
+          </a:lnRef>
+          <a:fillRef idx="3">
+            <a:schemeClr val="accent1"/>
+          </a:fillRef>
+          <a:effectRef idx="2">
+            <a:schemeClr val="accent1"/>
+          </a:effectRef>
+          <a:fontRef idx="minor">
+            <a:schemeClr val="lt1"/>
+          </a:fontRef>
+        </p:style>
+        <p:txBody>
+          <a:bodyPr rtlCol="0" anchor="ctr"/>
+          <a:lstStyle/>
+          <a:p>
+            <a:pPr algn="ctr"/>
+          </a:p>
+        </p:txBody>
+      </p:sp>
+      <p:sp>
+        <p:nvSpPr>
+          <p:cNvPr id="144" name="TextBox 143"/>
+          <p:cNvSpPr txBox="1"/>
+          <p:nvPr/>
+        </p:nvSpPr>
+        <p:spPr>
+          <a:xfrm>
+            <a:off x="5742432" y="5783579"/>
+            <a:ext cx="1097280" cy="210312"/>
+          </a:xfrm>
+          <a:prstGeom prst="rect">
+            <a:avLst/>
+          </a:prstGeom>
+          <a:noFill/>
+        </p:spPr>
+        <p:txBody>
+          <a:bodyPr wrap="square" lIns="0" rIns="0" tIns="0" bIns="0" anchor="ctr">
+            <a:spAutoFit/>
+          </a:bodyPr>
+          <a:lstStyle/>
+          <a:p>
+            <a:pPr algn="ctr">
+              <a:spcAft>
+                <a:spcPts val="0"/>
+              </a:spcAft>
+            </a:pPr>
+            <a:r>
+              <a:rPr sz="780" b="1" i="0">
+                <a:solidFill>
+                  <a:srgbClr val="263746"/>
+                </a:solidFill>
+                <a:latin typeface="Arial"/>
+              </a:rPr>
+              <a:t>Material type</a:t>
+            </a:r>
+          </a:p>
+        </p:txBody>
+      </p:sp>
+      <p:sp>
+        <p:nvSpPr>
+          <p:cNvPr id="145" name="TextBox 144"/>
+          <p:cNvSpPr txBox="1"/>
+          <p:nvPr/>
+        </p:nvSpPr>
+        <p:spPr>
+          <a:xfrm>
+            <a:off x="7095744" y="5824728"/>
+            <a:ext cx="749808" cy="146304"/>
+          </a:xfrm>
+          <a:prstGeom prst="rect">
+            <a:avLst/>
+          </a:prstGeom>
+          <a:noFill/>
+        </p:spPr>
+        <p:txBody>
+          <a:bodyPr wrap="square" lIns="0" rIns="0" tIns="0" bIns="0" anchor="t">
+            <a:spAutoFit/>
+          </a:bodyPr>
+          <a:lstStyle/>
+          <a:p>
+            <a:pPr algn="l">
+              <a:spcAft>
+                <a:spcPts val="0"/>
+              </a:spcAft>
+            </a:pPr>
+            <a:r>
+              <a:rPr sz="730" b="1" i="0">
+                <a:solidFill>
+                  <a:srgbClr val="8063A6"/>
+                </a:solidFill>
+                <a:latin typeface="Arial"/>
+              </a:rPr>
+              <a:t>HARMONIZE</a:t>
+            </a:r>
+          </a:p>
+        </p:txBody>
+      </p:sp>
+      <p:sp>
+        <p:nvSpPr>
+          <p:cNvPr id="146" name="Rounded Rectangle 145"/>
+          <p:cNvSpPr/>
+          <p:nvPr/>
+        </p:nvSpPr>
+        <p:spPr>
+          <a:xfrm>
+            <a:off x="7909560" y="5733288"/>
+            <a:ext cx="713232" cy="329184"/>
+          </a:xfrm>
+          <a:prstGeom prst="roundRect">
+            <a:avLst/>
+          </a:prstGeom>
+          <a:solidFill>
+            <a:srgbClr val="FFFFFF"/>
+          </a:solidFill>
+          <a:ln w="25400">
+            <a:solidFill>
+              <a:srgbClr val="8063A6"/>
+            </a:solidFill>
+          </a:ln>
+        </p:spPr>
+        <p:style>
+          <a:lnRef idx="1">
+            <a:schemeClr val="accent1"/>
+          </a:lnRef>
+          <a:fillRef idx="3">
+            <a:schemeClr val="accent1"/>
+          </a:fillRef>
+          <a:effectRef idx="2">
+            <a:schemeClr val="accent1"/>
+          </a:effectRef>
+          <a:fontRef idx="minor">
+            <a:schemeClr val="lt1"/>
+          </a:fontRef>
+        </p:style>
+        <p:txBody>
+          <a:bodyPr rtlCol="0" anchor="ctr"/>
+          <a:lstStyle/>
+          <a:p>
+            <a:pPr algn="ctr"/>
+          </a:p>
+        </p:txBody>
+      </p:sp>
+      <p:sp>
+        <p:nvSpPr>
+          <p:cNvPr id="147" name="Oval 146"/>
+          <p:cNvSpPr/>
+          <p:nvPr/>
+        </p:nvSpPr>
+        <p:spPr>
+          <a:xfrm>
+            <a:off x="7959852" y="5872276"/>
+            <a:ext cx="50292" cy="50292"/>
+          </a:xfrm>
+          <a:prstGeom prst="ellipse">
+            <a:avLst/>
+          </a:prstGeom>
+          <a:solidFill>
+            <a:srgbClr val="8063A6"/>
+          </a:solidFill>
+          <a:ln>
+            <a:noFill/>
+          </a:ln>
+        </p:spPr>
+        <p:style>
+          <a:lnRef idx="1">
+            <a:schemeClr val="accent1"/>
+          </a:lnRef>
+          <a:fillRef idx="3">
+            <a:schemeClr val="accent1"/>
+          </a:fillRef>
+          <a:effectRef idx="2">
+            <a:schemeClr val="accent1"/>
+          </a:effectRef>
+          <a:fontRef idx="minor">
+            <a:schemeClr val="lt1"/>
+          </a:fontRef>
+        </p:style>
+        <p:txBody>
+          <a:bodyPr rtlCol="0" anchor="ctr"/>
+          <a:lstStyle/>
+          <a:p>
+            <a:pPr algn="ctr"/>
+          </a:p>
+        </p:txBody>
+      </p:sp>
+      <p:sp>
+        <p:nvSpPr>
+          <p:cNvPr id="148" name="TextBox 147"/>
+          <p:cNvSpPr txBox="1"/>
+          <p:nvPr/>
+        </p:nvSpPr>
+        <p:spPr>
+          <a:xfrm>
+            <a:off x="8046720" y="5783579"/>
+            <a:ext cx="548640" cy="210312"/>
+          </a:xfrm>
+          <a:prstGeom prst="rect">
+            <a:avLst/>
+          </a:prstGeom>
+          <a:noFill/>
+        </p:spPr>
+        <p:txBody>
+          <a:bodyPr wrap="square" lIns="0" rIns="0" tIns="0" bIns="0" anchor="ctr">
+            <a:spAutoFit/>
+          </a:bodyPr>
+          <a:lstStyle/>
+          <a:p>
+            <a:pPr algn="ctr">
+              <a:spcAft>
+                <a:spcPts val="0"/>
+              </a:spcAft>
+            </a:pPr>
+            <a:r>
+              <a:rPr sz="780" b="1" i="0">
+                <a:solidFill>
+                  <a:srgbClr val="263746"/>
+                </a:solidFill>
+                <a:latin typeface="Arial"/>
+              </a:rPr>
+              <a:t>None</a:t>
+            </a:r>
+          </a:p>
+        </p:txBody>
+      </p:sp>
+      <p:sp>
+        <p:nvSpPr>
+          <p:cNvPr id="149" name="TextBox 148"/>
+          <p:cNvSpPr txBox="1"/>
+          <p:nvPr/>
+        </p:nvSpPr>
+        <p:spPr>
+          <a:xfrm>
+            <a:off x="8869680" y="5824728"/>
+            <a:ext cx="420624" cy="146304"/>
+          </a:xfrm>
+          <a:prstGeom prst="rect">
+            <a:avLst/>
+          </a:prstGeom>
+          <a:noFill/>
+        </p:spPr>
+        <p:txBody>
+          <a:bodyPr wrap="square" lIns="0" rIns="0" tIns="0" bIns="0" anchor="t">
+            <a:spAutoFit/>
+          </a:bodyPr>
+          <a:lstStyle/>
+          <a:p>
+            <a:pPr algn="l">
+              <a:spcAft>
+                <a:spcPts val="0"/>
+              </a:spcAft>
+            </a:pPr>
+            <a:r>
+              <a:rPr sz="730" b="1" i="0">
+                <a:solidFill>
+                  <a:srgbClr val="2D6496"/>
+                </a:solidFill>
+                <a:latin typeface="Arial"/>
+              </a:rPr>
+              <a:t>SCOPE</a:t>
+            </a:r>
+          </a:p>
+        </p:txBody>
+      </p:sp>
+      <p:sp>
+        <p:nvSpPr>
+          <p:cNvPr id="150" name="Rounded Rectangle 149"/>
+          <p:cNvSpPr/>
+          <p:nvPr/>
+        </p:nvSpPr>
+        <p:spPr>
+          <a:xfrm>
+            <a:off x="9363456" y="5733288"/>
+            <a:ext cx="1097280" cy="329184"/>
           </a:xfrm>
           <a:prstGeom prst="roundRect">
             <a:avLst/>
@@ -46943,13 +48146,13 @@
       </p:sp>
       <p:sp>
         <p:nvSpPr>
-          <p:cNvPr id="122" name="Oval 121"/>
+          <p:cNvPr id="151" name="Oval 150"/>
           <p:cNvSpPr/>
           <p:nvPr/>
         </p:nvSpPr>
         <p:spPr>
           <a:xfrm>
-            <a:off x="3909059" y="5442508"/>
+            <a:off x="9413748" y="5872276"/>
             <a:ext cx="50292" cy="50292"/>
           </a:xfrm>
           <a:prstGeom prst="ellipse">
@@ -46986,14 +48189,14 @@
       </p:sp>
       <p:sp>
         <p:nvSpPr>
-          <p:cNvPr id="123" name="TextBox 122"/>
+          <p:cNvPr id="152" name="TextBox 151"/>
           <p:cNvSpPr txBox="1"/>
           <p:nvPr/>
         </p:nvSpPr>
         <p:spPr>
           <a:xfrm>
-            <a:off x="3995928" y="5353812"/>
-            <a:ext cx="1426464" cy="210312"/>
+            <a:off x="9500616" y="5783579"/>
+            <a:ext cx="932688" cy="210312"/>
           </a:xfrm>
           <a:prstGeom prst="rect">
             <a:avLst/>
@@ -47012,268 +48215,20 @@
               </a:spcAft>
             </a:pPr>
             <a:r>
-              <a:rPr sz="930" b="1" i="0">
+              <a:rPr sz="780" b="1" i="0">
                 <a:solidFill>
                   <a:srgbClr val="263746"/>
                 </a:solidFill>
                 <a:latin typeface="Arial"/>
               </a:rPr>
-              <a:t>OSDR adaptation</a:t>
-            </a:r>
-          </a:p>
-        </p:txBody>
-      </p:sp>
-      <p:sp>
-        <p:nvSpPr>
-          <p:cNvPr id="124" name="Right Arrow 123"/>
-          <p:cNvSpPr/>
-          <p:nvPr/>
-        </p:nvSpPr>
-        <p:spPr>
-          <a:xfrm>
-            <a:off x="5504688" y="5367528"/>
-            <a:ext cx="210312" cy="182880"/>
-          </a:xfrm>
-          <a:prstGeom prst="rightArrow">
-            <a:avLst/>
-          </a:prstGeom>
-          <a:solidFill>
-            <a:srgbClr val="8A969E"/>
-          </a:solidFill>
-          <a:ln>
-            <a:noFill/>
-          </a:ln>
-        </p:spPr>
-        <p:style>
-          <a:lnRef idx="1">
-            <a:schemeClr val="accent1"/>
-          </a:lnRef>
-          <a:fillRef idx="3">
-            <a:schemeClr val="accent1"/>
-          </a:fillRef>
-          <a:effectRef idx="2">
-            <a:schemeClr val="accent1"/>
-          </a:effectRef>
-          <a:fontRef idx="minor">
-            <a:schemeClr val="lt1"/>
-          </a:fontRef>
-        </p:style>
-        <p:txBody>
-          <a:bodyPr rtlCol="0" anchor="ctr"/>
-          <a:lstStyle/>
-          <a:p>
-            <a:pPr algn="ctr"/>
-          </a:p>
-        </p:txBody>
-      </p:sp>
-      <p:sp>
-        <p:nvSpPr>
-          <p:cNvPr id="125" name="Rounded Rectangle 124"/>
-          <p:cNvSpPr/>
-          <p:nvPr/>
-        </p:nvSpPr>
-        <p:spPr>
-          <a:xfrm>
-            <a:off x="5779008" y="5303520"/>
-            <a:ext cx="1591056" cy="329184"/>
-          </a:xfrm>
-          <a:prstGeom prst="roundRect">
-            <a:avLst/>
-          </a:prstGeom>
-          <a:solidFill>
-            <a:srgbClr val="FFFFFF"/>
-          </a:solidFill>
-          <a:ln w="25400">
-            <a:solidFill>
-              <a:srgbClr val="D37B00"/>
-            </a:solidFill>
-          </a:ln>
-        </p:spPr>
-        <p:style>
-          <a:lnRef idx="1">
-            <a:schemeClr val="accent1"/>
-          </a:lnRef>
-          <a:fillRef idx="3">
-            <a:schemeClr val="accent1"/>
-          </a:fillRef>
-          <a:effectRef idx="2">
-            <a:schemeClr val="accent1"/>
-          </a:effectRef>
-          <a:fontRef idx="minor">
-            <a:schemeClr val="lt1"/>
-          </a:fontRef>
-        </p:style>
-        <p:txBody>
-          <a:bodyPr rtlCol="0" anchor="ctr"/>
-          <a:lstStyle/>
-          <a:p>
-            <a:pPr algn="ctr"/>
-          </a:p>
-        </p:txBody>
-      </p:sp>
-      <p:sp>
-        <p:nvSpPr>
-          <p:cNvPr id="126" name="Oval 125"/>
-          <p:cNvSpPr/>
-          <p:nvPr/>
-        </p:nvSpPr>
-        <p:spPr>
-          <a:xfrm>
-            <a:off x="5829300" y="5442508"/>
-            <a:ext cx="50292" cy="50292"/>
-          </a:xfrm>
-          <a:prstGeom prst="ellipse">
-            <a:avLst/>
-          </a:prstGeom>
-          <a:solidFill>
-            <a:srgbClr val="D37B00"/>
-          </a:solidFill>
-          <a:ln>
-            <a:noFill/>
-          </a:ln>
-        </p:spPr>
-        <p:style>
-          <a:lnRef idx="1">
-            <a:schemeClr val="accent1"/>
-          </a:lnRef>
-          <a:fillRef idx="3">
-            <a:schemeClr val="accent1"/>
-          </a:fillRef>
-          <a:effectRef idx="2">
-            <a:schemeClr val="accent1"/>
-          </a:effectRef>
-          <a:fontRef idx="minor">
-            <a:schemeClr val="lt1"/>
-          </a:fontRef>
-        </p:style>
-        <p:txBody>
-          <a:bodyPr rtlCol="0" anchor="ctr"/>
-          <a:lstStyle/>
-          <a:p>
-            <a:pPr algn="ctr"/>
-          </a:p>
-        </p:txBody>
-      </p:sp>
-      <p:sp>
-        <p:nvSpPr>
-          <p:cNvPr id="127" name="TextBox 126"/>
-          <p:cNvSpPr txBox="1"/>
-          <p:nvPr/>
-        </p:nvSpPr>
-        <p:spPr>
-          <a:xfrm>
-            <a:off x="5916168" y="5353812"/>
-            <a:ext cx="1426464" cy="210312"/>
-          </a:xfrm>
-          <a:prstGeom prst="rect">
-            <a:avLst/>
-          </a:prstGeom>
-          <a:noFill/>
-        </p:spPr>
-        <p:txBody>
-          <a:bodyPr wrap="square" lIns="0" rIns="0" tIns="0" bIns="0" anchor="ctr">
-            <a:spAutoFit/>
-          </a:bodyPr>
-          <a:lstStyle/>
-          <a:p>
-            <a:pPr algn="ctr">
-              <a:spcAft>
-                <a:spcPts val="0"/>
-              </a:spcAft>
-            </a:pPr>
-            <a:r>
-              <a:rPr sz="930" b="1" i="0">
-                <a:solidFill>
-                  <a:srgbClr val="263746"/>
-                </a:solidFill>
-                <a:latin typeface="Arial"/>
-              </a:rPr>
-              <a:t>Conditional DDIM</a:t>
-            </a:r>
-          </a:p>
-        </p:txBody>
-      </p:sp>
-      <p:sp>
-        <p:nvSpPr>
-          <p:cNvPr id="128" name="TextBox 127"/>
-          <p:cNvSpPr txBox="1"/>
-          <p:nvPr/>
-        </p:nvSpPr>
-        <p:spPr>
-          <a:xfrm>
-            <a:off x="7699248" y="5276088"/>
-            <a:ext cx="3675887" cy="246888"/>
-          </a:xfrm>
-          <a:prstGeom prst="rect">
-            <a:avLst/>
-          </a:prstGeom>
-          <a:noFill/>
-        </p:spPr>
-        <p:txBody>
-          <a:bodyPr wrap="square" lIns="18288" rIns="18288" tIns="18288" bIns="18288" anchor="t">
-            <a:spAutoFit/>
-          </a:bodyPr>
-          <a:lstStyle/>
-          <a:p>
-            <a:pPr algn="l">
-              <a:spcAft>
-                <a:spcPts val="0"/>
-              </a:spcAft>
-            </a:pPr>
-            <a:r>
-              <a:rPr sz="1170" b="1" i="0">
-                <a:solidFill>
-                  <a:srgbClr val="082B55"/>
-                </a:solidFill>
-                <a:latin typeface="Arial"/>
-              </a:rPr>
-              <a:t>TPM | MaxAbs | 974 landmarks</a:t>
-            </a:r>
-          </a:p>
-        </p:txBody>
-      </p:sp>
-      <p:sp>
-        <p:nvSpPr>
-          <p:cNvPr id="129" name="TextBox 128"/>
-          <p:cNvSpPr txBox="1"/>
-          <p:nvPr/>
-        </p:nvSpPr>
-        <p:spPr>
-          <a:xfrm>
-            <a:off x="7699248" y="5614416"/>
-            <a:ext cx="3675887" cy="246888"/>
-          </a:xfrm>
-          <a:prstGeom prst="rect">
-            <a:avLst/>
-          </a:prstGeom>
-          <a:noFill/>
-        </p:spPr>
-        <p:txBody>
-          <a:bodyPr wrap="square" lIns="18288" rIns="18288" tIns="18288" bIns="18288" anchor="t">
-            <a:spAutoFit/>
-          </a:bodyPr>
-          <a:lstStyle/>
-          <a:p>
-            <a:pPr algn="l">
-              <a:spcAft>
-                <a:spcPts val="0"/>
-              </a:spcAft>
-            </a:pPr>
-            <a:r>
-              <a:rPr sz="1080" b="0" i="0">
-                <a:solidFill>
-                  <a:srgbClr val="263746"/>
-                </a:solidFill>
-                <a:latin typeface="Arial"/>
-              </a:rPr>
-              <a:t>Tissue | FLT / GC | Accession | Material type</a:t>
-            </a:r>
-          </a:p>
-        </p:txBody>
-      </p:sp>
-      <p:sp>
-        <p:nvSpPr>
-          <p:cNvPr id="130" name="TextBox 129"/>
+              <a:t>All tissues</a:t>
+            </a:r>
+          </a:p>
+        </p:txBody>
+      </p:sp>
+      <p:sp>
+        <p:nvSpPr>
+          <p:cNvPr id="153" name="TextBox 152"/>
           <p:cNvSpPr txBox="1"/>
           <p:nvPr/>
         </p:nvSpPr>

</xml_diff>

<commit_message>
Rebalance diffusion validation slide
</commit_message>
<xml_diff>
--- a/presentation/SLSTP_2026_Generative_Transcriptomics.pptx
+++ b/presentation/SLSTP_2026_Generative_Transcriptomics.pptx
@@ -1039,7 +1039,7 @@
           <a:p/>
           <a:p>
             <a:r>
-              <a:t>Thymus produced the clearest promoted panel. The lower mitotic and DNA-replication genes agree with prior reports of thymic involution and altered cell-cycle expression after flight. Higher Hsd17b11 and Etv1 add lipid-handling and T-cell-state hypotheses. Because this is bulk RNA-seq, the pattern may reflect transcription, cell composition or both.</a:t>
+              <a:t>Thymus produced the clearest promoted panel. The lower mitotic and DNA-replication genes agree with prior reports of thymic involution and altered cell-cycle expression after flight. Higher Hsd17b11 and Etv1 add lipid-handling and T-cell-state hypotheses. A matched sensitivity model without material-type conditioning preserved the cell-cycle interpretation, so the process-level result did not depend on that label. Because this is bulk RNA-seq, the pattern may reflect transcription, cell composition or both.</a:t>
             </a:r>
           </a:p>
         </p:txBody>
@@ -1115,7 +1115,7 @@
           <a:p/>
           <a:p>
             <a:r>
-              <a:t>Soleus improved with real plus generated training. The selected genes were already stable in real-only analysis, so synthetic data reinforced rather than introduced the panel. Lower Bdh1, Ech1, Bnip3 and Decr1, with higher Tpm1, support altered oxidative metabolism and contractile remodeling. The literature is mixed for Bnip3 and Tpm1, which is recorded explicitly.</a:t>
+              <a:t>Soleus improved with real plus generated training. The selected genes were already stable in real-only analysis, so synthetic data reinforced rather than introduced the panel. Lower Bdh1, Ech1, Bnip3 and Decr1, with higher Tpm1, support altered oxidative metabolism and contractile remodeling. In the matched no-material sensitivity model, soleus selected the real-only arm and the synthetic attribution disappeared. The real OSDR association remains, but the contribution attributed to generated profiles is conditioning-sensitive.</a:t>
             </a:r>
           </a:p>
         </p:txBody>
@@ -33347,7 +33347,7 @@
                 </a:solidFill>
                 <a:latin typeface="Arial"/>
               </a:rPr>
-              <a:t>The core panel recovers cell-cycle biology; two flight-higher genes extend the hypothesis.</a:t>
+              <a:t>The cell-cycle program persisted without material conditioning; two FLT-higher genes extend the hypothesis.</a:t>
             </a:r>
           </a:p>
         </p:txBody>
@@ -34070,7 +34070,7 @@
                 </a:solidFill>
                 <a:latin typeface="Arial"/>
               </a:rPr>
-              <a:t>This result strengthens an existing real-data pattern rather than promoting a new soleus gene.</a:t>
+              <a:t>The real-data program is coherent, but its synthetic reinforcement required explicit material conditioning.</a:t>
             </a:r>
           </a:p>
         </p:txBody>
@@ -39006,7 +39006,7 @@
                 </a:solidFill>
                 <a:latin typeface="Arial"/>
               </a:rPr>
-              <a:t>Thymus and soleus were clearest. Literature review separated recovery from complementary hypotheses.</a:t>
+              <a:t>Thymus was robust to material ablation; soleus was conditioning-sensitive. Literature review separated recovery from extension.</a:t>
             </a:r>
           </a:p>
         </p:txBody>
@@ -46836,7 +46836,7 @@
         <p:spPr>
           <a:xfrm>
             <a:off x="475488" y="1901952"/>
-            <a:ext cx="3584448" cy="292608"/>
+            <a:ext cx="5504688" cy="292608"/>
           </a:xfrm>
           <a:prstGeom prst="rect">
             <a:avLst/>
@@ -46882,8 +46882,8 @@
         </p:blipFill>
         <p:spPr>
           <a:xfrm>
-            <a:off x="438912" y="2675147"/>
-            <a:ext cx="3675887" cy="1343112"/>
+            <a:off x="347472" y="2263491"/>
+            <a:ext cx="5779008" cy="2111560"/>
           </a:xfrm>
           <a:prstGeom prst="rect">
             <a:avLst/>
@@ -46898,8 +46898,8 @@
         </p:nvSpPr>
         <p:spPr>
           <a:xfrm>
-            <a:off x="512064" y="4507992"/>
-            <a:ext cx="3529584" cy="256032"/>
+            <a:off x="512064" y="4471416"/>
+            <a:ext cx="5449824" cy="256032"/>
           </a:xfrm>
           <a:prstGeom prst="rect">
             <a:avLst/>
@@ -46918,7 +46918,7 @@
               </a:spcAft>
             </a:pPr>
             <a:r>
-              <a:rPr sz="1080" b="1" i="0">
+              <a:rPr sz="1130" b="1" i="0">
                 <a:solidFill>
                   <a:srgbClr val="263746"/>
                 </a:solidFill>
@@ -46937,8 +46937,8 @@
         </p:nvSpPr>
         <p:spPr>
           <a:xfrm>
-            <a:off x="512064" y="4828032"/>
-            <a:ext cx="3529584" cy="347472"/>
+            <a:off x="512064" y="4782312"/>
+            <a:ext cx="5449824" cy="310896"/>
           </a:xfrm>
           <a:prstGeom prst="rect">
             <a:avLst/>
@@ -46957,7 +46957,7 @@
               </a:spcAft>
             </a:pPr>
             <a:r>
-              <a:rPr sz="1010" b="0" i="0">
+              <a:rPr sz="1060" b="0" i="0">
                 <a:solidFill>
                   <a:srgbClr val="59697A"/>
                 </a:solidFill>
@@ -46976,8 +46976,8 @@
         </p:nvSpPr>
         <p:spPr>
           <a:xfrm>
-            <a:off x="4233672" y="1874519"/>
-            <a:ext cx="13716" cy="3429000"/>
+            <a:off x="6281928" y="1874519"/>
+            <a:ext cx="13716" cy="3950208"/>
           </a:xfrm>
           <a:prstGeom prst="rect">
             <a:avLst/>
@@ -47019,8 +47019,8 @@
         </p:nvSpPr>
         <p:spPr>
           <a:xfrm>
-            <a:off x="4498848" y="1984248"/>
-            <a:ext cx="1920240" cy="256032"/>
+            <a:off x="6537960" y="1984248"/>
+            <a:ext cx="1554480" cy="256032"/>
           </a:xfrm>
           <a:prstGeom prst="rect">
             <a:avLst/>
@@ -47039,7 +47039,7 @@
               </a:spcAft>
             </a:pPr>
             <a:r>
-              <a:rPr sz="1150" b="1" i="0">
+              <a:rPr sz="1050" b="1" i="0">
                 <a:solidFill>
                   <a:srgbClr val="59697A"/>
                 </a:solidFill>
@@ -47058,8 +47058,8 @@
         </p:nvSpPr>
         <p:spPr>
           <a:xfrm>
-            <a:off x="6720840" y="1984248"/>
-            <a:ext cx="1188720" cy="256032"/>
+            <a:off x="8165592" y="1984248"/>
+            <a:ext cx="960120" cy="256032"/>
           </a:xfrm>
           <a:prstGeom prst="rect">
             <a:avLst/>
@@ -47078,7 +47078,7 @@
               </a:spcAft>
             </a:pPr>
             <a:r>
-              <a:rPr sz="1150" b="1" i="0">
+              <a:rPr sz="1050" b="1" i="0">
                 <a:solidFill>
                   <a:srgbClr val="D96552"/>
                 </a:solidFill>
@@ -47097,8 +47097,8 @@
         </p:nvSpPr>
         <p:spPr>
           <a:xfrm>
-            <a:off x="8311896" y="1984248"/>
-            <a:ext cx="1188720" cy="256032"/>
+            <a:off x="9262872" y="1984248"/>
+            <a:ext cx="804672" cy="256032"/>
           </a:xfrm>
           <a:prstGeom prst="rect">
             <a:avLst/>
@@ -47117,7 +47117,7 @@
               </a:spcAft>
             </a:pPr>
             <a:r>
-              <a:rPr sz="1150" b="1" i="0">
+              <a:rPr sz="1050" b="1" i="0">
                 <a:solidFill>
                   <a:srgbClr val="178681"/>
                 </a:solidFill>
@@ -47136,8 +47136,8 @@
         </p:nvSpPr>
         <p:spPr>
           <a:xfrm>
-            <a:off x="9838944" y="1984248"/>
-            <a:ext cx="1627632" cy="256032"/>
+            <a:off x="10222992" y="1984248"/>
+            <a:ext cx="1234440" cy="256032"/>
           </a:xfrm>
           <a:prstGeom prst="rect">
             <a:avLst/>
@@ -47156,13 +47156,13 @@
               </a:spcAft>
             </a:pPr>
             <a:r>
-              <a:rPr sz="1150" b="1" i="0">
+              <a:rPr sz="1050" b="1" i="0">
                 <a:solidFill>
                   <a:srgbClr val="59697A"/>
                 </a:solidFill>
                 <a:latin typeface="Arial"/>
               </a:rPr>
-              <a:t>How to read it</a:t>
+              <a:t>Read</a:t>
             </a:r>
           </a:p>
         </p:txBody>
@@ -47175,8 +47175,8 @@
         </p:nvSpPr>
         <p:spPr>
           <a:xfrm>
-            <a:off x="4498848" y="2340864"/>
-            <a:ext cx="7059168" cy="20116"/>
+            <a:off x="6537960" y="2340864"/>
+            <a:ext cx="4983480" cy="20116"/>
           </a:xfrm>
           <a:prstGeom prst="rect">
             <a:avLst/>
@@ -47218,8 +47218,8 @@
         </p:nvSpPr>
         <p:spPr>
           <a:xfrm>
-            <a:off x="4480560" y="2505456"/>
-            <a:ext cx="7086600" cy="493776"/>
+            <a:off x="6519672" y="2496312"/>
+            <a:ext cx="5020056" cy="457200"/>
           </a:xfrm>
           <a:prstGeom prst="rect">
             <a:avLst/>
@@ -47261,8 +47261,8 @@
         </p:nvSpPr>
         <p:spPr>
           <a:xfrm>
-            <a:off x="4562856" y="2578608"/>
-            <a:ext cx="1920240" cy="310896"/>
+            <a:off x="6601968" y="2560320"/>
+            <a:ext cx="1490472" cy="292608"/>
           </a:xfrm>
           <a:prstGeom prst="rect">
             <a:avLst/>
@@ -47281,7 +47281,7 @@
               </a:spcAft>
             </a:pPr>
             <a:r>
-              <a:rPr sz="1350" b="0" i="0">
+              <a:rPr sz="1120" b="0" i="0">
                 <a:solidFill>
                   <a:srgbClr val="263746"/>
                 </a:solidFill>
@@ -47300,8 +47300,8 @@
         </p:nvSpPr>
         <p:spPr>
           <a:xfrm>
-            <a:off x="6684264" y="2578608"/>
-            <a:ext cx="1261872" cy="310896"/>
+            <a:off x="8165592" y="2560320"/>
+            <a:ext cx="960120" cy="292608"/>
           </a:xfrm>
           <a:prstGeom prst="rect">
             <a:avLst/>
@@ -47320,7 +47320,7 @@
               </a:spcAft>
             </a:pPr>
             <a:r>
-              <a:rPr sz="1550" b="1" i="0">
+              <a:rPr sz="1330" b="1" i="0">
                 <a:solidFill>
                   <a:srgbClr val="D96552"/>
                 </a:solidFill>
@@ -47339,8 +47339,8 @@
         </p:nvSpPr>
         <p:spPr>
           <a:xfrm>
-            <a:off x="8275320" y="2578608"/>
-            <a:ext cx="1261872" cy="310896"/>
+            <a:off x="9253728" y="2560320"/>
+            <a:ext cx="804672" cy="292608"/>
           </a:xfrm>
           <a:prstGeom prst="rect">
             <a:avLst/>
@@ -47359,7 +47359,7 @@
               </a:spcAft>
             </a:pPr>
             <a:r>
-              <a:rPr sz="1550" b="1" i="0">
+              <a:rPr sz="1330" b="1" i="0">
                 <a:solidFill>
                   <a:srgbClr val="178681"/>
                 </a:solidFill>
@@ -47378,8 +47378,8 @@
         </p:nvSpPr>
         <p:spPr>
           <a:xfrm>
-            <a:off x="9857232" y="2578608"/>
-            <a:ext cx="1481328" cy="310896"/>
+            <a:off x="10222992" y="2560320"/>
+            <a:ext cx="1234440" cy="292608"/>
           </a:xfrm>
           <a:prstGeom prst="rect">
             <a:avLst/>
@@ -47398,7 +47398,7 @@
               </a:spcAft>
             </a:pPr>
             <a:r>
-              <a:rPr sz="1300" b="0" i="0">
+              <a:rPr sz="1070" b="0" i="0">
                 <a:solidFill>
                   <a:srgbClr val="59697A"/>
                 </a:solidFill>
@@ -47417,8 +47417,8 @@
         </p:nvSpPr>
         <p:spPr>
           <a:xfrm>
-            <a:off x="4562856" y="3163824"/>
-            <a:ext cx="1920240" cy="310896"/>
+            <a:off x="6601968" y="3099815"/>
+            <a:ext cx="1490472" cy="292608"/>
           </a:xfrm>
           <a:prstGeom prst="rect">
             <a:avLst/>
@@ -47437,7 +47437,7 @@
               </a:spcAft>
             </a:pPr>
             <a:r>
-              <a:rPr sz="1350" b="0" i="0">
+              <a:rPr sz="1120" b="0" i="0">
                 <a:solidFill>
                   <a:srgbClr val="263746"/>
                 </a:solidFill>
@@ -47456,8 +47456,8 @@
         </p:nvSpPr>
         <p:spPr>
           <a:xfrm>
-            <a:off x="6684264" y="3163824"/>
-            <a:ext cx="1261872" cy="310896"/>
+            <a:off x="8165592" y="3099815"/>
+            <a:ext cx="960120" cy="292608"/>
           </a:xfrm>
           <a:prstGeom prst="rect">
             <a:avLst/>
@@ -47476,7 +47476,7 @@
               </a:spcAft>
             </a:pPr>
             <a:r>
-              <a:rPr sz="1550" b="1" i="0">
+              <a:rPr sz="1330" b="1" i="0">
                 <a:solidFill>
                   <a:srgbClr val="D96552"/>
                 </a:solidFill>
@@ -47495,8 +47495,8 @@
         </p:nvSpPr>
         <p:spPr>
           <a:xfrm>
-            <a:off x="8275320" y="3163824"/>
-            <a:ext cx="1261872" cy="310896"/>
+            <a:off x="9253728" y="3099815"/>
+            <a:ext cx="804672" cy="292608"/>
           </a:xfrm>
           <a:prstGeom prst="rect">
             <a:avLst/>
@@ -47515,7 +47515,7 @@
               </a:spcAft>
             </a:pPr>
             <a:r>
-              <a:rPr sz="1550" b="1" i="0">
+              <a:rPr sz="1330" b="1" i="0">
                 <a:solidFill>
                   <a:srgbClr val="178681"/>
                 </a:solidFill>
@@ -47534,8 +47534,8 @@
         </p:nvSpPr>
         <p:spPr>
           <a:xfrm>
-            <a:off x="9857232" y="3163824"/>
-            <a:ext cx="1481328" cy="310896"/>
+            <a:off x="10222992" y="3099815"/>
+            <a:ext cx="1234440" cy="292608"/>
           </a:xfrm>
           <a:prstGeom prst="rect">
             <a:avLst/>
@@ -47554,7 +47554,7 @@
               </a:spcAft>
             </a:pPr>
             <a:r>
-              <a:rPr sz="1300" b="0" i="0">
+              <a:rPr sz="1070" b="0" i="0">
                 <a:solidFill>
                   <a:srgbClr val="59697A"/>
                 </a:solidFill>
@@ -47573,8 +47573,8 @@
         </p:nvSpPr>
         <p:spPr>
           <a:xfrm>
-            <a:off x="4480560" y="3675887"/>
-            <a:ext cx="7086600" cy="493776"/>
+            <a:off x="6519672" y="3575303"/>
+            <a:ext cx="5020056" cy="457200"/>
           </a:xfrm>
           <a:prstGeom prst="rect">
             <a:avLst/>
@@ -47616,8 +47616,8 @@
         </p:nvSpPr>
         <p:spPr>
           <a:xfrm>
-            <a:off x="4562856" y="3749039"/>
-            <a:ext cx="1920240" cy="310896"/>
+            <a:off x="6601968" y="3639311"/>
+            <a:ext cx="1490472" cy="292608"/>
           </a:xfrm>
           <a:prstGeom prst="rect">
             <a:avLst/>
@@ -47636,7 +47636,7 @@
               </a:spcAft>
             </a:pPr>
             <a:r>
-              <a:rPr sz="1350" b="1" i="0">
+              <a:rPr sz="1120" b="1" i="0">
                 <a:solidFill>
                   <a:srgbClr val="263746"/>
                 </a:solidFill>
@@ -47655,8 +47655,8 @@
         </p:nvSpPr>
         <p:spPr>
           <a:xfrm>
-            <a:off x="6684264" y="3749039"/>
-            <a:ext cx="1261872" cy="310896"/>
+            <a:off x="8165592" y="3639311"/>
+            <a:ext cx="960120" cy="292608"/>
           </a:xfrm>
           <a:prstGeom prst="rect">
             <a:avLst/>
@@ -47675,7 +47675,7 @@
               </a:spcAft>
             </a:pPr>
             <a:r>
-              <a:rPr sz="1550" b="1" i="0">
+              <a:rPr sz="1330" b="1" i="0">
                 <a:solidFill>
                   <a:srgbClr val="D96552"/>
                 </a:solidFill>
@@ -47694,8 +47694,8 @@
         </p:nvSpPr>
         <p:spPr>
           <a:xfrm>
-            <a:off x="8275320" y="3749039"/>
-            <a:ext cx="1261872" cy="310896"/>
+            <a:off x="9253728" y="3639311"/>
+            <a:ext cx="804672" cy="292608"/>
           </a:xfrm>
           <a:prstGeom prst="rect">
             <a:avLst/>
@@ -47714,7 +47714,7 @@
               </a:spcAft>
             </a:pPr>
             <a:r>
-              <a:rPr sz="1550" b="1" i="0">
+              <a:rPr sz="1330" b="1" i="0">
                 <a:solidFill>
                   <a:srgbClr val="178681"/>
                 </a:solidFill>
@@ -47733,8 +47733,8 @@
         </p:nvSpPr>
         <p:spPr>
           <a:xfrm>
-            <a:off x="9857232" y="3749039"/>
-            <a:ext cx="1481328" cy="310896"/>
+            <a:off x="10222992" y="3639311"/>
+            <a:ext cx="1234440" cy="292608"/>
           </a:xfrm>
           <a:prstGeom prst="rect">
             <a:avLst/>
@@ -47753,7 +47753,7 @@
               </a:spcAft>
             </a:pPr>
             <a:r>
-              <a:rPr sz="1300" b="0" i="0">
+              <a:rPr sz="1070" b="0" i="0">
                 <a:solidFill>
                   <a:srgbClr val="59697A"/>
                 </a:solidFill>
@@ -47772,8 +47772,8 @@
         </p:nvSpPr>
         <p:spPr>
           <a:xfrm>
-            <a:off x="4562856" y="4334256"/>
-            <a:ext cx="1920240" cy="310896"/>
+            <a:off x="6601968" y="4178808"/>
+            <a:ext cx="1490472" cy="292608"/>
           </a:xfrm>
           <a:prstGeom prst="rect">
             <a:avLst/>
@@ -47792,7 +47792,7 @@
               </a:spcAft>
             </a:pPr>
             <a:r>
-              <a:rPr sz="1350" b="1" i="0">
+              <a:rPr sz="1120" b="1" i="0">
                 <a:solidFill>
                   <a:srgbClr val="263746"/>
                 </a:solidFill>
@@ -47811,8 +47811,8 @@
         </p:nvSpPr>
         <p:spPr>
           <a:xfrm>
-            <a:off x="6684264" y="4334256"/>
-            <a:ext cx="1261872" cy="310896"/>
+            <a:off x="8165592" y="4178808"/>
+            <a:ext cx="960120" cy="292608"/>
           </a:xfrm>
           <a:prstGeom prst="rect">
             <a:avLst/>
@@ -47831,7 +47831,7 @@
               </a:spcAft>
             </a:pPr>
             <a:r>
-              <a:rPr sz="1550" b="1" i="0">
+              <a:rPr sz="1330" b="1" i="0">
                 <a:solidFill>
                   <a:srgbClr val="D96552"/>
                 </a:solidFill>
@@ -47850,8 +47850,8 @@
         </p:nvSpPr>
         <p:spPr>
           <a:xfrm>
-            <a:off x="8275320" y="4334256"/>
-            <a:ext cx="1261872" cy="310896"/>
+            <a:off x="9253728" y="4178808"/>
+            <a:ext cx="804672" cy="292608"/>
           </a:xfrm>
           <a:prstGeom prst="rect">
             <a:avLst/>
@@ -47870,7 +47870,7 @@
               </a:spcAft>
             </a:pPr>
             <a:r>
-              <a:rPr sz="1550" b="1" i="0">
+              <a:rPr sz="1330" b="1" i="0">
                 <a:solidFill>
                   <a:srgbClr val="178681"/>
                 </a:solidFill>
@@ -47889,8 +47889,8 @@
         </p:nvSpPr>
         <p:spPr>
           <a:xfrm>
-            <a:off x="9857232" y="4334256"/>
-            <a:ext cx="1481328" cy="310896"/>
+            <a:off x="10222992" y="4178808"/>
+            <a:ext cx="1234440" cy="292608"/>
           </a:xfrm>
           <a:prstGeom prst="rect">
             <a:avLst/>
@@ -47909,7 +47909,7 @@
               </a:spcAft>
             </a:pPr>
             <a:r>
-              <a:rPr sz="1300" b="0" i="0">
+              <a:rPr sz="1070" b="0" i="0">
                 <a:solidFill>
                   <a:srgbClr val="59697A"/>
                 </a:solidFill>
@@ -47922,14 +47922,57 @@
       </p:sp>
       <p:sp>
         <p:nvSpPr>
-          <p:cNvPr id="35" name="TextBox 34"/>
+          <p:cNvPr id="35" name="Rectangle 34"/>
+          <p:cNvSpPr/>
+          <p:nvPr/>
+        </p:nvSpPr>
+        <p:spPr>
+          <a:xfrm>
+            <a:off x="502920" y="5212080"/>
+            <a:ext cx="5513832" cy="13716"/>
+          </a:xfrm>
+          <a:prstGeom prst="rect">
+            <a:avLst/>
+          </a:prstGeom>
+          <a:solidFill>
+            <a:srgbClr val="D5DDE2"/>
+          </a:solidFill>
+          <a:ln>
+            <a:noFill/>
+          </a:ln>
+        </p:spPr>
+        <p:style>
+          <a:lnRef idx="1">
+            <a:schemeClr val="accent1"/>
+          </a:lnRef>
+          <a:fillRef idx="3">
+            <a:schemeClr val="accent1"/>
+          </a:fillRef>
+          <a:effectRef idx="2">
+            <a:schemeClr val="accent1"/>
+          </a:effectRef>
+          <a:fontRef idx="minor">
+            <a:schemeClr val="lt1"/>
+          </a:fontRef>
+        </p:style>
+        <p:txBody>
+          <a:bodyPr rtlCol="0" anchor="ctr"/>
+          <a:lstStyle/>
+          <a:p>
+            <a:pPr algn="ctr"/>
+          </a:p>
+        </p:txBody>
+      </p:sp>
+      <p:sp>
+        <p:nvSpPr>
+          <p:cNvPr id="36" name="TextBox 35"/>
           <p:cNvSpPr txBox="1"/>
           <p:nvPr/>
         </p:nvSpPr>
         <p:spPr>
           <a:xfrm>
-            <a:off x="502920" y="5431536"/>
-            <a:ext cx="1463040" cy="219456"/>
+            <a:off x="502920" y="5376672"/>
+            <a:ext cx="1600200" cy="219456"/>
           </a:xfrm>
           <a:prstGeom prst="rect">
             <a:avLst/>
@@ -47948,7 +47991,7 @@
               </a:spcAft>
             </a:pPr>
             <a:r>
-              <a:rPr sz="1000" b="1" i="0">
+              <a:rPr sz="1040" b="1" i="0">
                 <a:solidFill>
                   <a:srgbClr val="2D6496"/>
                 </a:solidFill>
@@ -47961,14 +48004,14 @@
       </p:sp>
       <p:sp>
         <p:nvSpPr>
-          <p:cNvPr id="36" name="TextBox 35"/>
+          <p:cNvPr id="37" name="TextBox 36"/>
           <p:cNvSpPr txBox="1"/>
           <p:nvPr/>
         </p:nvSpPr>
         <p:spPr>
           <a:xfrm>
-            <a:off x="1874519" y="5413248"/>
-            <a:ext cx="2231136" cy="246888"/>
+            <a:off x="3108960" y="5358384"/>
+            <a:ext cx="2852928" cy="246888"/>
           </a:xfrm>
           <a:prstGeom prst="rect">
             <a:avLst/>
@@ -47987,7 +48030,7 @@
               </a:spcAft>
             </a:pPr>
             <a:r>
-              <a:rPr sz="1000" b="0" i="0">
+              <a:rPr sz="1040" b="0" i="0">
                 <a:solidFill>
                   <a:srgbClr val="263746"/>
                 </a:solidFill>
@@ -48000,14 +48043,53 @@
       </p:sp>
       <p:sp>
         <p:nvSpPr>
-          <p:cNvPr id="37" name="Rectangle 36"/>
+          <p:cNvPr id="38" name="TextBox 37"/>
+          <p:cNvSpPr txBox="1"/>
+          <p:nvPr/>
+        </p:nvSpPr>
+        <p:spPr>
+          <a:xfrm>
+            <a:off x="502920" y="5678424"/>
+            <a:ext cx="5458968" cy="228600"/>
+          </a:xfrm>
+          <a:prstGeom prst="rect">
+            <a:avLst/>
+          </a:prstGeom>
+          <a:noFill/>
+        </p:spPr>
+        <p:txBody>
+          <a:bodyPr wrap="square" lIns="0" rIns="0" tIns="0" bIns="0" anchor="t">
+            <a:spAutoFit/>
+          </a:bodyPr>
+          <a:lstStyle/>
+          <a:p>
+            <a:pPr algn="ctr">
+              <a:spcAft>
+                <a:spcPts val="0"/>
+              </a:spcAft>
+            </a:pPr>
+            <a:r>
+              <a:rPr sz="969" b="0" i="0">
+                <a:solidFill>
+                  <a:srgbClr val="59697A"/>
+                </a:solidFill>
+                <a:latin typeface="Arial"/>
+              </a:rPr>
+              <a:t>Balanced accuracy is preserved in generated tissue labels.</a:t>
+            </a:r>
+          </a:p>
+        </p:txBody>
+      </p:sp>
+      <p:sp>
+        <p:nvSpPr>
+          <p:cNvPr id="39" name="Rectangle 38"/>
           <p:cNvSpPr/>
           <p:nvPr/>
         </p:nvSpPr>
         <p:spPr>
           <a:xfrm>
-            <a:off x="4498848" y="5266944"/>
-            <a:ext cx="50292" cy="676656"/>
+            <a:off x="6537960" y="4901184"/>
+            <a:ext cx="50292" cy="713232"/>
           </a:xfrm>
           <a:prstGeom prst="rect">
             <a:avLst/>
@@ -48043,14 +48125,14 @@
       </p:sp>
       <p:sp>
         <p:nvSpPr>
-          <p:cNvPr id="38" name="TextBox 37"/>
+          <p:cNvPr id="40" name="TextBox 39"/>
           <p:cNvSpPr txBox="1"/>
           <p:nvPr/>
         </p:nvSpPr>
         <p:spPr>
           <a:xfrm>
-            <a:off x="4736592" y="5358384"/>
-            <a:ext cx="1353312" cy="283464"/>
+            <a:off x="6766560" y="4937760"/>
+            <a:ext cx="1298448" cy="283464"/>
           </a:xfrm>
           <a:prstGeom prst="rect">
             <a:avLst/>
@@ -48069,7 +48151,7 @@
               </a:spcAft>
             </a:pPr>
             <a:r>
-              <a:rPr sz="1700" b="1" i="0">
+              <a:rPr sz="1600" b="1" i="0">
                 <a:solidFill>
                   <a:srgbClr val="082B55"/>
                 </a:solidFill>
@@ -48082,14 +48164,14 @@
       </p:sp>
       <p:sp>
         <p:nvSpPr>
-          <p:cNvPr id="39" name="TextBox 38"/>
+          <p:cNvPr id="41" name="TextBox 40"/>
           <p:cNvSpPr txBox="1"/>
           <p:nvPr/>
         </p:nvSpPr>
         <p:spPr>
           <a:xfrm>
-            <a:off x="6272784" y="5349240"/>
-            <a:ext cx="5084064" cy="292608"/>
+            <a:off x="8147304" y="4919472"/>
+            <a:ext cx="3310128" cy="429768"/>
           </a:xfrm>
           <a:prstGeom prst="rect">
             <a:avLst/>
@@ -48097,7 +48179,7 @@
           <a:noFill/>
         </p:spPr>
         <p:txBody>
-          <a:bodyPr wrap="square" lIns="0" rIns="0" tIns="0" bIns="0" anchor="t">
+          <a:bodyPr wrap="square" lIns="0" rIns="0" tIns="0" bIns="0" anchor="ctr">
             <a:spAutoFit/>
           </a:bodyPr>
           <a:lstStyle/>
@@ -48108,27 +48190,27 @@
               </a:spcAft>
             </a:pPr>
             <a:r>
-              <a:rPr sz="1330" b="0" i="0">
+              <a:rPr sz="1180" b="0" i="0">
                 <a:solidFill>
                   <a:srgbClr val="263746"/>
                 </a:solidFill>
                 <a:latin typeface="Arial"/>
               </a:rPr>
-              <a:t>Comparable correlation, higher F1, and lower separability and FD.</a:t>
-            </a:r>
-          </a:p>
-        </p:txBody>
-      </p:sp>
-      <p:sp>
-        <p:nvSpPr>
-          <p:cNvPr id="40" name="TextBox 39"/>
+              <a:t>Higher F1 with lower separability and FD.</a:t>
+            </a:r>
+          </a:p>
+        </p:txBody>
+      </p:sp>
+      <p:sp>
+        <p:nvSpPr>
+          <p:cNvPr id="42" name="TextBox 41"/>
           <p:cNvSpPr txBox="1"/>
           <p:nvPr/>
         </p:nvSpPr>
         <p:spPr>
           <a:xfrm>
-            <a:off x="4736592" y="5742432"/>
-            <a:ext cx="6620256" cy="228600"/>
+            <a:off x="6766560" y="5458968"/>
+            <a:ext cx="4663440" cy="365760"/>
           </a:xfrm>
           <a:prstGeom prst="rect">
             <a:avLst/>
@@ -48147,7 +48229,7 @@
               </a:spcAft>
             </a:pPr>
             <a:r>
-              <a:rPr sz="1070" b="0" i="0">
+              <a:rPr sz="980" b="0" i="0">
                 <a:solidFill>
                   <a:srgbClr val="59697A"/>
                 </a:solidFill>
@@ -48160,7 +48242,7 @@
       </p:sp>
       <p:sp>
         <p:nvSpPr>
-          <p:cNvPr id="41" name="TextBox 40"/>
+          <p:cNvPr id="43" name="TextBox 42"/>
           <p:cNvSpPr txBox="1"/>
           <p:nvPr/>
         </p:nvSpPr>

</xml_diff>

<commit_message>
Enlarge diffusion architecture figure
</commit_message>
<xml_diff>
--- a/presentation/SLSTP_2026_Generative_Transcriptomics.pptx
+++ b/presentation/SLSTP_2026_Generative_Transcriptomics.pptx
@@ -46836,7 +46836,7 @@
         <p:spPr>
           <a:xfrm>
             <a:off x="475488" y="1901952"/>
-            <a:ext cx="5504688" cy="292608"/>
+            <a:ext cx="6510528" cy="292608"/>
           </a:xfrm>
           <a:prstGeom prst="rect">
             <a:avLst/>
@@ -46882,8 +46882,8 @@
         </p:blipFill>
         <p:spPr>
           <a:xfrm>
-            <a:off x="347472" y="2263491"/>
-            <a:ext cx="5779008" cy="2111560"/>
+            <a:off x="186730" y="2185416"/>
+            <a:ext cx="6832011" cy="2496312"/>
           </a:xfrm>
           <a:prstGeom prst="rect">
             <a:avLst/>
@@ -46898,8 +46898,8 @@
         </p:nvSpPr>
         <p:spPr>
           <a:xfrm>
-            <a:off x="512064" y="4471416"/>
-            <a:ext cx="5449824" cy="256032"/>
+            <a:off x="512064" y="4727448"/>
+            <a:ext cx="6309360" cy="256032"/>
           </a:xfrm>
           <a:prstGeom prst="rect">
             <a:avLst/>
@@ -46937,8 +46937,8 @@
         </p:nvSpPr>
         <p:spPr>
           <a:xfrm>
-            <a:off x="512064" y="4782312"/>
-            <a:ext cx="5449824" cy="310896"/>
+            <a:off x="512064" y="5038344"/>
+            <a:ext cx="6309360" cy="310896"/>
           </a:xfrm>
           <a:prstGeom prst="rect">
             <a:avLst/>
@@ -46976,7 +46976,7 @@
         </p:nvSpPr>
         <p:spPr>
           <a:xfrm>
-            <a:off x="6281928" y="1874519"/>
+            <a:off x="7159752" y="1874519"/>
             <a:ext cx="13716" cy="3950208"/>
           </a:xfrm>
           <a:prstGeom prst="rect">
@@ -47019,8 +47019,8 @@
         </p:nvSpPr>
         <p:spPr>
           <a:xfrm>
-            <a:off x="6537960" y="1984248"/>
-            <a:ext cx="1554480" cy="256032"/>
+            <a:off x="7351775" y="1984248"/>
+            <a:ext cx="1298448" cy="256032"/>
           </a:xfrm>
           <a:prstGeom prst="rect">
             <a:avLst/>
@@ -47039,7 +47039,7 @@
               </a:spcAft>
             </a:pPr>
             <a:r>
-              <a:rPr sz="1050" b="1" i="0">
+              <a:rPr sz="1000" b="1" i="0">
                 <a:solidFill>
                   <a:srgbClr val="59697A"/>
                 </a:solidFill>
@@ -47058,8 +47058,8 @@
         </p:nvSpPr>
         <p:spPr>
           <a:xfrm>
-            <a:off x="8165592" y="1984248"/>
-            <a:ext cx="960120" cy="256032"/>
+            <a:off x="8750808" y="1984248"/>
+            <a:ext cx="777240" cy="256032"/>
           </a:xfrm>
           <a:prstGeom prst="rect">
             <a:avLst/>
@@ -47078,7 +47078,7 @@
               </a:spcAft>
             </a:pPr>
             <a:r>
-              <a:rPr sz="1050" b="1" i="0">
+              <a:rPr sz="1000" b="1" i="0">
                 <a:solidFill>
                   <a:srgbClr val="D96552"/>
                 </a:solidFill>
@@ -47097,8 +47097,8 @@
         </p:nvSpPr>
         <p:spPr>
           <a:xfrm>
-            <a:off x="9262872" y="1984248"/>
-            <a:ext cx="804672" cy="256032"/>
+            <a:off x="9619488" y="1984248"/>
+            <a:ext cx="694944" cy="256032"/>
           </a:xfrm>
           <a:prstGeom prst="rect">
             <a:avLst/>
@@ -47117,7 +47117,7 @@
               </a:spcAft>
             </a:pPr>
             <a:r>
-              <a:rPr sz="1050" b="1" i="0">
+              <a:rPr sz="1000" b="1" i="0">
                 <a:solidFill>
                   <a:srgbClr val="178681"/>
                 </a:solidFill>
@@ -47136,8 +47136,8 @@
         </p:nvSpPr>
         <p:spPr>
           <a:xfrm>
-            <a:off x="10222992" y="1984248"/>
-            <a:ext cx="1234440" cy="256032"/>
+            <a:off x="10451592" y="1984248"/>
+            <a:ext cx="1005840" cy="256032"/>
           </a:xfrm>
           <a:prstGeom prst="rect">
             <a:avLst/>
@@ -47156,7 +47156,7 @@
               </a:spcAft>
             </a:pPr>
             <a:r>
-              <a:rPr sz="1050" b="1" i="0">
+              <a:rPr sz="1000" b="1" i="0">
                 <a:solidFill>
                   <a:srgbClr val="59697A"/>
                 </a:solidFill>
@@ -47175,8 +47175,8 @@
         </p:nvSpPr>
         <p:spPr>
           <a:xfrm>
-            <a:off x="6537960" y="2340864"/>
-            <a:ext cx="4983480" cy="20116"/>
+            <a:off x="7351775" y="2340864"/>
+            <a:ext cx="4187952" cy="20116"/>
           </a:xfrm>
           <a:prstGeom prst="rect">
             <a:avLst/>
@@ -47218,8 +47218,8 @@
         </p:nvSpPr>
         <p:spPr>
           <a:xfrm>
-            <a:off x="6519672" y="2496312"/>
-            <a:ext cx="5020056" cy="457200"/>
+            <a:off x="7333488" y="2496312"/>
+            <a:ext cx="4215384" cy="457200"/>
           </a:xfrm>
           <a:prstGeom prst="rect">
             <a:avLst/>
@@ -47261,8 +47261,8 @@
         </p:nvSpPr>
         <p:spPr>
           <a:xfrm>
-            <a:off x="6601968" y="2560320"/>
-            <a:ext cx="1490472" cy="292608"/>
+            <a:off x="7406640" y="2560320"/>
+            <a:ext cx="1271016" cy="292608"/>
           </a:xfrm>
           <a:prstGeom prst="rect">
             <a:avLst/>
@@ -47281,7 +47281,7 @@
               </a:spcAft>
             </a:pPr>
             <a:r>
-              <a:rPr sz="1120" b="0" i="0">
+              <a:rPr sz="1030" b="0" i="0">
                 <a:solidFill>
                   <a:srgbClr val="263746"/>
                 </a:solidFill>
@@ -47300,8 +47300,8 @@
         </p:nvSpPr>
         <p:spPr>
           <a:xfrm>
-            <a:off x="8165592" y="2560320"/>
-            <a:ext cx="960120" cy="292608"/>
+            <a:off x="8750808" y="2560320"/>
+            <a:ext cx="777240" cy="292608"/>
           </a:xfrm>
           <a:prstGeom prst="rect">
             <a:avLst/>
@@ -47320,7 +47320,7 @@
               </a:spcAft>
             </a:pPr>
             <a:r>
-              <a:rPr sz="1330" b="1" i="0">
+              <a:rPr sz="1260" b="1" i="0">
                 <a:solidFill>
                   <a:srgbClr val="D96552"/>
                 </a:solidFill>
@@ -47339,8 +47339,8 @@
         </p:nvSpPr>
         <p:spPr>
           <a:xfrm>
-            <a:off x="9253728" y="2560320"/>
-            <a:ext cx="804672" cy="292608"/>
+            <a:off x="9619488" y="2560320"/>
+            <a:ext cx="694944" cy="292608"/>
           </a:xfrm>
           <a:prstGeom prst="rect">
             <a:avLst/>
@@ -47359,7 +47359,7 @@
               </a:spcAft>
             </a:pPr>
             <a:r>
-              <a:rPr sz="1330" b="1" i="0">
+              <a:rPr sz="1260" b="1" i="0">
                 <a:solidFill>
                   <a:srgbClr val="178681"/>
                 </a:solidFill>
@@ -47378,8 +47378,8 @@
         </p:nvSpPr>
         <p:spPr>
           <a:xfrm>
-            <a:off x="10222992" y="2560320"/>
-            <a:ext cx="1234440" cy="292608"/>
+            <a:off x="10451592" y="2560320"/>
+            <a:ext cx="1005840" cy="292608"/>
           </a:xfrm>
           <a:prstGeom prst="rect">
             <a:avLst/>
@@ -47398,7 +47398,7 @@
               </a:spcAft>
             </a:pPr>
             <a:r>
-              <a:rPr sz="1070" b="0" i="0">
+              <a:rPr sz="1019" b="0" i="0">
                 <a:solidFill>
                   <a:srgbClr val="59697A"/>
                 </a:solidFill>
@@ -47417,8 +47417,8 @@
         </p:nvSpPr>
         <p:spPr>
           <a:xfrm>
-            <a:off x="6601968" y="3099815"/>
-            <a:ext cx="1490472" cy="292608"/>
+            <a:off x="7406640" y="3099815"/>
+            <a:ext cx="1271016" cy="292608"/>
           </a:xfrm>
           <a:prstGeom prst="rect">
             <a:avLst/>
@@ -47437,7 +47437,7 @@
               </a:spcAft>
             </a:pPr>
             <a:r>
-              <a:rPr sz="1120" b="0" i="0">
+              <a:rPr sz="1030" b="0" i="0">
                 <a:solidFill>
                   <a:srgbClr val="263746"/>
                 </a:solidFill>
@@ -47456,8 +47456,8 @@
         </p:nvSpPr>
         <p:spPr>
           <a:xfrm>
-            <a:off x="8165592" y="3099815"/>
-            <a:ext cx="960120" cy="292608"/>
+            <a:off x="8750808" y="3099815"/>
+            <a:ext cx="777240" cy="292608"/>
           </a:xfrm>
           <a:prstGeom prst="rect">
             <a:avLst/>
@@ -47476,7 +47476,7 @@
               </a:spcAft>
             </a:pPr>
             <a:r>
-              <a:rPr sz="1330" b="1" i="0">
+              <a:rPr sz="1260" b="1" i="0">
                 <a:solidFill>
                   <a:srgbClr val="D96552"/>
                 </a:solidFill>
@@ -47495,8 +47495,8 @@
         </p:nvSpPr>
         <p:spPr>
           <a:xfrm>
-            <a:off x="9253728" y="3099815"/>
-            <a:ext cx="804672" cy="292608"/>
+            <a:off x="9619488" y="3099815"/>
+            <a:ext cx="694944" cy="292608"/>
           </a:xfrm>
           <a:prstGeom prst="rect">
             <a:avLst/>
@@ -47515,7 +47515,7 @@
               </a:spcAft>
             </a:pPr>
             <a:r>
-              <a:rPr sz="1330" b="1" i="0">
+              <a:rPr sz="1260" b="1" i="0">
                 <a:solidFill>
                   <a:srgbClr val="178681"/>
                 </a:solidFill>
@@ -47534,8 +47534,8 @@
         </p:nvSpPr>
         <p:spPr>
           <a:xfrm>
-            <a:off x="10222992" y="3099815"/>
-            <a:ext cx="1234440" cy="292608"/>
+            <a:off x="10451592" y="3099815"/>
+            <a:ext cx="1005840" cy="292608"/>
           </a:xfrm>
           <a:prstGeom prst="rect">
             <a:avLst/>
@@ -47554,7 +47554,7 @@
               </a:spcAft>
             </a:pPr>
             <a:r>
-              <a:rPr sz="1070" b="0" i="0">
+              <a:rPr sz="1019" b="0" i="0">
                 <a:solidFill>
                   <a:srgbClr val="59697A"/>
                 </a:solidFill>
@@ -47573,8 +47573,8 @@
         </p:nvSpPr>
         <p:spPr>
           <a:xfrm>
-            <a:off x="6519672" y="3575303"/>
-            <a:ext cx="5020056" cy="457200"/>
+            <a:off x="7333488" y="3575303"/>
+            <a:ext cx="4215384" cy="457200"/>
           </a:xfrm>
           <a:prstGeom prst="rect">
             <a:avLst/>
@@ -47616,8 +47616,8 @@
         </p:nvSpPr>
         <p:spPr>
           <a:xfrm>
-            <a:off x="6601968" y="3639311"/>
-            <a:ext cx="1490472" cy="292608"/>
+            <a:off x="7406640" y="3639311"/>
+            <a:ext cx="1271016" cy="292608"/>
           </a:xfrm>
           <a:prstGeom prst="rect">
             <a:avLst/>
@@ -47636,13 +47636,13 @@
               </a:spcAft>
             </a:pPr>
             <a:r>
-              <a:rPr sz="1120" b="1" i="0">
+              <a:rPr sz="1030" b="1" i="0">
                 <a:solidFill>
                   <a:srgbClr val="263746"/>
                 </a:solidFill>
                 <a:latin typeface="Arial"/>
               </a:rPr>
-              <a:t>Adversarial accuracy</a:t>
+              <a:t>Adversarial acc.</a:t>
             </a:r>
           </a:p>
         </p:txBody>
@@ -47655,8 +47655,8 @@
         </p:nvSpPr>
         <p:spPr>
           <a:xfrm>
-            <a:off x="8165592" y="3639311"/>
-            <a:ext cx="960120" cy="292608"/>
+            <a:off x="8750808" y="3639311"/>
+            <a:ext cx="777240" cy="292608"/>
           </a:xfrm>
           <a:prstGeom prst="rect">
             <a:avLst/>
@@ -47675,7 +47675,7 @@
               </a:spcAft>
             </a:pPr>
             <a:r>
-              <a:rPr sz="1330" b="1" i="0">
+              <a:rPr sz="1260" b="1" i="0">
                 <a:solidFill>
                   <a:srgbClr val="D96552"/>
                 </a:solidFill>
@@ -47694,8 +47694,8 @@
         </p:nvSpPr>
         <p:spPr>
           <a:xfrm>
-            <a:off x="9253728" y="3639311"/>
-            <a:ext cx="804672" cy="292608"/>
+            <a:off x="9619488" y="3639311"/>
+            <a:ext cx="694944" cy="292608"/>
           </a:xfrm>
           <a:prstGeom prst="rect">
             <a:avLst/>
@@ -47714,7 +47714,7 @@
               </a:spcAft>
             </a:pPr>
             <a:r>
-              <a:rPr sz="1330" b="1" i="0">
+              <a:rPr sz="1260" b="1" i="0">
                 <a:solidFill>
                   <a:srgbClr val="178681"/>
                 </a:solidFill>
@@ -47733,8 +47733,8 @@
         </p:nvSpPr>
         <p:spPr>
           <a:xfrm>
-            <a:off x="10222992" y="3639311"/>
-            <a:ext cx="1234440" cy="292608"/>
+            <a:off x="10451592" y="3639311"/>
+            <a:ext cx="1005840" cy="292608"/>
           </a:xfrm>
           <a:prstGeom prst="rect">
             <a:avLst/>
@@ -47753,13 +47753,13 @@
               </a:spcAft>
             </a:pPr>
             <a:r>
-              <a:rPr sz="1070" b="0" i="0">
+              <a:rPr sz="1019" b="0" i="0">
                 <a:solidFill>
                   <a:srgbClr val="59697A"/>
                 </a:solidFill>
                 <a:latin typeface="Arial"/>
               </a:rPr>
-              <a:t>closer to 0.5</a:t>
+              <a:t>near 0.5</a:t>
             </a:r>
           </a:p>
         </p:txBody>
@@ -47772,8 +47772,8 @@
         </p:nvSpPr>
         <p:spPr>
           <a:xfrm>
-            <a:off x="6601968" y="4178808"/>
-            <a:ext cx="1490472" cy="292608"/>
+            <a:off x="7406640" y="4178808"/>
+            <a:ext cx="1271016" cy="292608"/>
           </a:xfrm>
           <a:prstGeom prst="rect">
             <a:avLst/>
@@ -47792,7 +47792,7 @@
               </a:spcAft>
             </a:pPr>
             <a:r>
-              <a:rPr sz="1120" b="1" i="0">
+              <a:rPr sz="1030" b="1" i="0">
                 <a:solidFill>
                   <a:srgbClr val="263746"/>
                 </a:solidFill>
@@ -47811,8 +47811,8 @@
         </p:nvSpPr>
         <p:spPr>
           <a:xfrm>
-            <a:off x="8165592" y="4178808"/>
-            <a:ext cx="960120" cy="292608"/>
+            <a:off x="8750808" y="4178808"/>
+            <a:ext cx="777240" cy="292608"/>
           </a:xfrm>
           <a:prstGeom prst="rect">
             <a:avLst/>
@@ -47831,7 +47831,7 @@
               </a:spcAft>
             </a:pPr>
             <a:r>
-              <a:rPr sz="1330" b="1" i="0">
+              <a:rPr sz="1260" b="1" i="0">
                 <a:solidFill>
                   <a:srgbClr val="D96552"/>
                 </a:solidFill>
@@ -47850,8 +47850,8 @@
         </p:nvSpPr>
         <p:spPr>
           <a:xfrm>
-            <a:off x="9253728" y="4178808"/>
-            <a:ext cx="804672" cy="292608"/>
+            <a:off x="9619488" y="4178808"/>
+            <a:ext cx="694944" cy="292608"/>
           </a:xfrm>
           <a:prstGeom prst="rect">
             <a:avLst/>
@@ -47870,7 +47870,7 @@
               </a:spcAft>
             </a:pPr>
             <a:r>
-              <a:rPr sz="1330" b="1" i="0">
+              <a:rPr sz="1260" b="1" i="0">
                 <a:solidFill>
                   <a:srgbClr val="178681"/>
                 </a:solidFill>
@@ -47889,8 +47889,8 @@
         </p:nvSpPr>
         <p:spPr>
           <a:xfrm>
-            <a:off x="10222992" y="4178808"/>
-            <a:ext cx="1234440" cy="292608"/>
+            <a:off x="10451592" y="4178808"/>
+            <a:ext cx="1005840" cy="292608"/>
           </a:xfrm>
           <a:prstGeom prst="rect">
             <a:avLst/>
@@ -47909,7 +47909,7 @@
               </a:spcAft>
             </a:pPr>
             <a:r>
-              <a:rPr sz="1070" b="0" i="0">
+              <a:rPr sz="1019" b="0" i="0">
                 <a:solidFill>
                   <a:srgbClr val="59697A"/>
                 </a:solidFill>
@@ -47928,8 +47928,8 @@
         </p:nvSpPr>
         <p:spPr>
           <a:xfrm>
-            <a:off x="502920" y="5212080"/>
-            <a:ext cx="5513832" cy="13716"/>
+            <a:off x="502920" y="5404104"/>
+            <a:ext cx="6428232" cy="13716"/>
           </a:xfrm>
           <a:prstGeom prst="rect">
             <a:avLst/>
@@ -47971,7 +47971,7 @@
         </p:nvSpPr>
         <p:spPr>
           <a:xfrm>
-            <a:off x="502920" y="5376672"/>
+            <a:off x="502920" y="5559552"/>
             <a:ext cx="1600200" cy="219456"/>
           </a:xfrm>
           <a:prstGeom prst="rect">
@@ -48010,7 +48010,7 @@
         </p:nvSpPr>
         <p:spPr>
           <a:xfrm>
-            <a:off x="3108960" y="5358384"/>
+            <a:off x="3931920" y="5541264"/>
             <a:ext cx="2852928" cy="246888"/>
           </a:xfrm>
           <a:prstGeom prst="rect">
@@ -48049,8 +48049,8 @@
         </p:nvSpPr>
         <p:spPr>
           <a:xfrm>
-            <a:off x="502920" y="5678424"/>
-            <a:ext cx="5458968" cy="228600"/>
+            <a:off x="502920" y="5843016"/>
+            <a:ext cx="6281928" cy="228600"/>
           </a:xfrm>
           <a:prstGeom prst="rect">
             <a:avLst/>
@@ -48088,7 +48088,7 @@
         </p:nvSpPr>
         <p:spPr>
           <a:xfrm>
-            <a:off x="6537960" y="4901184"/>
+            <a:off x="7351775" y="4901184"/>
             <a:ext cx="50292" cy="713232"/>
           </a:xfrm>
           <a:prstGeom prst="rect">
@@ -48131,8 +48131,8 @@
         </p:nvSpPr>
         <p:spPr>
           <a:xfrm>
-            <a:off x="6766560" y="4937760"/>
-            <a:ext cx="1298448" cy="283464"/>
+            <a:off x="7580375" y="4937760"/>
+            <a:ext cx="1207008" cy="283464"/>
           </a:xfrm>
           <a:prstGeom prst="rect">
             <a:avLst/>
@@ -48170,8 +48170,8 @@
         </p:nvSpPr>
         <p:spPr>
           <a:xfrm>
-            <a:off x="8147304" y="4919472"/>
-            <a:ext cx="3310128" cy="429768"/>
+            <a:off x="8897112" y="4919472"/>
+            <a:ext cx="2542032" cy="429768"/>
           </a:xfrm>
           <a:prstGeom prst="rect">
             <a:avLst/>
@@ -48190,7 +48190,7 @@
               </a:spcAft>
             </a:pPr>
             <a:r>
-              <a:rPr sz="1180" b="0" i="0">
+              <a:rPr sz="1130" b="0" i="0">
                 <a:solidFill>
                   <a:srgbClr val="263746"/>
                 </a:solidFill>
@@ -48209,8 +48209,8 @@
         </p:nvSpPr>
         <p:spPr>
           <a:xfrm>
-            <a:off x="6766560" y="5458968"/>
-            <a:ext cx="4663440" cy="365760"/>
+            <a:off x="7580375" y="5458968"/>
+            <a:ext cx="3858768" cy="365760"/>
           </a:xfrm>
           <a:prstGeom prst="rect">
             <a:avLst/>
@@ -48229,7 +48229,7 @@
               </a:spcAft>
             </a:pPr>
             <a:r>
-              <a:rPr sz="980" b="0" i="0">
+              <a:rPr sz="950" b="0" i="0">
                 <a:solidFill>
                   <a:srgbClr val="59697A"/>
                 </a:solidFill>

</xml_diff>

<commit_message>
Refine feature selection slide spacing
</commit_message>
<xml_diff>
--- a/presentation/SLSTP_2026_Generative_Transcriptomics.pptx
+++ b/presentation/SLSTP_2026_Generative_Transcriptomics.pptx
@@ -54942,8 +54942,8 @@
         </p:nvSpPr>
         <p:spPr>
           <a:xfrm>
-            <a:off x="1024128" y="3913632"/>
-            <a:ext cx="1371600" cy="475488"/>
+            <a:off x="941832" y="3941063"/>
+            <a:ext cx="1536192" cy="219456"/>
           </a:xfrm>
           <a:prstGeom prst="rect">
             <a:avLst/>
@@ -54962,14 +54962,13 @@
               </a:spcAft>
             </a:pPr>
             <a:r>
-              <a:rPr sz="1030" b="0" i="0">
-                <a:solidFill>
-                  <a:srgbClr val="59697A"/>
-                </a:solidFill>
-                <a:latin typeface="Arial"/>
-              </a:rPr>
-              <a:t>stable only in
-real ranking</a:t>
+              <a:rPr sz="919" b="1" i="0">
+                <a:solidFill>
+                  <a:srgbClr val="2D6496"/>
+                </a:solidFill>
+                <a:latin typeface="Arial"/>
+              </a:rPr>
+              <a:t>WITHOUT GUIDANCE</a:t>
             </a:r>
           </a:p>
         </p:txBody>
@@ -55060,8 +55059,8 @@
         </p:nvSpPr>
         <p:spPr>
           <a:xfrm>
-            <a:off x="2807208" y="3913632"/>
-            <a:ext cx="1225296" cy="274320"/>
+            <a:off x="2779776" y="3941063"/>
+            <a:ext cx="1280160" cy="219456"/>
           </a:xfrm>
           <a:prstGeom prst="rect">
             <a:avLst/>
@@ -55080,13 +55079,13 @@
               </a:spcAft>
             </a:pPr>
             <a:r>
-              <a:rPr sz="1030" b="0" i="0">
-                <a:solidFill>
-                  <a:srgbClr val="59697A"/>
-                </a:solidFill>
-                <a:latin typeface="Arial"/>
-              </a:rPr>
-              <a:t>stable in both</a:t>
+              <a:rPr sz="919" b="1" i="0">
+                <a:solidFill>
+                  <a:srgbClr val="D37B00"/>
+                </a:solidFill>
+                <a:latin typeface="Arial"/>
+              </a:rPr>
+              <a:t>BOTH RANKINGS</a:t>
             </a:r>
           </a:p>
         </p:txBody>
@@ -55177,8 +55176,8 @@
         </p:nvSpPr>
         <p:spPr>
           <a:xfrm>
-            <a:off x="4443984" y="3913632"/>
-            <a:ext cx="1426464" cy="475488"/>
+            <a:off x="4389120" y="3941063"/>
+            <a:ext cx="1536192" cy="219456"/>
           </a:xfrm>
           <a:prstGeom prst="rect">
             <a:avLst/>
@@ -55197,14 +55196,13 @@
               </a:spcAft>
             </a:pPr>
             <a:r>
-              <a:rPr sz="1030" b="0" i="0">
-                <a:solidFill>
-                  <a:srgbClr val="59697A"/>
-                </a:solidFill>
-                <a:latin typeface="Arial"/>
-              </a:rPr>
-              <a:t>stable only with
-synthetic guidance</a:t>
+              <a:rPr sz="919" b="1" i="0">
+                <a:solidFill>
+                  <a:srgbClr val="178681"/>
+                </a:solidFill>
+                <a:latin typeface="Arial"/>
+              </a:rPr>
+              <a:t>GUIDANCE ONLY</a:t>
             </a:r>
           </a:p>
         </p:txBody>
@@ -55299,7 +55297,7 @@
         </p:nvSpPr>
         <p:spPr>
           <a:xfrm>
-            <a:off x="7068312" y="3017520"/>
+            <a:off x="7123176" y="2999232"/>
             <a:ext cx="91440" cy="91440"/>
           </a:xfrm>
           <a:prstGeom prst="ellipse">
@@ -55342,8 +55340,8 @@
         </p:nvSpPr>
         <p:spPr>
           <a:xfrm>
-            <a:off x="7232904" y="2907792"/>
-            <a:ext cx="3886200" cy="557784"/>
+            <a:off x="7360920" y="2907792"/>
+            <a:ext cx="3794760" cy="347472"/>
           </a:xfrm>
           <a:prstGeom prst="rect">
             <a:avLst/>
@@ -55351,7 +55349,7 @@
           <a:noFill/>
         </p:spPr>
         <p:txBody>
-          <a:bodyPr wrap="square" lIns="18288" rIns="18288" tIns="18288" bIns="18288" anchor="ctr">
+          <a:bodyPr wrap="square" lIns="0" rIns="0" tIns="0" bIns="0" anchor="t">
             <a:spAutoFit/>
           </a:bodyPr>
           <a:lstStyle/>
@@ -55381,7 +55379,7 @@
         </p:nvSpPr>
         <p:spPr>
           <a:xfrm>
-            <a:off x="7068312" y="3575304"/>
+            <a:off x="7123176" y="3584448"/>
             <a:ext cx="91440" cy="91440"/>
           </a:xfrm>
           <a:prstGeom prst="ellipse">
@@ -55424,8 +55422,8 @@
         </p:nvSpPr>
         <p:spPr>
           <a:xfrm>
-            <a:off x="7232904" y="3465576"/>
-            <a:ext cx="3886200" cy="557784"/>
+            <a:off x="7360920" y="3493008"/>
+            <a:ext cx="3794760" cy="530352"/>
           </a:xfrm>
           <a:prstGeom prst="rect">
             <a:avLst/>
@@ -55433,7 +55431,7 @@
           <a:noFill/>
         </p:spPr>
         <p:txBody>
-          <a:bodyPr wrap="square" lIns="18288" rIns="18288" tIns="18288" bIns="18288" anchor="ctr">
+          <a:bodyPr wrap="square" lIns="0" rIns="0" tIns="0" bIns="0" anchor="t">
             <a:spAutoFit/>
           </a:bodyPr>
           <a:lstStyle/>
@@ -55450,7 +55448,8 @@
                 </a:solidFill>
                 <a:latin typeface="Arial"/>
               </a:rPr>
-              <a:t>Combine accession effects with a random-effects model</a:t>
+              <a:t>Combine accession effects with a
+random-effects model</a:t>
             </a:r>
           </a:p>
         </p:txBody>
@@ -55463,7 +55462,7 @@
         </p:nvSpPr>
         <p:spPr>
           <a:xfrm>
-            <a:off x="7068312" y="4133088"/>
+            <a:off x="7123176" y="4325112"/>
             <a:ext cx="91440" cy="91440"/>
           </a:xfrm>
           <a:prstGeom prst="ellipse">
@@ -55506,8 +55505,8 @@
         </p:nvSpPr>
         <p:spPr>
           <a:xfrm>
-            <a:off x="7232904" y="4023360"/>
-            <a:ext cx="3886200" cy="557784"/>
+            <a:off x="7360920" y="4233672"/>
+            <a:ext cx="3794760" cy="347472"/>
           </a:xfrm>
           <a:prstGeom prst="rect">
             <a:avLst/>
@@ -55515,7 +55514,7 @@
           <a:noFill/>
         </p:spPr>
         <p:txBody>
-          <a:bodyPr wrap="square" lIns="18288" rIns="18288" tIns="18288" bIns="18288" anchor="ctr">
+          <a:bodyPr wrap="square" lIns="0" rIns="0" tIns="0" bIns="0" anchor="t">
             <a:spAutoFit/>
           </a:bodyPr>
           <a:lstStyle/>

</xml_diff>

<commit_message>
Polish PCA caption and utility labels
</commit_message>
<xml_diff>
--- a/presentation/SLSTP_2026_Generative_Transcriptomics.pptx
+++ b/presentation/SLSTP_2026_Generative_Transcriptomics.pptx
@@ -48900,7 +48900,7 @@
                 </a:solidFill>
                 <a:latin typeface="Arial"/>
               </a:rPr>
-              <a:t>Interpretation: tissue structure dominates; FLT and GC are subtler. PCA is descriptive, so quantitative metrics determine validation.</a:t>
+              <a:t>Tissues separate clearly here. Flight and ground-control samples overlap much more, so we test that difference statistically.</a:t>
             </a:r>
           </a:p>
         </p:txBody>
@@ -53762,7 +53762,7 @@
         </p:nvSpPr>
         <p:spPr>
           <a:xfrm>
-            <a:off x="950976" y="3418027"/>
+            <a:off x="905256" y="3418027"/>
             <a:ext cx="566928" cy="2068372"/>
           </a:xfrm>
           <a:prstGeom prst="rect">
@@ -53805,7 +53805,7 @@
         </p:nvSpPr>
         <p:spPr>
           <a:xfrm>
-            <a:off x="877824" y="3097987"/>
+            <a:off x="832104" y="3097987"/>
             <a:ext cx="713232" cy="256032"/>
           </a:xfrm>
           <a:prstGeom prst="rect">
@@ -53844,8 +53844,8 @@
         </p:nvSpPr>
         <p:spPr>
           <a:xfrm>
-            <a:off x="859536" y="5559552"/>
-            <a:ext cx="749808" cy="502920"/>
+            <a:off x="786384" y="5559552"/>
+            <a:ext cx="804672" cy="292608"/>
           </a:xfrm>
           <a:prstGeom prst="rect">
             <a:avLst/>
@@ -53853,7 +53853,7 @@
           <a:noFill/>
         </p:spPr>
         <p:txBody>
-          <a:bodyPr wrap="square" lIns="18288" rIns="18288" tIns="18288" bIns="18288" anchor="t">
+          <a:bodyPr wrap="square" lIns="0" rIns="0" tIns="0" bIns="0" anchor="t">
             <a:spAutoFit/>
           </a:bodyPr>
           <a:lstStyle/>
@@ -53864,14 +53864,13 @@
               </a:spcAft>
             </a:pPr>
             <a:r>
-              <a:rPr sz="960" b="0" i="0">
+              <a:rPr sz="900" b="0" i="0">
                 <a:solidFill>
                   <a:srgbClr val="263746"/>
                 </a:solidFill>
                 <a:latin typeface="Arial"/>
               </a:rPr>
-              <a:t>Real
-only</a:t>
+              <a:t>Real</a:t>
             </a:r>
           </a:p>
         </p:txBody>
@@ -53884,7 +53883,7 @@
         </p:nvSpPr>
         <p:spPr>
           <a:xfrm>
-            <a:off x="1737360" y="3579876"/>
+            <a:off x="1719072" y="3579876"/>
             <a:ext cx="566928" cy="1906524"/>
           </a:xfrm>
           <a:prstGeom prst="rect">
@@ -53927,7 +53926,7 @@
         </p:nvSpPr>
         <p:spPr>
           <a:xfrm>
-            <a:off x="1664207" y="3259836"/>
+            <a:off x="1645919" y="3259836"/>
             <a:ext cx="713232" cy="256032"/>
           </a:xfrm>
           <a:prstGeom prst="rect">
@@ -53966,8 +53965,8 @@
         </p:nvSpPr>
         <p:spPr>
           <a:xfrm>
-            <a:off x="1645919" y="5559552"/>
-            <a:ext cx="749808" cy="502920"/>
+            <a:off x="1600200" y="5559552"/>
+            <a:ext cx="804672" cy="292608"/>
           </a:xfrm>
           <a:prstGeom prst="rect">
             <a:avLst/>
@@ -53975,7 +53974,7 @@
           <a:noFill/>
         </p:spPr>
         <p:txBody>
-          <a:bodyPr wrap="square" lIns="18288" rIns="18288" tIns="18288" bIns="18288" anchor="t">
+          <a:bodyPr wrap="square" lIns="0" rIns="0" tIns="0" bIns="0" anchor="t">
             <a:spAutoFit/>
           </a:bodyPr>
           <a:lstStyle/>
@@ -53986,14 +53985,13 @@
               </a:spcAft>
             </a:pPr>
             <a:r>
-              <a:rPr sz="960" b="0" i="0">
+              <a:rPr sz="900" b="0" i="0">
                 <a:solidFill>
                   <a:srgbClr val="263746"/>
                 </a:solidFill>
                 <a:latin typeface="Arial"/>
               </a:rPr>
-              <a:t>Generated
-only</a:t>
+              <a:t>Generated</a:t>
             </a:r>
           </a:p>
         </p:txBody>
@@ -54006,7 +54004,7 @@
         </p:nvSpPr>
         <p:spPr>
           <a:xfrm>
-            <a:off x="2523744" y="3464661"/>
+            <a:off x="2532888" y="3464661"/>
             <a:ext cx="566928" cy="2021738"/>
           </a:xfrm>
           <a:prstGeom prst="rect">
@@ -54049,7 +54047,7 @@
         </p:nvSpPr>
         <p:spPr>
           <a:xfrm>
-            <a:off x="2450591" y="3144621"/>
+            <a:off x="2459736" y="3144621"/>
             <a:ext cx="713232" cy="256032"/>
           </a:xfrm>
           <a:prstGeom prst="rect">
@@ -54088,8 +54086,8 @@
         </p:nvSpPr>
         <p:spPr>
           <a:xfrm>
-            <a:off x="2432303" y="5559552"/>
-            <a:ext cx="749808" cy="502920"/>
+            <a:off x="2414016" y="5559552"/>
+            <a:ext cx="804672" cy="292608"/>
           </a:xfrm>
           <a:prstGeom prst="rect">
             <a:avLst/>
@@ -54097,7 +54095,7 @@
           <a:noFill/>
         </p:spPr>
         <p:txBody>
-          <a:bodyPr wrap="square" lIns="18288" rIns="18288" tIns="18288" bIns="18288" anchor="t">
+          <a:bodyPr wrap="square" lIns="0" rIns="0" tIns="0" bIns="0" anchor="t">
             <a:spAutoFit/>
           </a:bodyPr>
           <a:lstStyle/>
@@ -54108,14 +54106,13 @@
               </a:spcAft>
             </a:pPr>
             <a:r>
-              <a:rPr sz="960" b="0" i="0">
+              <a:rPr sz="900" b="0" i="0">
                 <a:solidFill>
                   <a:srgbClr val="263746"/>
                 </a:solidFill>
                 <a:latin typeface="Arial"/>
               </a:rPr>
-              <a:t>Real +
-synth.</a:t>
+              <a:t>Real + synth.</a:t>
             </a:r>
           </a:p>
         </p:txBody>

</xml_diff>

<commit_message>
Clean up slide 4 outcome label
</commit_message>
<xml_diff>
--- a/presentation/SLSTP_2026_Generative_Transcriptomics.pptx
+++ b/presentation/SLSTP_2026_Generative_Transcriptomics.pptx
@@ -50280,8 +50280,8 @@
         </p:nvSpPr>
         <p:spPr>
           <a:xfrm>
-            <a:off x="9290304" y="3355848"/>
-            <a:ext cx="384048" cy="256032"/>
+            <a:off x="9125712" y="3355848"/>
+            <a:ext cx="283464" cy="256032"/>
           </a:xfrm>
           <a:prstGeom prst="rightArrow">
             <a:avLst/>
@@ -50317,14 +50317,59 @@
       </p:sp>
       <p:sp>
         <p:nvSpPr>
-          <p:cNvPr id="72" name="TextBox 71"/>
+          <p:cNvPr id="72" name="Rectangle 71"/>
+          <p:cNvSpPr/>
+          <p:nvPr/>
+        </p:nvSpPr>
+        <p:spPr>
+          <a:xfrm>
+            <a:off x="9592056" y="3017520"/>
+            <a:ext cx="1828800" cy="1042415"/>
+          </a:xfrm>
+          <a:prstGeom prst="rect">
+            <a:avLst/>
+          </a:prstGeom>
+          <a:solidFill>
+            <a:srgbClr val="E9F1F7"/>
+          </a:solidFill>
+          <a:ln w="10160">
+            <a:solidFill>
+              <a:srgbClr val="D4E2EC"/>
+            </a:solidFill>
+          </a:ln>
+        </p:spPr>
+        <p:style>
+          <a:lnRef idx="1">
+            <a:schemeClr val="accent1"/>
+          </a:lnRef>
+          <a:fillRef idx="3">
+            <a:schemeClr val="accent1"/>
+          </a:fillRef>
+          <a:effectRef idx="2">
+            <a:schemeClr val="accent1"/>
+          </a:effectRef>
+          <a:fontRef idx="minor">
+            <a:schemeClr val="lt1"/>
+          </a:fontRef>
+        </p:style>
+        <p:txBody>
+          <a:bodyPr rtlCol="0" anchor="ctr"/>
+          <a:lstStyle/>
+          <a:p>
+            <a:pPr algn="ctr"/>
+          </a:p>
+        </p:txBody>
+      </p:sp>
+      <p:sp>
+        <p:nvSpPr>
+          <p:cNvPr id="73" name="TextBox 72"/>
           <p:cNvSpPr txBox="1"/>
           <p:nvPr/>
         </p:nvSpPr>
         <p:spPr>
           <a:xfrm>
-            <a:off x="9893808" y="3063240"/>
-            <a:ext cx="1060704" cy="246888"/>
+            <a:off x="9765792" y="3172968"/>
+            <a:ext cx="1490472" cy="164592"/>
           </a:xfrm>
           <a:prstGeom prst="rect">
             <a:avLst/>
@@ -50343,27 +50388,27 @@
               </a:spcAft>
             </a:pPr>
             <a:r>
-              <a:rPr sz="1350" b="1" i="0">
-                <a:solidFill>
-                  <a:srgbClr val="082B55"/>
-                </a:solidFill>
-                <a:latin typeface="Arial"/>
-              </a:rPr>
-              <a:t>genes</a:t>
-            </a:r>
-          </a:p>
-        </p:txBody>
-      </p:sp>
-      <p:sp>
-        <p:nvSpPr>
-          <p:cNvPr id="73" name="TextBox 72"/>
+              <a:rPr sz="919" b="1" i="0">
+                <a:solidFill>
+                  <a:srgbClr val="2D6496"/>
+                </a:solidFill>
+                <a:latin typeface="Arial"/>
+              </a:rPr>
+              <a:t>OUTPUT</a:t>
+            </a:r>
+          </a:p>
+        </p:txBody>
+      </p:sp>
+      <p:sp>
+        <p:nvSpPr>
+          <p:cNvPr id="74" name="TextBox 73"/>
           <p:cNvSpPr txBox="1"/>
           <p:nvPr/>
         </p:nvSpPr>
         <p:spPr>
           <a:xfrm>
-            <a:off x="9893808" y="3429000"/>
-            <a:ext cx="1353312" cy="246888"/>
+            <a:off x="9765792" y="3429000"/>
+            <a:ext cx="1490472" cy="493776"/>
           </a:xfrm>
           <a:prstGeom prst="rect">
             <a:avLst/>
@@ -50382,52 +50427,14 @@
               </a:spcAft>
             </a:pPr>
             <a:r>
-              <a:rPr sz="1350" b="1" i="0">
+              <a:rPr sz="1220" b="1" i="0">
                 <a:solidFill>
                   <a:srgbClr val="082B55"/>
                 </a:solidFill>
                 <a:latin typeface="Arial"/>
               </a:rPr>
-              <a:t>+ pathways</a:t>
-            </a:r>
-          </a:p>
-        </p:txBody>
-      </p:sp>
-      <p:sp>
-        <p:nvSpPr>
-          <p:cNvPr id="74" name="TextBox 73"/>
-          <p:cNvSpPr txBox="1"/>
-          <p:nvPr/>
-        </p:nvSpPr>
-        <p:spPr>
-          <a:xfrm>
-            <a:off x="9893808" y="3794760"/>
-            <a:ext cx="1417320" cy="219456"/>
-          </a:xfrm>
-          <a:prstGeom prst="rect">
-            <a:avLst/>
-          </a:prstGeom>
-          <a:noFill/>
-        </p:spPr>
-        <p:txBody>
-          <a:bodyPr wrap="square" lIns="0" rIns="0" tIns="0" bIns="0" anchor="t">
-            <a:spAutoFit/>
-          </a:bodyPr>
-          <a:lstStyle/>
-          <a:p>
-            <a:pPr algn="l">
-              <a:spcAft>
-                <a:spcPts val="0"/>
-              </a:spcAft>
-            </a:pPr>
-            <a:r>
-              <a:rPr sz="1100" b="0" i="0">
-                <a:solidFill>
-                  <a:srgbClr val="59697A"/>
-                </a:solidFill>
-                <a:latin typeface="Arial"/>
-              </a:rPr>
-              <a:t>for each tissue</a:t>
+              <a:t>Tissue-specific
+genes and pathways</a:t>
             </a:r>
           </a:p>
         </p:txBody>

</xml_diff>